<commit_message>
Show concrete MX lowering in editable slides
</commit_message>
<xml_diff>
--- a/docs/presentations/mx_gemmini_dialect_overview.pptx
+++ b/docs/presentations/mx_gemmini_dialect_overview.pptx
@@ -16556,82 +16556,33 @@
                 </a:solidFill>
                 <a:latin typeface="Inter"/>
               </a:rPr>
-              <a:t>One dialect, many MX configurations</a:t>
+              <a:t>One JSON profile changes legal MLIR</a:t>
             </a:r>
           </a:p>
         </p:txBody>
       </p:sp>
       <p:sp>
         <p:nvSpPr>
-          <p:cNvPr id="12" name="Text | 01"/>
-          <p:cNvSpPr txBox="1"/>
-          <p:nvPr/>
-        </p:nvSpPr>
-        <p:spPr>
-          <a:xfrm>
-            <a:off x="859536" y="1856231"/>
-            <a:ext cx="1892807" cy="557784"/>
-          </a:xfrm>
-          <a:prstGeom prst="rect">
-            <a:avLst/>
-          </a:prstGeom>
-          <a:noFill/>
-          <a:effectLst/>
-        </p:spPr>
-        <p:txBody>
-          <a:bodyPr wrap="square" lIns="0" rIns="0" tIns="0" bIns="0" anchor="t">
-            <a:spAutoFit/>
-          </a:bodyPr>
-          <a:lstStyle/>
-          <a:p>
-            <a:pPr algn="ctr">
-              <a:lnSpc>
-                <a:spcPct val="112000"/>
-              </a:lnSpc>
-              <a:spcBef>
-                <a:spcPts val="0"/>
-              </a:spcBef>
-              <a:spcAft>
-                <a:spcPts val="0"/>
-              </a:spcAft>
-            </a:pPr>
-            <a:r>
-              <a:rPr sz="2900" b="0">
-                <a:solidFill>
-                  <a:srgbClr val="83776B"/>
-                </a:solidFill>
-                <a:latin typeface="DM Serif Display"/>
-              </a:rPr>
-              <a:t>01</a:t>
-            </a:r>
-          </a:p>
-        </p:txBody>
-      </p:sp>
-      <p:sp>
-        <p:nvSpPr>
-          <p:cNvPr id="13" name="Component | Stage 1"/>
+          <p:cNvPr id="6" name="Rounded Rectangle 5"/>
           <p:cNvSpPr/>
           <p:nvPr/>
         </p:nvSpPr>
         <p:spPr>
           <a:xfrm>
-            <a:off x="859536" y="2734056"/>
-            <a:ext cx="1892807" cy="1133856"/>
+            <a:off x="859536" y="1481328"/>
+            <a:ext cx="5522976" cy="4407408"/>
           </a:xfrm>
           <a:prstGeom prst="roundRect">
-            <a:avLst>
-              <a:gd name="adj" fmla="val 8000"/>
-            </a:avLst>
+            <a:avLst/>
           </a:prstGeom>
           <a:solidFill>
-            <a:srgbClr val="ECE3DA"/>
+            <a:srgbClr val="EDE5DC"/>
           </a:solidFill>
-          <a:ln w="14604">
+          <a:ln>
             <a:solidFill>
-              <a:srgbClr val="AB9A89"/>
+              <a:srgbClr val="B0A597"/>
             </a:solidFill>
           </a:ln>
-          <a:effectLst/>
         </p:spPr>
         <p:style>
           <a:lnRef idx="1">
@@ -16640,7 +16591,7 @@
           <a:fillRef idx="3">
             <a:schemeClr val="accent1"/>
           </a:fillRef>
-          <a:effectRef idx="0">
+          <a:effectRef idx="2">
             <a:schemeClr val="accent1"/>
           </a:effectRef>
           <a:fontRef idx="minor">
@@ -16657,242 +16608,26 @@
       </p:sp>
       <p:sp>
         <p:nvSpPr>
-          <p:cNvPr id="14" name="Text | Stage 1"/>
-          <p:cNvSpPr txBox="1"/>
-          <p:nvPr/>
-        </p:nvSpPr>
-        <p:spPr>
-          <a:xfrm>
-            <a:off x="969264" y="2788920"/>
-            <a:ext cx="1673351" cy="1024128"/>
-          </a:xfrm>
-          <a:prstGeom prst="rect">
-            <a:avLst/>
-          </a:prstGeom>
-          <a:noFill/>
-          <a:effectLst/>
-        </p:spPr>
-        <p:txBody>
-          <a:bodyPr wrap="square" lIns="0" rIns="0" tIns="0" bIns="0" anchor="ctr">
-            <a:spAutoFit/>
-          </a:bodyPr>
-          <a:lstStyle/>
-          <a:p>
-            <a:pPr algn="ctr">
-              <a:lnSpc>
-                <a:spcPct val="112000"/>
-              </a:lnSpc>
-              <a:spcBef>
-                <a:spcPts val="0"/>
-              </a:spcBef>
-              <a:spcAft>
-                <a:spcPts val="0"/>
-              </a:spcAft>
-            </a:pPr>
-            <a:r>
-              <a:rPr sz="1720" b="1">
-                <a:solidFill>
-                  <a:srgbClr val="313455"/>
-                </a:solidFill>
-                <a:latin typeface="Inter"/>
-              </a:rPr>
-              <a:t>RTL + MxGen</a:t>
-            </a:r>
-          </a:p>
-        </p:txBody>
-      </p:sp>
-      <p:sp>
-        <p:nvSpPr>
-          <p:cNvPr id="15" name="Text | Input / action&#10;and expected&#10;output."/>
-          <p:cNvSpPr txBox="1"/>
-          <p:nvPr/>
-        </p:nvSpPr>
-        <p:spPr>
-          <a:xfrm>
-            <a:off x="859536" y="4288536"/>
-            <a:ext cx="1892807" cy="1069848"/>
-          </a:xfrm>
-          <a:prstGeom prst="rect">
-            <a:avLst/>
-          </a:prstGeom>
-          <a:noFill/>
-          <a:effectLst/>
-        </p:spPr>
-        <p:txBody>
-          <a:bodyPr wrap="square" lIns="0" rIns="0" tIns="0" bIns="0" anchor="ctr">
-            <a:spAutoFit/>
-          </a:bodyPr>
-          <a:lstStyle/>
-          <a:p>
-            <a:pPr algn="ctr">
-              <a:lnSpc>
-                <a:spcPct val="120000"/>
-              </a:lnSpc>
-              <a:spcBef>
-                <a:spcPts val="0"/>
-              </a:spcBef>
-              <a:spcAft>
-                <a:spcPts val="0"/>
-              </a:spcAft>
-            </a:pPr>
-            <a:r>
-              <a:rPr sz="1300" b="0">
-                <a:solidFill>
-                  <a:srgbClr val="313455"/>
-                </a:solidFill>
-                <a:latin typeface="Inter"/>
-              </a:rPr>
-              <a:t>41 MX fragments</a:t>
-            </a:r>
-          </a:p>
-          <a:p>
-            <a:pPr algn="ctr">
-              <a:spcBef>
-                <a:spcPts val="0"/>
-              </a:spcBef>
-              <a:spcAft>
-                <a:spcPts val="0"/>
-              </a:spcAft>
-            </a:pPr>
-            <a:r>
-              <a:rPr sz="1300" b="0">
-                <a:solidFill>
-                  <a:srgbClr val="313455"/>
-                </a:solidFill>
-                <a:latin typeface="Inter"/>
-              </a:rPr>
-              <a:t>40 SoC wrappers</a:t>
-            </a:r>
-          </a:p>
-          <a:p>
-            <a:pPr algn="ctr">
-              <a:spcBef>
-                <a:spcPts val="0"/>
-              </a:spcBef>
-              <a:spcAft>
-                <a:spcPts val="0"/>
-              </a:spcAft>
-            </a:pPr>
-            <a:r>
-              <a:rPr sz="1300" b="0">
-                <a:solidFill>
-                  <a:srgbClr val="313455"/>
-                </a:solidFill>
-                <a:latin typeface="Inter"/>
-              </a:rPr>
-              <a:t>pinned source hashes</a:t>
-            </a:r>
-          </a:p>
-        </p:txBody>
-      </p:sp>
-      <p:cxnSp>
-        <p:nvCxnSpPr>
-          <p:cNvPr id="16" name="Connector"/>
-          <p:cNvCxnSpPr/>
-          <p:nvPr/>
-        </p:nvCxnSpPr>
-        <p:spPr>
-          <a:xfrm>
-            <a:off x="2788920" y="3300984"/>
-            <a:ext cx="164592" cy="0"/>
-          </a:xfrm>
-          <a:prstGeom prst="line">
-            <a:avLst/>
-          </a:prstGeom>
-          <a:ln w="16510">
-            <a:solidFill>
-              <a:srgbClr val="2E2D2C"/>
-            </a:solidFill>
-            <a:tailEnd type="triangle" w="sm" len="sm"/>
-          </a:ln>
-          <a:effectLst/>
-        </p:spPr>
-        <p:style>
-          <a:lnRef idx="2">
-            <a:schemeClr val="accent1"/>
-          </a:lnRef>
-          <a:fillRef idx="0">
-            <a:schemeClr val="accent1"/>
-          </a:fillRef>
-          <a:effectRef idx="0">
-            <a:schemeClr val="accent1"/>
-          </a:effectRef>
-          <a:fontRef idx="minor">
-            <a:schemeClr val="tx1"/>
-          </a:fontRef>
-        </p:style>
-      </p:cxnSp>
-      <p:sp>
-        <p:nvSpPr>
-          <p:cNvPr id="17" name="Text | 02"/>
-          <p:cNvSpPr txBox="1"/>
-          <p:nvPr/>
-        </p:nvSpPr>
-        <p:spPr>
-          <a:xfrm>
-            <a:off x="3008376" y="1856231"/>
-            <a:ext cx="1892807" cy="557784"/>
-          </a:xfrm>
-          <a:prstGeom prst="rect">
-            <a:avLst/>
-          </a:prstGeom>
-          <a:noFill/>
-          <a:effectLst/>
-        </p:spPr>
-        <p:txBody>
-          <a:bodyPr wrap="square" lIns="0" rIns="0" tIns="0" bIns="0" anchor="t">
-            <a:spAutoFit/>
-          </a:bodyPr>
-          <a:lstStyle/>
-          <a:p>
-            <a:pPr algn="ctr">
-              <a:lnSpc>
-                <a:spcPct val="112000"/>
-              </a:lnSpc>
-              <a:spcBef>
-                <a:spcPts val="0"/>
-              </a:spcBef>
-              <a:spcAft>
-                <a:spcPts val="0"/>
-              </a:spcAft>
-            </a:pPr>
-            <a:r>
-              <a:rPr sz="2900" b="0">
-                <a:solidFill>
-                  <a:srgbClr val="0F3759"/>
-                </a:solidFill>
-                <a:latin typeface="DM Serif Display"/>
-              </a:rPr>
-              <a:t>02</a:t>
-            </a:r>
-          </a:p>
-        </p:txBody>
-      </p:sp>
-      <p:sp>
-        <p:nvSpPr>
-          <p:cNvPr id="18" name="Component | Stage 2"/>
+          <p:cNvPr id="7" name="Rounded Rectangle 6"/>
           <p:cNvSpPr/>
           <p:nvPr/>
         </p:nvSpPr>
         <p:spPr>
           <a:xfrm>
-            <a:off x="3008376" y="2734056"/>
-            <a:ext cx="1892807" cy="1133856"/>
+            <a:off x="6547104" y="1481328"/>
+            <a:ext cx="4800600" cy="4407408"/>
           </a:xfrm>
           <a:prstGeom prst="roundRect">
-            <a:avLst>
-              <a:gd name="adj" fmla="val 8000"/>
-            </a:avLst>
+            <a:avLst/>
           </a:prstGeom>
           <a:solidFill>
-            <a:srgbClr val="CBCFD0"/>
+            <a:srgbClr val="E1E8EC"/>
           </a:solidFill>
-          <a:ln w="14604">
+          <a:ln>
             <a:solidFill>
-              <a:srgbClr val="0F3759"/>
+              <a:srgbClr val="B0A597"/>
             </a:solidFill>
           </a:ln>
-          <a:effectLst/>
         </p:spPr>
         <p:style>
           <a:lnRef idx="1">
@@ -16901,7 +16636,7 @@
           <a:fillRef idx="3">
             <a:schemeClr val="accent1"/>
           </a:fillRef>
-          <a:effectRef idx="0">
+          <a:effectRef idx="2">
             <a:schemeClr val="accent1"/>
           </a:effectRef>
           <a:fontRef idx="minor">
@@ -16918,31 +16653,27 @@
       </p:sp>
       <p:sp>
         <p:nvSpPr>
-          <p:cNvPr id="19" name="Text | Stage 2"/>
+          <p:cNvPr id="8" name="TextBox 7"/>
           <p:cNvSpPr txBox="1"/>
           <p:nvPr/>
         </p:nvSpPr>
         <p:spPr>
           <a:xfrm>
-            <a:off x="3118104" y="2788920"/>
-            <a:ext cx="1673351" cy="1024128"/>
+            <a:off x="1051560" y="1636776"/>
+            <a:ext cx="5102352" cy="310896"/>
           </a:xfrm>
           <a:prstGeom prst="rect">
             <a:avLst/>
           </a:prstGeom>
           <a:noFill/>
-          <a:effectLst/>
         </p:spPr>
         <p:txBody>
-          <a:bodyPr wrap="square" lIns="0" rIns="0" tIns="0" bIns="0" anchor="ctr">
+          <a:bodyPr wrap="square" lIns="18288" rIns="18288" tIns="9144" bIns="9144" anchor="ctr">
             <a:spAutoFit/>
           </a:bodyPr>
           <a:lstStyle/>
           <a:p>
-            <a:pPr algn="ctr">
-              <a:lnSpc>
-                <a:spcPct val="112000"/>
-              </a:lnSpc>
+            <a:pPr algn="l">
               <a:spcBef>
                 <a:spcPts val="0"/>
               </a:spcBef>
@@ -16953,207 +16684,37 @@
             <a:r>
               <a:rPr sz="1720" b="1">
                 <a:solidFill>
-                  <a:srgbClr val="313455"/>
+                  <a:srgbClr val="103552"/>
                 </a:solidFill>
                 <a:latin typeface="Inter"/>
               </a:rPr>
-              <a:t>Profile JSON</a:t>
+              <a:t>Selected RTL profile fields</a:t>
             </a:r>
           </a:p>
         </p:txBody>
       </p:sp>
       <p:sp>
         <p:nvSpPr>
-          <p:cNvPr id="20" name="Text | Input / action&#10;and expected&#10;output."/>
-          <p:cNvSpPr txBox="1"/>
-          <p:nvPr/>
-        </p:nvSpPr>
-        <p:spPr>
-          <a:xfrm>
-            <a:off x="3008376" y="4288536"/>
-            <a:ext cx="1892807" cy="1069848"/>
-          </a:xfrm>
-          <a:prstGeom prst="rect">
-            <a:avLst/>
-          </a:prstGeom>
-          <a:noFill/>
-          <a:effectLst/>
-        </p:spPr>
-        <p:txBody>
-          <a:bodyPr wrap="square" lIns="0" rIns="0" tIns="0" bIns="0" anchor="ctr">
-            <a:spAutoFit/>
-          </a:bodyPr>
-          <a:lstStyle/>
-          <a:p>
-            <a:pPr algn="ctr">
-              <a:lnSpc>
-                <a:spcPct val="120000"/>
-              </a:lnSpc>
-              <a:spcBef>
-                <a:spcPts val="0"/>
-              </a:spcBef>
-              <a:spcAft>
-                <a:spcPts val="0"/>
-              </a:spcAft>
-            </a:pPr>
-            <a:r>
-              <a:rPr sz="1300" b="0">
-                <a:solidFill>
-                  <a:srgbClr val="313455"/>
-                </a:solidFill>
-                <a:latin typeface="Inter"/>
-              </a:rPr>
-              <a:t>mesh / DMA / queues</a:t>
-            </a:r>
-          </a:p>
-          <a:p>
-            <a:pPr algn="ctr">
-              <a:spcBef>
-                <a:spcPts val="0"/>
-              </a:spcBef>
-              <a:spcAft>
-                <a:spcPts val="0"/>
-              </a:spcAft>
-            </a:pPr>
-            <a:r>
-              <a:rPr sz="1300" b="0">
-                <a:solidFill>
-                  <a:srgbClr val="313455"/>
-                </a:solidFill>
-                <a:latin typeface="Inter"/>
-              </a:rPr>
-              <a:t>LUT + scales + VPU</a:t>
-            </a:r>
-          </a:p>
-          <a:p>
-            <a:pPr algn="ctr">
-              <a:spcBef>
-                <a:spcPts val="0"/>
-              </a:spcBef>
-              <a:spcAft>
-                <a:spcPts val="0"/>
-              </a:spcAft>
-            </a:pPr>
-            <a:r>
-              <a:rPr sz="1300" b="0">
-                <a:solidFill>
-                  <a:srgbClr val="313455"/>
-                </a:solidFill>
-                <a:latin typeface="Inter"/>
-              </a:rPr>
-              <a:t>legal PE tuples</a:t>
-            </a:r>
-          </a:p>
-        </p:txBody>
-      </p:sp>
-      <p:cxnSp>
-        <p:nvCxnSpPr>
-          <p:cNvPr id="21" name="Connector"/>
-          <p:cNvCxnSpPr/>
-          <p:nvPr/>
-        </p:nvCxnSpPr>
-        <p:spPr>
-          <a:xfrm>
-            <a:off x="4937760" y="3300984"/>
-            <a:ext cx="164592" cy="0"/>
-          </a:xfrm>
-          <a:prstGeom prst="line">
-            <a:avLst/>
-          </a:prstGeom>
-          <a:ln w="16510">
-            <a:solidFill>
-              <a:srgbClr val="2E2D2C"/>
-            </a:solidFill>
-            <a:tailEnd type="triangle" w="sm" len="sm"/>
-          </a:ln>
-          <a:effectLst/>
-        </p:spPr>
-        <p:style>
-          <a:lnRef idx="2">
-            <a:schemeClr val="accent1"/>
-          </a:lnRef>
-          <a:fillRef idx="0">
-            <a:schemeClr val="accent1"/>
-          </a:fillRef>
-          <a:effectRef idx="0">
-            <a:schemeClr val="accent1"/>
-          </a:effectRef>
-          <a:fontRef idx="minor">
-            <a:schemeClr val="tx1"/>
-          </a:fontRef>
-        </p:style>
-      </p:cxnSp>
-      <p:sp>
-        <p:nvSpPr>
-          <p:cNvPr id="22" name="Text | 03"/>
-          <p:cNvSpPr txBox="1"/>
-          <p:nvPr/>
-        </p:nvSpPr>
-        <p:spPr>
-          <a:xfrm>
-            <a:off x="5157216" y="1856231"/>
-            <a:ext cx="1892807" cy="557784"/>
-          </a:xfrm>
-          <a:prstGeom prst="rect">
-            <a:avLst/>
-          </a:prstGeom>
-          <a:noFill/>
-          <a:effectLst/>
-        </p:spPr>
-        <p:txBody>
-          <a:bodyPr wrap="square" lIns="0" rIns="0" tIns="0" bIns="0" anchor="t">
-            <a:spAutoFit/>
-          </a:bodyPr>
-          <a:lstStyle/>
-          <a:p>
-            <a:pPr algn="ctr">
-              <a:lnSpc>
-                <a:spcPct val="112000"/>
-              </a:lnSpc>
-              <a:spcBef>
-                <a:spcPts val="0"/>
-              </a:spcBef>
-              <a:spcAft>
-                <a:spcPts val="0"/>
-              </a:spcAft>
-            </a:pPr>
-            <a:r>
-              <a:rPr sz="2900" b="0">
-                <a:solidFill>
-                  <a:srgbClr val="6D727F"/>
-                </a:solidFill>
-                <a:latin typeface="DM Serif Display"/>
-              </a:rPr>
-              <a:t>03</a:t>
-            </a:r>
-          </a:p>
-        </p:txBody>
-      </p:sp>
-      <p:sp>
-        <p:nvSpPr>
-          <p:cNvPr id="23" name="Component | Stage 3"/>
+          <p:cNvPr id="9" name="Rounded Rectangle 8"/>
           <p:cNvSpPr/>
           <p:nvPr/>
         </p:nvSpPr>
         <p:spPr>
           <a:xfrm>
-            <a:off x="5157216" y="2734056"/>
-            <a:ext cx="1892807" cy="1133856"/>
+            <a:off x="1051560" y="2029968"/>
+            <a:ext cx="5093208" cy="2569464"/>
           </a:xfrm>
           <a:prstGeom prst="roundRect">
-            <a:avLst>
-              <a:gd name="adj" fmla="val 8000"/>
-            </a:avLst>
+            <a:avLst/>
           </a:prstGeom>
           <a:solidFill>
-            <a:srgbClr val="E5E2E0"/>
+            <a:srgbClr val="FDF8F1"/>
           </a:solidFill>
-          <a:ln w="14604">
+          <a:ln>
             <a:solidFill>
-              <a:srgbClr val="8B93A6"/>
+              <a:srgbClr val="D3CABF"/>
             </a:solidFill>
           </a:ln>
-          <a:effectLst/>
         </p:spPr>
         <p:style>
           <a:lnRef idx="1">
@@ -17162,7 +16723,7 @@
           <a:fillRef idx="3">
             <a:schemeClr val="accent1"/>
           </a:fillRef>
-          <a:effectRef idx="0">
+          <a:effectRef idx="2">
             <a:schemeClr val="accent1"/>
           </a:effectRef>
           <a:fontRef idx="minor">
@@ -17170,40 +16731,326 @@
           </a:fontRef>
         </p:style>
         <p:txBody>
-          <a:bodyPr rtlCol="0" anchor="ctr"/>
+          <a:bodyPr rtlCol="0" anchor="t" wrap="none" lIns="109728" tIns="91440" rIns="73152" bIns="36576"/>
           <a:lstStyle/>
           <a:p>
-            <a:pPr algn="ctr"/>
+            <a:pPr algn="ctr">
+              <a:spcBef>
+                <a:spcPts val="0"/>
+              </a:spcBef>
+              <a:spcAft>
+                <a:spcPts val="0"/>
+              </a:spcAft>
+            </a:pPr>
+            <a:r>
+              <a:rPr sz="1045">
+                <a:solidFill>
+                  <a:srgbClr val="103552"/>
+                </a:solidFill>
+                <a:latin typeface="Liberation Mono"/>
+              </a:rPr>
+              <a:t>{</a:t>
+            </a:r>
+          </a:p>
+          <a:p>
+            <a:pPr>
+              <a:spcBef>
+                <a:spcPts val="0"/>
+              </a:spcBef>
+              <a:spcAft>
+                <a:spcPts val="0"/>
+              </a:spcAft>
+            </a:pPr>
+            <a:r>
+              <a:rPr sz="1045">
+                <a:solidFill>
+                  <a:srgbClr val="103552"/>
+                </a:solidFill>
+                <a:latin typeface="Liberation Mono"/>
+              </a:rPr>
+              <a:t> "geometry": {"mesh_rows":16,"mesh_columns":16},</a:t>
+            </a:r>
+          </a:p>
+          <a:p>
+            <a:pPr>
+              <a:spcBef>
+                <a:spcPts val="0"/>
+              </a:spcBef>
+              <a:spcAft>
+                <a:spcPts val="0"/>
+              </a:spcAft>
+            </a:pPr>
+            <a:r>
+              <a:rPr sz="1045">
+                <a:solidFill>
+                  <a:srgbClr val="103552"/>
+                </a:solidFill>
+                <a:latin typeface="Liberation Mono"/>
+              </a:rPr>
+              <a:t> "legal_compute": [</a:t>
+            </a:r>
+          </a:p>
+          <a:p>
+            <a:pPr>
+              <a:spcBef>
+                <a:spcPts val="0"/>
+              </a:spcBef>
+              <a:spcAft>
+                <a:spcPts val="0"/>
+              </a:spcAft>
+            </a:pPr>
+            <a:r>
+              <a:rPr sz="1045">
+                <a:solidFill>
+                  <a:srgbClr val="103552"/>
+                </a:solidFill>
+                <a:latin typeface="Liberation Mono"/>
+              </a:rPr>
+              <a:t>  {"activation_format":"fp4_e2m1",</a:t>
+            </a:r>
+          </a:p>
+          <a:p>
+            <a:pPr>
+              <a:spcBef>
+                <a:spcPts val="0"/>
+              </a:spcBef>
+              <a:spcAft>
+                <a:spcPts val="0"/>
+              </a:spcAft>
+            </a:pPr>
+            <a:r>
+              <a:rPr sz="1045">
+                <a:solidFill>
+                  <a:srgbClr val="103552"/>
+                </a:solidFill>
+                <a:latin typeface="Liberation Mono"/>
+              </a:rPr>
+              <a:t>   "weight_format":"fp4_e2m1","pe_mode":0},</a:t>
+            </a:r>
+          </a:p>
+          <a:p>
+            <a:pPr>
+              <a:spcBef>
+                <a:spcPts val="0"/>
+              </a:spcBef>
+              <a:spcAft>
+                <a:spcPts val="0"/>
+              </a:spcAft>
+            </a:pPr>
+            <a:r>
+              <a:rPr sz="1045">
+                <a:solidFill>
+                  <a:srgbClr val="103552"/>
+                </a:solidFill>
+                <a:latin typeface="Liberation Mono"/>
+              </a:rPr>
+              <a:t>  {"activation_format":"fp8_e4m3",</a:t>
+            </a:r>
+          </a:p>
+          <a:p>
+            <a:pPr>
+              <a:spcBef>
+                <a:spcPts val="0"/>
+              </a:spcBef>
+              <a:spcAft>
+                <a:spcPts val="0"/>
+              </a:spcAft>
+            </a:pPr>
+            <a:r>
+              <a:rPr sz="1045">
+                <a:solidFill>
+                  <a:srgbClr val="103552"/>
+                </a:solidFill>
+                <a:latin typeface="Liberation Mono"/>
+              </a:rPr>
+              <a:t>   "weight_format":"fp8_e4m3","pe_mode":8}</a:t>
+            </a:r>
+          </a:p>
+          <a:p>
+            <a:pPr>
+              <a:spcBef>
+                <a:spcPts val="0"/>
+              </a:spcBef>
+              <a:spcAft>
+                <a:spcPts val="0"/>
+              </a:spcAft>
+            </a:pPr>
+            <a:r>
+              <a:rPr sz="1045">
+                <a:solidFill>
+                  <a:srgbClr val="103552"/>
+                </a:solidFill>
+                <a:latin typeface="Liberation Mono"/>
+              </a:rPr>
+              <a:t> ],</a:t>
+            </a:r>
+          </a:p>
+          <a:p>
+            <a:pPr>
+              <a:spcBef>
+                <a:spcPts val="0"/>
+              </a:spcBef>
+              <a:spcAft>
+                <a:spcPts val="0"/>
+              </a:spcAft>
+            </a:pPr>
+            <a:r>
+              <a:rPr sz="1045">
+                <a:solidFill>
+                  <a:srgbClr val="103552"/>
+                </a:solidFill>
+                <a:latin typeface="Liberation Mono"/>
+              </a:rPr>
+              <a:t> "resources": {"scratchpad_bytes":262144,</a:t>
+            </a:r>
+          </a:p>
+          <a:p>
+            <a:pPr>
+              <a:spcBef>
+                <a:spcPts val="0"/>
+              </a:spcBef>
+              <a:spcAft>
+                <a:spcPts val="0"/>
+              </a:spcAft>
+            </a:pPr>
+            <a:r>
+              <a:rPr sz="1045">
+                <a:solidFill>
+                  <a:srgbClr val="103552"/>
+                </a:solidFill>
+                <a:latin typeface="Liberation Mono"/>
+              </a:rPr>
+              <a:t>               "vpu":true,"spad_requant":true}</a:t>
+            </a:r>
+          </a:p>
+          <a:p>
+            <a:pPr>
+              <a:spcBef>
+                <a:spcPts val="0"/>
+              </a:spcBef>
+              <a:spcAft>
+                <a:spcPts val="0"/>
+              </a:spcAft>
+            </a:pPr>
+            <a:r>
+              <a:rPr sz="1045">
+                <a:solidFill>
+                  <a:srgbClr val="103552"/>
+                </a:solidFill>
+                <a:latin typeface="Liberation Mono"/>
+              </a:rPr>
+              <a:t>}</a:t>
+            </a:r>
           </a:p>
         </p:txBody>
       </p:sp>
       <p:sp>
         <p:nvSpPr>
-          <p:cNvPr id="24" name="Text | Stage 3"/>
+          <p:cNvPr id="10" name="TextBox 9"/>
           <p:cNvSpPr txBox="1"/>
           <p:nvPr/>
         </p:nvSpPr>
         <p:spPr>
           <a:xfrm>
-            <a:off x="5266944" y="2788920"/>
-            <a:ext cx="1673351" cy="1024128"/>
+            <a:off x="1051560" y="4736592"/>
+            <a:ext cx="5093208" cy="475488"/>
           </a:xfrm>
           <a:prstGeom prst="rect">
             <a:avLst/>
           </a:prstGeom>
           <a:noFill/>
-          <a:effectLst/>
         </p:spPr>
         <p:txBody>
-          <a:bodyPr wrap="square" lIns="0" rIns="0" tIns="0" bIns="0" anchor="ctr">
+          <a:bodyPr wrap="square" lIns="18288" rIns="18288" tIns="9144" bIns="9144" anchor="ctr">
             <a:spAutoFit/>
           </a:bodyPr>
           <a:lstStyle/>
           <a:p>
-            <a:pPr algn="ctr">
-              <a:lnSpc>
-                <a:spcPct val="112000"/>
-              </a:lnSpc>
+            <a:pPr algn="l">
+              <a:spcBef>
+                <a:spcPts val="0"/>
+              </a:spcBef>
+              <a:spcAft>
+                <a:spcPts val="0"/>
+              </a:spcAft>
+            </a:pPr>
+            <a:r>
+              <a:rPr sz="1110" b="0">
+                <a:solidFill>
+                  <a:srgbClr val="313455"/>
+                </a:solidFill>
+                <a:latin typeface="Inter"/>
+              </a:rPr>
+              <a:t>MxE4M3Fp4VpuGemminiRocketConfig · direct projections in both legal rows · two 8-lane BF16 VPUs.</a:t>
+            </a:r>
+          </a:p>
+        </p:txBody>
+      </p:sp>
+      <p:sp>
+        <p:nvSpPr>
+          <p:cNvPr id="11" name="TextBox 10"/>
+          <p:cNvSpPr txBox="1"/>
+          <p:nvPr/>
+        </p:nvSpPr>
+        <p:spPr>
+          <a:xfrm>
+            <a:off x="1051560" y="5312664"/>
+            <a:ext cx="5093208" cy="356616"/>
+          </a:xfrm>
+          <a:prstGeom prst="rect">
+            <a:avLst/>
+          </a:prstGeom>
+          <a:noFill/>
+        </p:spPr>
+        <p:txBody>
+          <a:bodyPr wrap="square" lIns="18288" rIns="18288" tIns="9144" bIns="9144" anchor="ctr">
+            <a:spAutoFit/>
+          </a:bodyPr>
+          <a:lstStyle/>
+          <a:p>
+            <a:pPr algn="l">
+              <a:spcBef>
+                <a:spcPts val="0"/>
+              </a:spcBef>
+              <a:spcAft>
+                <a:spcPts val="0"/>
+              </a:spcAft>
+            </a:pPr>
+            <a:r>
+              <a:rPr sz="1040" b="0">
+                <a:solidFill>
+                  <a:srgbClr val="5B5957"/>
+                </a:solidFill>
+                <a:latin typeface="Inter"/>
+              </a:rPr>
+              <a:t>RTL 266c593 + MxGen dba3e7 → 41 fragments / 40 SoC wrappers; each JSON stores source hashes.</a:t>
+            </a:r>
+          </a:p>
+        </p:txBody>
+      </p:sp>
+      <p:sp>
+        <p:nvSpPr>
+          <p:cNvPr id="12" name="TextBox 11"/>
+          <p:cNvSpPr txBox="1"/>
+          <p:nvPr/>
+        </p:nvSpPr>
+        <p:spPr>
+          <a:xfrm>
+            <a:off x="6748272" y="1636776"/>
+            <a:ext cx="4370832" cy="310896"/>
+          </a:xfrm>
+          <a:prstGeom prst="rect">
+            <a:avLst/>
+          </a:prstGeom>
+          <a:noFill/>
+        </p:spPr>
+        <p:txBody>
+          <a:bodyPr wrap="square" lIns="18288" rIns="18288" tIns="9144" bIns="9144" anchor="ctr">
+            <a:spAutoFit/>
+          </a:bodyPr>
+          <a:lstStyle/>
+          <a:p>
+            <a:pPr algn="l">
               <a:spcBef>
                 <a:spcPts val="0"/>
               </a:spcBef>
@@ -17214,207 +17061,37 @@
             <a:r>
               <a:rPr sz="1720" b="1">
                 <a:solidFill>
-                  <a:srgbClr val="313455"/>
+                  <a:srgbClr val="103552"/>
                 </a:solidFill>
                 <a:latin typeface="Inter"/>
               </a:rPr>
-              <a:t>Typed legality</a:t>
+              <a:t>Before → after bind_profile</a:t>
             </a:r>
           </a:p>
         </p:txBody>
       </p:sp>
       <p:sp>
         <p:nvSpPr>
-          <p:cNvPr id="25" name="Text | Input / action&#10;and expected&#10;output."/>
-          <p:cNvSpPr txBox="1"/>
-          <p:nvPr/>
-        </p:nvSpPr>
-        <p:spPr>
-          <a:xfrm>
-            <a:off x="5157216" y="4288536"/>
-            <a:ext cx="1892807" cy="1069848"/>
-          </a:xfrm>
-          <a:prstGeom prst="rect">
-            <a:avLst/>
-          </a:prstGeom>
-          <a:noFill/>
-          <a:effectLst/>
-        </p:spPr>
-        <p:txBody>
-          <a:bodyPr wrap="square" lIns="0" rIns="0" tIns="0" bIns="0" anchor="ctr">
-            <a:spAutoFit/>
-          </a:bodyPr>
-          <a:lstStyle/>
-          <a:p>
-            <a:pPr algn="ctr">
-              <a:lnSpc>
-                <a:spcPct val="120000"/>
-              </a:lnSpc>
-              <a:spcBef>
-                <a:spcPts val="0"/>
-              </a:spcBef>
-              <a:spcAft>
-                <a:spcPts val="0"/>
-              </a:spcAft>
-            </a:pPr>
-            <a:r>
-              <a:rPr sz="1300" b="0">
-                <a:solidFill>
-                  <a:srgbClr val="313455"/>
-                </a:solidFill>
-                <a:latin typeface="Inter"/>
-              </a:rPr>
-              <a:t>format + projection</a:t>
-            </a:r>
-          </a:p>
-          <a:p>
-            <a:pPr algn="ctr">
-              <a:spcBef>
-                <a:spcPts val="0"/>
-              </a:spcBef>
-              <a:spcAft>
-                <a:spcPts val="0"/>
-              </a:spcAft>
-            </a:pPr>
-            <a:r>
-              <a:rPr sz="1300" b="0">
-                <a:solidFill>
-                  <a:srgbClr val="313455"/>
-                </a:solidFill>
-                <a:latin typeface="Inter"/>
-              </a:rPr>
-              <a:t>DIM / SRAM bounds</a:t>
-            </a:r>
-          </a:p>
-          <a:p>
-            <a:pPr algn="ctr">
-              <a:spcBef>
-                <a:spcPts val="0"/>
-              </a:spcBef>
-              <a:spcAft>
-                <a:spcPts val="0"/>
-              </a:spcAft>
-            </a:pPr>
-            <a:r>
-              <a:rPr sz="1300" b="0">
-                <a:solidFill>
-                  <a:srgbClr val="313455"/>
-                </a:solidFill>
-                <a:latin typeface="Inter"/>
-              </a:rPr>
-              <a:t>reject invalid modes</a:t>
-            </a:r>
-          </a:p>
-        </p:txBody>
-      </p:sp>
-      <p:cxnSp>
-        <p:nvCxnSpPr>
-          <p:cNvPr id="26" name="Connector"/>
-          <p:cNvCxnSpPr/>
-          <p:nvPr/>
-        </p:nvCxnSpPr>
-        <p:spPr>
-          <a:xfrm>
-            <a:off x="7086600" y="3300984"/>
-            <a:ext cx="164592" cy="0"/>
-          </a:xfrm>
-          <a:prstGeom prst="line">
-            <a:avLst/>
-          </a:prstGeom>
-          <a:ln w="16510">
-            <a:solidFill>
-              <a:srgbClr val="2E2D2C"/>
-            </a:solidFill>
-            <a:tailEnd type="triangle" w="sm" len="sm"/>
-          </a:ln>
-          <a:effectLst/>
-        </p:spPr>
-        <p:style>
-          <a:lnRef idx="2">
-            <a:schemeClr val="accent1"/>
-          </a:lnRef>
-          <a:fillRef idx="0">
-            <a:schemeClr val="accent1"/>
-          </a:fillRef>
-          <a:effectRef idx="0">
-            <a:schemeClr val="accent1"/>
-          </a:effectRef>
-          <a:fontRef idx="minor">
-            <a:schemeClr val="tx1"/>
-          </a:fontRef>
-        </p:style>
-      </p:cxnSp>
-      <p:sp>
-        <p:nvSpPr>
-          <p:cNvPr id="27" name="Text | 04"/>
-          <p:cNvSpPr txBox="1"/>
-          <p:nvPr/>
-        </p:nvSpPr>
-        <p:spPr>
-          <a:xfrm>
-            <a:off x="7306056" y="1856231"/>
-            <a:ext cx="1892807" cy="557784"/>
-          </a:xfrm>
-          <a:prstGeom prst="rect">
-            <a:avLst/>
-          </a:prstGeom>
-          <a:noFill/>
-          <a:effectLst/>
-        </p:spPr>
-        <p:txBody>
-          <a:bodyPr wrap="square" lIns="0" rIns="0" tIns="0" bIns="0" anchor="t">
-            <a:spAutoFit/>
-          </a:bodyPr>
-          <a:lstStyle/>
-          <a:p>
-            <a:pPr algn="ctr">
-              <a:lnSpc>
-                <a:spcPct val="112000"/>
-              </a:lnSpc>
-              <a:spcBef>
-                <a:spcPts val="0"/>
-              </a:spcBef>
-              <a:spcAft>
-                <a:spcPts val="0"/>
-              </a:spcAft>
-            </a:pPr>
-            <a:r>
-              <a:rPr sz="2900" b="0">
-                <a:solidFill>
-                  <a:srgbClr val="815E5E"/>
-                </a:solidFill>
-                <a:latin typeface="DM Serif Display"/>
-              </a:rPr>
-              <a:t>04</a:t>
-            </a:r>
-          </a:p>
-        </p:txBody>
-      </p:sp>
-      <p:sp>
-        <p:nvSpPr>
-          <p:cNvPr id="28" name="Component | Stage 4"/>
+          <p:cNvPr id="13" name="Rounded Rectangle 12"/>
           <p:cNvSpPr/>
           <p:nvPr/>
         </p:nvSpPr>
         <p:spPr>
           <a:xfrm>
-            <a:off x="7306056" y="2734056"/>
-            <a:ext cx="1892807" cy="1133856"/>
+            <a:off x="6748272" y="2029968"/>
+            <a:ext cx="4379976" cy="1499616"/>
           </a:xfrm>
           <a:prstGeom prst="roundRect">
-            <a:avLst>
-              <a:gd name="adj" fmla="val 8000"/>
-            </a:avLst>
+            <a:avLst/>
           </a:prstGeom>
           <a:solidFill>
-            <a:srgbClr val="E3D7D1"/>
+            <a:srgbClr val="FDF8F1"/>
           </a:solidFill>
-          <a:ln w="14604">
+          <a:ln>
             <a:solidFill>
-              <a:srgbClr val="815E5E"/>
+              <a:srgbClr val="D3CABF"/>
             </a:solidFill>
           </a:ln>
-          <a:effectLst/>
         </p:spPr>
         <p:style>
           <a:lnRef idx="1">
@@ -17423,7 +17100,7 @@
           <a:fillRef idx="3">
             <a:schemeClr val="accent1"/>
           </a:fillRef>
-          <a:effectRef idx="0">
+          <a:effectRef idx="2">
             <a:schemeClr val="accent1"/>
           </a:effectRef>
           <a:fontRef idx="minor">
@@ -17431,414 +17108,134 @@
           </a:fontRef>
         </p:style>
         <p:txBody>
-          <a:bodyPr rtlCol="0" anchor="ctr"/>
+          <a:bodyPr rtlCol="0" anchor="t" wrap="none" lIns="109728" tIns="91440" rIns="73152" bIns="36576"/>
           <a:lstStyle/>
           <a:p>
-            <a:pPr algn="ctr"/>
+            <a:pPr algn="ctr">
+              <a:spcBef>
+                <a:spcPts val="0"/>
+              </a:spcBef>
+              <a:spcAft>
+                <a:spcPts val="0"/>
+              </a:spcAft>
+            </a:pPr>
+            <a:r>
+              <a:rPr sz="1085">
+                <a:solidFill>
+                  <a:srgbClr val="103552"/>
+                </a:solidFill>
+                <a:latin typeface="Liberation Mono"/>
+              </a:rPr>
+              <a:t>before: contract {format = "mxfp4"}</a:t>
+            </a:r>
+          </a:p>
+          <a:p>
+            <a:pPr>
+              <a:spcBef>
+                <a:spcPts val="0"/>
+              </a:spcBef>
+              <a:spcAft>
+                <a:spcPts val="0"/>
+              </a:spcAft>
+            </a:pPr>
+            <a:r>
+              <a:rPr sz="1085">
+                <a:solidFill>
+                  <a:srgbClr val="103552"/>
+                </a:solidFill>
+                <a:latin typeface="Liberation Mono"/>
+              </a:rPr>
+              <a:t>after:  contract {</a:t>
+            </a:r>
+          </a:p>
+          <a:p>
+            <a:pPr>
+              <a:spcBef>
+                <a:spcPts val="0"/>
+              </a:spcBef>
+              <a:spcAft>
+                <a:spcPts val="0"/>
+              </a:spcAft>
+            </a:pPr>
+            <a:r>
+              <a:rPr sz="1085">
+                <a:solidFill>
+                  <a:srgbClr val="103552"/>
+                </a:solidFill>
+                <a:latin typeface="Liberation Mono"/>
+              </a:rPr>
+              <a:t>  activation_format = "fp4_e2m1",</a:t>
+            </a:r>
+          </a:p>
+          <a:p>
+            <a:pPr>
+              <a:spcBef>
+                <a:spcPts val="0"/>
+              </a:spcBef>
+              <a:spcAft>
+                <a:spcPts val="0"/>
+              </a:spcAft>
+            </a:pPr>
+            <a:r>
+              <a:rPr sz="1085">
+                <a:solidFill>
+                  <a:srgbClr val="103552"/>
+                </a:solidFill>
+                <a:latin typeface="Liberation Mono"/>
+              </a:rPr>
+              <a:t>  weight_format = "fp4_e2m1",</a:t>
+            </a:r>
+          </a:p>
+          <a:p>
+            <a:pPr>
+              <a:spcBef>
+                <a:spcPts val="0"/>
+              </a:spcBef>
+              <a:spcAft>
+                <a:spcPts val="0"/>
+              </a:spcAft>
+            </a:pPr>
+            <a:r>
+              <a:rPr sz="1085">
+                <a:solidFill>
+                  <a:srgbClr val="103552"/>
+                </a:solidFill>
+                <a:latin typeface="Liberation Mono"/>
+              </a:rPr>
+              <a:t>  pe_mode = 0 : i32,</a:t>
+            </a:r>
+          </a:p>
+          <a:p>
+            <a:pPr>
+              <a:spcBef>
+                <a:spcPts val="0"/>
+              </a:spcBef>
+              <a:spcAft>
+                <a:spcPts val="0"/>
+              </a:spcAft>
+            </a:pPr>
+            <a:r>
+              <a:rPr sz="1085">
+                <a:solidFill>
+                  <a:srgbClr val="103552"/>
+                </a:solidFill>
+                <a:latin typeface="Liberation Mono"/>
+              </a:rPr>
+              <a:t>  profile_sha256 = "e9e33f..." }</a:t>
+            </a:r>
           </a:p>
         </p:txBody>
       </p:sp>
       <p:sp>
         <p:nvSpPr>
-          <p:cNvPr id="29" name="Text | Stage 4"/>
+          <p:cNvPr id="14" name="TextBox 13"/>
           <p:cNvSpPr txBox="1"/>
           <p:nvPr/>
         </p:nvSpPr>
         <p:spPr>
           <a:xfrm>
-            <a:off x="7415783" y="2788920"/>
-            <a:ext cx="1673351" cy="1024128"/>
-          </a:xfrm>
-          <a:prstGeom prst="rect">
-            <a:avLst/>
-          </a:prstGeom>
-          <a:noFill/>
-          <a:effectLst/>
-        </p:spPr>
-        <p:txBody>
-          <a:bodyPr wrap="square" lIns="0" rIns="0" tIns="0" bIns="0" anchor="ctr">
-            <a:spAutoFit/>
-          </a:bodyPr>
-          <a:lstStyle/>
-          <a:p>
-            <a:pPr algn="ctr">
-              <a:lnSpc>
-                <a:spcPct val="112000"/>
-              </a:lnSpc>
-              <a:spcBef>
-                <a:spcPts val="0"/>
-              </a:spcBef>
-              <a:spcAft>
-                <a:spcPts val="0"/>
-              </a:spcAft>
-            </a:pPr>
-            <a:r>
-              <a:rPr sz="1720" b="1">
-                <a:solidFill>
-                  <a:srgbClr val="313455"/>
-                </a:solidFill>
-                <a:latin typeface="Inter"/>
-              </a:rPr>
-              <a:t>Schedule + emit</a:t>
-            </a:r>
-          </a:p>
-        </p:txBody>
-      </p:sp>
-      <p:sp>
-        <p:nvSpPr>
-          <p:cNvPr id="30" name="Text | Input / action&#10;and expected&#10;output."/>
-          <p:cNvSpPr txBox="1"/>
-          <p:nvPr/>
-        </p:nvSpPr>
-        <p:spPr>
-          <a:xfrm>
-            <a:off x="7306056" y="4288536"/>
-            <a:ext cx="1892807" cy="1069848"/>
-          </a:xfrm>
-          <a:prstGeom prst="rect">
-            <a:avLst/>
-          </a:prstGeom>
-          <a:noFill/>
-          <a:effectLst/>
-        </p:spPr>
-        <p:txBody>
-          <a:bodyPr wrap="square" lIns="0" rIns="0" tIns="0" bIns="0" anchor="ctr">
-            <a:spAutoFit/>
-          </a:bodyPr>
-          <a:lstStyle/>
-          <a:p>
-            <a:pPr algn="ctr">
-              <a:lnSpc>
-                <a:spcPct val="120000"/>
-              </a:lnSpc>
-              <a:spcBef>
-                <a:spcPts val="0"/>
-              </a:spcBef>
-              <a:spcAft>
-                <a:spcPts val="0"/>
-              </a:spcAft>
-            </a:pPr>
-            <a:r>
-              <a:rPr sz="1300" b="0">
-                <a:solidFill>
-                  <a:srgbClr val="313455"/>
-                </a:solidFill>
-                <a:latin typeface="Inter"/>
-              </a:rPr>
-              <a:t>schedule.plan + tiles</a:t>
-            </a:r>
-          </a:p>
-          <a:p>
-            <a:pPr algn="ctr">
-              <a:spcBef>
-                <a:spcPts val="0"/>
-              </a:spcBef>
-              <a:spcAft>
-                <a:spcPts val="0"/>
-              </a:spcAft>
-            </a:pPr>
-            <a:r>
-              <a:rPr sz="1300" b="0">
-                <a:solidFill>
-                  <a:srgbClr val="313455"/>
-                </a:solidFill>
-                <a:latin typeface="Inter"/>
-              </a:rPr>
-              <a:t>SPAD / DMA / loops</a:t>
-            </a:r>
-          </a:p>
-          <a:p>
-            <a:pPr algn="ctr">
-              <a:spcBef>
-                <a:spcPts val="0"/>
-              </a:spcBef>
-              <a:spcAft>
-                <a:spcPts val="0"/>
-              </a:spcAft>
-            </a:pPr>
-            <a:r>
-              <a:rPr sz="1300" b="0">
-                <a:solidFill>
-                  <a:srgbClr val="313455"/>
-                </a:solidFill>
-                <a:latin typeface="Inter"/>
-              </a:rPr>
-              <a:t>RoCC command IR</a:t>
-            </a:r>
-          </a:p>
-        </p:txBody>
-      </p:sp>
-      <p:cxnSp>
-        <p:nvCxnSpPr>
-          <p:cNvPr id="31" name="Connector"/>
-          <p:cNvCxnSpPr/>
-          <p:nvPr/>
-        </p:nvCxnSpPr>
-        <p:spPr>
-          <a:xfrm>
-            <a:off x="9235440" y="3300984"/>
-            <a:ext cx="164592" cy="0"/>
-          </a:xfrm>
-          <a:prstGeom prst="line">
-            <a:avLst/>
-          </a:prstGeom>
-          <a:ln w="16510">
-            <a:solidFill>
-              <a:srgbClr val="2E2D2C"/>
-            </a:solidFill>
-            <a:tailEnd type="triangle" w="sm" len="sm"/>
-          </a:ln>
-          <a:effectLst/>
-        </p:spPr>
-        <p:style>
-          <a:lnRef idx="2">
-            <a:schemeClr val="accent1"/>
-          </a:lnRef>
-          <a:fillRef idx="0">
-            <a:schemeClr val="accent1"/>
-          </a:fillRef>
-          <a:effectRef idx="0">
-            <a:schemeClr val="accent1"/>
-          </a:effectRef>
-          <a:fontRef idx="minor">
-            <a:schemeClr val="tx1"/>
-          </a:fontRef>
-        </p:style>
-      </p:cxnSp>
-      <p:sp>
-        <p:nvSpPr>
-          <p:cNvPr id="32" name="Text | 05"/>
-          <p:cNvSpPr txBox="1"/>
-          <p:nvPr/>
-        </p:nvSpPr>
-        <p:spPr>
-          <a:xfrm>
-            <a:off x="9454896" y="1856231"/>
-            <a:ext cx="1892807" cy="557784"/>
-          </a:xfrm>
-          <a:prstGeom prst="rect">
-            <a:avLst/>
-          </a:prstGeom>
-          <a:noFill/>
-          <a:effectLst/>
-        </p:spPr>
-        <p:txBody>
-          <a:bodyPr wrap="square" lIns="0" rIns="0" tIns="0" bIns="0" anchor="t">
-            <a:spAutoFit/>
-          </a:bodyPr>
-          <a:lstStyle/>
-          <a:p>
-            <a:pPr algn="ctr">
-              <a:lnSpc>
-                <a:spcPct val="112000"/>
-              </a:lnSpc>
-              <a:spcBef>
-                <a:spcPts val="0"/>
-              </a:spcBef>
-              <a:spcAft>
-                <a:spcPts val="0"/>
-              </a:spcAft>
-            </a:pPr>
-            <a:r>
-              <a:rPr sz="2900" b="0">
-                <a:solidFill>
-                  <a:srgbClr val="7D886C"/>
-                </a:solidFill>
-                <a:latin typeface="DM Serif Display"/>
-              </a:rPr>
-              <a:t>05</a:t>
-            </a:r>
-          </a:p>
-        </p:txBody>
-      </p:sp>
-      <p:sp>
-        <p:nvSpPr>
-          <p:cNvPr id="33" name="Component | Stage 5"/>
-          <p:cNvSpPr/>
-          <p:nvPr/>
-        </p:nvSpPr>
-        <p:spPr>
-          <a:xfrm>
-            <a:off x="9454896" y="2734056"/>
-            <a:ext cx="1892807" cy="1133856"/>
-          </a:xfrm>
-          <a:prstGeom prst="roundRect">
-            <a:avLst>
-              <a:gd name="adj" fmla="val 8000"/>
-            </a:avLst>
-          </a:prstGeom>
-          <a:solidFill>
-            <a:srgbClr val="E2E0D3"/>
-          </a:solidFill>
-          <a:ln w="14604">
-            <a:solidFill>
-              <a:srgbClr val="7D886C"/>
-            </a:solidFill>
-          </a:ln>
-          <a:effectLst/>
-        </p:spPr>
-        <p:style>
-          <a:lnRef idx="1">
-            <a:schemeClr val="accent1"/>
-          </a:lnRef>
-          <a:fillRef idx="3">
-            <a:schemeClr val="accent1"/>
-          </a:fillRef>
-          <a:effectRef idx="0">
-            <a:schemeClr val="accent1"/>
-          </a:effectRef>
-          <a:fontRef idx="minor">
-            <a:schemeClr val="lt1"/>
-          </a:fontRef>
-        </p:style>
-        <p:txBody>
-          <a:bodyPr rtlCol="0" anchor="ctr"/>
-          <a:lstStyle/>
-          <a:p>
-            <a:pPr algn="ctr"/>
-          </a:p>
-        </p:txBody>
-      </p:sp>
-      <p:sp>
-        <p:nvSpPr>
-          <p:cNvPr id="34" name="Text | Stage 5"/>
-          <p:cNvSpPr txBox="1"/>
-          <p:nvPr/>
-        </p:nvSpPr>
-        <p:spPr>
-          <a:xfrm>
-            <a:off x="9564624" y="2788920"/>
-            <a:ext cx="1673351" cy="1024128"/>
-          </a:xfrm>
-          <a:prstGeom prst="rect">
-            <a:avLst/>
-          </a:prstGeom>
-          <a:noFill/>
-          <a:effectLst/>
-        </p:spPr>
-        <p:txBody>
-          <a:bodyPr wrap="square" lIns="0" rIns="0" tIns="0" bIns="0" anchor="ctr">
-            <a:spAutoFit/>
-          </a:bodyPr>
-          <a:lstStyle/>
-          <a:p>
-            <a:pPr algn="ctr">
-              <a:lnSpc>
-                <a:spcPct val="112000"/>
-              </a:lnSpc>
-              <a:spcBef>
-                <a:spcPts val="0"/>
-              </a:spcBef>
-              <a:spcAft>
-                <a:spcPts val="0"/>
-              </a:spcAft>
-            </a:pPr>
-            <a:r>
-              <a:rPr sz="1720" b="1">
-                <a:solidFill>
-                  <a:srgbClr val="313455"/>
-                </a:solidFill>
-                <a:latin typeface="Inter"/>
-              </a:rPr>
-              <a:t>Spike qualify</a:t>
-            </a:r>
-          </a:p>
-        </p:txBody>
-      </p:sp>
-      <p:sp>
-        <p:nvSpPr>
-          <p:cNvPr id="35" name="Text | Input / action&#10;and expected&#10;output."/>
-          <p:cNvSpPr txBox="1"/>
-          <p:nvPr/>
-        </p:nvSpPr>
-        <p:spPr>
-          <a:xfrm>
-            <a:off x="9454896" y="4288536"/>
-            <a:ext cx="1892807" cy="1069848"/>
-          </a:xfrm>
-          <a:prstGeom prst="rect">
-            <a:avLst/>
-          </a:prstGeom>
-          <a:noFill/>
-          <a:effectLst/>
-        </p:spPr>
-        <p:txBody>
-          <a:bodyPr wrap="square" lIns="0" rIns="0" tIns="0" bIns="0" anchor="ctr">
-            <a:spAutoFit/>
-          </a:bodyPr>
-          <a:lstStyle/>
-          <a:p>
-            <a:pPr algn="ctr">
-              <a:lnSpc>
-                <a:spcPct val="120000"/>
-              </a:lnSpc>
-              <a:spcBef>
-                <a:spcPts val="0"/>
-              </a:spcBef>
-              <a:spcAft>
-                <a:spcPts val="0"/>
-              </a:spcAft>
-            </a:pPr>
-            <a:r>
-              <a:rPr sz="1300" b="0">
-                <a:solidFill>
-                  <a:srgbClr val="313455"/>
-                </a:solidFill>
-                <a:latin typeface="Inter"/>
-              </a:rPr>
-              <a:t>Nicolas kernels</a:t>
-            </a:r>
-          </a:p>
-          <a:p>
-            <a:pPr algn="ctr">
-              <a:spcBef>
-                <a:spcPts val="0"/>
-              </a:spcBef>
-              <a:spcAft>
-                <a:spcPts val="0"/>
-              </a:spcAft>
-            </a:pPr>
-            <a:r>
-              <a:rPr sz="1300" b="0">
-                <a:solidFill>
-                  <a:srgbClr val="313455"/>
-                </a:solidFill>
-                <a:latin typeface="Inter"/>
-              </a:rPr>
-              <a:t>numeric + cycle receipts</a:t>
-            </a:r>
-          </a:p>
-          <a:p>
-            <a:pPr algn="ctr">
-              <a:spcBef>
-                <a:spcPts val="0"/>
-              </a:spcBef>
-              <a:spcAft>
-                <a:spcPts val="0"/>
-              </a:spcAft>
-            </a:pPr>
-            <a:r>
-              <a:rPr sz="1300" b="0">
-                <a:solidFill>
-                  <a:srgbClr val="313455"/>
-                </a:solidFill>
-                <a:latin typeface="Inter"/>
-              </a:rPr>
-              <a:t>per config / mode</a:t>
-            </a:r>
-          </a:p>
-        </p:txBody>
-      </p:sp>
-      <p:sp>
-        <p:nvSpPr>
-          <p:cNvPr id="36" name="TextBox 35"/>
-          <p:cNvSpPr txBox="1"/>
-          <p:nvPr/>
-        </p:nvSpPr>
-        <p:spPr>
-          <a:xfrm>
-            <a:off x="868680" y="5532120"/>
-            <a:ext cx="9646920" cy="557784"/>
+            <a:off x="6748272" y="3712463"/>
+            <a:ext cx="4370832" cy="274320"/>
           </a:xfrm>
           <a:prstGeom prst="rect">
             <a:avLst/>
@@ -17860,15 +17257,137 @@
               </a:spcAft>
             </a:pPr>
             <a:r>
-              <a:rPr sz="1019" b="0">
-                <a:solidFill>
-                  <a:srgbClr val="5B5957"/>
+              <a:rPr sz="1410" b="1">
+                <a:solidFill>
+                  <a:srgbClr val="103552"/>
                 </a:solidFill>
                 <a:latin typeface="Inter"/>
               </a:rPr>
-              <a:t>RTL/MxGen defines capabilities; npu-exploration supplies reference kernels. Selected DIM16 MX+VPU: E4M3 + FP4,</a:t>
+              <a:t>Compiler consequences</a:t>
             </a:r>
           </a:p>
+        </p:txBody>
+      </p:sp>
+      <p:sp>
+        <p:nvSpPr>
+          <p:cNvPr id="15" name="TextBox 14"/>
+          <p:cNvSpPr txBox="1"/>
+          <p:nvPr/>
+        </p:nvSpPr>
+        <p:spPr>
+          <a:xfrm>
+            <a:off x="6748272" y="4041648"/>
+            <a:ext cx="4370832" cy="1481328"/>
+          </a:xfrm>
+          <a:prstGeom prst="rect">
+            <a:avLst/>
+          </a:prstGeom>
+          <a:noFill/>
+        </p:spPr>
+        <p:txBody>
+          <a:bodyPr wrap="square" lIns="18288" rIns="18288" tIns="9144" bIns="9144" anchor="ctr">
+            <a:spAutoFit/>
+          </a:bodyPr>
+          <a:lstStyle/>
+          <a:p>
+            <a:pPr algn="l">
+              <a:spcBef>
+                <a:spcPts val="0"/>
+              </a:spcBef>
+              <a:spcAft>
+                <a:spcPts val="0"/>
+              </a:spcAft>
+            </a:pPr>
+            <a:r>
+              <a:rPr sz="1160" b="0">
+                <a:solidFill>
+                  <a:srgbClr val="313455"/>
+                </a:solidFill>
+                <a:latin typeface="Inter"/>
+              </a:rPr>
+              <a:t>• FP4 selects PE 0; 256 KiB SPAD bounds tiling.</a:t>
+            </a:r>
+          </a:p>
+          <a:p>
+            <a:pPr algn="l">
+              <a:spcBef>
+                <a:spcPts val="0"/>
+              </a:spcBef>
+              <a:spcAft>
+                <a:spcPts val="0"/>
+              </a:spcAft>
+            </a:pPr>
+            <a:r>
+              <a:rPr sz="1160" b="0">
+                <a:solidFill>
+                  <a:srgbClr val="313455"/>
+                </a:solidFill>
+                <a:latin typeface="Inter"/>
+              </a:rPr>
+              <a:t>• vpu_execute / spad_requant become legal.</a:t>
+            </a:r>
+          </a:p>
+          <a:p>
+            <a:pPr algn="l">
+              <a:spcBef>
+                <a:spcPts val="0"/>
+              </a:spcBef>
+              <a:spcAft>
+                <a:spcPts val="0"/>
+              </a:spcAft>
+            </a:pPr>
+            <a:r>
+              <a:rPr sz="1160" b="0">
+                <a:solidFill>
+                  <a:srgbClr val="313455"/>
+                </a:solidFill>
+                <a:latin typeface="Inter"/>
+              </a:rPr>
+              <a:t>• FP6 contracts reject here; use its LUT profile.</a:t>
+            </a:r>
+          </a:p>
+          <a:p>
+            <a:pPr algn="l">
+              <a:spcBef>
+                <a:spcPts val="0"/>
+              </a:spcBef>
+              <a:spcAft>
+                <a:spcPts val="0"/>
+              </a:spcAft>
+            </a:pPr>
+            <a:r>
+              <a:rPr sz="1160" b="0">
+                <a:solidFill>
+                  <a:srgbClr val="313455"/>
+                </a:solidFill>
+                <a:latin typeface="Inter"/>
+              </a:rPr>
+              <a:t>• load_profile(rtl_root) rejects RTL drift.</a:t>
+            </a:r>
+          </a:p>
+        </p:txBody>
+      </p:sp>
+      <p:sp>
+        <p:nvSpPr>
+          <p:cNvPr id="16" name="TextBox 15"/>
+          <p:cNvSpPr txBox="1"/>
+          <p:nvPr/>
+        </p:nvSpPr>
+        <p:spPr>
+          <a:xfrm>
+            <a:off x="877824" y="5943600"/>
+            <a:ext cx="10469880" cy="228600"/>
+          </a:xfrm>
+          <a:prstGeom prst="rect">
+            <a:avLst/>
+          </a:prstGeom>
+          <a:noFill/>
+        </p:spPr>
+        <p:txBody>
+          <a:bodyPr wrap="square" lIns="18288" rIns="18288" tIns="9144" bIns="9144" anchor="ctr">
+            <a:spAutoFit/>
+          </a:bodyPr>
+          <a:lstStyle/>
           <a:p>
             <a:pPr algn="l">
               <a:spcBef>
@@ -17885,14 +17404,14 @@
                 </a:solidFill>
                 <a:latin typeface="Inter"/>
               </a:rPr>
-              <a:t>two 8-lane BF16 VPUs and SPAD_REQUANT. FP6 is separate; each profile needs numerical qualification.</a:t>
+              <a:t>npu-exploration supplies source kernels for per-mode Spike checks; the RTL profile alone is structural, not a performance claim.</a:t>
             </a:r>
           </a:p>
         </p:txBody>
       </p:sp>
       <p:sp>
         <p:nvSpPr>
-          <p:cNvPr id="37" name="TextBox 36"/>
+          <p:cNvPr id="17" name="TextBox 16"/>
           <p:cNvSpPr txBox="1"/>
           <p:nvPr/>
         </p:nvSpPr>
@@ -17999,34 +17518,33 @@
                 </a:solidFill>
                 <a:latin typeface="Inter"/>
               </a:rPr>
-              <a:t>MX Gemmini dialect to executable</a:t>
+              <a:t>MX dialect: typed IR to RV64</a:t>
             </a:r>
           </a:p>
         </p:txBody>
       </p:sp>
       <p:sp>
         <p:nvSpPr>
-          <p:cNvPr id="12" name="Shape"/>
+          <p:cNvPr id="6" name="Rounded Rectangle 5"/>
           <p:cNvSpPr/>
           <p:nvPr/>
         </p:nvSpPr>
         <p:spPr>
           <a:xfrm>
-            <a:off x="859536" y="1572768"/>
-            <a:ext cx="10488168" cy="4096512"/>
+            <a:off x="859536" y="1499616"/>
+            <a:ext cx="5166360" cy="2724912"/>
           </a:xfrm>
           <a:prstGeom prst="roundRect">
-            <a:avLst>
-              <a:gd name="adj" fmla="val 2500"/>
-            </a:avLst>
-          </a:prstGeom>
-          <a:noFill/>
-          <a:ln w="13970">
+            <a:avLst/>
+          </a:prstGeom>
+          <a:solidFill>
+            <a:srgbClr val="EDE5DC"/>
+          </a:solidFill>
+          <a:ln>
             <a:solidFill>
-              <a:srgbClr val="C0B1A2"/>
+              <a:srgbClr val="B0A597"/>
             </a:solidFill>
           </a:ln>
-          <a:effectLst/>
         </p:spPr>
         <p:style>
           <a:lnRef idx="1">
@@ -18035,7 +17553,7 @@
           <a:fillRef idx="3">
             <a:schemeClr val="accent1"/>
           </a:fillRef>
-          <a:effectRef idx="0">
+          <a:effectRef idx="2">
             <a:schemeClr val="accent1"/>
           </a:effectRef>
           <a:fontRef idx="minor">
@@ -18052,73 +17570,26 @@
       </p:sp>
       <p:sp>
         <p:nvSpPr>
-          <p:cNvPr id="13" name="Text | SYSTEM / MODULE NAME"/>
-          <p:cNvSpPr txBox="1"/>
-          <p:nvPr/>
-        </p:nvSpPr>
-        <p:spPr>
-          <a:xfrm>
-            <a:off x="1069848" y="1801368"/>
-            <a:ext cx="9985248" cy="292608"/>
-          </a:xfrm>
-          <a:prstGeom prst="rect">
-            <a:avLst/>
-          </a:prstGeom>
-          <a:noFill/>
-          <a:effectLst/>
-        </p:spPr>
-        <p:txBody>
-          <a:bodyPr wrap="square" lIns="0" rIns="0" tIns="0" bIns="0" anchor="ctr">
-            <a:spAutoFit/>
-          </a:bodyPr>
-          <a:lstStyle/>
-          <a:p>
-            <a:pPr algn="l">
-              <a:lnSpc>
-                <a:spcPct val="112000"/>
-              </a:lnSpc>
-              <a:spcBef>
-                <a:spcPts val="0"/>
-              </a:spcBef>
-              <a:spcAft>
-                <a:spcPts val="0"/>
-              </a:spcAft>
-            </a:pPr>
-            <a:r>
-              <a:rPr sz="1200" b="1">
-                <a:solidFill>
-                  <a:srgbClr val="5B5957"/>
-                </a:solidFill>
-                <a:latin typeface="Inter"/>
-              </a:rPr>
-              <a:t>TYPED TARGET IR  →  PROFILED SCHEDULE  →  RISC-V COMMAND PROGRAM</a:t>
-            </a:r>
-          </a:p>
-        </p:txBody>
-      </p:sp>
-      <p:sp>
-        <p:nvSpPr>
-          <p:cNvPr id="14" name="Shape"/>
+          <p:cNvPr id="7" name="Rounded Rectangle 6"/>
           <p:cNvSpPr/>
           <p:nvPr/>
         </p:nvSpPr>
         <p:spPr>
           <a:xfrm>
-            <a:off x="1143000" y="2459736"/>
-            <a:ext cx="2916936" cy="2514600"/>
+            <a:off x="6181344" y="1499616"/>
+            <a:ext cx="5166360" cy="2724912"/>
           </a:xfrm>
           <a:prstGeom prst="roundRect">
-            <a:avLst>
-              <a:gd name="adj" fmla="val 2500"/>
-            </a:avLst>
+            <a:avLst/>
           </a:prstGeom>
           <a:solidFill>
-            <a:srgbClr val="ECE3DA"/>
+            <a:srgbClr val="E1E8EC"/>
           </a:solidFill>
           <a:ln>
-            <a:noFill/>
+            <a:solidFill>
+              <a:srgbClr val="B0A597"/>
+            </a:solidFill>
           </a:ln>
-          <a:effectLst/>
         </p:spPr>
         <p:style>
           <a:lnRef idx="1">
@@ -18127,7 +17598,7 @@
           <a:fillRef idx="3">
             <a:schemeClr val="accent1"/>
           </a:fillRef>
-          <a:effectRef idx="0">
+          <a:effectRef idx="2">
             <a:schemeClr val="accent1"/>
           </a:effectRef>
           <a:fontRef idx="minor">
@@ -18144,31 +17615,27 @@
       </p:sp>
       <p:sp>
         <p:nvSpPr>
-          <p:cNvPr id="15" name="Text | Control"/>
+          <p:cNvPr id="8" name="TextBox 7"/>
           <p:cNvSpPr txBox="1"/>
           <p:nvPr/>
         </p:nvSpPr>
         <p:spPr>
           <a:xfrm>
-            <a:off x="1307592" y="2688336"/>
-            <a:ext cx="2587752" cy="411480"/>
+            <a:off x="1051560" y="1664208"/>
+            <a:ext cx="4754880" cy="310896"/>
           </a:xfrm>
           <a:prstGeom prst="rect">
             <a:avLst/>
           </a:prstGeom>
           <a:noFill/>
-          <a:effectLst/>
         </p:spPr>
         <p:txBody>
-          <a:bodyPr wrap="square" lIns="0" rIns="0" tIns="0" bIns="0" anchor="ctr">
+          <a:bodyPr wrap="square" lIns="18288" rIns="18288" tIns="9144" bIns="9144" anchor="ctr">
             <a:spAutoFit/>
           </a:bodyPr>
           <a:lstStyle/>
           <a:p>
-            <a:pPr algn="ctr">
-              <a:lnSpc>
-                <a:spcPct val="112000"/>
-              </a:lnSpc>
+            <a:pPr algn="l">
               <a:spcBef>
                 <a:spcPts val="0"/>
               </a:spcBef>
@@ -18177,42 +17644,39 @@
               </a:spcAft>
             </a:pPr>
             <a:r>
-              <a:rPr sz="1800" b="1">
-                <a:solidFill>
-                  <a:srgbClr val="5B5957"/>
+              <a:rPr sz="1750" b="1">
+                <a:solidFill>
+                  <a:srgbClr val="103552"/>
                 </a:solidFill>
                 <a:latin typeface="Inter"/>
               </a:rPr>
-              <a:t>Typed MX IR</a:t>
+              <a:t>Radiance FP4 GEMM → typed MX</a:t>
             </a:r>
           </a:p>
         </p:txBody>
       </p:sp>
       <p:sp>
         <p:nvSpPr>
-          <p:cNvPr id="16" name="Component | Component A"/>
+          <p:cNvPr id="9" name="Rounded Rectangle 8"/>
           <p:cNvSpPr/>
           <p:nvPr/>
         </p:nvSpPr>
         <p:spPr>
           <a:xfrm>
-            <a:off x="1399032" y="3401568"/>
-            <a:ext cx="2404872" cy="475488"/>
+            <a:off x="1051560" y="2048256"/>
+            <a:ext cx="4754880" cy="1298448"/>
           </a:xfrm>
           <a:prstGeom prst="roundRect">
-            <a:avLst>
-              <a:gd name="adj" fmla="val 8000"/>
-            </a:avLst>
+            <a:avLst/>
           </a:prstGeom>
           <a:solidFill>
-            <a:srgbClr val="ECE3DA"/>
+            <a:srgbClr val="FDF8F1"/>
           </a:solidFill>
-          <a:ln w="14604">
+          <a:ln>
             <a:solidFill>
-              <a:srgbClr val="AB9A89"/>
+              <a:srgbClr val="D3CABF"/>
             </a:solidFill>
           </a:ln>
-          <a:effectLst/>
         </p:spPr>
         <p:style>
           <a:lnRef idx="1">
@@ -18221,7 +17685,430 @@
           <a:fillRef idx="3">
             <a:schemeClr val="accent1"/>
           </a:fillRef>
-          <a:effectRef idx="0">
+          <a:effectRef idx="2">
+            <a:schemeClr val="accent1"/>
+          </a:effectRef>
+          <a:fontRef idx="minor">
+            <a:schemeClr val="lt1"/>
+          </a:fontRef>
+        </p:style>
+        <p:txBody>
+          <a:bodyPr rtlCol="0" anchor="t" wrap="none" lIns="109728" tIns="91440" rIns="73152" bIns="36576"/>
+          <a:lstStyle/>
+          <a:p>
+            <a:pPr algn="ctr">
+              <a:spcBef>
+                <a:spcPts val="0"/>
+              </a:spcBef>
+              <a:spcAft>
+                <a:spcPts val="0"/>
+              </a:spcAft>
+            </a:pPr>
+            <a:r>
+              <a:rPr sz="1110">
+                <a:solidFill>
+                  <a:srgbClr val="103552"/>
+                </a:solidFill>
+                <a:latin typeface="Liberation Mono"/>
+              </a:rPr>
+              <a:t>%acc = "mx_gemmini.contract"(%A,%As,%B,%Bs) {</a:t>
+            </a:r>
+          </a:p>
+          <a:p>
+            <a:pPr>
+              <a:spcBef>
+                <a:spcPts val="0"/>
+              </a:spcBef>
+              <a:spcAft>
+                <a:spcPts val="0"/>
+              </a:spcAft>
+            </a:pPr>
+            <a:r>
+              <a:rPr sz="1110">
+                <a:solidFill>
+                  <a:srgbClr val="103552"/>
+                </a:solidFill>
+                <a:latin typeface="Liberation Mono"/>
+              </a:rPr>
+              <a:t>  activation_format = "fp4_e2m1",</a:t>
+            </a:r>
+          </a:p>
+          <a:p>
+            <a:pPr>
+              <a:spcBef>
+                <a:spcPts val="0"/>
+              </a:spcBef>
+              <a:spcAft>
+                <a:spcPts val="0"/>
+              </a:spcAft>
+            </a:pPr>
+            <a:r>
+              <a:rPr sz="1110">
+                <a:solidFill>
+                  <a:srgbClr val="103552"/>
+                </a:solidFill>
+                <a:latin typeface="Liberation Mono"/>
+              </a:rPr>
+              <a:t>  weight_format = "fp4_e2m1", pe_mode = 0 : i32 }</a:t>
+            </a:r>
+          </a:p>
+          <a:p>
+            <a:pPr>
+              <a:spcBef>
+                <a:spcPts val="0"/>
+              </a:spcBef>
+              <a:spcAft>
+                <a:spcPts val="0"/>
+              </a:spcAft>
+            </a:pPr>
+            <a:r>
+              <a:rPr sz="1110">
+                <a:solidFill>
+                  <a:srgbClr val="103552"/>
+                </a:solidFill>
+                <a:latin typeface="Liberation Mono"/>
+              </a:rPr>
+              <a:t>%out = "mx_gemmini.readout_bf16"(%acc)</a:t>
+            </a:r>
+          </a:p>
+        </p:txBody>
+      </p:sp>
+      <p:sp>
+        <p:nvSpPr>
+          <p:cNvPr id="10" name="TextBox 9"/>
+          <p:cNvSpPr txBox="1"/>
+          <p:nvPr/>
+        </p:nvSpPr>
+        <p:spPr>
+          <a:xfrm>
+            <a:off x="1051560" y="3438144"/>
+            <a:ext cx="4727448" cy="685800"/>
+          </a:xfrm>
+          <a:prstGeom prst="rect">
+            <a:avLst/>
+          </a:prstGeom>
+          <a:noFill/>
+        </p:spPr>
+        <p:txBody>
+          <a:bodyPr wrap="square" lIns="18288" rIns="18288" tIns="9144" bIns="9144" anchor="ctr">
+            <a:spAutoFit/>
+          </a:bodyPr>
+          <a:lstStyle/>
+          <a:p>
+            <a:pPr algn="l">
+              <a:spcBef>
+                <a:spcPts val="0"/>
+              </a:spcBef>
+              <a:spcAft>
+                <a:spcPts val="0"/>
+              </a:spcAft>
+            </a:pPr>
+            <a:r>
+              <a:rPr sz="1060" b="0">
+                <a:solidFill>
+                  <a:srgbClr val="313455"/>
+                </a:solidFill>
+                <a:latin typeface="Inter"/>
+              </a:rPr>
+              <a:t>resource → packed codes + E8M0 scales → mvin; contract → MX compute. Radiance softmax uses vpu_execute; readout_bf16 / spad_requant / wait finish the tile.</a:t>
+            </a:r>
+          </a:p>
+        </p:txBody>
+      </p:sp>
+      <p:sp>
+        <p:nvSpPr>
+          <p:cNvPr id="11" name="TextBox 10"/>
+          <p:cNvSpPr txBox="1"/>
+          <p:nvPr/>
+        </p:nvSpPr>
+        <p:spPr>
+          <a:xfrm>
+            <a:off x="6382512" y="1664208"/>
+            <a:ext cx="4754880" cy="310896"/>
+          </a:xfrm>
+          <a:prstGeom prst="rect">
+            <a:avLst/>
+          </a:prstGeom>
+          <a:noFill/>
+        </p:spPr>
+        <p:txBody>
+          <a:bodyPr wrap="square" lIns="18288" rIns="18288" tIns="9144" bIns="9144" anchor="ctr">
+            <a:spAutoFit/>
+          </a:bodyPr>
+          <a:lstStyle/>
+          <a:p>
+            <a:pPr algn="l">
+              <a:spcBef>
+                <a:spcPts val="0"/>
+              </a:spcBef>
+              <a:spcAft>
+                <a:spcPts val="0"/>
+              </a:spcAft>
+            </a:pPr>
+            <a:r>
+              <a:rPr sz="1750" b="1">
+                <a:solidFill>
+                  <a:srgbClr val="103552"/>
+                </a:solidFill>
+                <a:latin typeface="Inter"/>
+              </a:rPr>
+              <a:t>Compiled attention object → binary</a:t>
+            </a:r>
+          </a:p>
+        </p:txBody>
+      </p:sp>
+      <p:sp>
+        <p:nvSpPr>
+          <p:cNvPr id="12" name="Rounded Rectangle 11"/>
+          <p:cNvSpPr/>
+          <p:nvPr/>
+        </p:nvSpPr>
+        <p:spPr>
+          <a:xfrm>
+            <a:off x="6382512" y="2048256"/>
+            <a:ext cx="4754880" cy="1298448"/>
+          </a:xfrm>
+          <a:prstGeom prst="roundRect">
+            <a:avLst/>
+          </a:prstGeom>
+          <a:solidFill>
+            <a:srgbClr val="FDF8F1"/>
+          </a:solidFill>
+          <a:ln>
+            <a:solidFill>
+              <a:srgbClr val="D3CABF"/>
+            </a:solidFill>
+          </a:ln>
+        </p:spPr>
+        <p:style>
+          <a:lnRef idx="1">
+            <a:schemeClr val="accent1"/>
+          </a:lnRef>
+          <a:fillRef idx="3">
+            <a:schemeClr val="accent1"/>
+          </a:fillRef>
+          <a:effectRef idx="2">
+            <a:schemeClr val="accent1"/>
+          </a:effectRef>
+          <a:fontRef idx="minor">
+            <a:schemeClr val="lt1"/>
+          </a:fontRef>
+        </p:style>
+        <p:txBody>
+          <a:bodyPr rtlCol="0" anchor="t" wrap="none" lIns="109728" tIns="91440" rIns="73152" bIns="36576"/>
+          <a:lstStyle/>
+          <a:p>
+            <a:pPr algn="ctr">
+              <a:spcBef>
+                <a:spcPts val="0"/>
+              </a:spcBef>
+              <a:spcAft>
+                <a:spcPts val="0"/>
+              </a:spcAft>
+            </a:pPr>
+            <a:r>
+              <a:rPr sz="1030">
+                <a:solidFill>
+                  <a:srgbClr val="103552"/>
+                </a:solidFill>
+                <a:latin typeface="Liberation Mono"/>
+              </a:rPr>
+              <a:t>__asm__ volatile(</a:t>
+            </a:r>
+          </a:p>
+          <a:p>
+            <a:pPr>
+              <a:spcBef>
+                <a:spcPts val="0"/>
+              </a:spcBef>
+              <a:spcAft>
+                <a:spcPts val="0"/>
+              </a:spcAft>
+            </a:pPr>
+            <a:r>
+              <a:rPr sz="1030">
+                <a:solidFill>
+                  <a:srgbClr val="103552"/>
+                </a:solidFill>
+                <a:latin typeface="Liberation Mono"/>
+              </a:rPr>
+              <a:t>  ".insn r 0x7b, 3, 2, x0, %0, %1"</a:t>
+            </a:r>
+          </a:p>
+          <a:p>
+            <a:pPr>
+              <a:spcBef>
+                <a:spcPts val="0"/>
+              </a:spcBef>
+              <a:spcAft>
+                <a:spcPts val="0"/>
+              </a:spcAft>
+            </a:pPr>
+            <a:r>
+              <a:rPr sz="1030">
+                <a:solidFill>
+                  <a:srgbClr val="103552"/>
+                </a:solidFill>
+                <a:latin typeface="Liberation Mono"/>
+              </a:rPr>
+              <a:t>  : : "r"(Q_IN),</a:t>
+            </a:r>
+          </a:p>
+          <a:p>
+            <a:pPr>
+              <a:spcBef>
+                <a:spcPts val="0"/>
+              </a:spcBef>
+              <a:spcAft>
+                <a:spcPts val="0"/>
+              </a:spcAft>
+            </a:pPr>
+            <a:r>
+              <a:rPr sz="1030">
+                <a:solidFill>
+                  <a:srgbClr val="103552"/>
+                </a:solidFill>
+                <a:latin typeface="Liberation Mono"/>
+              </a:rPr>
+              <a:t>      "r"(0x0010001000000000));</a:t>
+            </a:r>
+          </a:p>
+          <a:p>
+            <a:pPr>
+              <a:spcBef>
+                <a:spcPts val="0"/>
+              </a:spcBef>
+              <a:spcAft>
+                <a:spcPts val="0"/>
+              </a:spcAft>
+            </a:pPr>
+            <a:r>
+              <a:rPr sz="1030">
+                <a:solidFill>
+                  <a:srgbClr val="103552"/>
+                </a:solidFill>
+                <a:latin typeface="Liberation Mono"/>
+              </a:rPr>
+              <a:t>objdump: 4a: 04b6b07b  .insn 4, 0x04b6b07b</a:t>
+            </a:r>
+          </a:p>
+        </p:txBody>
+      </p:sp>
+      <p:sp>
+        <p:nvSpPr>
+          <p:cNvPr id="13" name="TextBox 12"/>
+          <p:cNvSpPr txBox="1"/>
+          <p:nvPr/>
+        </p:nvSpPr>
+        <p:spPr>
+          <a:xfrm>
+            <a:off x="6382512" y="3493008"/>
+            <a:ext cx="4727448" cy="548640"/>
+          </a:xfrm>
+          <a:prstGeom prst="rect">
+            <a:avLst/>
+          </a:prstGeom>
+          <a:noFill/>
+        </p:spPr>
+        <p:txBody>
+          <a:bodyPr wrap="square" lIns="18288" rIns="18288" tIns="9144" bIns="9144" anchor="ctr">
+            <a:spAutoFit/>
+          </a:bodyPr>
+          <a:lstStyle/>
+          <a:p>
+            <a:pPr algn="l">
+              <a:spcBef>
+                <a:spcPts val="0"/>
+              </a:spcBef>
+              <a:spcAft>
+                <a:spcPts val="0"/>
+              </a:spcAft>
+            </a:pPr>
+            <a:r>
+              <a:rPr sz="1100" b="0">
+                <a:solidFill>
+                  <a:srgbClr val="313455"/>
+                </a:solidFill>
+                <a:latin typeface="Inter"/>
+              </a:rPr>
+              <a:t>physical_program orders mvin → compute → VPU → mvout. RoCC C + data asm → RV64 GCC → ELF → Nicolas Spike.</a:t>
+            </a:r>
+          </a:p>
+        </p:txBody>
+      </p:sp>
+      <p:sp>
+        <p:nvSpPr>
+          <p:cNvPr id="14" name="TextBox 13"/>
+          <p:cNvSpPr txBox="1"/>
+          <p:nvPr/>
+        </p:nvSpPr>
+        <p:spPr>
+          <a:xfrm>
+            <a:off x="877824" y="4352544"/>
+            <a:ext cx="10424160" cy="274320"/>
+          </a:xfrm>
+          <a:prstGeom prst="rect">
+            <a:avLst/>
+          </a:prstGeom>
+          <a:noFill/>
+        </p:spPr>
+        <p:txBody>
+          <a:bodyPr wrap="square" lIns="18288" rIns="18288" tIns="9144" bIns="9144" anchor="ctr">
+            <a:spAutoFit/>
+          </a:bodyPr>
+          <a:lstStyle/>
+          <a:p>
+            <a:pPr algn="l">
+              <a:spcBef>
+                <a:spcPts val="0"/>
+              </a:spcBef>
+              <a:spcAft>
+                <a:spcPts val="0"/>
+              </a:spcAft>
+            </a:pPr>
+            <a:r>
+              <a:rPr sz="1600" b="1">
+                <a:solidFill>
+                  <a:srgbClr val="103552"/>
+                </a:solidFill>
+                <a:latin typeface="Inter"/>
+              </a:rPr>
+              <a:t>Implemented transforms and checks</a:t>
+            </a:r>
+          </a:p>
+        </p:txBody>
+      </p:sp>
+      <p:sp>
+        <p:nvSpPr>
+          <p:cNvPr id="15" name="Rounded Rectangle 14"/>
+          <p:cNvSpPr/>
+          <p:nvPr/>
+        </p:nvSpPr>
+        <p:spPr>
+          <a:xfrm>
+            <a:off x="859536" y="4709160"/>
+            <a:ext cx="1965960" cy="987552"/>
+          </a:xfrm>
+          <a:prstGeom prst="roundRect">
+            <a:avLst/>
+          </a:prstGeom>
+          <a:solidFill>
+            <a:srgbClr val="FDF8F1"/>
+          </a:solidFill>
+          <a:ln>
+            <a:solidFill>
+              <a:srgbClr val="B0A597"/>
+            </a:solidFill>
+          </a:ln>
+        </p:spPr>
+        <p:style>
+          <a:lnRef idx="1">
+            <a:schemeClr val="accent1"/>
+          </a:lnRef>
+          <a:fillRef idx="3">
+            <a:schemeClr val="accent1"/>
+          </a:fillRef>
+          <a:effectRef idx="2">
             <a:schemeClr val="accent1"/>
           </a:effectRef>
           <a:fontRef idx="minor">
@@ -18238,31 +18125,27 @@
       </p:sp>
       <p:sp>
         <p:nvSpPr>
-          <p:cNvPr id="17" name="Text | Component A"/>
+          <p:cNvPr id="16" name="TextBox 15"/>
           <p:cNvSpPr txBox="1"/>
           <p:nvPr/>
         </p:nvSpPr>
         <p:spPr>
           <a:xfrm>
-            <a:off x="1508760" y="3392424"/>
-            <a:ext cx="2185415" cy="621792"/>
+            <a:off x="950976" y="4800600"/>
+            <a:ext cx="1783080" cy="338328"/>
           </a:xfrm>
           <a:prstGeom prst="rect">
             <a:avLst/>
           </a:prstGeom>
           <a:noFill/>
-          <a:effectLst/>
         </p:spPr>
         <p:txBody>
-          <a:bodyPr wrap="square" lIns="0" rIns="0" tIns="0" bIns="0" anchor="ctr">
+          <a:bodyPr wrap="square" lIns="18288" rIns="18288" tIns="9144" bIns="9144" anchor="ctr">
             <a:spAutoFit/>
           </a:bodyPr>
           <a:lstStyle/>
           <a:p>
             <a:pPr algn="ctr">
-              <a:lnSpc>
-                <a:spcPct val="112000"/>
-              </a:lnSpc>
               <a:spcBef>
                 <a:spcPts val="0"/>
               </a:spcBef>
@@ -18271,61 +18154,100 @@
               </a:spcAft>
             </a:pPr>
             <a:r>
-              <a:rPr sz="1110" b="1">
-                <a:solidFill>
-                  <a:srgbClr val="313455"/>
+              <a:rPr sz="1170" b="1">
+                <a:solidFill>
+                  <a:srgbClr val="103552"/>
                 </a:solidFill>
                 <a:latin typeface="Inter"/>
               </a:rPr>
-              <a:t>resource · contract</a:t>
-            </a:r>
-          </a:p>
-          <a:p>
-            <a:pPr algn="ctr">
-              <a:spcBef>
-                <a:spcPts val="0"/>
-              </a:spcBef>
-              <a:spcAft>
-                <a:spcPts val="0"/>
-              </a:spcAft>
-            </a:pPr>
-            <a:r>
-              <a:rPr sz="1110" b="1">
-                <a:solidFill>
-                  <a:srgbClr val="313455"/>
-                </a:solidFill>
-                <a:latin typeface="Inter"/>
-              </a:rPr>
-              <a:t>upload_lut · encode</a:t>
+              <a:t>bind_profile</a:t>
             </a:r>
           </a:p>
         </p:txBody>
       </p:sp>
       <p:sp>
         <p:nvSpPr>
-          <p:cNvPr id="18" name="Component | Component B"/>
+          <p:cNvPr id="17" name="TextBox 16"/>
+          <p:cNvSpPr txBox="1"/>
+          <p:nvPr/>
+        </p:nvSpPr>
+        <p:spPr>
+          <a:xfrm>
+            <a:off x="950976" y="5230368"/>
+            <a:ext cx="1783080" cy="365760"/>
+          </a:xfrm>
+          <a:prstGeom prst="rect">
+            <a:avLst/>
+          </a:prstGeom>
+          <a:noFill/>
+        </p:spPr>
+        <p:txBody>
+          <a:bodyPr wrap="square" lIns="18288" rIns="18288" tIns="9144" bIns="9144" anchor="ctr">
+            <a:spAutoFit/>
+          </a:bodyPr>
+          <a:lstStyle/>
+          <a:p>
+            <a:pPr algn="ctr">
+              <a:spcBef>
+                <a:spcPts val="0"/>
+              </a:spcBef>
+              <a:spcAft>
+                <a:spcPts val="0"/>
+              </a:spcAft>
+            </a:pPr>
+            <a:r>
+              <a:rPr sz="1080" b="0">
+                <a:solidFill>
+                  <a:srgbClr val="313455"/>
+                </a:solidFill>
+                <a:latin typeface="Inter"/>
+              </a:rPr>
+              <a:t>Legal PE tuple +</a:t>
+            </a:r>
+          </a:p>
+          <a:p>
+            <a:pPr algn="ctr">
+              <a:spcBef>
+                <a:spcPts val="0"/>
+              </a:spcBef>
+              <a:spcAft>
+                <a:spcPts val="0"/>
+              </a:spcAft>
+            </a:pPr>
+            <a:r>
+              <a:rPr sz="1080" b="0">
+                <a:solidFill>
+                  <a:srgbClr val="313455"/>
+                </a:solidFill>
+                <a:latin typeface="Inter"/>
+              </a:rPr>
+              <a:t>profile digest</a:t>
+            </a:r>
+          </a:p>
+        </p:txBody>
+      </p:sp>
+      <p:sp>
+        <p:nvSpPr>
+          <p:cNvPr id="18" name="Rounded Rectangle 17"/>
           <p:cNvSpPr/>
           <p:nvPr/>
         </p:nvSpPr>
         <p:spPr>
           <a:xfrm>
-            <a:off x="1399032" y="4142232"/>
-            <a:ext cx="2404872" cy="475488"/>
+            <a:off x="2999232" y="4709160"/>
+            <a:ext cx="1965960" cy="987552"/>
           </a:xfrm>
           <a:prstGeom prst="roundRect">
-            <a:avLst>
-              <a:gd name="adj" fmla="val 8000"/>
-            </a:avLst>
+            <a:avLst/>
           </a:prstGeom>
           <a:solidFill>
-            <a:srgbClr val="ECE3DA"/>
+            <a:srgbClr val="E1E8EC"/>
           </a:solidFill>
-          <a:ln w="14604">
+          <a:ln>
             <a:solidFill>
-              <a:srgbClr val="AB9A89"/>
+              <a:srgbClr val="B0A597"/>
             </a:solidFill>
           </a:ln>
-          <a:effectLst/>
         </p:spPr>
         <p:style>
           <a:lnRef idx="1">
@@ -18334,7 +18256,7 @@
           <a:fillRef idx="3">
             <a:schemeClr val="accent1"/>
           </a:fillRef>
-          <a:effectRef idx="0">
+          <a:effectRef idx="2">
             <a:schemeClr val="accent1"/>
           </a:effectRef>
           <a:fontRef idx="minor">
@@ -18351,31 +18273,27 @@
       </p:sp>
       <p:sp>
         <p:nvSpPr>
-          <p:cNvPr id="19" name="Text | Component B"/>
+          <p:cNvPr id="19" name="TextBox 18"/>
           <p:cNvSpPr txBox="1"/>
           <p:nvPr/>
         </p:nvSpPr>
         <p:spPr>
           <a:xfrm>
-            <a:off x="1508760" y="4123944"/>
-            <a:ext cx="2185415" cy="621792"/>
+            <a:off x="3090672" y="4800600"/>
+            <a:ext cx="1783080" cy="338328"/>
           </a:xfrm>
           <a:prstGeom prst="rect">
             <a:avLst/>
           </a:prstGeom>
           <a:noFill/>
-          <a:effectLst/>
         </p:spPr>
         <p:txBody>
-          <a:bodyPr wrap="square" lIns="0" rIns="0" tIns="0" bIns="0" anchor="ctr">
+          <a:bodyPr wrap="square" lIns="18288" rIns="18288" tIns="9144" bIns="9144" anchor="ctr">
             <a:spAutoFit/>
           </a:bodyPr>
           <a:lstStyle/>
           <a:p>
             <a:pPr algn="ctr">
-              <a:lnSpc>
-                <a:spcPct val="112000"/>
-              </a:lnSpc>
               <a:spcBef>
                 <a:spcPts val="0"/>
               </a:spcBef>
@@ -18384,13 +18302,13 @@
               </a:spcAft>
             </a:pPr>
             <a:r>
-              <a:rPr sz="1110" b="1">
-                <a:solidFill>
-                  <a:srgbClr val="313455"/>
+              <a:rPr sz="1170" b="1">
+                <a:solidFill>
+                  <a:srgbClr val="103552"/>
                 </a:solidFill>
                 <a:latin typeface="Inter"/>
               </a:rPr>
-              <a:t>vpu_execute · spad_requant</a:t>
+              <a:t>MXBF16Catalog</a:t>
             </a:r>
           </a:p>
           <a:p>
@@ -18403,77 +18321,100 @@
               </a:spcAft>
             </a:pPr>
             <a:r>
-              <a:rPr sz="1110" b="1">
-                <a:solidFill>
-                  <a:srgbClr val="313455"/>
+              <a:rPr sz="1170" b="1">
+                <a:solidFill>
+                  <a:srgbClr val="103552"/>
                 </a:solidFill>
                 <a:latin typeface="Inter"/>
               </a:rPr>
-              <a:t>readout · wait</a:t>
+              <a:t>Preparation</a:t>
             </a:r>
           </a:p>
         </p:txBody>
       </p:sp>
-      <p:cxnSp>
-        <p:nvCxnSpPr>
-          <p:cNvPr id="20" name="Connector"/>
-          <p:cNvCxnSpPr/>
-          <p:nvPr/>
-        </p:nvCxnSpPr>
-        <p:spPr>
-          <a:xfrm>
-            <a:off x="4123944" y="3703320"/>
-            <a:ext cx="438912" cy="0"/>
-          </a:xfrm>
-          <a:prstGeom prst="line">
-            <a:avLst/>
-          </a:prstGeom>
-          <a:ln w="17780">
-            <a:solidFill>
-              <a:srgbClr val="2E2D2C"/>
-            </a:solidFill>
-            <a:tailEnd type="triangle" w="sm" len="sm"/>
-          </a:ln>
-          <a:effectLst/>
-        </p:spPr>
-        <p:style>
-          <a:lnRef idx="2">
-            <a:schemeClr val="accent1"/>
-          </a:lnRef>
-          <a:fillRef idx="0">
-            <a:schemeClr val="accent1"/>
-          </a:fillRef>
-          <a:effectRef idx="0">
-            <a:schemeClr val="accent1"/>
-          </a:effectRef>
-          <a:fontRef idx="minor">
-            <a:schemeClr val="tx1"/>
-          </a:fontRef>
-        </p:style>
-      </p:cxnSp>
       <p:sp>
         <p:nvSpPr>
-          <p:cNvPr id="21" name="Shape"/>
+          <p:cNvPr id="20" name="TextBox 19"/>
+          <p:cNvSpPr txBox="1"/>
+          <p:nvPr/>
+        </p:nvSpPr>
+        <p:spPr>
+          <a:xfrm>
+            <a:off x="3090672" y="5230368"/>
+            <a:ext cx="1783080" cy="365760"/>
+          </a:xfrm>
+          <a:prstGeom prst="rect">
+            <a:avLst/>
+          </a:prstGeom>
+          <a:noFill/>
+        </p:spPr>
+        <p:txBody>
+          <a:bodyPr wrap="square" lIns="18288" rIns="18288" tIns="9144" bIns="9144" anchor="ctr">
+            <a:spAutoFit/>
+          </a:bodyPr>
+          <a:lstStyle/>
+          <a:p>
+            <a:pPr algn="ctr">
+              <a:spcBef>
+                <a:spcPts val="0"/>
+              </a:spcBef>
+              <a:spcAft>
+                <a:spcPts val="0"/>
+              </a:spcAft>
+            </a:pPr>
+            <a:r>
+              <a:rPr sz="1080" b="0">
+                <a:solidFill>
+                  <a:srgbClr val="313455"/>
+                </a:solidFill>
+                <a:latin typeface="Inter"/>
+              </a:rPr>
+              <a:t>Select BF16</a:t>
+            </a:r>
+          </a:p>
+          <a:p>
+            <a:pPr algn="ctr">
+              <a:spcBef>
+                <a:spcPts val="0"/>
+              </a:spcBef>
+              <a:spcAft>
+                <a:spcPts val="0"/>
+              </a:spcAft>
+            </a:pPr>
+            <a:r>
+              <a:rPr sz="1080" b="0">
+                <a:solidFill>
+                  <a:srgbClr val="313455"/>
+                </a:solidFill>
+                <a:latin typeface="Inter"/>
+              </a:rPr>
+              <a:t>MX sites</a:t>
+            </a:r>
+          </a:p>
+        </p:txBody>
+      </p:sp>
+      <p:sp>
+        <p:nvSpPr>
+          <p:cNvPr id="21" name="Rounded Rectangle 20"/>
           <p:cNvSpPr/>
           <p:nvPr/>
         </p:nvSpPr>
         <p:spPr>
           <a:xfrm>
-            <a:off x="4636008" y="2459736"/>
-            <a:ext cx="2916936" cy="2514600"/>
+            <a:off x="5138927" y="4709160"/>
+            <a:ext cx="1965960" cy="987552"/>
           </a:xfrm>
           <a:prstGeom prst="roundRect">
-            <a:avLst>
-              <a:gd name="adj" fmla="val 2500"/>
-            </a:avLst>
+            <a:avLst/>
           </a:prstGeom>
           <a:solidFill>
-            <a:srgbClr val="CBCFD0"/>
+            <a:srgbClr val="FDF8F1"/>
           </a:solidFill>
           <a:ln>
-            <a:noFill/>
+            <a:solidFill>
+              <a:srgbClr val="B0A597"/>
+            </a:solidFill>
           </a:ln>
-          <a:effectLst/>
         </p:spPr>
         <p:style>
           <a:lnRef idx="1">
@@ -18482,7 +18423,7 @@
           <a:fillRef idx="3">
             <a:schemeClr val="accent1"/>
           </a:fillRef>
-          <a:effectRef idx="0">
+          <a:effectRef idx="2">
             <a:schemeClr val="accent1"/>
           </a:effectRef>
           <a:fontRef idx="minor">
@@ -18499,31 +18440,27 @@
       </p:sp>
       <p:sp>
         <p:nvSpPr>
-          <p:cNvPr id="22" name="Text | State / storage"/>
+          <p:cNvPr id="22" name="TextBox 21"/>
           <p:cNvSpPr txBox="1"/>
           <p:nvPr/>
         </p:nvSpPr>
         <p:spPr>
           <a:xfrm>
-            <a:off x="4800600" y="2688336"/>
-            <a:ext cx="2587752" cy="411480"/>
+            <a:off x="5230367" y="4800600"/>
+            <a:ext cx="1783080" cy="338328"/>
           </a:xfrm>
           <a:prstGeom prst="rect">
             <a:avLst/>
           </a:prstGeom>
           <a:noFill/>
-          <a:effectLst/>
         </p:spPr>
         <p:txBody>
-          <a:bodyPr wrap="square" lIns="0" rIns="0" tIns="0" bIns="0" anchor="ctr">
+          <a:bodyPr wrap="square" lIns="18288" rIns="18288" tIns="9144" bIns="9144" anchor="ctr">
             <a:spAutoFit/>
           </a:bodyPr>
           <a:lstStyle/>
           <a:p>
             <a:pPr algn="ctr">
-              <a:lnSpc>
-                <a:spcPct val="112000"/>
-              </a:lnSpc>
               <a:spcBef>
                 <a:spcPts val="0"/>
               </a:spcBef>
@@ -18532,42 +18469,100 @@
               </a:spcAft>
             </a:pPr>
             <a:r>
-              <a:rPr sz="1800" b="1">
+              <a:rPr sz="1170" b="1">
                 <a:solidFill>
                   <a:srgbClr val="103552"/>
                 </a:solidFill>
                 <a:latin typeface="Inter"/>
               </a:rPr>
-              <a:t>Legality + schedule</a:t>
+              <a:t>schedule.plan</a:t>
             </a:r>
           </a:p>
         </p:txBody>
       </p:sp>
       <p:sp>
         <p:nvSpPr>
-          <p:cNvPr id="23" name="Component | Component A"/>
+          <p:cNvPr id="23" name="TextBox 22"/>
+          <p:cNvSpPr txBox="1"/>
+          <p:nvPr/>
+        </p:nvSpPr>
+        <p:spPr>
+          <a:xfrm>
+            <a:off x="5230367" y="5230368"/>
+            <a:ext cx="1783080" cy="365760"/>
+          </a:xfrm>
+          <a:prstGeom prst="rect">
+            <a:avLst/>
+          </a:prstGeom>
+          <a:noFill/>
+        </p:spPr>
+        <p:txBody>
+          <a:bodyPr wrap="square" lIns="18288" rIns="18288" tIns="9144" bIns="9144" anchor="ctr">
+            <a:spAutoFit/>
+          </a:bodyPr>
+          <a:lstStyle/>
+          <a:p>
+            <a:pPr algn="ctr">
+              <a:spcBef>
+                <a:spcPts val="0"/>
+              </a:spcBef>
+              <a:spcAft>
+                <a:spcPts val="0"/>
+              </a:spcAft>
+            </a:pPr>
+            <a:r>
+              <a:rPr sz="1080" b="0">
+                <a:solidFill>
+                  <a:srgbClr val="313455"/>
+                </a:solidFill>
+                <a:latin typeface="Inter"/>
+              </a:rPr>
+              <a:t>Choose native</a:t>
+            </a:r>
+          </a:p>
+          <a:p>
+            <a:pPr algn="ctr">
+              <a:spcBef>
+                <a:spcPts val="0"/>
+              </a:spcBef>
+              <a:spcAft>
+                <a:spcPts val="0"/>
+              </a:spcAft>
+            </a:pPr>
+            <a:r>
+              <a:rPr sz="1080" b="0">
+                <a:solidFill>
+                  <a:srgbClr val="313455"/>
+                </a:solidFill>
+                <a:latin typeface="Inter"/>
+              </a:rPr>
+              <a:t>loop and tiles</a:t>
+            </a:r>
+          </a:p>
+        </p:txBody>
+      </p:sp>
+      <p:sp>
+        <p:nvSpPr>
+          <p:cNvPr id="24" name="Rounded Rectangle 23"/>
           <p:cNvSpPr/>
           <p:nvPr/>
         </p:nvSpPr>
         <p:spPr>
           <a:xfrm>
-            <a:off x="4892040" y="3401568"/>
-            <a:ext cx="2404872" cy="475488"/>
+            <a:off x="7278623" y="4709160"/>
+            <a:ext cx="1965960" cy="987552"/>
           </a:xfrm>
           <a:prstGeom prst="roundRect">
-            <a:avLst>
-              <a:gd name="adj" fmla="val 8000"/>
-            </a:avLst>
+            <a:avLst/>
           </a:prstGeom>
           <a:solidFill>
-            <a:srgbClr val="CBCFD0"/>
+            <a:srgbClr val="E5E7DA"/>
           </a:solidFill>
-          <a:ln w="14604">
+          <a:ln>
             <a:solidFill>
-              <a:srgbClr val="0F3759"/>
+              <a:srgbClr val="B0A597"/>
             </a:solidFill>
           </a:ln>
-          <a:effectLst/>
         </p:spPr>
         <p:style>
           <a:lnRef idx="1">
@@ -18576,7 +18571,7 @@
           <a:fillRef idx="3">
             <a:schemeClr val="accent1"/>
           </a:fillRef>
-          <a:effectRef idx="0">
+          <a:effectRef idx="2">
             <a:schemeClr val="accent1"/>
           </a:effectRef>
           <a:fontRef idx="minor">
@@ -18593,31 +18588,27 @@
       </p:sp>
       <p:sp>
         <p:nvSpPr>
-          <p:cNvPr id="24" name="Text | Component A"/>
+          <p:cNvPr id="25" name="TextBox 24"/>
           <p:cNvSpPr txBox="1"/>
           <p:nvPr/>
         </p:nvSpPr>
         <p:spPr>
           <a:xfrm>
-            <a:off x="5001768" y="3392424"/>
-            <a:ext cx="2185415" cy="621792"/>
+            <a:off x="7370063" y="4800600"/>
+            <a:ext cx="1783080" cy="338328"/>
           </a:xfrm>
           <a:prstGeom prst="rect">
             <a:avLst/>
           </a:prstGeom>
           <a:noFill/>
-          <a:effectLst/>
         </p:spPr>
         <p:txBody>
-          <a:bodyPr wrap="square" lIns="0" rIns="0" tIns="0" bIns="0" anchor="ctr">
+          <a:bodyPr wrap="square" lIns="18288" rIns="18288" tIns="9144" bIns="9144" anchor="ctr">
             <a:spAutoFit/>
           </a:bodyPr>
           <a:lstStyle/>
           <a:p>
             <a:pPr algn="ctr">
-              <a:lnSpc>
-                <a:spcPct val="112000"/>
-              </a:lnSpc>
               <a:spcBef>
                 <a:spcPts val="0"/>
               </a:spcBef>
@@ -18626,61 +18617,100 @@
               </a:spcAft>
             </a:pPr>
             <a:r>
-              <a:rPr sz="1110" b="1">
-                <a:solidFill>
-                  <a:srgbClr val="313455"/>
+              <a:rPr sz="1170" b="1">
+                <a:solidFill>
+                  <a:srgbClr val="103552"/>
                 </a:solidFill>
                 <a:latin typeface="Inter"/>
               </a:rPr>
-              <a:t>RTL profile + payload</a:t>
-            </a:r>
-          </a:p>
-          <a:p>
-            <a:pPr algn="ctr">
-              <a:spcBef>
-                <a:spcPts val="0"/>
-              </a:spcBef>
-              <a:spcAft>
-                <a:spcPts val="0"/>
-              </a:spcAft>
-            </a:pPr>
-            <a:r>
-              <a:rPr sz="1110" b="1">
-                <a:solidFill>
-                  <a:srgbClr val="313455"/>
-                </a:solidFill>
-                <a:latin typeface="Inter"/>
-              </a:rPr>
-              <a:t>PE tuple · capacity checks</a:t>
+              <a:t>MXVPUPostOffload</a:t>
             </a:r>
           </a:p>
         </p:txBody>
       </p:sp>
       <p:sp>
         <p:nvSpPr>
-          <p:cNvPr id="25" name="Component | Component B"/>
+          <p:cNvPr id="26" name="TextBox 25"/>
+          <p:cNvSpPr txBox="1"/>
+          <p:nvPr/>
+        </p:nvSpPr>
+        <p:spPr>
+          <a:xfrm>
+            <a:off x="7370063" y="5230368"/>
+            <a:ext cx="1783080" cy="365760"/>
+          </a:xfrm>
+          <a:prstGeom prst="rect">
+            <a:avLst/>
+          </a:prstGeom>
+          <a:noFill/>
+        </p:spPr>
+        <p:txBody>
+          <a:bodyPr wrap="square" lIns="18288" rIns="18288" tIns="9144" bIns="9144" anchor="ctr">
+            <a:spAutoFit/>
+          </a:bodyPr>
+          <a:lstStyle/>
+          <a:p>
+            <a:pPr algn="ctr">
+              <a:spcBef>
+                <a:spcPts val="0"/>
+              </a:spcBef>
+              <a:spcAft>
+                <a:spcPts val="0"/>
+              </a:spcAft>
+            </a:pPr>
+            <a:r>
+              <a:rPr sz="1080" b="0">
+                <a:solidFill>
+                  <a:srgbClr val="313455"/>
+                </a:solidFill>
+                <a:latin typeface="Inter"/>
+              </a:rPr>
+              <a:t>Map softmax, add</a:t>
+            </a:r>
+          </a:p>
+          <a:p>
+            <a:pPr algn="ctr">
+              <a:spcBef>
+                <a:spcPts val="0"/>
+              </a:spcBef>
+              <a:spcAft>
+                <a:spcPts val="0"/>
+              </a:spcAft>
+            </a:pPr>
+            <a:r>
+              <a:rPr sz="1080" b="0">
+                <a:solidFill>
+                  <a:srgbClr val="313455"/>
+                </a:solidFill>
+                <a:latin typeface="Inter"/>
+              </a:rPr>
+              <a:t>and reductions</a:t>
+            </a:r>
+          </a:p>
+        </p:txBody>
+      </p:sp>
+      <p:sp>
+        <p:nvSpPr>
+          <p:cNvPr id="27" name="Rounded Rectangle 26"/>
           <p:cNvSpPr/>
           <p:nvPr/>
         </p:nvSpPr>
         <p:spPr>
           <a:xfrm>
-            <a:off x="4892040" y="4142232"/>
-            <a:ext cx="2404872" cy="475488"/>
+            <a:off x="9418319" y="4709160"/>
+            <a:ext cx="1965960" cy="987552"/>
           </a:xfrm>
           <a:prstGeom prst="roundRect">
-            <a:avLst>
-              <a:gd name="adj" fmla="val 8000"/>
-            </a:avLst>
+            <a:avLst/>
           </a:prstGeom>
           <a:solidFill>
-            <a:srgbClr val="CBCFD0"/>
+            <a:srgbClr val="FDF8F1"/>
           </a:solidFill>
-          <a:ln w="14604">
+          <a:ln>
             <a:solidFill>
-              <a:srgbClr val="0F3759"/>
+              <a:srgbClr val="B0A597"/>
             </a:solidFill>
           </a:ln>
-          <a:effectLst/>
         </p:spPr>
         <p:style>
           <a:lnRef idx="1">
@@ -18689,7 +18719,7 @@
           <a:fillRef idx="3">
             <a:schemeClr val="accent1"/>
           </a:fillRef>
-          <a:effectRef idx="0">
+          <a:effectRef idx="2">
             <a:schemeClr val="accent1"/>
           </a:effectRef>
           <a:fontRef idx="minor">
@@ -18706,31 +18736,27 @@
       </p:sp>
       <p:sp>
         <p:nvSpPr>
-          <p:cNvPr id="26" name="Text | Component B"/>
+          <p:cNvPr id="28" name="TextBox 27"/>
           <p:cNvSpPr txBox="1"/>
           <p:nvPr/>
         </p:nvSpPr>
         <p:spPr>
           <a:xfrm>
-            <a:off x="5001768" y="4123944"/>
-            <a:ext cx="2185415" cy="621792"/>
+            <a:off x="9509759" y="4800600"/>
+            <a:ext cx="1783080" cy="338328"/>
           </a:xfrm>
           <a:prstGeom prst="rect">
             <a:avLst/>
           </a:prstGeom>
           <a:noFill/>
-          <a:effectLst/>
         </p:spPr>
         <p:txBody>
-          <a:bodyPr wrap="square" lIns="0" rIns="0" tIns="0" bIns="0" anchor="ctr">
+          <a:bodyPr wrap="square" lIns="18288" rIns="18288" tIns="9144" bIns="9144" anchor="ctr">
             <a:spAutoFit/>
           </a:bodyPr>
           <a:lstStyle/>
           <a:p>
             <a:pPr algn="ctr">
-              <a:lnSpc>
-                <a:spcPct val="112000"/>
-              </a:lnSpc>
               <a:spcBef>
                 <a:spcPts val="0"/>
               </a:spcBef>
@@ -18739,146 +18765,40 @@
               </a:spcAft>
             </a:pPr>
             <a:r>
-              <a:rPr sz="1110" b="1">
-                <a:solidFill>
-                  <a:srgbClr val="313455"/>
+              <a:rPr sz="1170" b="1">
+                <a:solidFill>
+                  <a:srgbClr val="103552"/>
                 </a:solidFill>
                 <a:latin typeface="Inter"/>
               </a:rPr>
-              <a:t>precision + tiling policy</a:t>
+              <a:t>physical_program</a:t>
             </a:r>
-          </a:p>
-          <a:p>
-            <a:pPr algn="ctr">
-              <a:spcBef>
-                <a:spcPts val="0"/>
-              </a:spcBef>
-              <a:spcAft>
-                <a:spcPts val="0"/>
-              </a:spcAft>
-            </a:pPr>
-            <a:r>
-              <a:rPr sz="1110" b="1">
-                <a:solidFill>
-                  <a:srgbClr val="313455"/>
-                </a:solidFill>
-                <a:latin typeface="Inter"/>
-              </a:rPr>
-              <a:t>schedule.plan · native loops</a:t>
-            </a:r>
-          </a:p>
-        </p:txBody>
-      </p:sp>
-      <p:cxnSp>
-        <p:nvCxnSpPr>
-          <p:cNvPr id="27" name="Connector"/>
-          <p:cNvCxnSpPr/>
-          <p:nvPr/>
-        </p:nvCxnSpPr>
-        <p:spPr>
-          <a:xfrm>
-            <a:off x="7616952" y="3703320"/>
-            <a:ext cx="438912" cy="0"/>
-          </a:xfrm>
-          <a:prstGeom prst="line">
-            <a:avLst/>
-          </a:prstGeom>
-          <a:ln w="17780">
-            <a:solidFill>
-              <a:srgbClr val="2E2D2C"/>
-            </a:solidFill>
-            <a:tailEnd type="triangle" w="sm" len="sm"/>
-          </a:ln>
-          <a:effectLst/>
-        </p:spPr>
-        <p:style>
-          <a:lnRef idx="2">
-            <a:schemeClr val="accent1"/>
-          </a:lnRef>
-          <a:fillRef idx="0">
-            <a:schemeClr val="accent1"/>
-          </a:fillRef>
-          <a:effectRef idx="0">
-            <a:schemeClr val="accent1"/>
-          </a:effectRef>
-          <a:fontRef idx="minor">
-            <a:schemeClr val="tx1"/>
-          </a:fontRef>
-        </p:style>
-      </p:cxnSp>
-      <p:sp>
-        <p:nvSpPr>
-          <p:cNvPr id="28" name="Shape"/>
-          <p:cNvSpPr/>
-          <p:nvPr/>
-        </p:nvSpPr>
-        <p:spPr>
-          <a:xfrm>
-            <a:off x="8129016" y="2459736"/>
-            <a:ext cx="2916936" cy="2514600"/>
-          </a:xfrm>
-          <a:prstGeom prst="roundRect">
-            <a:avLst>
-              <a:gd name="adj" fmla="val 2500"/>
-            </a:avLst>
-          </a:prstGeom>
-          <a:solidFill>
-            <a:srgbClr val="E2E0D3"/>
-          </a:solidFill>
-          <a:ln>
-            <a:noFill/>
-          </a:ln>
-          <a:effectLst/>
-        </p:spPr>
-        <p:style>
-          <a:lnRef idx="1">
-            <a:schemeClr val="accent1"/>
-          </a:lnRef>
-          <a:fillRef idx="3">
-            <a:schemeClr val="accent1"/>
-          </a:fillRef>
-          <a:effectRef idx="0">
-            <a:schemeClr val="accent1"/>
-          </a:effectRef>
-          <a:fontRef idx="minor">
-            <a:schemeClr val="lt1"/>
-          </a:fontRef>
-        </p:style>
-        <p:txBody>
-          <a:bodyPr rtlCol="0" anchor="ctr"/>
-          <a:lstStyle/>
-          <a:p>
-            <a:pPr algn="ctr"/>
           </a:p>
         </p:txBody>
       </p:sp>
       <p:sp>
         <p:nvSpPr>
-          <p:cNvPr id="29" name="Text | Execution"/>
+          <p:cNvPr id="29" name="TextBox 28"/>
           <p:cNvSpPr txBox="1"/>
           <p:nvPr/>
         </p:nvSpPr>
         <p:spPr>
           <a:xfrm>
-            <a:off x="8293608" y="2688336"/>
-            <a:ext cx="2587752" cy="411480"/>
+            <a:off x="9509759" y="5230368"/>
+            <a:ext cx="1783080" cy="365760"/>
           </a:xfrm>
           <a:prstGeom prst="rect">
             <a:avLst/>
           </a:prstGeom>
           <a:noFill/>
-          <a:effectLst/>
         </p:spPr>
         <p:txBody>
-          <a:bodyPr wrap="square" lIns="0" rIns="0" tIns="0" bIns="0" anchor="ctr">
+          <a:bodyPr wrap="square" lIns="18288" rIns="18288" tIns="9144" bIns="9144" anchor="ctr">
             <a:spAutoFit/>
           </a:bodyPr>
           <a:lstStyle/>
           <a:p>
             <a:pPr algn="ctr">
-              <a:lnSpc>
-                <a:spcPct val="112000"/>
-              </a:lnSpc>
               <a:spcBef>
                 <a:spcPts val="0"/>
               </a:spcBef>
@@ -18887,311 +18807,81 @@
               </a:spcAft>
             </a:pPr>
             <a:r>
-              <a:rPr sz="1800" b="1">
-                <a:solidFill>
-                  <a:srgbClr val="75846A"/>
+              <a:rPr sz="1080" b="0">
+                <a:solidFill>
+                  <a:srgbClr val="313455"/>
                 </a:solidFill>
                 <a:latin typeface="Inter"/>
               </a:rPr>
-              <a:t>Binary + Spike</a:t>
+              <a:t>Order DMA, compute</a:t>
+            </a:r>
+          </a:p>
+          <a:p>
+            <a:pPr algn="ctr">
+              <a:spcBef>
+                <a:spcPts val="0"/>
+              </a:spcBef>
+              <a:spcAft>
+                <a:spcPts val="0"/>
+              </a:spcAft>
+            </a:pPr>
+            <a:r>
+              <a:rPr sz="1080" b="0">
+                <a:solidFill>
+                  <a:srgbClr val="313455"/>
+                </a:solidFill>
+                <a:latin typeface="Inter"/>
+              </a:rPr>
+              <a:t>and VPU commands</a:t>
             </a:r>
           </a:p>
         </p:txBody>
       </p:sp>
       <p:sp>
         <p:nvSpPr>
-          <p:cNvPr id="30" name="Component | Component A"/>
-          <p:cNvSpPr/>
+          <p:cNvPr id="30" name="TextBox 29"/>
+          <p:cNvSpPr txBox="1"/>
           <p:nvPr/>
         </p:nvSpPr>
         <p:spPr>
           <a:xfrm>
-            <a:off x="8385048" y="3401568"/>
-            <a:ext cx="2404872" cy="475488"/>
-          </a:xfrm>
-          <a:prstGeom prst="roundRect">
-            <a:avLst>
-              <a:gd name="adj" fmla="val 8000"/>
-            </a:avLst>
-          </a:prstGeom>
-          <a:solidFill>
-            <a:srgbClr val="E2E0D3"/>
-          </a:solidFill>
-          <a:ln w="14604">
-            <a:solidFill>
-              <a:srgbClr val="7D886C"/>
-            </a:solidFill>
-          </a:ln>
-          <a:effectLst/>
-        </p:spPr>
-        <p:style>
-          <a:lnRef idx="1">
-            <a:schemeClr val="accent1"/>
-          </a:lnRef>
-          <a:fillRef idx="3">
-            <a:schemeClr val="accent1"/>
-          </a:fillRef>
-          <a:effectRef idx="0">
-            <a:schemeClr val="accent1"/>
-          </a:effectRef>
-          <a:fontRef idx="minor">
-            <a:schemeClr val="lt1"/>
-          </a:fontRef>
-        </p:style>
+            <a:off x="877824" y="5833872"/>
+            <a:ext cx="10469880" cy="329184"/>
+          </a:xfrm>
+          <a:prstGeom prst="rect">
+            <a:avLst/>
+          </a:prstGeom>
+          <a:noFill/>
+        </p:spPr>
         <p:txBody>
-          <a:bodyPr rtlCol="0" anchor="ctr"/>
+          <a:bodyPr wrap="square" lIns="18288" rIns="18288" tIns="9144" bIns="9144" anchor="ctr">
+            <a:spAutoFit/>
+          </a:bodyPr>
           <a:lstStyle/>
           <a:p>
-            <a:pPr algn="ctr"/>
+            <a:pPr algn="l">
+              <a:spcBef>
+                <a:spcPts val="0"/>
+              </a:spcBef>
+              <a:spcAft>
+                <a:spcPts val="0"/>
+              </a:spcAft>
+            </a:pPr>
+            <a:r>
+              <a:rPr sz="1019" b="0">
+                <a:solidFill>
+                  <a:srgbClr val="5B5957"/>
+                </a:solidFill>
+                <a:latin typeface="Inter"/>
+              </a:rPr>
+              <a:t>mx-gemmini-opt verifies typed IR. The standalone command path bypasses LLVM; the generic full-model host currently uses Merlin → LLVM → RV64.</a:t>
+            </a:r>
           </a:p>
         </p:txBody>
       </p:sp>
       <p:sp>
         <p:nvSpPr>
-          <p:cNvPr id="31" name="Text | Component A"/>
-          <p:cNvSpPr txBox="1"/>
-          <p:nvPr/>
-        </p:nvSpPr>
-        <p:spPr>
-          <a:xfrm>
-            <a:off x="8494776" y="3392424"/>
-            <a:ext cx="2185415" cy="621792"/>
-          </a:xfrm>
-          <a:prstGeom prst="rect">
-            <a:avLst/>
-          </a:prstGeom>
-          <a:noFill/>
-          <a:effectLst/>
-        </p:spPr>
-        <p:txBody>
-          <a:bodyPr wrap="square" lIns="0" rIns="0" tIns="0" bIns="0" anchor="ctr">
-            <a:spAutoFit/>
-          </a:bodyPr>
-          <a:lstStyle/>
-          <a:p>
-            <a:pPr algn="ctr">
-              <a:lnSpc>
-                <a:spcPct val="112000"/>
-              </a:lnSpc>
-              <a:spcBef>
-                <a:spcPts val="0"/>
-              </a:spcBef>
-              <a:spcAft>
-                <a:spcPts val="0"/>
-              </a:spcAft>
-            </a:pPr>
-            <a:r>
-              <a:rPr sz="1110" b="1">
-                <a:solidFill>
-                  <a:srgbClr val="313455"/>
-                </a:solidFill>
-                <a:latin typeface="Inter"/>
-              </a:rPr>
-              <a:t>physical_program → RoCC</a:t>
-            </a:r>
-          </a:p>
-          <a:p>
-            <a:pPr algn="ctr">
-              <a:spcBef>
-                <a:spcPts val="0"/>
-              </a:spcBef>
-              <a:spcAft>
-                <a:spcPts val="0"/>
-              </a:spcAft>
-            </a:pPr>
-            <a:r>
-              <a:rPr sz="1110" b="1">
-                <a:solidFill>
-                  <a:srgbClr val="313455"/>
-                </a:solidFill>
-                <a:latin typeface="Inter"/>
-              </a:rPr>
-              <a:t>DMA · compute · VPU</a:t>
-            </a:r>
-          </a:p>
-        </p:txBody>
-      </p:sp>
-      <p:sp>
-        <p:nvSpPr>
-          <p:cNvPr id="32" name="Component | Component B"/>
-          <p:cNvSpPr/>
-          <p:nvPr/>
-        </p:nvSpPr>
-        <p:spPr>
-          <a:xfrm>
-            <a:off x="8385048" y="4142232"/>
-            <a:ext cx="2404872" cy="475488"/>
-          </a:xfrm>
-          <a:prstGeom prst="roundRect">
-            <a:avLst>
-              <a:gd name="adj" fmla="val 8000"/>
-            </a:avLst>
-          </a:prstGeom>
-          <a:solidFill>
-            <a:srgbClr val="E2E0D3"/>
-          </a:solidFill>
-          <a:ln w="14604">
-            <a:solidFill>
-              <a:srgbClr val="7D886C"/>
-            </a:solidFill>
-          </a:ln>
-          <a:effectLst/>
-        </p:spPr>
-        <p:style>
-          <a:lnRef idx="1">
-            <a:schemeClr val="accent1"/>
-          </a:lnRef>
-          <a:fillRef idx="3">
-            <a:schemeClr val="accent1"/>
-          </a:fillRef>
-          <a:effectRef idx="0">
-            <a:schemeClr val="accent1"/>
-          </a:effectRef>
-          <a:fontRef idx="minor">
-            <a:schemeClr val="lt1"/>
-          </a:fontRef>
-        </p:style>
-        <p:txBody>
-          <a:bodyPr rtlCol="0" anchor="ctr"/>
-          <a:lstStyle/>
-          <a:p>
-            <a:pPr algn="ctr"/>
-          </a:p>
-        </p:txBody>
-      </p:sp>
-      <p:sp>
-        <p:nvSpPr>
-          <p:cNvPr id="33" name="Text | Component B"/>
-          <p:cNvSpPr txBox="1"/>
-          <p:nvPr/>
-        </p:nvSpPr>
-        <p:spPr>
-          <a:xfrm>
-            <a:off x="8494776" y="4123944"/>
-            <a:ext cx="2185415" cy="621792"/>
-          </a:xfrm>
-          <a:prstGeom prst="rect">
-            <a:avLst/>
-          </a:prstGeom>
-          <a:noFill/>
-          <a:effectLst/>
-        </p:spPr>
-        <p:txBody>
-          <a:bodyPr wrap="square" lIns="0" rIns="0" tIns="0" bIns="0" anchor="ctr">
-            <a:spAutoFit/>
-          </a:bodyPr>
-          <a:lstStyle/>
-          <a:p>
-            <a:pPr algn="ctr">
-              <a:lnSpc>
-                <a:spcPct val="112000"/>
-              </a:lnSpc>
-              <a:spcBef>
-                <a:spcPts val="0"/>
-              </a:spcBef>
-              <a:spcAft>
-                <a:spcPts val="0"/>
-              </a:spcAft>
-            </a:pPr>
-            <a:r>
-              <a:rPr sz="1110" b="1">
-                <a:solidFill>
-                  <a:srgbClr val="313455"/>
-                </a:solidFill>
-                <a:latin typeface="Inter"/>
-              </a:rPr>
-              <a:t>RoCC C + data asm</a:t>
-            </a:r>
-          </a:p>
-          <a:p>
-            <a:pPr algn="ctr">
-              <a:spcBef>
-                <a:spcPts val="0"/>
-              </a:spcBef>
-              <a:spcAft>
-                <a:spcPts val="0"/>
-              </a:spcAft>
-            </a:pPr>
-            <a:r>
-              <a:rPr sz="1110" b="1">
-                <a:solidFill>
-                  <a:srgbClr val="313455"/>
-                </a:solidFill>
-                <a:latin typeface="Inter"/>
-              </a:rPr>
-              <a:t>RV64 GCC → ELF → Spike</a:t>
-            </a:r>
-          </a:p>
-        </p:txBody>
-      </p:sp>
-      <p:sp>
-        <p:nvSpPr>
-          <p:cNvPr id="34" name="Text | [Boundary, interfaces and omitted componen"/>
-          <p:cNvSpPr txBox="1"/>
-          <p:nvPr/>
-        </p:nvSpPr>
-        <p:spPr>
-          <a:xfrm>
-            <a:off x="1069848" y="5148072"/>
-            <a:ext cx="10003536" cy="466344"/>
-          </a:xfrm>
-          <a:prstGeom prst="rect">
-            <a:avLst/>
-          </a:prstGeom>
-          <a:noFill/>
-          <a:effectLst/>
-        </p:spPr>
-        <p:txBody>
-          <a:bodyPr wrap="square" lIns="0" rIns="0" tIns="0" bIns="0" anchor="ctr">
-            <a:spAutoFit/>
-          </a:bodyPr>
-          <a:lstStyle/>
-          <a:p>
-            <a:pPr algn="l">
-              <a:lnSpc>
-                <a:spcPct val="112000"/>
-              </a:lnSpc>
-              <a:spcBef>
-                <a:spcPts val="0"/>
-              </a:spcBef>
-              <a:spcAft>
-                <a:spcPts val="0"/>
-              </a:spcAft>
-            </a:pPr>
-            <a:r>
-              <a:rPr sz="1019" b="0">
-                <a:solidFill>
-                  <a:srgbClr val="5B5957"/>
-                </a:solidFill>
-                <a:latin typeface="Inter"/>
-              </a:rPr>
-              <a:t>Merlin transforms: MXBF16CatalogPreparation + MXVPUPostOffload; mx-gemmini-opt verifies typed IR.</a:t>
-            </a:r>
-          </a:p>
-          <a:p>
-            <a:pPr algn="l">
-              <a:spcBef>
-                <a:spcPts val="0"/>
-              </a:spcBef>
-              <a:spcAft>
-                <a:spcPts val="0"/>
-              </a:spcAft>
-            </a:pPr>
-            <a:r>
-              <a:rPr sz="1019" b="0">
-                <a:solidFill>
-                  <a:srgbClr val="5B5957"/>
-                </a:solidFill>
-                <a:latin typeface="Inter"/>
-              </a:rPr>
-              <a:t>Standalone commands bypass LLVM; the full-model host currently uses Merlin → LLVM → RV64.</a:t>
-            </a:r>
-          </a:p>
-        </p:txBody>
-      </p:sp>
-      <p:sp>
-        <p:nvSpPr>
-          <p:cNvPr id="35" name="TextBox 34"/>
+          <p:cNvPr id="31" name="TextBox 30"/>
           <p:cNvSpPr txBox="1"/>
           <p:nvPr/>
         </p:nvSpPr>
@@ -19298,7 +18988,7 @@
                 </a:solidFill>
                 <a:latin typeface="Inter"/>
               </a:rPr>
-              <a:t>What paired Spike runs show</a:t>
+              <a:t>MX+VPU Spike cycle results</a:t>
             </a:r>
           </a:p>
         </p:txBody>
@@ -19313,7 +19003,7 @@
         </p:nvGraphicFramePr>
         <p:xfrm>
           <a:off x="859536" y="1673352"/>
-          <a:ext cx="10479023" cy="2578608"/>
+          <a:ext cx="10479023" cy="2852928"/>
         </p:xfrm>
         <a:graphic>
           <a:graphicData uri="http://schemas.openxmlformats.org/drawingml/2006/table">
@@ -19327,7 +19017,7 @@
                 <a:gridCol w="2176272"/>
                 <a:gridCol w="2185416"/>
               </a:tblGrid>
-              <a:tr h="603504">
+              <a:tr h="548640">
                 <a:tc>
                   <a:txBody>
                     <a:bodyPr/>
@@ -19342,13 +19032,13 @@
                         </a:spcAft>
                       </a:pPr>
                       <a:r>
-                        <a:rPr sz="1220" b="1">
+                        <a:rPr sz="1180" b="1">
                           <a:solidFill>
                             <a:srgbClr val="FFFFFF"/>
                           </a:solidFill>
                           <a:latin typeface="Inter"/>
                         </a:rPr>
-                        <a:t>Paired workload</a:t>
+                        <a:t>Workload / scope</a:t>
                       </a:r>
                     </a:p>
                   </a:txBody>
@@ -19392,7 +19082,7 @@
                         </a:spcAft>
                       </a:pPr>
                       <a:r>
-                        <a:rPr sz="1220" b="1">
+                        <a:rPr sz="1180" b="1">
                           <a:solidFill>
                             <a:srgbClr val="FFFFFF"/>
                           </a:solidFill>
@@ -19442,13 +19132,13 @@
                         </a:spcAft>
                       </a:pPr>
                       <a:r>
-                        <a:rPr sz="1220" b="1">
+                        <a:rPr sz="1180" b="1">
                           <a:solidFill>
                             <a:srgbClr val="FFFFFF"/>
                           </a:solidFill>
                           <a:latin typeface="Inter"/>
                         </a:rPr>
-                        <a:t>Nicolas cycles</a:t>
+                        <a:t>Native source cycles</a:t>
                       </a:r>
                     </a:p>
                   </a:txBody>
@@ -19492,7 +19182,7 @@
                         </a:spcAft>
                       </a:pPr>
                       <a:r>
-                        <a:rPr sz="1220" b="1">
+                        <a:rPr sz="1180" b="1">
                           <a:solidFill>
                             <a:srgbClr val="FFFFFF"/>
                           </a:solidFill>
@@ -19529,7 +19219,7 @@
                   </a:tcPr>
                 </a:tc>
               </a:tr>
-              <a:tr h="658368">
+              <a:tr h="576072">
                 <a:tc>
                   <a:txBody>
                     <a:bodyPr/>
@@ -19544,13 +19234,13 @@
                         </a:spcAft>
                       </a:pPr>
                       <a:r>
-                        <a:rPr sz="1300" b="0">
+                        <a:rPr sz="1240" b="1">
                           <a:solidFill>
                             <a:srgbClr val="313455"/>
                           </a:solidFill>
                           <a:latin typeface="Inter"/>
                         </a:rPr>
-                        <a:t>Dense attention 64×256×128</a:t>
+                        <a:t>SmolVLA · full 12-step session</a:t>
                       </a:r>
                     </a:p>
                   </a:txBody>
@@ -19594,13 +19284,13 @@
                         </a:spcAft>
                       </a:pPr>
                       <a:r>
-                        <a:rPr sz="1310" b="0">
+                        <a:rPr sz="1240" b="0">
                           <a:solidFill>
                             <a:srgbClr val="313455"/>
                           </a:solidFill>
                           <a:latin typeface="Inter"/>
                         </a:rPr>
-                        <a:t>43,523</a:t>
+                        <a:t>72,066,544,354*</a:t>
                       </a:r>
                     </a:p>
                   </a:txBody>
@@ -19644,13 +19334,13 @@
                         </a:spcAft>
                       </a:pPr>
                       <a:r>
-                        <a:rPr sz="1310" b="0">
+                        <a:rPr sz="1240" b="0">
                           <a:solidFill>
                             <a:srgbClr val="313455"/>
                           </a:solidFill>
                           <a:latin typeface="Inter"/>
                         </a:rPr>
-                        <a:t>43,641</a:t>
+                        <a:t>running</a:t>
                       </a:r>
                     </a:p>
                   </a:txBody>
@@ -19694,13 +19384,13 @@
                         </a:spcAft>
                       </a:pPr>
                       <a:r>
-                        <a:rPr sz="1310" b="0">
+                        <a:rPr sz="1240" b="0">
                           <a:solidFill>
                             <a:srgbClr val="313455"/>
                           </a:solidFill>
                           <a:latin typeface="Inter"/>
                         </a:rPr>
-                        <a:t>−0.27%</a:t>
+                        <a:t>—</a:t>
                       </a:r>
                     </a:p>
                   </a:txBody>
@@ -19731,7 +19421,7 @@
                   </a:tcPr>
                 </a:tc>
               </a:tr>
-              <a:tr h="658368">
+              <a:tr h="576072">
                 <a:tc>
                   <a:txBody>
                     <a:bodyPr/>
@@ -19746,13 +19436,13 @@
                         </a:spcAft>
                       </a:pPr>
                       <a:r>
-                        <a:rPr sz="1300" b="0">
+                        <a:rPr sz="1240" b="1">
                           <a:solidFill>
                             <a:srgbClr val="313455"/>
                           </a:solidFill>
                           <a:latin typeface="Inter"/>
                         </a:rPr>
-                        <a:t>SmolVLA flow · one step</a:t>
+                        <a:t>TinyLlama · full 33-step session</a:t>
                       </a:r>
                     </a:p>
                   </a:txBody>
@@ -19796,13 +19486,13 @@
                         </a:spcAft>
                       </a:pPr>
                       <a:r>
-                        <a:rPr sz="1310" b="0">
+                        <a:rPr sz="1240" b="0">
                           <a:solidFill>
                             <a:srgbClr val="313455"/>
                           </a:solidFill>
                           <a:latin typeface="Inter"/>
                         </a:rPr>
-                        <a:t>2,112,653,481</a:t>
+                        <a:t>prefill trap</a:t>
                       </a:r>
                     </a:p>
                   </a:txBody>
@@ -19846,13 +19536,13 @@
                         </a:spcAft>
                       </a:pPr>
                       <a:r>
-                        <a:rPr sz="1310" b="0">
+                        <a:rPr sz="1240" b="0">
                           <a:solidFill>
                             <a:srgbClr val="313455"/>
                           </a:solidFill>
                           <a:latin typeface="Inter"/>
                         </a:rPr>
-                        <a:t>2,112,919,925</a:t>
+                        <a:t>pending</a:t>
                       </a:r>
                     </a:p>
                   </a:txBody>
@@ -19896,13 +19586,13 @@
                         </a:spcAft>
                       </a:pPr>
                       <a:r>
-                        <a:rPr sz="1310" b="0">
+                        <a:rPr sz="1240" b="0">
                           <a:solidFill>
                             <a:srgbClr val="313455"/>
                           </a:solidFill>
                           <a:latin typeface="Inter"/>
                         </a:rPr>
-                        <a:t>−0.0126%</a:t>
+                        <a:t>—</a:t>
                       </a:r>
                     </a:p>
                   </a:txBody>
@@ -19933,7 +19623,7 @@
                   </a:tcPr>
                 </a:tc>
               </a:tr>
-              <a:tr h="658368">
+              <a:tr h="576072">
                 <a:tc>
                   <a:txBody>
                     <a:bodyPr/>
@@ -19948,13 +19638,13 @@
                         </a:spcAft>
                       </a:pPr>
                       <a:r>
-                        <a:rPr sz="1300" b="1">
+                        <a:rPr sz="1240" b="0">
                           <a:solidFill>
                             <a:srgbClr val="313455"/>
                           </a:solidFill>
                           <a:latin typeface="Inter"/>
                         </a:rPr>
-                        <a:t>SmolVLA · 12-step matrix swap</a:t>
+                        <a:t>SmolVLA flow · one step</a:t>
                       </a:r>
                     </a:p>
                   </a:txBody>
@@ -19998,13 +19688,13 @@
                         </a:spcAft>
                       </a:pPr>
                       <a:r>
-                        <a:rPr sz="1310" b="0">
+                        <a:rPr sz="1240" b="0">
                           <a:solidFill>
                             <a:srgbClr val="313455"/>
                           </a:solidFill>
                           <a:latin typeface="Inter"/>
                         </a:rPr>
-                        <a:t>72,066,544,354*</a:t>
+                        <a:t>2,112,653,481</a:t>
                       </a:r>
                     </a:p>
                   </a:txBody>
@@ -20048,13 +19738,13 @@
                         </a:spcAft>
                       </a:pPr>
                       <a:r>
-                        <a:rPr sz="1310" b="0">
+                        <a:rPr sz="1240" b="0">
                           <a:solidFill>
                             <a:srgbClr val="313455"/>
                           </a:solidFill>
                           <a:latin typeface="Inter"/>
                         </a:rPr>
-                        <a:t>running</a:t>
+                        <a:t>2,112,919,925</a:t>
                       </a:r>
                     </a:p>
                   </a:txBody>
@@ -20098,19 +19788,221 @@
                         </a:spcAft>
                       </a:pPr>
                       <a:r>
-                        <a:rPr sz="1310" b="0">
+                        <a:rPr sz="1240" b="0">
                           <a:solidFill>
                             <a:srgbClr val="313455"/>
                           </a:solidFill>
                           <a:latin typeface="Inter"/>
                         </a:rPr>
-                        <a:t>—</a:t>
+                        <a:t>−0.0126%</a:t>
                       </a:r>
                     </a:p>
                   </a:txBody>
                   <a:tcPr marL="128016" marR="91440" marT="45720" marB="27432" anchor="ctr">
                     <a:solidFill>
                       <a:srgbClr val="CBCFD0"/>
+                    </a:solidFill>
+                    <a:lnL w="6350">
+                      <a:solidFill>
+                        <a:srgbClr val="E0D6CB"/>
+                      </a:solidFill>
+                    </a:lnL>
+                    <a:lnR w="6350">
+                      <a:solidFill>
+                        <a:srgbClr val="E0D6CB"/>
+                      </a:solidFill>
+                    </a:lnR>
+                    <a:lnT w="6350">
+                      <a:solidFill>
+                        <a:srgbClr val="E0D6CB"/>
+                      </a:solidFill>
+                    </a:lnT>
+                    <a:lnB w="6350">
+                      <a:solidFill>
+                        <a:srgbClr val="E0D6CB"/>
+                      </a:solidFill>
+                    </a:lnB>
+                  </a:tcPr>
+                </a:tc>
+              </a:tr>
+              <a:tr h="576072">
+                <a:tc>
+                  <a:txBody>
+                    <a:bodyPr/>
+                    <a:lstStyle/>
+                    <a:p>
+                      <a:pPr algn="l">
+                        <a:spcBef>
+                          <a:spcPts val="0"/>
+                        </a:spcBef>
+                        <a:spcAft>
+                          <a:spcPts val="0"/>
+                        </a:spcAft>
+                      </a:pPr>
+                      <a:r>
+                        <a:rPr sz="1240" b="0">
+                          <a:solidFill>
+                            <a:srgbClr val="313455"/>
+                          </a:solidFill>
+                          <a:latin typeface="Inter"/>
+                        </a:rPr>
+                        <a:t>Dense attention 64×256×128</a:t>
+                      </a:r>
+                    </a:p>
+                  </a:txBody>
+                  <a:tcPr marL="128016" marR="91440" marT="45720" marB="27432" anchor="ctr">
+                    <a:solidFill>
+                      <a:srgbClr val="FDF7EF"/>
+                    </a:solidFill>
+                    <a:lnL w="6350">
+                      <a:solidFill>
+                        <a:srgbClr val="E0D6CB"/>
+                      </a:solidFill>
+                    </a:lnL>
+                    <a:lnR w="6350">
+                      <a:solidFill>
+                        <a:srgbClr val="E0D6CB"/>
+                      </a:solidFill>
+                    </a:lnR>
+                    <a:lnT w="6350">
+                      <a:solidFill>
+                        <a:srgbClr val="E0D6CB"/>
+                      </a:solidFill>
+                    </a:lnT>
+                    <a:lnB w="6350">
+                      <a:solidFill>
+                        <a:srgbClr val="E0D6CB"/>
+                      </a:solidFill>
+                    </a:lnB>
+                  </a:tcPr>
+                </a:tc>
+                <a:tc>
+                  <a:txBody>
+                    <a:bodyPr/>
+                    <a:lstStyle/>
+                    <a:p>
+                      <a:pPr algn="ctr">
+                        <a:spcBef>
+                          <a:spcPts val="0"/>
+                        </a:spcBef>
+                        <a:spcAft>
+                          <a:spcPts val="0"/>
+                        </a:spcAft>
+                      </a:pPr>
+                      <a:r>
+                        <a:rPr sz="1240" b="0">
+                          <a:solidFill>
+                            <a:srgbClr val="313455"/>
+                          </a:solidFill>
+                          <a:latin typeface="Inter"/>
+                        </a:rPr>
+                        <a:t>43,523</a:t>
+                      </a:r>
+                    </a:p>
+                  </a:txBody>
+                  <a:tcPr marL="128016" marR="91440" marT="45720" marB="27432" anchor="ctr">
+                    <a:solidFill>
+                      <a:srgbClr val="FDF7EF"/>
+                    </a:solidFill>
+                    <a:lnL w="6350">
+                      <a:solidFill>
+                        <a:srgbClr val="E0D6CB"/>
+                      </a:solidFill>
+                    </a:lnL>
+                    <a:lnR w="6350">
+                      <a:solidFill>
+                        <a:srgbClr val="E0D6CB"/>
+                      </a:solidFill>
+                    </a:lnR>
+                    <a:lnT w="6350">
+                      <a:solidFill>
+                        <a:srgbClr val="E0D6CB"/>
+                      </a:solidFill>
+                    </a:lnT>
+                    <a:lnB w="6350">
+                      <a:solidFill>
+                        <a:srgbClr val="E0D6CB"/>
+                      </a:solidFill>
+                    </a:lnB>
+                  </a:tcPr>
+                </a:tc>
+                <a:tc>
+                  <a:txBody>
+                    <a:bodyPr/>
+                    <a:lstStyle/>
+                    <a:p>
+                      <a:pPr algn="ctr">
+                        <a:spcBef>
+                          <a:spcPts val="0"/>
+                        </a:spcBef>
+                        <a:spcAft>
+                          <a:spcPts val="0"/>
+                        </a:spcAft>
+                      </a:pPr>
+                      <a:r>
+                        <a:rPr sz="1240" b="0">
+                          <a:solidFill>
+                            <a:srgbClr val="313455"/>
+                          </a:solidFill>
+                          <a:latin typeface="Inter"/>
+                        </a:rPr>
+                        <a:t>43,641</a:t>
+                      </a:r>
+                    </a:p>
+                  </a:txBody>
+                  <a:tcPr marL="128016" marR="91440" marT="45720" marB="27432" anchor="ctr">
+                    <a:solidFill>
+                      <a:srgbClr val="FDF7EF"/>
+                    </a:solidFill>
+                    <a:lnL w="6350">
+                      <a:solidFill>
+                        <a:srgbClr val="E0D6CB"/>
+                      </a:solidFill>
+                    </a:lnL>
+                    <a:lnR w="6350">
+                      <a:solidFill>
+                        <a:srgbClr val="E0D6CB"/>
+                      </a:solidFill>
+                    </a:lnR>
+                    <a:lnT w="6350">
+                      <a:solidFill>
+                        <a:srgbClr val="E0D6CB"/>
+                      </a:solidFill>
+                    </a:lnT>
+                    <a:lnB w="6350">
+                      <a:solidFill>
+                        <a:srgbClr val="E0D6CB"/>
+                      </a:solidFill>
+                    </a:lnB>
+                  </a:tcPr>
+                </a:tc>
+                <a:tc>
+                  <a:txBody>
+                    <a:bodyPr/>
+                    <a:lstStyle/>
+                    <a:p>
+                      <a:pPr algn="ctr">
+                        <a:spcBef>
+                          <a:spcPts val="0"/>
+                        </a:spcBef>
+                        <a:spcAft>
+                          <a:spcPts val="0"/>
+                        </a:spcAft>
+                      </a:pPr>
+                      <a:r>
+                        <a:rPr sz="1240" b="0">
+                          <a:solidFill>
+                            <a:srgbClr val="313455"/>
+                          </a:solidFill>
+                          <a:latin typeface="Inter"/>
+                        </a:rPr>
+                        <a:t>−0.27%</a:t>
+                      </a:r>
+                    </a:p>
+                  </a:txBody>
+                  <a:tcPr marL="128016" marR="91440" marT="45720" marB="27432" anchor="ctr">
+                    <a:solidFill>
+                      <a:srgbClr val="FDF7EF"/>
                     </a:solidFill>
                     <a:lnL w="6350">
                       <a:solidFill>
@@ -20174,13 +20066,13 @@
               </a:spcAft>
             </a:pPr>
             <a:r>
-              <a:rPr sz="1000" b="0">
+              <a:rPr sz="960" b="0">
                 <a:solidFill>
                   <a:srgbClr val="5B5957"/>
                 </a:solidFill>
                 <a:latin typeface="Inter"/>
               </a:rPr>
-              <a:t>* Completed compiler timing receipt; full-session numeric qualification pending. Spike e4m3_vpu model, host tracking off.</a:t>
+              <a:t>* Completed timing receipt; independent quantized accuracy remains open. TinyLlama optimized prefill trapped before output; no model cycle total.</a:t>
             </a:r>
           </a:p>
           <a:p>
@@ -20193,13 +20085,13 @@
               </a:spcAft>
             </a:pPr>
             <a:r>
-              <a:rPr sz="1000" b="0">
+              <a:rPr sz="960" b="0">
                 <a:solidFill>
                   <a:srgbClr val="5B5957"/>
                 </a:solidFill>
                 <a:latin typeface="Inter"/>
               </a:rPr>
-              <a:t>Evidence: docs/evidence/attn_vpu_equal_work_20261013 and docs/evidence/nicolas_matrix_substitution_smolvla_20261013.</a:t>
+              <a:t>Nicolas e4m3_vpu Spike, host tracking off. Paired flow/attention output hashes match. Full SmolVLA issuer-swap parity awaits its source run.</a:t>
             </a:r>
           </a:p>
         </p:txBody>
@@ -20212,8 +20104,8 @@
         </p:nvSpPr>
         <p:spPr>
           <a:xfrm>
-            <a:off x="859536" y="4645152"/>
-            <a:ext cx="10479024" cy="585216"/>
+            <a:off x="859536" y="4663440"/>
+            <a:ext cx="10479024" cy="557784"/>
           </a:xfrm>
           <a:prstGeom prst="roundRect">
             <a:avLst/>
@@ -20258,7 +20150,7 @@
                 </a:solidFill>
                 <a:latin typeface="Inter"/>
               </a:rPr>
-              <a:t>Paired kernel / flow results match outputs. The source swap changes MX issuers only; no matched full fused handwritten MX+VPU model baseline exists yet.</a:t>
+              <a:t>Native source swaps only MX matrix issuers; host graph and VPU stay fixed. A matched full fused handwritten MX+VPU baseline is still missing.</a:t>
             </a:r>
           </a:p>
         </p:txBody>

</xml_diff>

<commit_message>
Document full SmolVLA paired Spike cycles
</commit_message>
<xml_diff>
--- a/docs/presentations/mx_gemmini_dialect_overview.pptx
+++ b/docs/presentations/mx_gemmini_dialect_overview.pptx
@@ -17362,7 +17362,7 @@
                 </a:solidFill>
                 <a:latin typeface="Inter"/>
               </a:rPr>
-              <a:t>• load_profile(rtl_root) rejects RTL drift.</a:t>
+              <a:t>• load_profile(profile, rtl_root=rtl) rejects drift.</a:t>
             </a:r>
           </a:p>
         </p:txBody>
@@ -17650,7 +17650,7 @@
                 </a:solidFill>
                 <a:latin typeface="Inter"/>
               </a:rPr>
-              <a:t>Radiance FP4 GEMM → typed MX</a:t>
+              <a:t>FP4 GEMM → typed MX</a:t>
             </a:r>
           </a:p>
         </p:txBody>
@@ -19340,7 +19340,7 @@
                           </a:solidFill>
                           <a:latin typeface="Inter"/>
                         </a:rPr>
-                        <a:t>running</a:t>
+                        <a:t>71,875,683,634</a:t>
                       </a:r>
                     </a:p>
                   </a:txBody>
@@ -19390,7 +19390,7 @@
                           </a:solidFill>
                           <a:latin typeface="Inter"/>
                         </a:rPr>
-                        <a:t>—</a:t>
+                        <a:t>+0.266%</a:t>
                       </a:r>
                     </a:p>
                   </a:txBody>
@@ -20091,7 +20091,7 @@
                 </a:solidFill>
                 <a:latin typeface="Inter"/>
               </a:rPr>
-              <a:t>Nicolas e4m3_vpu Spike, host tracking off. Paired flow/attention output hashes match. Full SmolVLA issuer-swap parity awaits its source run.</a:t>
+              <a:t>Nicolas e4m3_vpu Spike, host tracking off. Paired flow/attention output hashes match. Full SmolVLA issuer-swap outputs match.</a:t>
             </a:r>
           </a:p>
         </p:txBody>

</xml_diff>

<commit_message>
Update TinyLlama slide run status
</commit_message>
<xml_diff>
--- a/docs/presentations/mx_gemmini_dialect_overview.pptx
+++ b/docs/presentations/mx_gemmini_dialect_overview.pptx
@@ -19492,7 +19492,7 @@
                           </a:solidFill>
                           <a:latin typeface="Inter"/>
                         </a:rPr>
-                        <a:t>prefill trap</a:t>
+                        <a:t>running</a:t>
                       </a:r>
                     </a:p>
                   </a:txBody>
@@ -20072,7 +20072,7 @@
                 </a:solidFill>
                 <a:latin typeface="Inter"/>
               </a:rPr>
-              <a:t>* Completed timing receipt; independent quantized accuracy remains open. TinyLlama optimized prefill trapped before output; no model cycle total.</a:t>
+              <a:t>* Completed timing receipt; independent quantized accuracy remains open. TinyLlama corrected full Spike runs are in progress; no model cycle total.</a:t>
             </a:r>
           </a:p>
           <a:p>

</xml_diff>

<commit_message>
Clarify MX slide evidence and precision
</commit_message>
<xml_diff>
--- a/docs/presentations/mx_gemmini_dialect_overview.pptx
+++ b/docs/presentations/mx_gemmini_dialect_overview.pptx
@@ -17305,7 +17305,7 @@
                 </a:solidFill>
                 <a:latin typeface="Inter"/>
               </a:rPr>
-              <a:t>• FP4 selects PE 0; 256 KiB SPAD bounds tiling.</a:t>
+              <a:t>• TinyLlama: 155 FP4 / 45 FP8 MX sites per stage.</a:t>
             </a:r>
           </a:p>
           <a:p>
@@ -17324,7 +17324,7 @@
                 </a:solidFill>
                 <a:latin typeface="Inter"/>
               </a:rPr>
-              <a:t>• vpu_execute / spad_requant become legal.</a:t>
+              <a:t>• FP4 binds PE 0; 256 KiB SPAD caps tiles.</a:t>
             </a:r>
           </a:p>
           <a:p>
@@ -17343,7 +17343,7 @@
                 </a:solidFill>
                 <a:latin typeface="Inter"/>
               </a:rPr>
-              <a:t>• FP6 contracts reject here; use its LUT profile.</a:t>
+              <a:t>• VPU/requant legal; FP6 rejects in this profile.</a:t>
             </a:r>
           </a:p>
           <a:p>
@@ -20091,7 +20091,7 @@
                 </a:solidFill>
                 <a:latin typeface="Inter"/>
               </a:rPr>
-              <a:t>Nicolas e4m3_vpu Spike, host tracking off. Paired flow/attention output hashes match. Full SmolVLA issuer-swap outputs match.</a:t>
+              <a:t>Nicolas e4m3_vpu Spike, host tracking off. Paired flow/attention output hashes match. Full SmolVLA issuer-swap outputs match (33/33).</a:t>
             </a:r>
           </a:p>
         </p:txBody>
@@ -20150,7 +20150,7 @@
                 </a:solidFill>
                 <a:latin typeface="Inter"/>
               </a:rPr>
-              <a:t>Native source swaps only MX matrix issuers; host graph and VPU stay fixed. A matched full fused handwritten MX+VPU baseline is still missing.</a:t>
+              <a:t>Full-model source variants replace two MX issuer catalogs; host graph and VPU stay fixed. A matched fused handwritten whole-model baseline is unmeasured.</a:t>
             </a:r>
           </a:p>
         </p:txBody>

</xml_diff>

<commit_message>
Record full TinyLlama MX Spike comparison
</commit_message>
<xml_diff>
--- a/docs/presentations/mx_gemmini_dialect_overview.pptx
+++ b/docs/presentations/mx_gemmini_dialect_overview.pptx
@@ -19138,7 +19138,7 @@
                           </a:solidFill>
                           <a:latin typeface="Inter"/>
                         </a:rPr>
-                        <a:t>Native source cycles</a:t>
+                        <a:t>Nicolas cycles</a:t>
                       </a:r>
                     </a:p>
                   </a:txBody>
@@ -19492,7 +19492,7 @@
                           </a:solidFill>
                           <a:latin typeface="Inter"/>
                         </a:rPr>
-                        <a:t>running</a:t>
+                        <a:t>83,547,564,353*</a:t>
                       </a:r>
                     </a:p>
                   </a:txBody>
@@ -19542,7 +19542,7 @@
                           </a:solidFill>
                           <a:latin typeface="Inter"/>
                         </a:rPr>
-                        <a:t>pending</a:t>
+                        <a:t>83,544,602,795</a:t>
                       </a:r>
                     </a:p>
                   </a:txBody>
@@ -19592,7 +19592,7 @@
                           </a:solidFill>
                           <a:latin typeface="Inter"/>
                         </a:rPr>
-                        <a:t>—</a:t>
+                        <a:t>+0.004%</a:t>
                       </a:r>
                     </a:p>
                   </a:txBody>
@@ -20072,7 +20072,7 @@
                 </a:solidFill>
                 <a:latin typeface="Inter"/>
               </a:rPr>
-              <a:t>* Completed timing receipt; independent quantized accuracy remains open. TinyLlama corrected full Spike runs are in progress; no model cycle total.</a:t>
+              <a:t>* Full-session output hashes match: SmolVLA 33/33, TinyLlama 99/99. Independent quantized accuracy remains open.</a:t>
             </a:r>
           </a:p>
           <a:p>
@@ -20091,7 +20091,7 @@
                 </a:solidFill>
                 <a:latin typeface="Inter"/>
               </a:rPr>
-              <a:t>Nicolas e4m3_vpu Spike, host tracking off. Paired flow/attention output hashes match. Full SmolVLA issuer-swap outputs match (33/33).</a:t>
+              <a:t>Nicolas e4m3_vpu Spike, host tracking off. Paired flow/attention outputs also match.</a:t>
             </a:r>
           </a:p>
         </p:txBody>

</xml_diff>

<commit_message>
Clarify MX slide comparisons
</commit_message>
<xml_diff>
--- a/docs/presentations/mx_gemmini_dialect_overview.pptx
+++ b/docs/presentations/mx_gemmini_dialect_overview.pptx
@@ -16734,7 +16734,7 @@
           <a:bodyPr rtlCol="0" anchor="t" wrap="none" lIns="109728" tIns="91440" rIns="73152" bIns="36576"/>
           <a:lstStyle/>
           <a:p>
-            <a:pPr algn="ctr">
+            <a:pPr algn="l">
               <a:spcBef>
                 <a:spcPts val="0"/>
               </a:spcBef>
@@ -16753,7 +16753,7 @@
             </a:r>
           </a:p>
           <a:p>
-            <a:pPr>
+            <a:pPr algn="l">
               <a:spcBef>
                 <a:spcPts val="0"/>
               </a:spcBef>
@@ -16768,11 +16768,101 @@
                 </a:solidFill>
                 <a:latin typeface="Liberation Mono"/>
               </a:rPr>
-              <a:t> "geometry": {"mesh_rows":16,"mesh_columns":16},</a:t>
-            </a:r>
-          </a:p>
-          <a:p>
-            <a:pPr>
+              <a:t> </a:t>
+            </a:r>
+            <a:r>
+              <a:rPr sz="1045">
+                <a:solidFill>
+                  <a:srgbClr val="6C3D80"/>
+                </a:solidFill>
+                <a:latin typeface="Liberation Mono"/>
+              </a:rPr>
+              <a:t>"geometry"</a:t>
+            </a:r>
+            <a:r>
+              <a:rPr sz="1045">
+                <a:solidFill>
+                  <a:srgbClr val="103552"/>
+                </a:solidFill>
+                <a:latin typeface="Liberation Mono"/>
+              </a:rPr>
+              <a:t>: {</a:t>
+            </a:r>
+            <a:r>
+              <a:rPr sz="1045">
+                <a:solidFill>
+                  <a:srgbClr val="6C3D80"/>
+                </a:solidFill>
+                <a:latin typeface="Liberation Mono"/>
+              </a:rPr>
+              <a:t>"mesh_rows"</a:t>
+            </a:r>
+            <a:r>
+              <a:rPr sz="1045">
+                <a:solidFill>
+                  <a:srgbClr val="103552"/>
+                </a:solidFill>
+                <a:latin typeface="Liberation Mono"/>
+              </a:rPr>
+              <a:t>:</a:t>
+            </a:r>
+            <a:r>
+              <a:rPr sz="1045">
+                <a:solidFill>
+                  <a:srgbClr val="A44F25"/>
+                </a:solidFill>
+                <a:latin typeface="Liberation Mono"/>
+              </a:rPr>
+              <a:t>16</a:t>
+            </a:r>
+            <a:r>
+              <a:rPr sz="1045">
+                <a:solidFill>
+                  <a:srgbClr val="103552"/>
+                </a:solidFill>
+                <a:latin typeface="Liberation Mono"/>
+              </a:rPr>
+              <a:t>,</a:t>
+            </a:r>
+            <a:r>
+              <a:rPr sz="1045">
+                <a:solidFill>
+                  <a:srgbClr val="6C3D80"/>
+                </a:solidFill>
+                <a:latin typeface="Liberation Mono"/>
+              </a:rPr>
+              <a:t>"mesh_columns"</a:t>
+            </a:r>
+            <a:r>
+              <a:rPr sz="1045">
+                <a:solidFill>
+                  <a:srgbClr val="103552"/>
+                </a:solidFill>
+                <a:latin typeface="Liberation Mono"/>
+              </a:rPr>
+              <a:t>:</a:t>
+            </a:r>
+            <a:r>
+              <a:rPr sz="1045">
+                <a:solidFill>
+                  <a:srgbClr val="A44F25"/>
+                </a:solidFill>
+                <a:latin typeface="Liberation Mono"/>
+              </a:rPr>
+              <a:t>16</a:t>
+            </a:r>
+            <a:r>
+              <a:rPr sz="1045">
+                <a:solidFill>
+                  <a:srgbClr val="103552"/>
+                </a:solidFill>
+                <a:latin typeface="Liberation Mono"/>
+              </a:rPr>
+              <a:t>},</a:t>
+            </a:r>
+          </a:p>
+          <a:p>
+            <a:pPr algn="l">
               <a:spcBef>
                 <a:spcPts val="0"/>
               </a:spcBef>
@@ -16787,11 +16877,29 @@
                 </a:solidFill>
                 <a:latin typeface="Liberation Mono"/>
               </a:rPr>
-              <a:t> "legal_compute": [</a:t>
-            </a:r>
-          </a:p>
-          <a:p>
-            <a:pPr>
+              <a:t> </a:t>
+            </a:r>
+            <a:r>
+              <a:rPr sz="1045">
+                <a:solidFill>
+                  <a:srgbClr val="6C3D80"/>
+                </a:solidFill>
+                <a:latin typeface="Liberation Mono"/>
+              </a:rPr>
+              <a:t>"legal_compute"</a:t>
+            </a:r>
+            <a:r>
+              <a:rPr sz="1045">
+                <a:solidFill>
+                  <a:srgbClr val="103552"/>
+                </a:solidFill>
+                <a:latin typeface="Liberation Mono"/>
+              </a:rPr>
+              <a:t>: [</a:t>
+            </a:r>
+          </a:p>
+          <a:p>
+            <a:pPr algn="l">
               <a:spcBef>
                 <a:spcPts val="0"/>
               </a:spcBef>
@@ -16806,11 +16914,47 @@
                 </a:solidFill>
                 <a:latin typeface="Liberation Mono"/>
               </a:rPr>
-              <a:t>  {"activation_format":"fp4_e2m1",</a:t>
-            </a:r>
-          </a:p>
-          <a:p>
-            <a:pPr>
+              <a:t>  {</a:t>
+            </a:r>
+            <a:r>
+              <a:rPr sz="1045">
+                <a:solidFill>
+                  <a:srgbClr val="6C3D80"/>
+                </a:solidFill>
+                <a:latin typeface="Liberation Mono"/>
+              </a:rPr>
+              <a:t>"activation_format"</a:t>
+            </a:r>
+            <a:r>
+              <a:rPr sz="1045">
+                <a:solidFill>
+                  <a:srgbClr val="103552"/>
+                </a:solidFill>
+                <a:latin typeface="Liberation Mono"/>
+              </a:rPr>
+              <a:t>:</a:t>
+            </a:r>
+            <a:r>
+              <a:rPr sz="1045">
+                <a:solidFill>
+                  <a:srgbClr val="28704F"/>
+                </a:solidFill>
+                <a:latin typeface="Liberation Mono"/>
+              </a:rPr>
+              <a:t>"fp4_e2m1"</a:t>
+            </a:r>
+            <a:r>
+              <a:rPr sz="1045">
+                <a:solidFill>
+                  <a:srgbClr val="103552"/>
+                </a:solidFill>
+                <a:latin typeface="Liberation Mono"/>
+              </a:rPr>
+              <a:t>,</a:t>
+            </a:r>
+          </a:p>
+          <a:p>
+            <a:pPr algn="l">
               <a:spcBef>
                 <a:spcPts val="0"/>
               </a:spcBef>
@@ -16825,11 +16969,83 @@
                 </a:solidFill>
                 <a:latin typeface="Liberation Mono"/>
               </a:rPr>
-              <a:t>   "weight_format":"fp4_e2m1","pe_mode":0},</a:t>
-            </a:r>
-          </a:p>
-          <a:p>
-            <a:pPr>
+              <a:t>   </a:t>
+            </a:r>
+            <a:r>
+              <a:rPr sz="1045">
+                <a:solidFill>
+                  <a:srgbClr val="6C3D80"/>
+                </a:solidFill>
+                <a:latin typeface="Liberation Mono"/>
+              </a:rPr>
+              <a:t>"weight_format"</a:t>
+            </a:r>
+            <a:r>
+              <a:rPr sz="1045">
+                <a:solidFill>
+                  <a:srgbClr val="103552"/>
+                </a:solidFill>
+                <a:latin typeface="Liberation Mono"/>
+              </a:rPr>
+              <a:t>:</a:t>
+            </a:r>
+            <a:r>
+              <a:rPr sz="1045">
+                <a:solidFill>
+                  <a:srgbClr val="28704F"/>
+                </a:solidFill>
+                <a:latin typeface="Liberation Mono"/>
+              </a:rPr>
+              <a:t>"fp4_e2m1"</a:t>
+            </a:r>
+            <a:r>
+              <a:rPr sz="1045">
+                <a:solidFill>
+                  <a:srgbClr val="103552"/>
+                </a:solidFill>
+                <a:latin typeface="Liberation Mono"/>
+              </a:rPr>
+              <a:t>,</a:t>
+            </a:r>
+            <a:r>
+              <a:rPr sz="1045">
+                <a:solidFill>
+                  <a:srgbClr val="6C3D80"/>
+                </a:solidFill>
+                <a:latin typeface="Liberation Mono"/>
+              </a:rPr>
+              <a:t>"pe_mode"</a:t>
+            </a:r>
+            <a:r>
+              <a:rPr sz="1045">
+                <a:solidFill>
+                  <a:srgbClr val="103552"/>
+                </a:solidFill>
+                <a:latin typeface="Liberation Mono"/>
+              </a:rPr>
+              <a:t>:</a:t>
+            </a:r>
+            <a:r>
+              <a:rPr sz="1045">
+                <a:solidFill>
+                  <a:srgbClr val="A44F25"/>
+                </a:solidFill>
+                <a:latin typeface="Liberation Mono"/>
+              </a:rPr>
+              <a:t>0</a:t>
+            </a:r>
+            <a:r>
+              <a:rPr sz="1045">
+                <a:solidFill>
+                  <a:srgbClr val="103552"/>
+                </a:solidFill>
+                <a:latin typeface="Liberation Mono"/>
+              </a:rPr>
+              <a:t>},</a:t>
+            </a:r>
+          </a:p>
+          <a:p>
+            <a:pPr algn="l">
               <a:spcBef>
                 <a:spcPts val="0"/>
               </a:spcBef>
@@ -16844,11 +17060,47 @@
                 </a:solidFill>
                 <a:latin typeface="Liberation Mono"/>
               </a:rPr>
-              <a:t>  {"activation_format":"fp8_e4m3",</a:t>
-            </a:r>
-          </a:p>
-          <a:p>
-            <a:pPr>
+              <a:t>  {</a:t>
+            </a:r>
+            <a:r>
+              <a:rPr sz="1045">
+                <a:solidFill>
+                  <a:srgbClr val="6C3D80"/>
+                </a:solidFill>
+                <a:latin typeface="Liberation Mono"/>
+              </a:rPr>
+              <a:t>"activation_format"</a:t>
+            </a:r>
+            <a:r>
+              <a:rPr sz="1045">
+                <a:solidFill>
+                  <a:srgbClr val="103552"/>
+                </a:solidFill>
+                <a:latin typeface="Liberation Mono"/>
+              </a:rPr>
+              <a:t>:</a:t>
+            </a:r>
+            <a:r>
+              <a:rPr sz="1045">
+                <a:solidFill>
+                  <a:srgbClr val="28704F"/>
+                </a:solidFill>
+                <a:latin typeface="Liberation Mono"/>
+              </a:rPr>
+              <a:t>"fp8_e4m3"</a:t>
+            </a:r>
+            <a:r>
+              <a:rPr sz="1045">
+                <a:solidFill>
+                  <a:srgbClr val="103552"/>
+                </a:solidFill>
+                <a:latin typeface="Liberation Mono"/>
+              </a:rPr>
+              <a:t>,</a:t>
+            </a:r>
+          </a:p>
+          <a:p>
+            <a:pPr algn="l">
               <a:spcBef>
                 <a:spcPts val="0"/>
               </a:spcBef>
@@ -16863,11 +17115,83 @@
                 </a:solidFill>
                 <a:latin typeface="Liberation Mono"/>
               </a:rPr>
-              <a:t>   "weight_format":"fp8_e4m3","pe_mode":8}</a:t>
-            </a:r>
-          </a:p>
-          <a:p>
-            <a:pPr>
+              <a:t>   </a:t>
+            </a:r>
+            <a:r>
+              <a:rPr sz="1045">
+                <a:solidFill>
+                  <a:srgbClr val="6C3D80"/>
+                </a:solidFill>
+                <a:latin typeface="Liberation Mono"/>
+              </a:rPr>
+              <a:t>"weight_format"</a:t>
+            </a:r>
+            <a:r>
+              <a:rPr sz="1045">
+                <a:solidFill>
+                  <a:srgbClr val="103552"/>
+                </a:solidFill>
+                <a:latin typeface="Liberation Mono"/>
+              </a:rPr>
+              <a:t>:</a:t>
+            </a:r>
+            <a:r>
+              <a:rPr sz="1045">
+                <a:solidFill>
+                  <a:srgbClr val="28704F"/>
+                </a:solidFill>
+                <a:latin typeface="Liberation Mono"/>
+              </a:rPr>
+              <a:t>"fp8_e4m3"</a:t>
+            </a:r>
+            <a:r>
+              <a:rPr sz="1045">
+                <a:solidFill>
+                  <a:srgbClr val="103552"/>
+                </a:solidFill>
+                <a:latin typeface="Liberation Mono"/>
+              </a:rPr>
+              <a:t>,</a:t>
+            </a:r>
+            <a:r>
+              <a:rPr sz="1045">
+                <a:solidFill>
+                  <a:srgbClr val="6C3D80"/>
+                </a:solidFill>
+                <a:latin typeface="Liberation Mono"/>
+              </a:rPr>
+              <a:t>"pe_mode"</a:t>
+            </a:r>
+            <a:r>
+              <a:rPr sz="1045">
+                <a:solidFill>
+                  <a:srgbClr val="103552"/>
+                </a:solidFill>
+                <a:latin typeface="Liberation Mono"/>
+              </a:rPr>
+              <a:t>:</a:t>
+            </a:r>
+            <a:r>
+              <a:rPr sz="1045">
+                <a:solidFill>
+                  <a:srgbClr val="A44F25"/>
+                </a:solidFill>
+                <a:latin typeface="Liberation Mono"/>
+              </a:rPr>
+              <a:t>8</a:t>
+            </a:r>
+            <a:r>
+              <a:rPr sz="1045">
+                <a:solidFill>
+                  <a:srgbClr val="103552"/>
+                </a:solidFill>
+                <a:latin typeface="Liberation Mono"/>
+              </a:rPr>
+              <a:t>}</a:t>
+            </a:r>
+          </a:p>
+          <a:p>
+            <a:pPr algn="l">
               <a:spcBef>
                 <a:spcPts val="0"/>
               </a:spcBef>
@@ -16886,7 +17210,7 @@
             </a:r>
           </a:p>
           <a:p>
-            <a:pPr>
+            <a:pPr algn="l">
               <a:spcBef>
                 <a:spcPts val="0"/>
               </a:spcBef>
@@ -16901,11 +17225,65 @@
                 </a:solidFill>
                 <a:latin typeface="Liberation Mono"/>
               </a:rPr>
-              <a:t> "resources": {"scratchpad_bytes":262144,</a:t>
-            </a:r>
-          </a:p>
-          <a:p>
-            <a:pPr>
+              <a:t> </a:t>
+            </a:r>
+            <a:r>
+              <a:rPr sz="1045">
+                <a:solidFill>
+                  <a:srgbClr val="6C3D80"/>
+                </a:solidFill>
+                <a:latin typeface="Liberation Mono"/>
+              </a:rPr>
+              <a:t>"resources"</a:t>
+            </a:r>
+            <a:r>
+              <a:rPr sz="1045">
+                <a:solidFill>
+                  <a:srgbClr val="103552"/>
+                </a:solidFill>
+                <a:latin typeface="Liberation Mono"/>
+              </a:rPr>
+              <a:t>: {</a:t>
+            </a:r>
+            <a:r>
+              <a:rPr sz="1045">
+                <a:solidFill>
+                  <a:srgbClr val="6C3D80"/>
+                </a:solidFill>
+                <a:latin typeface="Liberation Mono"/>
+              </a:rPr>
+              <a:t>"scratchpad_bytes"</a:t>
+            </a:r>
+            <a:r>
+              <a:rPr sz="1045">
+                <a:solidFill>
+                  <a:srgbClr val="103552"/>
+                </a:solidFill>
+                <a:latin typeface="Liberation Mono"/>
+              </a:rPr>
+              <a:t>:</a:t>
+            </a:r>
+            <a:r>
+              <a:rPr sz="1045">
+                <a:solidFill>
+                  <a:srgbClr val="A44F25"/>
+                </a:solidFill>
+                <a:latin typeface="Liberation Mono"/>
+              </a:rPr>
+              <a:t>262144</a:t>
+            </a:r>
+            <a:r>
+              <a:rPr sz="1045">
+                <a:solidFill>
+                  <a:srgbClr val="103552"/>
+                </a:solidFill>
+                <a:latin typeface="Liberation Mono"/>
+              </a:rPr>
+              <a:t>,</a:t>
+            </a:r>
+          </a:p>
+          <a:p>
+            <a:pPr algn="l">
               <a:spcBef>
                 <a:spcPts val="0"/>
               </a:spcBef>
@@ -16920,11 +17298,83 @@
                 </a:solidFill>
                 <a:latin typeface="Liberation Mono"/>
               </a:rPr>
-              <a:t>               "vpu":true,"spad_requant":true}</a:t>
-            </a:r>
-          </a:p>
-          <a:p>
-            <a:pPr>
+              <a:t>               </a:t>
+            </a:r>
+            <a:r>
+              <a:rPr sz="1045">
+                <a:solidFill>
+                  <a:srgbClr val="6C3D80"/>
+                </a:solidFill>
+                <a:latin typeface="Liberation Mono"/>
+              </a:rPr>
+              <a:t>"vpu"</a:t>
+            </a:r>
+            <a:r>
+              <a:rPr sz="1045">
+                <a:solidFill>
+                  <a:srgbClr val="103552"/>
+                </a:solidFill>
+                <a:latin typeface="Liberation Mono"/>
+              </a:rPr>
+              <a:t>:</a:t>
+            </a:r>
+            <a:r>
+              <a:rPr sz="1045">
+                <a:solidFill>
+                  <a:srgbClr val="6C3D80"/>
+                </a:solidFill>
+                <a:latin typeface="Liberation Mono"/>
+              </a:rPr>
+              <a:t>true</a:t>
+            </a:r>
+            <a:r>
+              <a:rPr sz="1045">
+                <a:solidFill>
+                  <a:srgbClr val="103552"/>
+                </a:solidFill>
+                <a:latin typeface="Liberation Mono"/>
+              </a:rPr>
+              <a:t>,</a:t>
+            </a:r>
+            <a:r>
+              <a:rPr sz="1045">
+                <a:solidFill>
+                  <a:srgbClr val="6C3D80"/>
+                </a:solidFill>
+                <a:latin typeface="Liberation Mono"/>
+              </a:rPr>
+              <a:t>"spad_requant"</a:t>
+            </a:r>
+            <a:r>
+              <a:rPr sz="1045">
+                <a:solidFill>
+                  <a:srgbClr val="103552"/>
+                </a:solidFill>
+                <a:latin typeface="Liberation Mono"/>
+              </a:rPr>
+              <a:t>:</a:t>
+            </a:r>
+            <a:r>
+              <a:rPr sz="1045">
+                <a:solidFill>
+                  <a:srgbClr val="6C3D80"/>
+                </a:solidFill>
+                <a:latin typeface="Liberation Mono"/>
+              </a:rPr>
+              <a:t>true</a:t>
+            </a:r>
+            <a:r>
+              <a:rPr sz="1045">
+                <a:solidFill>
+                  <a:srgbClr val="103552"/>
+                </a:solidFill>
+                <a:latin typeface="Liberation Mono"/>
+              </a:rPr>
+              <a:t>}</a:t>
+            </a:r>
+          </a:p>
+          <a:p>
+            <a:pPr algn="l">
               <a:spcBef>
                 <a:spcPts val="0"/>
               </a:spcBef>
@@ -17111,7 +17561,7 @@
           <a:bodyPr rtlCol="0" anchor="t" wrap="none" lIns="109728" tIns="91440" rIns="73152" bIns="36576"/>
           <a:lstStyle/>
           <a:p>
-            <a:pPr algn="ctr">
+            <a:pPr algn="l">
               <a:spcBef>
                 <a:spcPts val="0"/>
               </a:spcBef>
@@ -17122,15 +17572,60 @@
             <a:r>
               <a:rPr sz="1085">
                 <a:solidFill>
+                  <a:srgbClr val="6C3D80"/>
+                </a:solidFill>
+                <a:latin typeface="Liberation Mono"/>
+              </a:rPr>
+              <a:t>before</a:t>
+            </a:r>
+            <a:r>
+              <a:rPr sz="1085">
+                <a:solidFill>
                   <a:srgbClr val="103552"/>
                 </a:solidFill>
                 <a:latin typeface="Liberation Mono"/>
               </a:rPr>
-              <a:t>before: contract {format = "mxfp4"}</a:t>
-            </a:r>
-          </a:p>
-          <a:p>
-            <a:pPr>
+              <a:t>: </a:t>
+            </a:r>
+            <a:r>
+              <a:rPr sz="1085">
+                <a:solidFill>
+                  <a:srgbClr val="6C3D80"/>
+                </a:solidFill>
+                <a:latin typeface="Liberation Mono"/>
+              </a:rPr>
+              <a:t>contract</a:t>
+            </a:r>
+            <a:r>
+              <a:rPr sz="1085">
+                <a:solidFill>
+                  <a:srgbClr val="103552"/>
+                </a:solidFill>
+                <a:latin typeface="Liberation Mono"/>
+              </a:rPr>
+              <a:t> {format = </a:t>
+            </a:r>
+            <a:r>
+              <a:rPr sz="1085">
+                <a:solidFill>
+                  <a:srgbClr val="28704F"/>
+                </a:solidFill>
+                <a:latin typeface="Liberation Mono"/>
+              </a:rPr>
+              <a:t>"mxfp4"</a:t>
+            </a:r>
+            <a:r>
+              <a:rPr sz="1085">
+                <a:solidFill>
+                  <a:srgbClr val="103552"/>
+                </a:solidFill>
+                <a:latin typeface="Liberation Mono"/>
+              </a:rPr>
+              <a:t>}</a:t>
+            </a:r>
+          </a:p>
+          <a:p>
+            <a:pPr algn="l">
               <a:spcBef>
                 <a:spcPts val="0"/>
               </a:spcBef>
@@ -17141,15 +17636,42 @@
             <a:r>
               <a:rPr sz="1085">
                 <a:solidFill>
+                  <a:srgbClr val="6C3D80"/>
+                </a:solidFill>
+                <a:latin typeface="Liberation Mono"/>
+              </a:rPr>
+              <a:t>after</a:t>
+            </a:r>
+            <a:r>
+              <a:rPr sz="1085">
+                <a:solidFill>
                   <a:srgbClr val="103552"/>
                 </a:solidFill>
                 <a:latin typeface="Liberation Mono"/>
               </a:rPr>
-              <a:t>after:  contract {</a:t>
-            </a:r>
-          </a:p>
-          <a:p>
-            <a:pPr>
+              <a:t>:  </a:t>
+            </a:r>
+            <a:r>
+              <a:rPr sz="1085">
+                <a:solidFill>
+                  <a:srgbClr val="6C3D80"/>
+                </a:solidFill>
+                <a:latin typeface="Liberation Mono"/>
+              </a:rPr>
+              <a:t>contract</a:t>
+            </a:r>
+            <a:r>
+              <a:rPr sz="1085">
+                <a:solidFill>
+                  <a:srgbClr val="103552"/>
+                </a:solidFill>
+                <a:latin typeface="Liberation Mono"/>
+              </a:rPr>
+              <a:t> {</a:t>
+            </a:r>
+          </a:p>
+          <a:p>
+            <a:pPr algn="l">
               <a:spcBef>
                 <a:spcPts val="0"/>
               </a:spcBef>
@@ -17164,11 +17686,47 @@
                 </a:solidFill>
                 <a:latin typeface="Liberation Mono"/>
               </a:rPr>
-              <a:t>  activation_format = "fp4_e2m1",</a:t>
-            </a:r>
-          </a:p>
-          <a:p>
-            <a:pPr>
+              <a:t>  </a:t>
+            </a:r>
+            <a:r>
+              <a:rPr sz="1085">
+                <a:solidFill>
+                  <a:srgbClr val="6C3D80"/>
+                </a:solidFill>
+                <a:latin typeface="Liberation Mono"/>
+              </a:rPr>
+              <a:t>activation_format</a:t>
+            </a:r>
+            <a:r>
+              <a:rPr sz="1085">
+                <a:solidFill>
+                  <a:srgbClr val="103552"/>
+                </a:solidFill>
+                <a:latin typeface="Liberation Mono"/>
+              </a:rPr>
+              <a:t> = </a:t>
+            </a:r>
+            <a:r>
+              <a:rPr sz="1085">
+                <a:solidFill>
+                  <a:srgbClr val="28704F"/>
+                </a:solidFill>
+                <a:latin typeface="Liberation Mono"/>
+              </a:rPr>
+              <a:t>"fp4_e2m1"</a:t>
+            </a:r>
+            <a:r>
+              <a:rPr sz="1085">
+                <a:solidFill>
+                  <a:srgbClr val="103552"/>
+                </a:solidFill>
+                <a:latin typeface="Liberation Mono"/>
+              </a:rPr>
+              <a:t>,</a:t>
+            </a:r>
+          </a:p>
+          <a:p>
+            <a:pPr algn="l">
               <a:spcBef>
                 <a:spcPts val="0"/>
               </a:spcBef>
@@ -17183,11 +17741,47 @@
                 </a:solidFill>
                 <a:latin typeface="Liberation Mono"/>
               </a:rPr>
-              <a:t>  weight_format = "fp4_e2m1",</a:t>
-            </a:r>
-          </a:p>
-          <a:p>
-            <a:pPr>
+              <a:t>  </a:t>
+            </a:r>
+            <a:r>
+              <a:rPr sz="1085">
+                <a:solidFill>
+                  <a:srgbClr val="6C3D80"/>
+                </a:solidFill>
+                <a:latin typeface="Liberation Mono"/>
+              </a:rPr>
+              <a:t>weight_format</a:t>
+            </a:r>
+            <a:r>
+              <a:rPr sz="1085">
+                <a:solidFill>
+                  <a:srgbClr val="103552"/>
+                </a:solidFill>
+                <a:latin typeface="Liberation Mono"/>
+              </a:rPr>
+              <a:t> = </a:t>
+            </a:r>
+            <a:r>
+              <a:rPr sz="1085">
+                <a:solidFill>
+                  <a:srgbClr val="28704F"/>
+                </a:solidFill>
+                <a:latin typeface="Liberation Mono"/>
+              </a:rPr>
+              <a:t>"fp4_e2m1"</a:t>
+            </a:r>
+            <a:r>
+              <a:rPr sz="1085">
+                <a:solidFill>
+                  <a:srgbClr val="103552"/>
+                </a:solidFill>
+                <a:latin typeface="Liberation Mono"/>
+              </a:rPr>
+              <a:t>,</a:t>
+            </a:r>
+          </a:p>
+          <a:p>
+            <a:pPr algn="l">
               <a:spcBef>
                 <a:spcPts val="0"/>
               </a:spcBef>
@@ -17202,11 +17796,47 @@
                 </a:solidFill>
                 <a:latin typeface="Liberation Mono"/>
               </a:rPr>
-              <a:t>  pe_mode = 0 : i32,</a:t>
-            </a:r>
-          </a:p>
-          <a:p>
-            <a:pPr>
+              <a:t>  </a:t>
+            </a:r>
+            <a:r>
+              <a:rPr sz="1085">
+                <a:solidFill>
+                  <a:srgbClr val="6C3D80"/>
+                </a:solidFill>
+                <a:latin typeface="Liberation Mono"/>
+              </a:rPr>
+              <a:t>pe_mode</a:t>
+            </a:r>
+            <a:r>
+              <a:rPr sz="1085">
+                <a:solidFill>
+                  <a:srgbClr val="103552"/>
+                </a:solidFill>
+                <a:latin typeface="Liberation Mono"/>
+              </a:rPr>
+              <a:t> = </a:t>
+            </a:r>
+            <a:r>
+              <a:rPr sz="1085">
+                <a:solidFill>
+                  <a:srgbClr val="A44F25"/>
+                </a:solidFill>
+                <a:latin typeface="Liberation Mono"/>
+              </a:rPr>
+              <a:t>0</a:t>
+            </a:r>
+            <a:r>
+              <a:rPr sz="1085">
+                <a:solidFill>
+                  <a:srgbClr val="103552"/>
+                </a:solidFill>
+                <a:latin typeface="Liberation Mono"/>
+              </a:rPr>
+              <a:t> : i32,</a:t>
+            </a:r>
+          </a:p>
+          <a:p>
+            <a:pPr algn="l">
               <a:spcBef>
                 <a:spcPts val="0"/>
               </a:spcBef>
@@ -17221,7 +17851,43 @@
                 </a:solidFill>
                 <a:latin typeface="Liberation Mono"/>
               </a:rPr>
-              <a:t>  profile_sha256 = "e9e33f..." }</a:t>
+              <a:t>  </a:t>
+            </a:r>
+            <a:r>
+              <a:rPr sz="1085">
+                <a:solidFill>
+                  <a:srgbClr val="6C3D80"/>
+                </a:solidFill>
+                <a:latin typeface="Liberation Mono"/>
+              </a:rPr>
+              <a:t>profile_sha256</a:t>
+            </a:r>
+            <a:r>
+              <a:rPr sz="1085">
+                <a:solidFill>
+                  <a:srgbClr val="103552"/>
+                </a:solidFill>
+                <a:latin typeface="Liberation Mono"/>
+              </a:rPr>
+              <a:t> = </a:t>
+            </a:r>
+            <a:r>
+              <a:rPr sz="1085">
+                <a:solidFill>
+                  <a:srgbClr val="28704F"/>
+                </a:solidFill>
+                <a:latin typeface="Liberation Mono"/>
+              </a:rPr>
+              <a:t>"e9e33f..."</a:t>
+            </a:r>
+            <a:r>
+              <a:rPr sz="1085">
+                <a:solidFill>
+                  <a:srgbClr val="103552"/>
+                </a:solidFill>
+                <a:latin typeface="Liberation Mono"/>
+              </a:rPr>
+              <a:t> }</a:t>
             </a:r>
           </a:p>
         </p:txBody>
@@ -17696,7 +18362,7 @@
           <a:bodyPr rtlCol="0" anchor="t" wrap="none" lIns="109728" tIns="91440" rIns="73152" bIns="36576"/>
           <a:lstStyle/>
           <a:p>
-            <a:pPr algn="ctr">
+            <a:pPr algn="l">
               <a:spcBef>
                 <a:spcPts val="0"/>
               </a:spcBef>
@@ -17707,15 +18373,114 @@
             <a:r>
               <a:rPr sz="1110">
                 <a:solidFill>
+                  <a:srgbClr val="006874"/>
+                </a:solidFill>
+                <a:latin typeface="Liberation Mono"/>
+              </a:rPr>
+              <a:t>%acc</a:t>
+            </a:r>
+            <a:r>
+              <a:rPr sz="1110">
+                <a:solidFill>
                   <a:srgbClr val="103552"/>
                 </a:solidFill>
                 <a:latin typeface="Liberation Mono"/>
               </a:rPr>
-              <a:t>%acc = "mx_gemmini.contract"(%A,%As,%B,%Bs) {</a:t>
-            </a:r>
-          </a:p>
-          <a:p>
-            <a:pPr>
+              <a:t> = </a:t>
+            </a:r>
+            <a:r>
+              <a:rPr sz="1110">
+                <a:solidFill>
+                  <a:srgbClr val="6C3D80"/>
+                </a:solidFill>
+                <a:latin typeface="Liberation Mono"/>
+              </a:rPr>
+              <a:t>"mx_gemmini.contract"</a:t>
+            </a:r>
+            <a:r>
+              <a:rPr sz="1110">
+                <a:solidFill>
+                  <a:srgbClr val="103552"/>
+                </a:solidFill>
+                <a:latin typeface="Liberation Mono"/>
+              </a:rPr>
+              <a:t>(</a:t>
+            </a:r>
+            <a:r>
+              <a:rPr sz="1110">
+                <a:solidFill>
+                  <a:srgbClr val="006874"/>
+                </a:solidFill>
+                <a:latin typeface="Liberation Mono"/>
+              </a:rPr>
+              <a:t>%A</a:t>
+            </a:r>
+            <a:r>
+              <a:rPr sz="1110">
+                <a:solidFill>
+                  <a:srgbClr val="103552"/>
+                </a:solidFill>
+                <a:latin typeface="Liberation Mono"/>
+              </a:rPr>
+              <a:t>,</a:t>
+            </a:r>
+            <a:r>
+              <a:rPr sz="1110">
+                <a:solidFill>
+                  <a:srgbClr val="006874"/>
+                </a:solidFill>
+                <a:latin typeface="Liberation Mono"/>
+              </a:rPr>
+              <a:t>%As</a:t>
+            </a:r>
+            <a:r>
+              <a:rPr sz="1110">
+                <a:solidFill>
+                  <a:srgbClr val="103552"/>
+                </a:solidFill>
+                <a:latin typeface="Liberation Mono"/>
+              </a:rPr>
+              <a:t>,</a:t>
+            </a:r>
+            <a:r>
+              <a:rPr sz="1110">
+                <a:solidFill>
+                  <a:srgbClr val="006874"/>
+                </a:solidFill>
+                <a:latin typeface="Liberation Mono"/>
+              </a:rPr>
+              <a:t>%B</a:t>
+            </a:r>
+            <a:r>
+              <a:rPr sz="1110">
+                <a:solidFill>
+                  <a:srgbClr val="103552"/>
+                </a:solidFill>
+                <a:latin typeface="Liberation Mono"/>
+              </a:rPr>
+              <a:t>,</a:t>
+            </a:r>
+            <a:r>
+              <a:rPr sz="1110">
+                <a:solidFill>
+                  <a:srgbClr val="006874"/>
+                </a:solidFill>
+                <a:latin typeface="Liberation Mono"/>
+              </a:rPr>
+              <a:t>%Bs</a:t>
+            </a:r>
+            <a:r>
+              <a:rPr sz="1110">
+                <a:solidFill>
+                  <a:srgbClr val="103552"/>
+                </a:solidFill>
+                <a:latin typeface="Liberation Mono"/>
+              </a:rPr>
+              <a:t>) {</a:t>
+            </a:r>
+          </a:p>
+          <a:p>
+            <a:pPr algn="l">
               <a:spcBef>
                 <a:spcPts val="0"/>
               </a:spcBef>
@@ -17730,11 +18495,47 @@
                 </a:solidFill>
                 <a:latin typeface="Liberation Mono"/>
               </a:rPr>
-              <a:t>  activation_format = "fp4_e2m1",</a:t>
-            </a:r>
-          </a:p>
-          <a:p>
-            <a:pPr>
+              <a:t>  </a:t>
+            </a:r>
+            <a:r>
+              <a:rPr sz="1110">
+                <a:solidFill>
+                  <a:srgbClr val="6C3D80"/>
+                </a:solidFill>
+                <a:latin typeface="Liberation Mono"/>
+              </a:rPr>
+              <a:t>activation_format</a:t>
+            </a:r>
+            <a:r>
+              <a:rPr sz="1110">
+                <a:solidFill>
+                  <a:srgbClr val="103552"/>
+                </a:solidFill>
+                <a:latin typeface="Liberation Mono"/>
+              </a:rPr>
+              <a:t> = </a:t>
+            </a:r>
+            <a:r>
+              <a:rPr sz="1110">
+                <a:solidFill>
+                  <a:srgbClr val="28704F"/>
+                </a:solidFill>
+                <a:latin typeface="Liberation Mono"/>
+              </a:rPr>
+              <a:t>"fp4_e2m1"</a:t>
+            </a:r>
+            <a:r>
+              <a:rPr sz="1110">
+                <a:solidFill>
+                  <a:srgbClr val="103552"/>
+                </a:solidFill>
+                <a:latin typeface="Liberation Mono"/>
+              </a:rPr>
+              <a:t>,</a:t>
+            </a:r>
+          </a:p>
+          <a:p>
+            <a:pPr algn="l">
               <a:spcBef>
                 <a:spcPts val="0"/>
               </a:spcBef>
@@ -17749,11 +18550,83 @@
                 </a:solidFill>
                 <a:latin typeface="Liberation Mono"/>
               </a:rPr>
-              <a:t>  weight_format = "fp4_e2m1", pe_mode = 0 : i32 }</a:t>
-            </a:r>
-          </a:p>
-          <a:p>
-            <a:pPr>
+              <a:t>  </a:t>
+            </a:r>
+            <a:r>
+              <a:rPr sz="1110">
+                <a:solidFill>
+                  <a:srgbClr val="6C3D80"/>
+                </a:solidFill>
+                <a:latin typeface="Liberation Mono"/>
+              </a:rPr>
+              <a:t>weight_format</a:t>
+            </a:r>
+            <a:r>
+              <a:rPr sz="1110">
+                <a:solidFill>
+                  <a:srgbClr val="103552"/>
+                </a:solidFill>
+                <a:latin typeface="Liberation Mono"/>
+              </a:rPr>
+              <a:t> = </a:t>
+            </a:r>
+            <a:r>
+              <a:rPr sz="1110">
+                <a:solidFill>
+                  <a:srgbClr val="28704F"/>
+                </a:solidFill>
+                <a:latin typeface="Liberation Mono"/>
+              </a:rPr>
+              <a:t>"fp4_e2m1"</a:t>
+            </a:r>
+            <a:r>
+              <a:rPr sz="1110">
+                <a:solidFill>
+                  <a:srgbClr val="103552"/>
+                </a:solidFill>
+                <a:latin typeface="Liberation Mono"/>
+              </a:rPr>
+              <a:t>, </a:t>
+            </a:r>
+            <a:r>
+              <a:rPr sz="1110">
+                <a:solidFill>
+                  <a:srgbClr val="6C3D80"/>
+                </a:solidFill>
+                <a:latin typeface="Liberation Mono"/>
+              </a:rPr>
+              <a:t>pe_mode</a:t>
+            </a:r>
+            <a:r>
+              <a:rPr sz="1110">
+                <a:solidFill>
+                  <a:srgbClr val="103552"/>
+                </a:solidFill>
+                <a:latin typeface="Liberation Mono"/>
+              </a:rPr>
+              <a:t> = </a:t>
+            </a:r>
+            <a:r>
+              <a:rPr sz="1110">
+                <a:solidFill>
+                  <a:srgbClr val="A44F25"/>
+                </a:solidFill>
+                <a:latin typeface="Liberation Mono"/>
+              </a:rPr>
+              <a:t>0</a:t>
+            </a:r>
+            <a:r>
+              <a:rPr sz="1110">
+                <a:solidFill>
+                  <a:srgbClr val="103552"/>
+                </a:solidFill>
+                <a:latin typeface="Liberation Mono"/>
+              </a:rPr>
+              <a:t> : i32 }</a:t>
+            </a:r>
+          </a:p>
+          <a:p>
+            <a:pPr algn="l">
               <a:spcBef>
                 <a:spcPts val="0"/>
               </a:spcBef>
@@ -17764,11 +18637,56 @@
             <a:r>
               <a:rPr sz="1110">
                 <a:solidFill>
+                  <a:srgbClr val="006874"/>
+                </a:solidFill>
+                <a:latin typeface="Liberation Mono"/>
+              </a:rPr>
+              <a:t>%out</a:t>
+            </a:r>
+            <a:r>
+              <a:rPr sz="1110">
+                <a:solidFill>
                   <a:srgbClr val="103552"/>
                 </a:solidFill>
                 <a:latin typeface="Liberation Mono"/>
               </a:rPr>
-              <a:t>%out = "mx_gemmini.readout_bf16"(%acc)</a:t>
+              <a:t> = </a:t>
+            </a:r>
+            <a:r>
+              <a:rPr sz="1110">
+                <a:solidFill>
+                  <a:srgbClr val="6C3D80"/>
+                </a:solidFill>
+                <a:latin typeface="Liberation Mono"/>
+              </a:rPr>
+              <a:t>"mx_gemmini.readout_bf16"</a:t>
+            </a:r>
+            <a:r>
+              <a:rPr sz="1110">
+                <a:solidFill>
+                  <a:srgbClr val="103552"/>
+                </a:solidFill>
+                <a:latin typeface="Liberation Mono"/>
+              </a:rPr>
+              <a:t>(</a:t>
+            </a:r>
+            <a:r>
+              <a:rPr sz="1110">
+                <a:solidFill>
+                  <a:srgbClr val="006874"/>
+                </a:solidFill>
+                <a:latin typeface="Liberation Mono"/>
+              </a:rPr>
+              <a:t>%acc</a:t>
+            </a:r>
+            <a:r>
+              <a:rPr sz="1110">
+                <a:solidFill>
+                  <a:srgbClr val="103552"/>
+                </a:solidFill>
+                <a:latin typeface="Liberation Mono"/>
+              </a:rPr>
+              <a:t>)</a:t>
             </a:r>
           </a:p>
         </p:txBody>
@@ -17898,7 +18816,7 @@
           <a:bodyPr rtlCol="0" anchor="t" wrap="none" lIns="109728" tIns="91440" rIns="73152" bIns="36576"/>
           <a:lstStyle/>
           <a:p>
-            <a:pPr algn="ctr">
+            <a:pPr algn="l">
               <a:spcBef>
                 <a:spcPts val="0"/>
               </a:spcBef>
@@ -17909,15 +18827,42 @@
             <a:r>
               <a:rPr sz="1030">
                 <a:solidFill>
+                  <a:srgbClr val="6C3D80"/>
+                </a:solidFill>
+                <a:latin typeface="Liberation Mono"/>
+              </a:rPr>
+              <a:t>__asm__</a:t>
+            </a:r>
+            <a:r>
+              <a:rPr sz="1030">
+                <a:solidFill>
                   <a:srgbClr val="103552"/>
                 </a:solidFill>
                 <a:latin typeface="Liberation Mono"/>
               </a:rPr>
-              <a:t>__asm__ volatile(</a:t>
-            </a:r>
-          </a:p>
-          <a:p>
-            <a:pPr>
+              <a:t> </a:t>
+            </a:r>
+            <a:r>
+              <a:rPr sz="1030">
+                <a:solidFill>
+                  <a:srgbClr val="6C3D80"/>
+                </a:solidFill>
+                <a:latin typeface="Liberation Mono"/>
+              </a:rPr>
+              <a:t>volatile</a:t>
+            </a:r>
+            <a:r>
+              <a:rPr sz="1030">
+                <a:solidFill>
+                  <a:srgbClr val="103552"/>
+                </a:solidFill>
+                <a:latin typeface="Liberation Mono"/>
+              </a:rPr>
+              <a:t>(</a:t>
+            </a:r>
+          </a:p>
+          <a:p>
+            <a:pPr algn="l">
               <a:spcBef>
                 <a:spcPts val="0"/>
               </a:spcBef>
@@ -17932,11 +18877,20 @@
                 </a:solidFill>
                 <a:latin typeface="Liberation Mono"/>
               </a:rPr>
-              <a:t>  ".insn r 0x7b, 3, 2, x0, %0, %1"</a:t>
-            </a:r>
-          </a:p>
-          <a:p>
-            <a:pPr>
+              <a:t>  </a:t>
+            </a:r>
+            <a:r>
+              <a:rPr sz="1030">
+                <a:solidFill>
+                  <a:srgbClr val="28704F"/>
+                </a:solidFill>
+                <a:latin typeface="Liberation Mono"/>
+              </a:rPr>
+              <a:t>".insn r 0x7b, 3, 2, x0, %0, %1"</a:t>
+            </a:r>
+          </a:p>
+          <a:p>
+            <a:pPr algn="l">
               <a:spcBef>
                 <a:spcPts val="0"/>
               </a:spcBef>
@@ -17951,11 +18905,29 @@
                 </a:solidFill>
                 <a:latin typeface="Liberation Mono"/>
               </a:rPr>
-              <a:t>  : : "r"(Q_IN),</a:t>
-            </a:r>
-          </a:p>
-          <a:p>
-            <a:pPr>
+              <a:t>  : : </a:t>
+            </a:r>
+            <a:r>
+              <a:rPr sz="1030">
+                <a:solidFill>
+                  <a:srgbClr val="28704F"/>
+                </a:solidFill>
+                <a:latin typeface="Liberation Mono"/>
+              </a:rPr>
+              <a:t>"r"</a:t>
+            </a:r>
+            <a:r>
+              <a:rPr sz="1030">
+                <a:solidFill>
+                  <a:srgbClr val="103552"/>
+                </a:solidFill>
+                <a:latin typeface="Liberation Mono"/>
+              </a:rPr>
+              <a:t>(Q_IN),</a:t>
+            </a:r>
+          </a:p>
+          <a:p>
+            <a:pPr algn="l">
               <a:spcBef>
                 <a:spcPts val="0"/>
               </a:spcBef>
@@ -17970,11 +18942,47 @@
                 </a:solidFill>
                 <a:latin typeface="Liberation Mono"/>
               </a:rPr>
-              <a:t>      "r"(0x0010001000000000));</a:t>
-            </a:r>
-          </a:p>
-          <a:p>
-            <a:pPr>
+              <a:t>      </a:t>
+            </a:r>
+            <a:r>
+              <a:rPr sz="1030">
+                <a:solidFill>
+                  <a:srgbClr val="28704F"/>
+                </a:solidFill>
+                <a:latin typeface="Liberation Mono"/>
+              </a:rPr>
+              <a:t>"r"</a:t>
+            </a:r>
+            <a:r>
+              <a:rPr sz="1030">
+                <a:solidFill>
+                  <a:srgbClr val="103552"/>
+                </a:solidFill>
+                <a:latin typeface="Liberation Mono"/>
+              </a:rPr>
+              <a:t>(</a:t>
+            </a:r>
+            <a:r>
+              <a:rPr sz="1030">
+                <a:solidFill>
+                  <a:srgbClr val="A44F25"/>
+                </a:solidFill>
+                <a:latin typeface="Liberation Mono"/>
+              </a:rPr>
+              <a:t>0x0010001000000000</a:t>
+            </a:r>
+            <a:r>
+              <a:rPr sz="1030">
+                <a:solidFill>
+                  <a:srgbClr val="103552"/>
+                </a:solidFill>
+                <a:latin typeface="Liberation Mono"/>
+              </a:rPr>
+              <a:t>));</a:t>
+            </a:r>
+          </a:p>
+          <a:p>
+            <a:pPr algn="l">
               <a:spcBef>
                 <a:spcPts val="0"/>
               </a:spcBef>
@@ -17985,11 +18993,47 @@
             <a:r>
               <a:rPr sz="1030">
                 <a:solidFill>
+                  <a:srgbClr val="6C3D80"/>
+                </a:solidFill>
+                <a:latin typeface="Liberation Mono"/>
+              </a:rPr>
+              <a:t>objdump</a:t>
+            </a:r>
+            <a:r>
+              <a:rPr sz="1030">
+                <a:solidFill>
                   <a:srgbClr val="103552"/>
                 </a:solidFill>
                 <a:latin typeface="Liberation Mono"/>
               </a:rPr>
-              <a:t>objdump: 4a: 04b6b07b  .insn 4, 0x04b6b07b</a:t>
+              <a:t>: 4a: 04b6b07b  .insn </a:t>
+            </a:r>
+            <a:r>
+              <a:rPr sz="1030">
+                <a:solidFill>
+                  <a:srgbClr val="A44F25"/>
+                </a:solidFill>
+                <a:latin typeface="Liberation Mono"/>
+              </a:rPr>
+              <a:t>4</a:t>
+            </a:r>
+            <a:r>
+              <a:rPr sz="1030">
+                <a:solidFill>
+                  <a:srgbClr val="103552"/>
+                </a:solidFill>
+                <a:latin typeface="Liberation Mono"/>
+              </a:rPr>
+              <a:t>, </a:t>
+            </a:r>
+            <a:r>
+              <a:rPr sz="1030">
+                <a:solidFill>
+                  <a:srgbClr val="A44F25"/>
+                </a:solidFill>
+                <a:latin typeface="Liberation Mono"/>
+              </a:rPr>
+              <a:t>0x04b6b07b</a:t>
             </a:r>
           </a:p>
         </p:txBody>
@@ -18536,7 +19580,7 @@
                 </a:solidFill>
                 <a:latin typeface="Inter"/>
               </a:rPr>
-              <a:t>loop and tiles</a:t>
+              <a:t>loop policy</a:t>
             </a:r>
           </a:p>
         </p:txBody>
@@ -18988,7 +20032,7 @@
                 </a:solidFill>
                 <a:latin typeface="Inter"/>
               </a:rPr>
-              <a:t>MX+VPU Spike cycle results</a:t>
+              <a:t>Spike cycles by comparison scope</a:t>
             </a:r>
           </a:p>
         </p:txBody>
@@ -19032,13 +20076,13 @@
                         </a:spcAft>
                       </a:pPr>
                       <a:r>
-                        <a:rPr sz="1180" b="1">
+                        <a:rPr sz="1120" b="1">
                           <a:solidFill>
                             <a:srgbClr val="FFFFFF"/>
                           </a:solidFill>
                           <a:latin typeface="Inter"/>
                         </a:rPr>
-                        <a:t>Workload / scope</a:t>
+                        <a:t>Workload / compared code</a:t>
                       </a:r>
                     </a:p>
                   </a:txBody>
@@ -19082,7 +20126,7 @@
                         </a:spcAft>
                       </a:pPr>
                       <a:r>
-                        <a:rPr sz="1180" b="1">
+                        <a:rPr sz="1120" b="1">
                           <a:solidFill>
                             <a:srgbClr val="FFFFFF"/>
                           </a:solidFill>
@@ -19132,13 +20176,13 @@
                         </a:spcAft>
                       </a:pPr>
                       <a:r>
-                        <a:rPr sz="1180" b="1">
+                        <a:rPr sz="1120" b="1">
                           <a:solidFill>
                             <a:srgbClr val="FFFFFF"/>
                           </a:solidFill>
                           <a:latin typeface="Inter"/>
                         </a:rPr>
-                        <a:t>Nicolas cycles</a:t>
+                        <a:t>Nicolas path cycles</a:t>
                       </a:r>
                     </a:p>
                   </a:txBody>
@@ -19182,7 +20226,7 @@
                         </a:spcAft>
                       </a:pPr>
                       <a:r>
-                        <a:rPr sz="1180" b="1">
+                        <a:rPr sz="1120" b="1">
                           <a:solidFill>
                             <a:srgbClr val="FFFFFF"/>
                           </a:solidFill>
@@ -19240,7 +20284,7 @@
                           </a:solidFill>
                           <a:latin typeface="Inter"/>
                         </a:rPr>
-                        <a:t>SmolVLA · full 12-step session</a:t>
+                        <a:t>SmolVLA full 12 steps · issuer swap</a:t>
                       </a:r>
                     </a:p>
                   </a:txBody>
@@ -19442,7 +20486,7 @@
                           </a:solidFill>
                           <a:latin typeface="Inter"/>
                         </a:rPr>
-                        <a:t>TinyLlama · full 33-step session</a:t>
+                        <a:t>TinyLlama full 33 steps · issuer swap</a:t>
                       </a:r>
                     </a:p>
                   </a:txBody>
@@ -19644,7 +20688,7 @@
                           </a:solidFill>
                           <a:latin typeface="Inter"/>
                         </a:rPr>
-                        <a:t>SmolVLA flow · one step</a:t>
+                        <a:t>SmolVLA flow 1 step · issuer swap</a:t>
                       </a:r>
                     </a:p>
                   </a:txBody>
@@ -19846,7 +20890,7 @@
                           </a:solidFill>
                           <a:latin typeface="Inter"/>
                         </a:rPr>
-                        <a:t>Dense attention 64×256×128</a:t>
+                        <a:t>Dense attention 64×256×128 · fused source</a:t>
                       </a:r>
                     </a:p>
                   </a:txBody>
@@ -20072,7 +21116,7 @@
                 </a:solidFill>
                 <a:latin typeface="Inter"/>
               </a:rPr>
-              <a:t>* Full-session output hashes match: SmolVLA 33/33, TinyLlama 99/99. Independent quantized accuracy remains open.</a:t>
+              <a:t>* Output hashes match: SmolVLA 33/33; TinyLlama 99/99. This checks the captured outputs, not model accuracy.</a:t>
             </a:r>
           </a:p>
           <a:p>
@@ -20091,7 +21135,7 @@
                 </a:solidFill>
                 <a:latin typeface="Inter"/>
               </a:rPr>
-              <a:t>Nicolas e4m3_vpu Spike, host tracking off. Paired flow/attention outputs also match.</a:t>
+              <a:t>Nicolas e4m3_vpu Spike, host tracking off. The dense attention row compares one fused kernel, not a whole model.</a:t>
             </a:r>
           </a:p>
         </p:txBody>
@@ -20144,13 +21188,32 @@
               </a:spcAft>
             </a:pPr>
             <a:r>
-              <a:rPr sz="1150" b="1">
+              <a:rPr sz="1060" b="1">
                 <a:solidFill>
                   <a:srgbClr val="103552"/>
                 </a:solidFill>
                 <a:latin typeface="Inter"/>
               </a:rPr>
-              <a:t>Full-model source variants replace two MX issuer catalogs; host graph and VPU stay fixed. A matched fused handwritten whole-model baseline is unmeasured.</a:t>
+              <a:t>Full-model rows change only the MX matrix command code. Both runs use the same Merlin host and VPU code.</a:t>
+            </a:r>
+          </a:p>
+          <a:p>
+            <a:pPr algn="ctr">
+              <a:spcBef>
+                <a:spcPts val="0"/>
+              </a:spcBef>
+              <a:spcAft>
+                <a:spcPts val="0"/>
+              </a:spcAft>
+            </a:pPr>
+            <a:r>
+              <a:rPr sz="1060" b="1">
+                <a:solidFill>
+                  <a:srgbClr val="103552"/>
+                </a:solidFill>
+                <a:latin typeface="Inter"/>
+              </a:rPr>
+              <a:t>Nicolas's fused MX+VPU kernels have not yet been stitched and timed as either complete model.</a:t>
             </a:r>
           </a:p>
         </p:txBody>

</xml_diff>

<commit_message>
Clarify issuer comparison in slides
</commit_message>
<xml_diff>
--- a/docs/presentations/mx_gemmini_dialect_overview.pptx
+++ b/docs/presentations/mx_gemmini_dialect_overview.pptx
@@ -21194,7 +21194,7 @@
                 </a:solidFill>
                 <a:latin typeface="Inter"/>
               </a:rPr>
-              <a:t>Full-model rows change only the MX matrix command code. Both runs use the same Merlin host and VPU code.</a:t>
+              <a:t>Full-model rows swap MX issuers inside the same Merlin host/VPU program; small cycle gaps are expected.</a:t>
             </a:r>
           </a:p>
           <a:p>
@@ -21213,7 +21213,7 @@
                 </a:solidFill>
                 <a:latin typeface="Inter"/>
               </a:rPr>
-              <a:t>Nicolas's fused MX+VPU kernels have not yet been stitched and timed as either complete model.</a:t>
+              <a:t>Nicolas's fused MX+VPU kernels have not yet been stitched and timed as complete models.</a:t>
             </a:r>
           </a:p>
         </p:txBody>

</xml_diff>

<commit_message>
Separate unpaired layer results on slide
</commit_message>
<xml_diff>
--- a/docs/presentations/mx_gemmini_dialect_overview.pptx
+++ b/docs/presentations/mx_gemmini_dialect_overview.pptx
@@ -20032,7 +20032,7 @@
                 </a:solidFill>
                 <a:latin typeface="Inter"/>
               </a:rPr>
-              <a:t>Spike cycles by comparison scope</a:t>
+              <a:t>Spike results by measurement scope</a:t>
             </a:r>
           </a:p>
         </p:txBody>
@@ -20682,13 +20682,13 @@
                         </a:spcAft>
                       </a:pPr>
                       <a:r>
-                        <a:rPr sz="1240" b="0">
+                        <a:rPr sz="1240" b="1">
                           <a:solidFill>
                             <a:srgbClr val="313455"/>
                           </a:solidFill>
                           <a:latin typeface="Inter"/>
                         </a:rPr>
-                        <a:t>SmolVLA flow 1 step · issuer swap</a:t>
+                        <a:t>TinyLlama cached layer · unpaired</a:t>
                       </a:r>
                     </a:p>
                   </a:txBody>
@@ -20738,7 +20738,7 @@
                           </a:solidFill>
                           <a:latin typeface="Inter"/>
                         </a:rPr>
-                        <a:t>2,112,653,481</a:t>
+                        <a:t>268,345,341†</a:t>
                       </a:r>
                     </a:p>
                   </a:txBody>
@@ -20788,7 +20788,7 @@
                           </a:solidFill>
                           <a:latin typeface="Inter"/>
                         </a:rPr>
-                        <a:t>2,112,919,925</a:t>
+                        <a:t>582,204†</a:t>
                       </a:r>
                     </a:p>
                   </a:txBody>
@@ -20838,7 +20838,7 @@
                           </a:solidFill>
                           <a:latin typeface="Inter"/>
                         </a:rPr>
-                        <a:t>−0.0126%</a:t>
+                        <a:t>NO RATIO</a:t>
                       </a:r>
                     </a:p>
                   </a:txBody>
@@ -21116,7 +21116,7 @@
                 </a:solidFill>
                 <a:latin typeface="Inter"/>
               </a:rPr>
-              <a:t>* Output hashes match: SmolVLA 33/33; TinyLlama 99/99. This checks the captured outputs, not model accuracy.</a:t>
+              <a:t>* Issuer-swap output hashes match: SmolVLA 33/33; TinyLlama 99/99. This is not an independent model accuracy check.</a:t>
             </a:r>
           </a:p>
           <a:p>
@@ -21135,7 +21135,7 @@
                 </a:solidFill>
                 <a:latin typeface="Inter"/>
               </a:rPr>
-              <a:t>e4m3_vpu Spike cycles are not FPGA latency. Dense attention compares one fused source kernel, not a full model.</a:t>
+              <a:t>† Layer error vs PyTorch: compiler 7.60%; source 7.10%. Dense attention is one fused kernel. Spike cycles are not FPGA latency.</a:t>
             </a:r>
           </a:p>
         </p:txBody>
@@ -21194,7 +21194,7 @@
                 </a:solidFill>
                 <a:latin typeface="Inter"/>
               </a:rPr>
-              <a:t>Full-model rows swap MX issuers inside the same Merlin host/VPU program; small cycle gaps are expected.</a:t>
+              <a:t>Full-model rows swap MX issuers inside one Merlin host/VPU program; small cycle gaps are expected.</a:t>
             </a:r>
           </a:p>
           <a:p>
@@ -21213,7 +21213,7 @@
                 </a:solidFill>
                 <a:latin typeface="Inter"/>
               </a:rPr>
-              <a:t>Nicolas's fused MX+VPU kernels have not yet been stitched and timed as complete models.</a:t>
+              <a:t>† The layer uses the same tokens and weights but different timed work and tensor formats. Its cycle ratio is invalid.</a:t>
             </a:r>
           </a:p>
         </p:txBody>

</xml_diff>

<commit_message>
Qualify TinyLlama MX and VPU comparisons
</commit_message>
<xml_diff>
--- a/docs/presentations/mx_gemmini_dialect_overview.pptx
+++ b/docs/presentations/mx_gemmini_dialect_overview.pptx
@@ -20182,7 +20182,7 @@
                           </a:solidFill>
                           <a:latin typeface="Inter"/>
                         </a:rPr>
-                        <a:t>Nicolas path cycles</a:t>
+                        <a:t>Control/source cycles</a:t>
                       </a:r>
                     </a:p>
                   </a:txBody>
@@ -20688,7 +20688,7 @@
                           </a:solidFill>
                           <a:latin typeface="Inter"/>
                         </a:rPr>
-                        <a:t>TinyLlama cached layer · unpaired</a:t>
+                        <a:t>TinyLlama 64 tokens · source vs compiler</a:t>
                       </a:r>
                     </a:p>
                   </a:txBody>
@@ -20738,7 +20738,7 @@
                           </a:solidFill>
                           <a:latin typeface="Inter"/>
                         </a:rPr>
-                        <a:t>268,345,341†</a:t>
+                        <a:t>5,369,620,807†</a:t>
                       </a:r>
                     </a:p>
                   </a:txBody>
@@ -20788,7 +20788,7 @@
                           </a:solidFill>
                           <a:latin typeface="Inter"/>
                         </a:rPr>
-                        <a:t>582,204†</a:t>
+                        <a:t>4,456,723,475†</a:t>
                       </a:r>
                     </a:p>
                   </a:txBody>
@@ -21116,7 +21116,7 @@
                 </a:solidFill>
                 <a:latin typeface="Inter"/>
               </a:rPr>
-              <a:t>* Issuer-swap output hashes match: SmolVLA 33/33; TinyLlama 99/99. This is not an independent model accuracy check.</a:t>
+              <a:t>* Issuer-swap hashes match: SmolVLA 33/33; TinyLlama 99/99. This is not an independent accuracy check.</a:t>
             </a:r>
           </a:p>
           <a:p>
@@ -21135,7 +21135,7 @@
                 </a:solidFill>
                 <a:latin typeface="Inter"/>
               </a:rPr>
-              <a:t>† Layer error vs PyTorch: compiler 7.60%; source 7.10%. Dense attention is one fused kernel. Spike cycles are not FPGA latency.</a:t>
+              <a:t>† Independent source vs compiler logits cosine 0.672. Dense attention is one fused kernel. Spike cycles are not FPGA latency.</a:t>
             </a:r>
           </a:p>
         </p:txBody>
@@ -21194,7 +21194,7 @@
                 </a:solidFill>
                 <a:latin typeface="Inter"/>
               </a:rPr>
-              <a:t>Full-model rows swap MX issuers inside one Merlin host/VPU program; small cycle gaps are expected.</a:t>
+              <a:t>Issuer-swap rows change only the MX command issuer; host and VPU code is the same.</a:t>
             </a:r>
           </a:p>
           <a:p>
@@ -21213,7 +21213,7 @@
                 </a:solidFill>
                 <a:latin typeface="Inter"/>
               </a:rPr>
-              <a:t>† The layer uses the same tokens and weights but different timed work and tensor formats. Its cycle ratio is invalid.</a:t>
+              <a:t>† Source and compiler time different work; their logits do not yet match. No speedup ratio.</a:t>
             </a:r>
           </a:p>
         </p:txBody>

</xml_diff>

<commit_message>
Qualify TinyLlama VPU controls and comparison scope
</commit_message>
<xml_diff>
--- a/docs/presentations/mx_gemmini_dialect_overview.pptx
+++ b/docs/presentations/mx_gemmini_dialect_overview.pptx
@@ -20688,7 +20688,7 @@
                           </a:solidFill>
                           <a:latin typeface="Inter"/>
                         </a:rPr>
-                        <a:t>TinyLlama 64 tokens · source vs compiler</a:t>
+                        <a:t>TinyLlama 64 tokens · independent runs</a:t>
                       </a:r>
                     </a:p>
                   </a:txBody>
@@ -20738,7 +20738,7 @@
                           </a:solidFill>
                           <a:latin typeface="Inter"/>
                         </a:rPr>
-                        <a:t>5,369,620,807†</a:t>
+                        <a:t>4,473,524,179†</a:t>
                       </a:r>
                     </a:p>
                   </a:txBody>
@@ -21135,7 +21135,7 @@
                 </a:solidFill>
                 <a:latin typeface="Inter"/>
               </a:rPr>
-              <a:t>† Independent source vs compiler logits cosine 0.672. Dense attention is one fused kernel. Spike cycles are not FPGA latency.</a:t>
+              <a:t>† Independent source vs selected-VPU compiler logits cosine 0.977; same token, different timed work. No full-model speedup claim.</a:t>
             </a:r>
           </a:p>
         </p:txBody>
@@ -21213,7 +21213,7 @@
                 </a:solidFill>
                 <a:latin typeface="Inter"/>
               </a:rPr>
-              <a:t>† Source and compiler time different work; their logits do not yet match. No speedup ratio.</a:t>
+              <a:t>† Source and compiler time different work and use different host/VPU operations. No speedup ratio.</a:t>
             </a:r>
           </a:p>
         </p:txBody>

</xml_diff>

<commit_message>
Clarify functional and modeled Spike cycle scopes
</commit_message>
<xml_diff>
--- a/docs/presentations/mx_gemmini_dialect_overview.pptx
+++ b/docs/presentations/mx_gemmini_dialect_overview.pptx
@@ -20688,7 +20688,7 @@
                           </a:solidFill>
                           <a:latin typeface="Inter"/>
                         </a:rPr>
-                        <a:t>TinyLlama 64 tokens · independent runs</a:t>
+                        <a:t>TinyLlama 64 tokens · functional Spike</a:t>
                       </a:r>
                     </a:p>
                   </a:txBody>
@@ -21116,7 +21116,7 @@
                 </a:solidFill>
                 <a:latin typeface="Inter"/>
               </a:rPr>
-              <a:t>* Issuer-swap hashes match: SmolVLA 33/33; TinyLlama 99/99. This is not an independent accuracy check.</a:t>
+              <a:t>* Issuer-swap rows use modeled e4m3_vpu cycles; hashes match SmolVLA 33/33 and TinyLlama 99/99.</a:t>
             </a:r>
           </a:p>
           <a:p>
@@ -21135,7 +21135,7 @@
                 </a:solidFill>
                 <a:latin typeface="Inter"/>
               </a:rPr>
-              <a:t>† Independent source vs selected-VPU compiler logits cosine 0.977; same token, different timed work. No full-model speedup claim.</a:t>
+              <a:t>† 64-token row uses functional rdcycle (timing model off); source/compiler logits cosine 0.977. Dense attention uses modeled cycles.</a:t>
             </a:r>
           </a:p>
         </p:txBody>
@@ -21213,7 +21213,7 @@
                 </a:solidFill>
                 <a:latin typeface="Inter"/>
               </a:rPr>
-              <a:t>† Source and compiler time different work and use different host/VPU operations. No speedup ratio.</a:t>
+              <a:t>† 64-token row uses functional Spike counters and different host/VPU work. No modeled speedup ratio.</a:t>
             </a:r>
           </a:p>
         </p:txBody>

</xml_diff>

<commit_message>
Clarify Spike comparison scope on slide three
</commit_message>
<xml_diff>
--- a/docs/presentations/mx_gemmini_dialect_overview.pptx
+++ b/docs/presentations/mx_gemmini_dialect_overview.pptx
@@ -20032,7 +20032,7 @@
                 </a:solidFill>
                 <a:latin typeface="Inter"/>
               </a:rPr>
-              <a:t>Spike results by measurement scope</a:t>
+              <a:t>What the Spike comparisons measure</a:t>
             </a:r>
           </a:p>
         </p:txBody>
@@ -21194,7 +21194,7 @@
                 </a:solidFill>
                 <a:latin typeface="Inter"/>
               </a:rPr>
-              <a:t>Issuer-swap rows change only the MX command issuer; host and VPU code is the same.</a:t>
+              <a:t>Full sessions: same host/VPU program; only the MX issuer changes. Near parity is expected.</a:t>
             </a:r>
           </a:p>
           <a:p>
@@ -21213,7 +21213,7 @@
                 </a:solidFill>
                 <a:latin typeface="Inter"/>
               </a:rPr>
-              <a:t>† 64-token row uses functional Spike counters and different host/VPU work. No modeled speedup ratio.</a:t>
+              <a:t>† Independent prefill: different host/VPU work, no speedup ratio. Fused attention: one kernel.</a:t>
             </a:r>
           </a:p>
         </p:txBody>

</xml_diff>

<commit_message>
Archive modeled TinyLlama source comparison
</commit_message>
<xml_diff>
--- a/docs/presentations/mx_gemmini_dialect_overview.pptx
+++ b/docs/presentations/mx_gemmini_dialect_overview.pptx
@@ -20688,7 +20688,7 @@
                           </a:solidFill>
                           <a:latin typeface="Inter"/>
                         </a:rPr>
-                        <a:t>TinyLlama 64 tokens · functional Spike</a:t>
+                        <a:t>TinyLlama 64-token prefill · independent</a:t>
                       </a:r>
                     </a:p>
                   </a:txBody>
@@ -20738,7 +20738,7 @@
                           </a:solidFill>
                           <a:latin typeface="Inter"/>
                         </a:rPr>
-                        <a:t>4,473,524,179†</a:t>
+                        <a:t>5,072,967,821†</a:t>
                       </a:r>
                     </a:p>
                   </a:txBody>
@@ -20788,7 +20788,7 @@
                           </a:solidFill>
                           <a:latin typeface="Inter"/>
                         </a:rPr>
-                        <a:t>4,456,723,475†</a:t>
+                        <a:t>4,328,997,732†</a:t>
                       </a:r>
                     </a:p>
                   </a:txBody>
@@ -21135,7 +21135,7 @@
                 </a:solidFill>
                 <a:latin typeface="Inter"/>
               </a:rPr>
-              <a:t>† 64-token row uses functional rdcycle (timing model off); source/compiler logits cosine 0.977. Dense attention uses modeled cycles.</a:t>
+              <a:t>† Full prefill: 200 weights and 64 IDs match; cosine 0.982, token 1230. VPU adds: 44 source calls, 88 compiler regions; host math differs.</a:t>
             </a:r>
           </a:p>
         </p:txBody>

</xml_diff>

<commit_message>
Document Radiance MX kernel controls in slides
</commit_message>
<xml_diff>
--- a/docs/presentations/mx_gemmini_dialect_overview.pptx
+++ b/docs/presentations/mx_gemmini_dialect_overview.pptx
@@ -18728,7 +18728,7 @@
                 </a:solidFill>
                 <a:latin typeface="Inter"/>
               </a:rPr>
-              <a:t>resource → packed codes + E8M0 scales → mvin; contract → MX compute. Radiance softmax uses vpu_execute; readout_bf16 / spad_requant / wait finish the tile.</a:t>
+              <a:t>resource binds packed codes + E8M0 scales; contract emits MX compute. Compiler softmax can use vpu_execute; Radiance's fused source uses Muon SIMT. readout_bf16 / spad_requant / wait finish the tile.</a:t>
             </a:r>
           </a:p>
         </p:txBody>
@@ -21194,7 +21194,7 @@
                 </a:solidFill>
                 <a:latin typeface="Inter"/>
               </a:rPr>
-              <a:t>Full sessions: same host/VPU program; only the MX issuer changes. Near parity is expected.</a:t>
+              <a:t>Radiance GEMMs: compiler matches 16,384 BF16 each; FP8/FP4 read-once B = 128/176 KiB versus 512 KiB FP8 re-stream.</a:t>
             </a:r>
           </a:p>
           <a:p>
@@ -21213,7 +21213,7 @@
                 </a:solidFill>
                 <a:latin typeface="Inter"/>
               </a:rPr>
-              <a:t>† Independent prefill: different host/VPU work, no speedup ratio. Fused attention: one kernel.</a:t>
+              <a:t>Radiance GQA: compiled MX PV matches 65,536 source-produced BF16 values. Muon source cycles remain unpaired.</a:t>
             </a:r>
           </a:p>
         </p:txBody>

</xml_diff>

<commit_message>
Prepare source-bound 128-token prefill comparison
</commit_message>
<xml_diff>
--- a/docs/presentations/mx_gemmini_dialect_overview.pptx
+++ b/docs/presentations/mx_gemmini_dialect_overview.pptx
@@ -20032,7 +20032,7 @@
                 </a:solidFill>
                 <a:latin typeface="Inter"/>
               </a:rPr>
-              <a:t>What the Spike comparisons measure</a:t>
+              <a:t>MX results: Spike and Radiance</a:t>
             </a:r>
           </a:p>
         </p:txBody>
@@ -21040,7 +21040,7 @@
                           </a:solidFill>
                           <a:latin typeface="Inter"/>
                         </a:rPr>
-                        <a:t>−0.27%</a:t>
+                        <a:t>-0.27%</a:t>
                       </a:r>
                     </a:p>
                   </a:txBody>
@@ -21116,7 +21116,7 @@
                 </a:solidFill>
                 <a:latin typeface="Inter"/>
               </a:rPr>
-              <a:t>* Issuer-swap rows use modeled e4m3_vpu cycles; hashes match SmolVLA 33/33 and TinyLlama 99/99.</a:t>
+              <a:t>* Issuer swap: host/VPU fixed; modeled cycles. Output hashes equal for SmolVLA 33/33 and TinyLlama 99/99.</a:t>
             </a:r>
           </a:p>
           <a:p>

</xml_diff>

<commit_message>
Add Radiance kernel comparison slide
</commit_message>
<xml_diff>
--- a/docs/presentations/mx_gemmini_dialect_overview.pptx
+++ b/docs/presentations/mx_gemmini_dialect_overview.pptx
@@ -8,6 +8,7 @@
     <p:sldId id="278" r:id="rId30"/>
     <p:sldId id="275" r:id="rId27"/>
     <p:sldId id="288" r:id="rId40"/>
+    <p:sldId id="289" r:id="rId11"/>
   </p:sldIdLst>
   <p:sldSz cx="12191999" cy="6858000" type="screen4x3"/>
   <p:notesSz cx="6858000" cy="9144000"/>
@@ -18112,7 +18113,7 @@
                 </a:solidFill>
                 <a:latin typeface="Inter"/>
               </a:rPr>
-              <a:t>02 / 03</a:t>
+              <a:t>02 / 04</a:t>
             </a:r>
           </a:p>
         </p:txBody>
@@ -19960,7 +19961,7 @@
                 </a:solidFill>
                 <a:latin typeface="Inter"/>
               </a:rPr>
-              <a:t>01 / 03</a:t>
+              <a:t>01 / 04</a:t>
             </a:r>
           </a:p>
         </p:txBody>
@@ -21255,7 +21256,1137 @@
                 </a:solidFill>
                 <a:latin typeface="Inter"/>
               </a:rPr>
-              <a:t>03 / 03</a:t>
+              <a:t>03 / 04</a:t>
+            </a:r>
+          </a:p>
+        </p:txBody>
+      </p:sp>
+    </p:spTree>
+  </p:cSld>
+  <p:clrMapOvr>
+    <a:masterClrMapping/>
+  </p:clrMapOvr>
+</p:sld>
+</file>
+
+<file path=ppt/slides/slide4.xml><?xml version="1.0" encoding="utf-8"?>
+<p:sld xmlns:a="http://schemas.openxmlformats.org/drawingml/2006/main" xmlns:p="http://schemas.openxmlformats.org/presentationml/2006/main" xmlns:r="http://schemas.openxmlformats.org/officeDocument/2006/relationships">
+  <p:cSld>
+    <p:spTree>
+      <p:nvGrpSpPr>
+        <p:cNvPr id="1" name=""/>
+        <p:cNvGrpSpPr/>
+        <p:nvPr/>
+      </p:nvGrpSpPr>
+      <p:grpSpPr/>
+      <p:sp>
+        <p:nvSpPr>
+          <p:cNvPr id="2" name="TextBox 1"/>
+          <p:cNvSpPr txBox="1"/>
+          <p:nvPr/>
+        </p:nvSpPr>
+        <p:spPr>
+          <a:xfrm>
+            <a:off x="2514600" y="438912"/>
+            <a:ext cx="7168896" cy="502920"/>
+          </a:xfrm>
+          <a:prstGeom prst="rect">
+            <a:avLst/>
+          </a:prstGeom>
+          <a:noFill/>
+        </p:spPr>
+        <p:txBody>
+          <a:bodyPr wrap="square" lIns="18288" rIns="18288" tIns="9144" bIns="9144" anchor="ctr">
+            <a:spAutoFit/>
+          </a:bodyPr>
+          <a:lstStyle/>
+          <a:p>
+            <a:pPr algn="ctr">
+              <a:spcBef>
+                <a:spcPts val="0"/>
+              </a:spcBef>
+              <a:spcAft>
+                <a:spcPts val="0"/>
+              </a:spcAft>
+            </a:pPr>
+            <a:r>
+              <a:rPr sz="2540" b="1">
+                <a:solidFill>
+                  <a:srgbClr val="313455"/>
+                </a:solidFill>
+                <a:latin typeface="Inter"/>
+              </a:rPr>
+              <a:t>Radiance MX: output and schedule</a:t>
+            </a:r>
+          </a:p>
+        </p:txBody>
+      </p:sp>
+      <p:graphicFrame>
+        <p:nvGraphicFramePr>
+          <p:cNvPr id="3" name="Table 2"/>
+          <p:cNvGraphicFramePr>
+            <a:graphicFrameLocks noGrp="1"/>
+          </p:cNvGraphicFramePr>
+          <p:nvPr/>
+        </p:nvGraphicFramePr>
+        <p:xfrm>
+          <a:off x="859536" y="1527048"/>
+          <a:ext cx="10479023" cy="2962656"/>
+        </p:xfrm>
+        <a:graphic>
+          <a:graphicData uri="http://schemas.openxmlformats.org/drawingml/2006/table">
+            <a:tbl>
+              <a:tblPr firstRow="1" bandRow="1">
+                <a:tableStyleId>{5C22544A-7EE6-4342-B048-85BDC9FD1C3A}</a:tableStyleId>
+              </a:tblPr>
+              <a:tblGrid>
+                <a:gridCol w="2834640"/>
+                <a:gridCol w="1508760"/>
+                <a:gridCol w="3749039"/>
+                <a:gridCol w="2386584"/>
+              </a:tblGrid>
+              <a:tr h="493776">
+                <a:tc>
+                  <a:txBody>
+                    <a:bodyPr/>
+                    <a:lstStyle/>
+                    <a:p>
+                      <a:pPr algn="l">
+                        <a:spcBef>
+                          <a:spcPts val="0"/>
+                        </a:spcBef>
+                        <a:spcAft>
+                          <a:spcPts val="0"/>
+                        </a:spcAft>
+                      </a:pPr>
+                      <a:r>
+                        <a:rPr sz="1050" b="1">
+                          <a:solidFill>
+                            <a:srgbClr val="FFFFFF"/>
+                          </a:solidFill>
+                          <a:latin typeface="Inter"/>
+                        </a:rPr>
+                        <a:t>Radiance source kernel</a:t>
+                      </a:r>
+                    </a:p>
+                  </a:txBody>
+                  <a:tcPr marL="128016" marR="91440" marT="45720" marB="27432" anchor="ctr"/>
+                </a:tc>
+                <a:tc>
+                  <a:txBody>
+                    <a:bodyPr/>
+                    <a:lstStyle/>
+                    <a:p>
+                      <a:pPr algn="ctr">
+                        <a:spcBef>
+                          <a:spcPts val="0"/>
+                        </a:spcBef>
+                        <a:spcAft>
+                          <a:spcPts val="0"/>
+                        </a:spcAft>
+                      </a:pPr>
+                      <a:r>
+                        <a:rPr sz="1050" b="1">
+                          <a:solidFill>
+                            <a:srgbClr val="FFFFFF"/>
+                          </a:solidFill>
+                          <a:latin typeface="Inter"/>
+                        </a:rPr>
+                        <a:t>Shape M×N×K</a:t>
+                      </a:r>
+                    </a:p>
+                  </a:txBody>
+                  <a:tcPr marL="128016" marR="91440" marT="45720" marB="27432" anchor="ctr"/>
+                </a:tc>
+                <a:tc>
+                  <a:txBody>
+                    <a:bodyPr/>
+                    <a:lstStyle/>
+                    <a:p>
+                      <a:pPr algn="l">
+                        <a:spcBef>
+                          <a:spcPts val="0"/>
+                        </a:spcBef>
+                        <a:spcAft>
+                          <a:spcPts val="0"/>
+                        </a:spcAft>
+                      </a:pPr>
+                      <a:r>
+                        <a:rPr sz="1050" b="1">
+                          <a:solidFill>
+                            <a:srgbClr val="FFFFFF"/>
+                          </a:solidFill>
+                          <a:latin typeface="Inter"/>
+                        </a:rPr>
+                        <a:t>Compiler check on Nicolas Spike</a:t>
+                      </a:r>
+                    </a:p>
+                  </a:txBody>
+                  <a:tcPr marL="128016" marR="91440" marT="45720" marB="27432" anchor="ctr"/>
+                </a:tc>
+                <a:tc>
+                  <a:txBody>
+                    <a:bodyPr/>
+                    <a:lstStyle/>
+                    <a:p>
+                      <a:pPr algn="ctr">
+                        <a:spcBef>
+                          <a:spcPts val="0"/>
+                        </a:spcBef>
+                        <a:spcAft>
+                          <a:spcPts val="0"/>
+                        </a:spcAft>
+                      </a:pPr>
+                      <a:r>
+                        <a:rPr sz="1050" b="1">
+                          <a:solidFill>
+                            <a:srgbClr val="FFFFFF"/>
+                          </a:solidFill>
+                          <a:latin typeface="Inter"/>
+                        </a:rPr>
+                        <a:t>B traffic / limit</a:t>
+                      </a:r>
+                    </a:p>
+                  </a:txBody>
+                  <a:tcPr marL="128016" marR="91440" marT="45720" marB="27432" anchor="ctr"/>
+                </a:tc>
+              </a:tr>
+              <a:tr h="493776">
+                <a:tc>
+                  <a:txBody>
+                    <a:bodyPr/>
+                    <a:lstStyle/>
+                    <a:p>
+                      <a:pPr algn="l">
+                        <a:spcBef>
+                          <a:spcPts val="0"/>
+                        </a:spcBef>
+                        <a:spcAft>
+                          <a:spcPts val="0"/>
+                        </a:spcAft>
+                      </a:pPr>
+                      <a:r>
+                        <a:rPr sz="1090" b="1">
+                          <a:solidFill>
+                            <a:srgbClr val="313455"/>
+                          </a:solidFill>
+                          <a:latin typeface="Inter"/>
+                        </a:rPr>
+                        <a:t>FP8 GEMM · read once</a:t>
+                      </a:r>
+                    </a:p>
+                  </a:txBody>
+                  <a:tcPr marL="128016" marR="91440" marT="45720" marB="27432" anchor="ctr"/>
+                </a:tc>
+                <a:tc>
+                  <a:txBody>
+                    <a:bodyPr/>
+                    <a:lstStyle/>
+                    <a:p>
+                      <a:pPr algn="ctr">
+                        <a:spcBef>
+                          <a:spcPts val="0"/>
+                        </a:spcBef>
+                        <a:spcAft>
+                          <a:spcPts val="0"/>
+                        </a:spcAft>
+                      </a:pPr>
+                      <a:r>
+                        <a:rPr sz="1090" b="0">
+                          <a:solidFill>
+                            <a:srgbClr val="313455"/>
+                          </a:solidFill>
+                          <a:latin typeface="Inter"/>
+                        </a:rPr>
+                        <a:t>256×64×2048</a:t>
+                      </a:r>
+                    </a:p>
+                  </a:txBody>
+                  <a:tcPr marL="128016" marR="91440" marT="45720" marB="27432" anchor="ctr"/>
+                </a:tc>
+                <a:tc>
+                  <a:txBody>
+                    <a:bodyPr/>
+                    <a:lstStyle/>
+                    <a:p>
+                      <a:pPr algn="l">
+                        <a:spcBef>
+                          <a:spcPts val="0"/>
+                        </a:spcBef>
+                        <a:spcAft>
+                          <a:spcPts val="0"/>
+                        </a:spcAft>
+                      </a:pPr>
+                      <a:r>
+                        <a:rPr sz="1090" b="0">
+                          <a:solidFill>
+                            <a:srgbClr val="313455"/>
+                          </a:solidFill>
+                          <a:latin typeface="Inter"/>
+                        </a:rPr>
+                        <a:t>16,384 BF16; one 256×64 tile</a:t>
+                      </a:r>
+                    </a:p>
+                  </a:txBody>
+                  <a:tcPr marL="128016" marR="91440" marT="45720" marB="27432" anchor="ctr"/>
+                </a:tc>
+                <a:tc>
+                  <a:txBody>
+                    <a:bodyPr/>
+                    <a:lstStyle/>
+                    <a:p>
+                      <a:pPr algn="ctr">
+                        <a:spcBef>
+                          <a:spcPts val="0"/>
+                        </a:spcBef>
+                        <a:spcAft>
+                          <a:spcPts val="0"/>
+                        </a:spcAft>
+                      </a:pPr>
+                      <a:r>
+                        <a:rPr sz="1090" b="0">
+                          <a:solidFill>
+                            <a:srgbClr val="313455"/>
+                          </a:solidFill>
+                          <a:latin typeface="Inter"/>
+                        </a:rPr>
+                        <a:t>128 KiB · 32 reads</a:t>
+                      </a:r>
+                    </a:p>
+                  </a:txBody>
+                  <a:tcPr marL="128016" marR="91440" marT="45720" marB="27432" anchor="ctr"/>
+                </a:tc>
+              </a:tr>
+              <a:tr h="493776">
+                <a:tc>
+                  <a:txBody>
+                    <a:bodyPr/>
+                    <a:lstStyle/>
+                    <a:p>
+                      <a:pPr algn="l">
+                        <a:spcBef>
+                          <a:spcPts val="0"/>
+                        </a:spcBef>
+                        <a:spcAft>
+                          <a:spcPts val="0"/>
+                        </a:spcAft>
+                      </a:pPr>
+                      <a:r>
+                        <a:rPr sz="1090" b="1">
+                          <a:solidFill>
+                            <a:srgbClr val="313455"/>
+                          </a:solidFill>
+                          <a:latin typeface="Inter"/>
+                        </a:rPr>
+                        <a:t>FP4 down-projection · read once</a:t>
+                      </a:r>
+                    </a:p>
+                  </a:txBody>
+                  <a:tcPr marL="128016" marR="91440" marT="45720" marB="27432" anchor="ctr"/>
+                </a:tc>
+                <a:tc>
+                  <a:txBody>
+                    <a:bodyPr/>
+                    <a:lstStyle/>
+                    <a:p>
+                      <a:pPr algn="ctr">
+                        <a:spcBef>
+                          <a:spcPts val="0"/>
+                        </a:spcBef>
+                        <a:spcAft>
+                          <a:spcPts val="0"/>
+                        </a:spcAft>
+                      </a:pPr>
+                      <a:r>
+                        <a:rPr sz="1090" b="0">
+                          <a:solidFill>
+                            <a:srgbClr val="313455"/>
+                          </a:solidFill>
+                          <a:latin typeface="Inter"/>
+                        </a:rPr>
+                        <a:t>256×64×5632</a:t>
+                      </a:r>
+                    </a:p>
+                  </a:txBody>
+                  <a:tcPr marL="128016" marR="91440" marT="45720" marB="27432" anchor="ctr"/>
+                </a:tc>
+                <a:tc>
+                  <a:txBody>
+                    <a:bodyPr/>
+                    <a:lstStyle/>
+                    <a:p>
+                      <a:pPr algn="l">
+                        <a:spcBef>
+                          <a:spcPts val="0"/>
+                        </a:spcBef>
+                        <a:spcAft>
+                          <a:spcPts val="0"/>
+                        </a:spcAft>
+                      </a:pPr>
+                      <a:r>
+                        <a:rPr sz="1090" b="0">
+                          <a:solidFill>
+                            <a:srgbClr val="313455"/>
+                          </a:solidFill>
+                          <a:latin typeface="Inter"/>
+                        </a:rPr>
+                        <a:t>16,384 BF16; one 256×64 tile</a:t>
+                      </a:r>
+                    </a:p>
+                  </a:txBody>
+                  <a:tcPr marL="128016" marR="91440" marT="45720" marB="27432" anchor="ctr"/>
+                </a:tc>
+                <a:tc>
+                  <a:txBody>
+                    <a:bodyPr/>
+                    <a:lstStyle/>
+                    <a:p>
+                      <a:pPr algn="ctr">
+                        <a:spcBef>
+                          <a:spcPts val="0"/>
+                        </a:spcBef>
+                        <a:spcAft>
+                          <a:spcPts val="0"/>
+                        </a:spcAft>
+                      </a:pPr>
+                      <a:r>
+                        <a:rPr sz="1090" b="0">
+                          <a:solidFill>
+                            <a:srgbClr val="313455"/>
+                          </a:solidFill>
+                          <a:latin typeface="Inter"/>
+                        </a:rPr>
+                        <a:t>176 KiB · 88 reads</a:t>
+                      </a:r>
+                    </a:p>
+                  </a:txBody>
+                  <a:tcPr marL="128016" marR="91440" marT="45720" marB="27432" anchor="ctr"/>
+                </a:tc>
+              </a:tr>
+              <a:tr h="493776">
+                <a:tc>
+                  <a:txBody>
+                    <a:bodyPr/>
+                    <a:lstStyle/>
+                    <a:p>
+                      <a:pPr algn="l">
+                        <a:spcBef>
+                          <a:spcPts val="0"/>
+                        </a:spcBef>
+                        <a:spcAft>
+                          <a:spcPts val="0"/>
+                        </a:spcAft>
+                      </a:pPr>
+                      <a:r>
+                        <a:rPr sz="1090" b="1">
+                          <a:solidFill>
+                            <a:srgbClr val="313455"/>
+                          </a:solidFill>
+                          <a:latin typeface="Inter"/>
+                        </a:rPr>
+                        <a:t>FP8 GEMM · four-pass re-stream</a:t>
+                      </a:r>
+                    </a:p>
+                  </a:txBody>
+                  <a:tcPr marL="128016" marR="91440" marT="45720" marB="27432" anchor="ctr"/>
+                </a:tc>
+                <a:tc>
+                  <a:txBody>
+                    <a:bodyPr/>
+                    <a:lstStyle/>
+                    <a:p>
+                      <a:pPr algn="ctr">
+                        <a:spcBef>
+                          <a:spcPts val="0"/>
+                        </a:spcBef>
+                        <a:spcAft>
+                          <a:spcPts val="0"/>
+                        </a:spcAft>
+                      </a:pPr>
+                      <a:r>
+                        <a:rPr sz="1090" b="0">
+                          <a:solidFill>
+                            <a:srgbClr val="313455"/>
+                          </a:solidFill>
+                          <a:latin typeface="Inter"/>
+                        </a:rPr>
+                        <a:t>256×64×2048</a:t>
+                      </a:r>
+                    </a:p>
+                  </a:txBody>
+                  <a:tcPr marL="128016" marR="91440" marT="45720" marB="27432" anchor="ctr"/>
+                </a:tc>
+                <a:tc>
+                  <a:txBody>
+                    <a:bodyPr/>
+                    <a:lstStyle/>
+                    <a:p>
+                      <a:pPr algn="l">
+                        <a:spcBef>
+                          <a:spcPts val="0"/>
+                        </a:spcBef>
+                        <a:spcAft>
+                          <a:spcPts val="0"/>
+                        </a:spcAft>
+                      </a:pPr>
+                      <a:r>
+                        <a:rPr sz="1090" b="0">
+                          <a:solidFill>
+                            <a:srgbClr val="313455"/>
+                          </a:solidFill>
+                          <a:latin typeface="Inter"/>
+                        </a:rPr>
+                        <a:t>16,384 BF16; four 64×64 tiles</a:t>
+                      </a:r>
+                    </a:p>
+                  </a:txBody>
+                  <a:tcPr marL="128016" marR="91440" marT="45720" marB="27432" anchor="ctr"/>
+                </a:tc>
+                <a:tc>
+                  <a:txBody>
+                    <a:bodyPr/>
+                    <a:lstStyle/>
+                    <a:p>
+                      <a:pPr algn="ctr">
+                        <a:spcBef>
+                          <a:spcPts val="0"/>
+                        </a:spcBef>
+                        <a:spcAft>
+                          <a:spcPts val="0"/>
+                        </a:spcAft>
+                      </a:pPr>
+                      <a:r>
+                        <a:rPr sz="1090" b="0">
+                          <a:solidFill>
+                            <a:srgbClr val="313455"/>
+                          </a:solidFill>
+                          <a:latin typeface="Inter"/>
+                        </a:rPr>
+                        <a:t>512 KiB · 128 reads</a:t>
+                      </a:r>
+                    </a:p>
+                  </a:txBody>
+                  <a:tcPr marL="128016" marR="91440" marT="45720" marB="27432" anchor="ctr"/>
+                </a:tc>
+              </a:tr>
+              <a:tr h="493776">
+                <a:tc>
+                  <a:txBody>
+                    <a:bodyPr/>
+                    <a:lstStyle/>
+                    <a:p>
+                      <a:pPr algn="l">
+                        <a:spcBef>
+                          <a:spcPts val="0"/>
+                        </a:spcBef>
+                        <a:spcAft>
+                          <a:spcPts val="0"/>
+                        </a:spcAft>
+                      </a:pPr>
+                      <a:r>
+                        <a:rPr sz="1090" b="1">
+                          <a:solidFill>
+                            <a:srgbClr val="313455"/>
+                          </a:solidFill>
+                          <a:latin typeface="Inter"/>
+                        </a:rPr>
+                        <a:t>Batched GEMV · FP8/FP4</a:t>
+                      </a:r>
+                    </a:p>
+                  </a:txBody>
+                  <a:tcPr marL="128016" marR="91440" marT="45720" marB="27432" anchor="ctr"/>
+                </a:tc>
+                <a:tc>
+                  <a:txBody>
+                    <a:bodyPr/>
+                    <a:lstStyle/>
+                    <a:p>
+                      <a:pPr algn="ctr">
+                        <a:spcBef>
+                          <a:spcPts val="0"/>
+                        </a:spcBef>
+                        <a:spcAft>
+                          <a:spcPts val="0"/>
+                        </a:spcAft>
+                      </a:pPr>
+                      <a:r>
+                        <a:rPr sz="1090" b="0">
+                          <a:solidFill>
+                            <a:srgbClr val="313455"/>
+                          </a:solidFill>
+                          <a:latin typeface="Inter"/>
+                        </a:rPr>
+                        <a:t>4 source shapes</a:t>
+                      </a:r>
+                    </a:p>
+                  </a:txBody>
+                  <a:tcPr marL="128016" marR="91440" marT="45720" marB="27432" anchor="ctr"/>
+                </a:tc>
+                <a:tc>
+                  <a:txBody>
+                    <a:bodyPr/>
+                    <a:lstStyle/>
+                    <a:p>
+                      <a:pPr algn="l">
+                        <a:spcBef>
+                          <a:spcPts val="0"/>
+                        </a:spcBef>
+                        <a:spcAft>
+                          <a:spcPts val="0"/>
+                        </a:spcAft>
+                      </a:pPr>
+                      <a:r>
+                        <a:rPr sz="1090" b="0">
+                          <a:solidFill>
+                            <a:srgbClr val="313455"/>
+                          </a:solidFill>
+                          <a:latin typeface="Inter"/>
+                        </a:rPr>
+                        <a:t>45,056 BF16 across four controls</a:t>
+                      </a:r>
+                    </a:p>
+                  </a:txBody>
+                  <a:tcPr marL="128016" marR="91440" marT="45720" marB="27432" anchor="ctr"/>
+                </a:tc>
+                <a:tc>
+                  <a:txBody>
+                    <a:bodyPr/>
+                    <a:lstStyle/>
+                    <a:p>
+                      <a:pPr algn="ctr">
+                        <a:spcBef>
+                          <a:spcPts val="0"/>
+                        </a:spcBef>
+                        <a:spcAft>
+                          <a:spcPts val="0"/>
+                        </a:spcAft>
+                      </a:pPr>
+                      <a:r>
+                        <a:rPr sz="1090" b="0">
+                          <a:solidFill>
+                            <a:srgbClr val="313455"/>
+                          </a:solidFill>
+                          <a:latin typeface="Inter"/>
+                        </a:rPr>
+                        <a:t>one-read controls</a:t>
+                      </a:r>
+                    </a:p>
+                  </a:txBody>
+                  <a:tcPr marL="128016" marR="91440" marT="45720" marB="27432" anchor="ctr"/>
+                </a:tc>
+              </a:tr>
+              <a:tr h="493776">
+                <a:tc>
+                  <a:txBody>
+                    <a:bodyPr/>
+                    <a:lstStyle/>
+                    <a:p>
+                      <a:pPr algn="l">
+                        <a:spcBef>
+                          <a:spcPts val="0"/>
+                        </a:spcBef>
+                        <a:spcAft>
+                          <a:spcPts val="0"/>
+                        </a:spcAft>
+                      </a:pPr>
+                      <a:r>
+                        <a:rPr sz="1090" b="1">
+                          <a:solidFill>
+                            <a:srgbClr val="313455"/>
+                          </a:solidFill>
+                          <a:latin typeface="Inter"/>
+                        </a:rPr>
+                        <a:t>GQA attention · MX PV only</a:t>
+                      </a:r>
+                    </a:p>
+                  </a:txBody>
+                  <a:tcPr marL="128016" marR="91440" marT="45720" marB="27432" anchor="ctr"/>
+                </a:tc>
+                <a:tc>
+                  <a:txBody>
+                    <a:bodyPr/>
+                    <a:lstStyle/>
+                    <a:p>
+                      <a:pPr algn="ctr">
+                        <a:spcBef>
+                          <a:spcPts val="0"/>
+                        </a:spcBef>
+                        <a:spcAft>
+                          <a:spcPts val="0"/>
+                        </a:spcAft>
+                      </a:pPr>
+                      <a:r>
+                        <a:rPr sz="1090" b="0">
+                          <a:solidFill>
+                            <a:srgbClr val="313455"/>
+                          </a:solidFill>
+                          <a:latin typeface="Inter"/>
+                        </a:rPr>
+                        <a:t>16 cutpoints</a:t>
+                      </a:r>
+                    </a:p>
+                  </a:txBody>
+                  <a:tcPr marL="128016" marR="91440" marT="45720" marB="27432" anchor="ctr"/>
+                </a:tc>
+                <a:tc>
+                  <a:txBody>
+                    <a:bodyPr/>
+                    <a:lstStyle/>
+                    <a:p>
+                      <a:pPr algn="l">
+                        <a:spcBef>
+                          <a:spcPts val="0"/>
+                        </a:spcBef>
+                        <a:spcAft>
+                          <a:spcPts val="0"/>
+                        </a:spcAft>
+                      </a:pPr>
+                      <a:r>
+                        <a:rPr sz="1090" b="0">
+                          <a:solidFill>
+                            <a:srgbClr val="313455"/>
+                          </a:solidFill>
+                          <a:latin typeface="Inter"/>
+                        </a:rPr>
+                        <a:t>65,536 BF16 PV outputs with source P tiles</a:t>
+                      </a:r>
+                    </a:p>
+                  </a:txBody>
+                  <a:tcPr marL="128016" marR="91440" marT="45720" marB="27432" anchor="ctr"/>
+                </a:tc>
+                <a:tc>
+                  <a:txBody>
+                    <a:bodyPr/>
+                    <a:lstStyle/>
+                    <a:p>
+                      <a:pPr algn="ctr">
+                        <a:spcBef>
+                          <a:spcPts val="0"/>
+                        </a:spcBef>
+                        <a:spcAft>
+                          <a:spcPts val="0"/>
+                        </a:spcAft>
+                      </a:pPr>
+                      <a:r>
+                        <a:rPr sz="1090" b="0">
+                          <a:solidFill>
+                            <a:srgbClr val="313455"/>
+                          </a:solidFill>
+                          <a:latin typeface="Inter"/>
+                        </a:rPr>
+                        <a:t>whole kernel open</a:t>
+                      </a:r>
+                    </a:p>
+                  </a:txBody>
+                  <a:tcPr marL="128016" marR="91440" marT="45720" marB="27432" anchor="ctr"/>
+                </a:tc>
+              </a:tr>
+            </a:tbl>
+          </a:graphicData>
+        </a:graphic>
+      </p:graphicFrame>
+      <p:sp>
+        <p:nvSpPr>
+          <p:cNvPr id="4" name="Rounded Rectangle 3"/>
+          <p:cNvSpPr/>
+          <p:nvPr/>
+        </p:nvSpPr>
+        <p:spPr>
+          <a:xfrm>
+            <a:off x="859536" y="4599432"/>
+            <a:ext cx="5120640" cy="685800"/>
+          </a:xfrm>
+          <a:prstGeom prst="roundRect">
+            <a:avLst/>
+          </a:prstGeom>
+          <a:solidFill>
+            <a:srgbClr val="FDF8F1"/>
+          </a:solidFill>
+          <a:ln>
+            <a:solidFill>
+              <a:srgbClr val="D3CABF"/>
+            </a:solidFill>
+          </a:ln>
+        </p:spPr>
+        <p:style>
+          <a:lnRef idx="1">
+            <a:schemeClr val="accent1"/>
+          </a:lnRef>
+          <a:fillRef idx="3">
+            <a:schemeClr val="accent1"/>
+          </a:fillRef>
+          <a:effectRef idx="2">
+            <a:schemeClr val="accent1"/>
+          </a:effectRef>
+          <a:fontRef idx="minor">
+            <a:schemeClr val="lt1"/>
+          </a:fontRef>
+        </p:style>
+        <p:txBody>
+          <a:bodyPr rtlCol="0" anchor="t" wrap="none" lIns="109728" tIns="91440" rIns="73152" bIns="36576"/>
+          <a:lstStyle/>
+          <a:p>
+            <a:pPr algn="l">
+              <a:spcBef>
+                <a:spcPts val="0"/>
+              </a:spcBef>
+              <a:spcAft>
+                <a:spcPts val="0"/>
+              </a:spcAft>
+            </a:pPr>
+            <a:r>
+              <a:rPr sz="950">
+                <a:solidFill>
+                  <a:srgbClr val="103552"/>
+                </a:solidFill>
+                <a:latin typeface="Liberation Mono"/>
+              </a:rPr>
+              <a:t>Radiance: TILE_M=</a:t>
+            </a:r>
+            <a:r>
+              <a:rPr sz="950">
+                <a:solidFill>
+                  <a:srgbClr val="A44F25"/>
+                </a:solidFill>
+                <a:latin typeface="Liberation Mono"/>
+              </a:rPr>
+              <a:t>256</a:t>
+            </a:r>
+            <a:r>
+              <a:rPr sz="950">
+                <a:solidFill>
+                  <a:srgbClr val="103552"/>
+                </a:solidFill>
+                <a:latin typeface="Liberation Mono"/>
+              </a:rPr>
+              <a:t>, TILE_N=</a:t>
+            </a:r>
+            <a:r>
+              <a:rPr sz="950">
+                <a:solidFill>
+                  <a:srgbClr val="A44F25"/>
+                </a:solidFill>
+                <a:latin typeface="Liberation Mono"/>
+              </a:rPr>
+              <a:t>64</a:t>
+            </a:r>
+            <a:r>
+              <a:rPr sz="950">
+                <a:solidFill>
+                  <a:srgbClr val="103552"/>
+                </a:solidFill>
+                <a:latin typeface="Liberation Mono"/>
+              </a:rPr>
+              <a:t>, TILE_K=</a:t>
+            </a:r>
+            <a:r>
+              <a:rPr sz="950">
+                <a:solidFill>
+                  <a:srgbClr val="A44F25"/>
+                </a:solidFill>
+                <a:latin typeface="Liberation Mono"/>
+              </a:rPr>
+              <a:t>64</a:t>
+            </a:r>
+            <a:r>
+              <a:rPr sz="950">
+                <a:solidFill>
+                  <a:srgbClr val="103552"/>
+                </a:solidFill>
+                <a:latin typeface="Liberation Mono"/>
+              </a:rPr>
+              <a:t>, FP8 read once</a:t>
+            </a:r>
+          </a:p>
+          <a:p>
+            <a:pPr algn="l">
+              <a:spcBef>
+                <a:spcPts val="0"/>
+              </a:spcBef>
+              <a:spcAft>
+                <a:spcPts val="0"/>
+              </a:spcAft>
+            </a:pPr>
+            <a:r>
+              <a:rPr sz="950">
+                <a:solidFill>
+                  <a:srgbClr val="103552"/>
+                </a:solidFill>
+                <a:latin typeface="Liberation Mono"/>
+              </a:rPr>
+              <a:t>Compiler: tile=[</a:t>
+            </a:r>
+            <a:r>
+              <a:rPr sz="950">
+                <a:solidFill>
+                  <a:srgbClr val="A44F25"/>
+                </a:solidFill>
+                <a:latin typeface="Liberation Mono"/>
+              </a:rPr>
+              <a:t>256</a:t>
+            </a:r>
+            <a:r>
+              <a:rPr sz="950">
+                <a:solidFill>
+                  <a:srgbClr val="103552"/>
+                </a:solidFill>
+                <a:latin typeface="Liberation Mono"/>
+              </a:rPr>
+              <a:t>,</a:t>
+            </a:r>
+            <a:r>
+              <a:rPr sz="950">
+                <a:solidFill>
+                  <a:srgbClr val="A44F25"/>
+                </a:solidFill>
+                <a:latin typeface="Liberation Mono"/>
+              </a:rPr>
+              <a:t>64</a:t>
+            </a:r>
+            <a:r>
+              <a:rPr sz="950">
+                <a:solidFill>
+                  <a:srgbClr val="103552"/>
+                </a:solidFill>
+                <a:latin typeface="Liberation Mono"/>
+              </a:rPr>
+              <a:t>,</a:t>
+            </a:r>
+            <a:r>
+              <a:rPr sz="950">
+                <a:solidFill>
+                  <a:srgbClr val="A44F25"/>
+                </a:solidFill>
+                <a:latin typeface="Liberation Mono"/>
+              </a:rPr>
+              <a:t>64</a:t>
+            </a:r>
+            <a:r>
+              <a:rPr sz="950">
+                <a:solidFill>
+                  <a:srgbClr val="103552"/>
+                </a:solidFill>
+                <a:latin typeface="Liberation Mono"/>
+              </a:rPr>
+              <a:t>], weight_reads=</a:t>
+            </a:r>
+            <a:r>
+              <a:rPr sz="950">
+                <a:solidFill>
+                  <a:srgbClr val="A44F25"/>
+                </a:solidFill>
+                <a:latin typeface="Liberation Mono"/>
+              </a:rPr>
+              <a:t>32</a:t>
+            </a:r>
+          </a:p>
+        </p:txBody>
+      </p:sp>
+      <p:sp>
+        <p:nvSpPr>
+          <p:cNvPr id="5" name="Rounded Rectangle 4"/>
+          <p:cNvSpPr/>
+          <p:nvPr/>
+        </p:nvSpPr>
+        <p:spPr>
+          <a:xfrm>
+            <a:off x="6153912" y="4599432"/>
+            <a:ext cx="5184648" cy="685800"/>
+          </a:xfrm>
+          <a:prstGeom prst="roundRect">
+            <a:avLst/>
+          </a:prstGeom>
+          <a:solidFill>
+            <a:srgbClr val="FDF8F1"/>
+          </a:solidFill>
+          <a:ln>
+            <a:solidFill>
+              <a:srgbClr val="D3CABF"/>
+            </a:solidFill>
+          </a:ln>
+        </p:spPr>
+        <p:style>
+          <a:lnRef idx="1">
+            <a:schemeClr val="accent1"/>
+          </a:lnRef>
+          <a:fillRef idx="3">
+            <a:schemeClr val="accent1"/>
+          </a:fillRef>
+          <a:effectRef idx="2">
+            <a:schemeClr val="accent1"/>
+          </a:effectRef>
+          <a:fontRef idx="minor">
+            <a:schemeClr val="lt1"/>
+          </a:fontRef>
+        </p:style>
+        <p:txBody>
+          <a:bodyPr rtlCol="0" anchor="t" wrap="none" lIns="109728" tIns="91440" rIns="73152" bIns="36576"/>
+          <a:lstStyle/>
+          <a:p>
+            <a:pPr algn="l">
+              <a:spcBef>
+                <a:spcPts val="0"/>
+              </a:spcBef>
+              <a:spcAft>
+                <a:spcPts val="0"/>
+              </a:spcAft>
+            </a:pPr>
+            <a:r>
+              <a:rPr sz="950">
+                <a:solidFill>
+                  <a:srgbClr val="103552"/>
+                </a:solidFill>
+                <a:latin typeface="Liberation Mono"/>
+              </a:rPr>
+              <a:t>Radiance: four </a:t>
+            </a:r>
+            <a:r>
+              <a:rPr sz="950">
+                <a:solidFill>
+                  <a:srgbClr val="A44F25"/>
+                </a:solidFill>
+                <a:latin typeface="Liberation Mono"/>
+              </a:rPr>
+              <a:t>64</a:t>
+            </a:r>
+            <a:r>
+              <a:rPr sz="950">
+                <a:solidFill>
+                  <a:srgbClr val="103552"/>
+                </a:solidFill>
+                <a:latin typeface="Liberation Mono"/>
+              </a:rPr>
+              <a:t>-row passes, B re-streamed each pass</a:t>
+            </a:r>
+          </a:p>
+          <a:p>
+            <a:pPr algn="l">
+              <a:spcBef>
+                <a:spcPts val="0"/>
+              </a:spcBef>
+              <a:spcAft>
+                <a:spcPts val="0"/>
+              </a:spcAft>
+            </a:pPr>
+            <a:r>
+              <a:rPr sz="950">
+                <a:solidFill>
+                  <a:srgbClr val="103552"/>
+                </a:solidFill>
+                <a:latin typeface="Liberation Mono"/>
+              </a:rPr>
+              <a:t>Compiler: </a:t>
+            </a:r>
+            <a:r>
+              <a:rPr sz="950">
+                <a:solidFill>
+                  <a:srgbClr val="A44F25"/>
+                </a:solidFill>
+                <a:latin typeface="Liberation Mono"/>
+              </a:rPr>
+              <a:t>4</a:t>
+            </a:r>
+            <a:r>
+              <a:rPr sz="950">
+                <a:solidFill>
+                  <a:srgbClr val="103552"/>
+                </a:solidFill>
+                <a:latin typeface="Liberation Mono"/>
+              </a:rPr>
+              <a:t> output tiles, weight_reads=</a:t>
+            </a:r>
+            <a:r>
+              <a:rPr sz="950">
+                <a:solidFill>
+                  <a:srgbClr val="A44F25"/>
+                </a:solidFill>
+                <a:latin typeface="Liberation Mono"/>
+              </a:rPr>
+              <a:t>128</a:t>
+            </a:r>
+          </a:p>
+        </p:txBody>
+      </p:sp>
+      <p:sp>
+        <p:nvSpPr>
+          <p:cNvPr id="6" name="TextBox 5"/>
+          <p:cNvSpPr txBox="1"/>
+          <p:nvPr/>
+        </p:nvSpPr>
+        <p:spPr>
+          <a:xfrm>
+            <a:off x="859536" y="5504688"/>
+            <a:ext cx="10479024" cy="566928"/>
+          </a:xfrm>
+          <a:prstGeom prst="rect">
+            <a:avLst/>
+          </a:prstGeom>
+          <a:noFill/>
+        </p:spPr>
+        <p:txBody>
+          <a:bodyPr wrap="square" lIns="18288" rIns="18288" tIns="9144" bIns="9144" anchor="ctr">
+            <a:spAutoFit/>
+          </a:bodyPr>
+          <a:lstStyle/>
+          <a:p>
+            <a:pPr algn="l">
+              <a:spcBef>
+                <a:spcPts val="0"/>
+              </a:spcBef>
+              <a:spcAft>
+                <a:spcPts val="0"/>
+              </a:spcAft>
+            </a:pPr>
+            <a:r>
+              <a:rPr sz="1019" b="0">
+                <a:solidFill>
+                  <a:srgbClr val="5B5957"/>
+                </a:solidFill>
+                <a:latin typeface="Inter"/>
+              </a:rPr>
+              <a:t>We supplied Radiance's packed data and tile sizes. The compiler matched output and weight traffic; it did not discover the schedule on its own. Radiance runs on Muon+MX, this check on Rocket+MX+VPU Spike, so there is no cycle ratio. GQA PV is one stage.</a:t>
+            </a:r>
+          </a:p>
+        </p:txBody>
+      </p:sp>
+      <p:sp>
+        <p:nvSpPr>
+          <p:cNvPr id="7" name="TextBox 6"/>
+          <p:cNvSpPr txBox="1"/>
+          <p:nvPr/>
+        </p:nvSpPr>
+        <p:spPr>
+          <a:xfrm>
+            <a:off x="10469880" y="6291072"/>
+            <a:ext cx="1234440" cy="256032"/>
+          </a:xfrm>
+          <a:prstGeom prst="rect">
+            <a:avLst/>
+          </a:prstGeom>
+          <a:noFill/>
+        </p:spPr>
+        <p:txBody>
+          <a:bodyPr wrap="square" lIns="18288" rIns="18288" tIns="9144" bIns="9144" anchor="ctr">
+            <a:spAutoFit/>
+          </a:bodyPr>
+          <a:lstStyle/>
+          <a:p>
+            <a:pPr algn="r">
+              <a:spcBef>
+                <a:spcPts val="0"/>
+              </a:spcBef>
+              <a:spcAft>
+                <a:spcPts val="0"/>
+              </a:spcAft>
+            </a:pPr>
+            <a:r>
+              <a:rPr sz="1000" b="0">
+                <a:solidFill>
+                  <a:srgbClr val="5B5957"/>
+                </a:solidFill>
+                <a:latin typeface="Inter"/>
+              </a:rPr>
+              <a:t>04 / 04</a:t>
             </a:r>
           </a:p>
         </p:txBody>

</xml_diff>

<commit_message>
Clarify MX PE modes in overview slides
</commit_message>
<xml_diff>
--- a/docs/presentations/mx_gemmini_dialect_overview.pptx
+++ b/docs/presentations/mx_gemmini_dialect_overview.pptx
@@ -17966,7 +17966,7 @@
               </a:spcAft>
             </a:pPr>
             <a:r>
-              <a:rPr sz="1160" b="0">
+              <a:rPr sz="1100" b="0">
                 <a:solidFill>
                   <a:srgbClr val="313455"/>
                 </a:solidFill>
@@ -17985,13 +17985,13 @@
               </a:spcAft>
             </a:pPr>
             <a:r>
-              <a:rPr sz="1160" b="0">
+              <a:rPr sz="1100" b="0">
                 <a:solidFill>
                   <a:srgbClr val="313455"/>
                 </a:solidFill>
                 <a:latin typeface="Inter"/>
               </a:rPr>
-              <a:t>• FP4 binds PE 0; 256 KiB SPAD caps tiles.</a:t>
+              <a:t>• PE 0 = direct FP4 × FP4; PE 8 = direct FP8 × FP8.</a:t>
             </a:r>
           </a:p>
           <a:p>
@@ -18004,13 +18004,13 @@
               </a:spcAft>
             </a:pPr>
             <a:r>
-              <a:rPr sz="1160" b="0">
+              <a:rPr sz="1100" b="0">
                 <a:solidFill>
                   <a:srgbClr val="313455"/>
                 </a:solidFill>
                 <a:latin typeface="Inter"/>
               </a:rPr>
-              <a:t>• VPU/requant legal; FP6 rejects in this profile.</a:t>
+              <a:t>• 256 KiB SPAD caps tiles; VPU/requant legal.</a:t>
             </a:r>
           </a:p>
           <a:p>
@@ -18023,7 +18023,26 @@
               </a:spcAft>
             </a:pPr>
             <a:r>
-              <a:rPr sz="1160" b="0">
+              <a:rPr sz="1100" b="0">
+                <a:solidFill>
+                  <a:srgbClr val="313455"/>
+                </a:solidFill>
+                <a:latin typeface="Inter"/>
+              </a:rPr>
+              <a:t>• FP6 has no legal mode in this profile.</a:t>
+            </a:r>
+          </a:p>
+          <a:p>
+            <a:pPr algn="l">
+              <a:spcBef>
+                <a:spcPts val="0"/>
+              </a:spcBef>
+              <a:spcAft>
+                <a:spcPts val="0"/>
+              </a:spcAft>
+            </a:pPr>
+            <a:r>
+              <a:rPr sz="1100" b="0">
                 <a:solidFill>
                   <a:srgbClr val="313455"/>
                 </a:solidFill>

</xml_diff>

<commit_message>
Clarify LUT absence in MX+VPU slides
</commit_message>
<xml_diff>
--- a/docs/presentations/mx_gemmini_dialect_overview.pptx
+++ b/docs/presentations/mx_gemmini_dialect_overview.pptx
@@ -17344,7 +17344,7 @@
                 </a:solidFill>
                 <a:latin typeface="Liberation Mono"/>
               </a:rPr>
-              <a:t>"spad_requant"</a:t>
+              <a:t>"lut"</a:t>
             </a:r>
             <a:r>
               <a:rPr sz="1045">
@@ -17362,7 +17362,7 @@
                 </a:solidFill>
                 <a:latin typeface="Liberation Mono"/>
               </a:rPr>
-              <a:t>true</a:t>
+              <a:t>false</a:t>
             </a:r>
             <a:r>
               <a:rPr sz="1045">
@@ -18029,7 +18029,7 @@
                 </a:solidFill>
                 <a:latin typeface="Inter"/>
               </a:rPr>
-              <a:t>• FP6 has no legal mode in this profile.</a:t>
+              <a:t>• No operand LUT or FP6 mode in this profile.</a:t>
             </a:r>
           </a:p>
           <a:p>

</xml_diff>

<commit_message>
Document TinyLlama prefill precision drift
</commit_message>
<xml_diff>
--- a/docs/presentations/mx_gemmini_dialect_overview.pptx
+++ b/docs/presentations/mx_gemmini_dialect_overview.pptx
@@ -20052,7 +20052,7 @@
                 </a:solidFill>
                 <a:latin typeface="Inter"/>
               </a:rPr>
-              <a:t>MX results: Spike and Radiance</a:t>
+              <a:t>MX results: Spike and numerical drift</a:t>
             </a:r>
           </a:p>
         </p:txBody>
@@ -21214,7 +21214,7 @@
                 </a:solidFill>
                 <a:latin typeface="Inter"/>
               </a:rPr>
-              <a:t>Radiance GEMMs: compiler matches 16,384 BF16 each; FP8/FP4 read-once B = 128/176 KiB versus 512 KiB FP8 re-stream.</a:t>
+              <a:t>Separate TinyLlama prefill vs FP32: mixed FP4/FP8 Spike cosine -0.313; all-FP8 0.943. Neither selects the FP32 top token.</a:t>
             </a:r>
           </a:p>
           <a:p>
@@ -21233,7 +21233,7 @@
                 </a:solidFill>
                 <a:latin typeface="Inter"/>
               </a:rPr>
-              <a:t>Radiance GQA: compiled MX PV matches 65,536 source-produced BF16 values. Muon source cycles remain unpaired.</a:t>
+              <a:t>Remaining 32 decode logits and final SmolVLA actions pending; this does not assess the 64-token timing row.</a:t>
             </a:r>
           </a:p>
         </p:txBody>

</xml_diff>

<commit_message>
Archive independent TinyLlama prefill result
</commit_message>
<xml_diff>
--- a/docs/presentations/mx_gemmini_dialect_overview.pptx
+++ b/docs/presentations/mx_gemmini_dialect_overview.pptx
@@ -20708,7 +20708,7 @@
                           </a:solidFill>
                           <a:latin typeface="Inter"/>
                         </a:rPr>
-                        <a:t>TinyLlama 64-token prefill · independent</a:t>
+                        <a:t>TinyLlama 128-token prefill · independent</a:t>
                       </a:r>
                     </a:p>
                   </a:txBody>
@@ -20758,7 +20758,7 @@
                           </a:solidFill>
                           <a:latin typeface="Inter"/>
                         </a:rPr>
-                        <a:t>5,072,967,821†</a:t>
+                        <a:t>11,442,665,332†</a:t>
                       </a:r>
                     </a:p>
                   </a:txBody>
@@ -20808,7 +20808,7 @@
                           </a:solidFill>
                           <a:latin typeface="Inter"/>
                         </a:rPr>
-                        <a:t>4,328,997,732†</a:t>
+                        <a:t>9,611,186,417†</a:t>
                       </a:r>
                     </a:p>
                   </a:txBody>
@@ -21155,7 +21155,7 @@
                 </a:solidFill>
                 <a:latin typeface="Inter"/>
               </a:rPr>
-              <a:t>† Full prefill: 200 weights and 64 IDs match; cosine 0.982, token 1230. VPU adds: 44 source calls, 88 compiler regions; host math differs.</a:t>
+              <a:t>† All-FP8 prefill: 200 weights and 128 IDs match; cosine 0.945, top tokens 29871/362. Host/VPU differ; source 128 keys, compiler 160 slots; no ratio.</a:t>
             </a:r>
           </a:p>
         </p:txBody>
@@ -21233,7 +21233,7 @@
                 </a:solidFill>
                 <a:latin typeface="Inter"/>
               </a:rPr>
-              <a:t>Remaining 32 decode logits and final SmolVLA actions pending; this does not assess the 64-token timing row.</a:t>
+              <a:t>Remaining 32 decode logits and final SmolVLA actions pending; the independent cycle row has no valid speedup ratio.</a:t>
             </a:r>
           </a:p>
         </p:txBody>

</xml_diff>

<commit_message>
Archive full SmolVLA action diagnostic
</commit_message>
<xml_diff>
--- a/docs/presentations/mx_gemmini_dialect_overview.pptx
+++ b/docs/presentations/mx_gemmini_dialect_overview.pptx
@@ -18029,7 +18029,26 @@
                 </a:solidFill>
                 <a:latin typeface="Inter"/>
               </a:rPr>
-              <a:t>• No operand LUT or FP6 mode in this profile.</a:t>
+              <a:t>• Selected profile: no operand LUT or FP6.</a:t>
+            </a:r>
+          </a:p>
+          <a:p>
+            <a:pPr algn="l">
+              <a:spcBef>
+                <a:spcPts val="0"/>
+              </a:spcBef>
+              <a:spcAft>
+                <a:spcPts val="0"/>
+              </a:spcAft>
+            </a:pPr>
+            <a:r>
+              <a:rPr sz="1100" b="0">
+                <a:solidFill>
+                  <a:srgbClr val="313455"/>
+                </a:solidFill>
+                <a:latin typeface="Inter"/>
+              </a:rPr>
+              <a:t>• FP6×FP4 profile: E3M2 LUT × FP4 direct → PE 3; VPU off.</a:t>
             </a:r>
           </a:p>
           <a:p>
@@ -20052,7 +20071,7 @@
                 </a:solidFill>
                 <a:latin typeface="Inter"/>
               </a:rPr>
-              <a:t>MX results: Spike and numerical drift</a:t>
+              <a:t>MX results: full-model Spike</a:t>
             </a:r>
           </a:p>
         </p:txBody>
@@ -21214,7 +21233,7 @@
                 </a:solidFill>
                 <a:latin typeface="Inter"/>
               </a:rPr>
-              <a:t>Separate TinyLlama prefill vs FP32: mixed FP4/FP8 Spike cosine -0.313; all-FP8 0.943. Neither selects the FP32 top token.</a:t>
+              <a:t>TinyLlama prefill vs FP32: mixed FP4/FP8 cosine -0.313, all-FP8 0.943. 33-step logits pending.</a:t>
             </a:r>
           </a:p>
           <a:p>
@@ -21233,7 +21252,7 @@
                 </a:solidFill>
                 <a:latin typeface="Inter"/>
               </a:rPr>
-              <a:t>Remaining 32 decode logits and final SmolVLA actions pending; the independent cycle row has no valid speedup ratio.</a:t>
+              <a:t>SmolVLA flow 0 → final action vs FP32: cosine 0.997 → 0.054; final normalized RMSE 1.726.</a:t>
             </a:r>
           </a:p>
         </p:txBody>

</xml_diff>

<commit_message>
Update Spike slide with precision control
</commit_message>
<xml_diff>
--- a/docs/presentations/mx_gemmini_dialect_overview.pptx
+++ b/docs/presentations/mx_gemmini_dialect_overview.pptx
@@ -16498,7 +16498,7 @@
 </p:sldMaster>
 </file>
 
-<file path=ppt/slides/slide20.xml><?xml version="1.0" encoding="utf-8"?>
+<file path=ppt/slides/slide1.xml><?xml version="1.0" encoding="utf-8"?>
 <p:sld xmlns:a="http://schemas.openxmlformats.org/drawingml/2006/main" xmlns:p="http://schemas.openxmlformats.org/presentationml/2006/main" xmlns:r="http://schemas.openxmlformats.org/officeDocument/2006/relationships" showMasterSp="1">
   <p:cSld>
     <p:bg>
@@ -16557,7 +16557,7 @@
                 </a:solidFill>
                 <a:latin typeface="Inter"/>
               </a:rPr>
-              <a:t>One JSON profile changes legal MLIR</a:t>
+              <a:t>MX dialect: typed IR to RV64</a:t>
             </a:r>
           </a:p>
         </p:txBody>
@@ -16570,8 +16570,8 @@
         </p:nvSpPr>
         <p:spPr>
           <a:xfrm>
-            <a:off x="859536" y="1481328"/>
-            <a:ext cx="5522976" cy="4407408"/>
+            <a:off x="859536" y="1499616"/>
+            <a:ext cx="5166360" cy="2724912"/>
           </a:xfrm>
           <a:prstGeom prst="roundRect">
             <a:avLst/>
@@ -16615,8 +16615,8 @@
         </p:nvSpPr>
         <p:spPr>
           <a:xfrm>
-            <a:off x="6547104" y="1481328"/>
-            <a:ext cx="4800600" cy="4407408"/>
+            <a:off x="6181344" y="1499616"/>
+            <a:ext cx="5166360" cy="2724912"/>
           </a:xfrm>
           <a:prstGeom prst="roundRect">
             <a:avLst/>
@@ -16660,8 +16660,8 @@
         </p:nvSpPr>
         <p:spPr>
           <a:xfrm>
-            <a:off x="1051560" y="1636776"/>
-            <a:ext cx="5102352" cy="310896"/>
+            <a:off x="1051560" y="1664208"/>
+            <a:ext cx="4754880" cy="310896"/>
           </a:xfrm>
           <a:prstGeom prst="rect">
             <a:avLst/>
@@ -16683,13 +16683,13 @@
               </a:spcAft>
             </a:pPr>
             <a:r>
-              <a:rPr sz="1720" b="1">
+              <a:rPr sz="1750" b="1">
                 <a:solidFill>
                   <a:srgbClr val="103552"/>
                 </a:solidFill>
                 <a:latin typeface="Inter"/>
               </a:rPr>
-              <a:t>Selected RTL profile fields</a:t>
+              <a:t>FP4 GEMM → typed MX</a:t>
             </a:r>
           </a:p>
         </p:txBody>
@@ -16702,8 +16702,8 @@
         </p:nvSpPr>
         <p:spPr>
           <a:xfrm>
-            <a:off x="1051560" y="2029968"/>
-            <a:ext cx="5093208" cy="2569464"/>
+            <a:off x="1051560" y="2048256"/>
+            <a:ext cx="4754880" cy="1298448"/>
           </a:xfrm>
           <a:prstGeom prst="roundRect">
             <a:avLst/>
@@ -16744,13 +16744,112 @@
               </a:spcAft>
             </a:pPr>
             <a:r>
-              <a:rPr sz="1045">
+              <a:rPr sz="1110">
+                <a:solidFill>
+                  <a:srgbClr val="006874"/>
+                </a:solidFill>
+                <a:latin typeface="Liberation Mono"/>
+              </a:rPr>
+              <a:t>%acc</a:t>
+            </a:r>
+            <a:r>
+              <a:rPr sz="1110">
                 <a:solidFill>
                   <a:srgbClr val="103552"/>
                 </a:solidFill>
                 <a:latin typeface="Liberation Mono"/>
               </a:rPr>
-              <a:t>{</a:t>
+              <a:t> = </a:t>
+            </a:r>
+            <a:r>
+              <a:rPr sz="1110">
+                <a:solidFill>
+                  <a:srgbClr val="6C3D80"/>
+                </a:solidFill>
+                <a:latin typeface="Liberation Mono"/>
+              </a:rPr>
+              <a:t>"mx_gemmini.contract"</a:t>
+            </a:r>
+            <a:r>
+              <a:rPr sz="1110">
+                <a:solidFill>
+                  <a:srgbClr val="103552"/>
+                </a:solidFill>
+                <a:latin typeface="Liberation Mono"/>
+              </a:rPr>
+              <a:t>(</a:t>
+            </a:r>
+            <a:r>
+              <a:rPr sz="1110">
+                <a:solidFill>
+                  <a:srgbClr val="006874"/>
+                </a:solidFill>
+                <a:latin typeface="Liberation Mono"/>
+              </a:rPr>
+              <a:t>%A</a:t>
+            </a:r>
+            <a:r>
+              <a:rPr sz="1110">
+                <a:solidFill>
+                  <a:srgbClr val="103552"/>
+                </a:solidFill>
+                <a:latin typeface="Liberation Mono"/>
+              </a:rPr>
+              <a:t>,</a:t>
+            </a:r>
+            <a:r>
+              <a:rPr sz="1110">
+                <a:solidFill>
+                  <a:srgbClr val="006874"/>
+                </a:solidFill>
+                <a:latin typeface="Liberation Mono"/>
+              </a:rPr>
+              <a:t>%As</a:t>
+            </a:r>
+            <a:r>
+              <a:rPr sz="1110">
+                <a:solidFill>
+                  <a:srgbClr val="103552"/>
+                </a:solidFill>
+                <a:latin typeface="Liberation Mono"/>
+              </a:rPr>
+              <a:t>,</a:t>
+            </a:r>
+            <a:r>
+              <a:rPr sz="1110">
+                <a:solidFill>
+                  <a:srgbClr val="006874"/>
+                </a:solidFill>
+                <a:latin typeface="Liberation Mono"/>
+              </a:rPr>
+              <a:t>%B</a:t>
+            </a:r>
+            <a:r>
+              <a:rPr sz="1110">
+                <a:solidFill>
+                  <a:srgbClr val="103552"/>
+                </a:solidFill>
+                <a:latin typeface="Liberation Mono"/>
+              </a:rPr>
+              <a:t>,</a:t>
+            </a:r>
+            <a:r>
+              <a:rPr sz="1110">
+                <a:solidFill>
+                  <a:srgbClr val="006874"/>
+                </a:solidFill>
+                <a:latin typeface="Liberation Mono"/>
+              </a:rPr>
+              <a:t>%Bs</a:t>
+            </a:r>
+            <a:r>
+              <a:rPr sz="1110">
+                <a:solidFill>
+                  <a:srgbClr val="103552"/>
+                </a:solidFill>
+                <a:latin typeface="Liberation Mono"/>
+              </a:rPr>
+              <a:t>) {</a:t>
             </a:r>
           </a:p>
           <a:p>
@@ -16763,103 +16862,49 @@
               </a:spcAft>
             </a:pPr>
             <a:r>
-              <a:rPr sz="1045">
+              <a:rPr sz="1110">
                 <a:solidFill>
                   <a:srgbClr val="103552"/>
                 </a:solidFill>
                 <a:latin typeface="Liberation Mono"/>
               </a:rPr>
-              <a:t> </a:t>
-            </a:r>
-            <a:r>
-              <a:rPr sz="1045">
+              <a:t>  </a:t>
+            </a:r>
+            <a:r>
+              <a:rPr sz="1110">
                 <a:solidFill>
                   <a:srgbClr val="6C3D80"/>
                 </a:solidFill>
                 <a:latin typeface="Liberation Mono"/>
               </a:rPr>
-              <a:t>"geometry"</a:t>
-            </a:r>
-            <a:r>
-              <a:rPr sz="1045">
+              <a:t>activation_format</a:t>
+            </a:r>
+            <a:r>
+              <a:rPr sz="1110">
                 <a:solidFill>
                   <a:srgbClr val="103552"/>
                 </a:solidFill>
                 <a:latin typeface="Liberation Mono"/>
               </a:rPr>
-              <a:t>: {</a:t>
-            </a:r>
-            <a:r>
-              <a:rPr sz="1045">
-                <a:solidFill>
-                  <a:srgbClr val="6C3D80"/>
+              <a:t> = </a:t>
+            </a:r>
+            <a:r>
+              <a:rPr sz="1110">
+                <a:solidFill>
+                  <a:srgbClr val="28704F"/>
                 </a:solidFill>
                 <a:latin typeface="Liberation Mono"/>
               </a:rPr>
-              <a:t>"mesh_rows"</a:t>
-            </a:r>
-            <a:r>
-              <a:rPr sz="1045">
+              <a:t>"fp4_e2m1"</a:t>
+            </a:r>
+            <a:r>
+              <a:rPr sz="1110">
                 <a:solidFill>
                   <a:srgbClr val="103552"/>
                 </a:solidFill>
                 <a:latin typeface="Liberation Mono"/>
               </a:rPr>
-              <a:t>:</a:t>
-            </a:r>
-            <a:r>
-              <a:rPr sz="1045">
-                <a:solidFill>
-                  <a:srgbClr val="A44F25"/>
-                </a:solidFill>
-                <a:latin typeface="Liberation Mono"/>
-              </a:rPr>
-              <a:t>16</a:t>
-            </a:r>
-            <a:r>
-              <a:rPr sz="1045">
-                <a:solidFill>
-                  <a:srgbClr val="103552"/>
-                </a:solidFill>
-                <a:latin typeface="Liberation Mono"/>
-              </a:rPr>
               <a:t>,</a:t>
-            </a:r>
-            <a:r>
-              <a:rPr sz="1045">
-                <a:solidFill>
-                  <a:srgbClr val="6C3D80"/>
-                </a:solidFill>
-                <a:latin typeface="Liberation Mono"/>
-              </a:rPr>
-              <a:t>"mesh_columns"</a:t>
-            </a:r>
-            <a:r>
-              <a:rPr sz="1045">
-                <a:solidFill>
-                  <a:srgbClr val="103552"/>
-                </a:solidFill>
-                <a:latin typeface="Liberation Mono"/>
-              </a:rPr>
-              <a:t>:</a:t>
-            </a:r>
-            <a:r>
-              <a:rPr sz="1045">
-                <a:solidFill>
-                  <a:srgbClr val="A44F25"/>
-                </a:solidFill>
-                <a:latin typeface="Liberation Mono"/>
-              </a:rPr>
-              <a:t>16</a:t>
-            </a:r>
-            <a:r>
-              <a:rPr sz="1045">
-                <a:solidFill>
-                  <a:srgbClr val="103552"/>
-                </a:solidFill>
-                <a:latin typeface="Liberation Mono"/>
-              </a:rPr>
-              <a:t>},</a:t>
             </a:r>
           </a:p>
           <a:p>
@@ -16872,31 +16917,85 @@
               </a:spcAft>
             </a:pPr>
             <a:r>
-              <a:rPr sz="1045">
+              <a:rPr sz="1110">
                 <a:solidFill>
                   <a:srgbClr val="103552"/>
                 </a:solidFill>
                 <a:latin typeface="Liberation Mono"/>
               </a:rPr>
-              <a:t> </a:t>
-            </a:r>
-            <a:r>
-              <a:rPr sz="1045">
+              <a:t>  </a:t>
+            </a:r>
+            <a:r>
+              <a:rPr sz="1110">
                 <a:solidFill>
                   <a:srgbClr val="6C3D80"/>
                 </a:solidFill>
                 <a:latin typeface="Liberation Mono"/>
               </a:rPr>
-              <a:t>"legal_compute"</a:t>
-            </a:r>
-            <a:r>
-              <a:rPr sz="1045">
+              <a:t>weight_format</a:t>
+            </a:r>
+            <a:r>
+              <a:rPr sz="1110">
                 <a:solidFill>
                   <a:srgbClr val="103552"/>
                 </a:solidFill>
                 <a:latin typeface="Liberation Mono"/>
               </a:rPr>
-              <a:t>: [</a:t>
+              <a:t> = </a:t>
+            </a:r>
+            <a:r>
+              <a:rPr sz="1110">
+                <a:solidFill>
+                  <a:srgbClr val="28704F"/>
+                </a:solidFill>
+                <a:latin typeface="Liberation Mono"/>
+              </a:rPr>
+              <a:t>"fp4_e2m1"</a:t>
+            </a:r>
+            <a:r>
+              <a:rPr sz="1110">
+                <a:solidFill>
+                  <a:srgbClr val="103552"/>
+                </a:solidFill>
+                <a:latin typeface="Liberation Mono"/>
+              </a:rPr>
+              <a:t>, </a:t>
+            </a:r>
+            <a:r>
+              <a:rPr sz="1110">
+                <a:solidFill>
+                  <a:srgbClr val="6C3D80"/>
+                </a:solidFill>
+                <a:latin typeface="Liberation Mono"/>
+              </a:rPr>
+              <a:t>pe_mode</a:t>
+            </a:r>
+            <a:r>
+              <a:rPr sz="1110">
+                <a:solidFill>
+                  <a:srgbClr val="103552"/>
+                </a:solidFill>
+                <a:latin typeface="Liberation Mono"/>
+              </a:rPr>
+              <a:t> = </a:t>
+            </a:r>
+            <a:r>
+              <a:rPr sz="1110">
+                <a:solidFill>
+                  <a:srgbClr val="A44F25"/>
+                </a:solidFill>
+                <a:latin typeface="Liberation Mono"/>
+              </a:rPr>
+              <a:t>0</a:t>
+            </a:r>
+            <a:r>
+              <a:rPr sz="1110">
+                <a:solidFill>
+                  <a:srgbClr val="103552"/>
+                </a:solidFill>
+                <a:latin typeface="Liberation Mono"/>
+              </a:rPr>
+              <a:t> : i32 }</a:t>
             </a:r>
           </a:p>
           <a:p>
@@ -16909,488 +17008,58 @@
               </a:spcAft>
             </a:pPr>
             <a:r>
-              <a:rPr sz="1045">
+              <a:rPr sz="1110">
+                <a:solidFill>
+                  <a:srgbClr val="006874"/>
+                </a:solidFill>
+                <a:latin typeface="Liberation Mono"/>
+              </a:rPr>
+              <a:t>%out</a:t>
+            </a:r>
+            <a:r>
+              <a:rPr sz="1110">
                 <a:solidFill>
                   <a:srgbClr val="103552"/>
                 </a:solidFill>
                 <a:latin typeface="Liberation Mono"/>
               </a:rPr>
-              <a:t>  {</a:t>
-            </a:r>
-            <a:r>
-              <a:rPr sz="1045">
+              <a:t> = </a:t>
+            </a:r>
+            <a:r>
+              <a:rPr sz="1110">
                 <a:solidFill>
                   <a:srgbClr val="6C3D80"/>
                 </a:solidFill>
                 <a:latin typeface="Liberation Mono"/>
               </a:rPr>
-              <a:t>"activation_format"</a:t>
-            </a:r>
-            <a:r>
-              <a:rPr sz="1045">
+              <a:t>"mx_gemmini.readout_bf16"</a:t>
+            </a:r>
+            <a:r>
+              <a:rPr sz="1110">
                 <a:solidFill>
                   <a:srgbClr val="103552"/>
                 </a:solidFill>
                 <a:latin typeface="Liberation Mono"/>
               </a:rPr>
-              <a:t>:</a:t>
-            </a:r>
-            <a:r>
-              <a:rPr sz="1045">
-                <a:solidFill>
-                  <a:srgbClr val="28704F"/>
+              <a:t>(</a:t>
+            </a:r>
+            <a:r>
+              <a:rPr sz="1110">
+                <a:solidFill>
+                  <a:srgbClr val="006874"/>
                 </a:solidFill>
                 <a:latin typeface="Liberation Mono"/>
               </a:rPr>
-              <a:t>"fp4_e2m1"</a:t>
-            </a:r>
-            <a:r>
-              <a:rPr sz="1045">
+              <a:t>%acc</a:t>
+            </a:r>
+            <a:r>
+              <a:rPr sz="1110">
                 <a:solidFill>
                   <a:srgbClr val="103552"/>
                 </a:solidFill>
                 <a:latin typeface="Liberation Mono"/>
               </a:rPr>
-              <a:t>,</a:t>
-            </a:r>
-          </a:p>
-          <a:p>
-            <a:pPr algn="l">
-              <a:spcBef>
-                <a:spcPts val="0"/>
-              </a:spcBef>
-              <a:spcAft>
-                <a:spcPts val="0"/>
-              </a:spcAft>
-            </a:pPr>
-            <a:r>
-              <a:rPr sz="1045">
-                <a:solidFill>
-                  <a:srgbClr val="103552"/>
-                </a:solidFill>
-                <a:latin typeface="Liberation Mono"/>
-              </a:rPr>
-              <a:t>   </a:t>
-            </a:r>
-            <a:r>
-              <a:rPr sz="1045">
-                <a:solidFill>
-                  <a:srgbClr val="6C3D80"/>
-                </a:solidFill>
-                <a:latin typeface="Liberation Mono"/>
-              </a:rPr>
-              <a:t>"weight_format"</a:t>
-            </a:r>
-            <a:r>
-              <a:rPr sz="1045">
-                <a:solidFill>
-                  <a:srgbClr val="103552"/>
-                </a:solidFill>
-                <a:latin typeface="Liberation Mono"/>
-              </a:rPr>
-              <a:t>:</a:t>
-            </a:r>
-            <a:r>
-              <a:rPr sz="1045">
-                <a:solidFill>
-                  <a:srgbClr val="28704F"/>
-                </a:solidFill>
-                <a:latin typeface="Liberation Mono"/>
-              </a:rPr>
-              <a:t>"fp4_e2m1"</a:t>
-            </a:r>
-            <a:r>
-              <a:rPr sz="1045">
-                <a:solidFill>
-                  <a:srgbClr val="103552"/>
-                </a:solidFill>
-                <a:latin typeface="Liberation Mono"/>
-              </a:rPr>
-              <a:t>,</a:t>
-            </a:r>
-            <a:r>
-              <a:rPr sz="1045">
-                <a:solidFill>
-                  <a:srgbClr val="6C3D80"/>
-                </a:solidFill>
-                <a:latin typeface="Liberation Mono"/>
-              </a:rPr>
-              <a:t>"pe_mode"</a:t>
-            </a:r>
-            <a:r>
-              <a:rPr sz="1045">
-                <a:solidFill>
-                  <a:srgbClr val="103552"/>
-                </a:solidFill>
-                <a:latin typeface="Liberation Mono"/>
-              </a:rPr>
-              <a:t>:</a:t>
-            </a:r>
-            <a:r>
-              <a:rPr sz="1045">
-                <a:solidFill>
-                  <a:srgbClr val="A44F25"/>
-                </a:solidFill>
-                <a:latin typeface="Liberation Mono"/>
-              </a:rPr>
-              <a:t>0</a:t>
-            </a:r>
-            <a:r>
-              <a:rPr sz="1045">
-                <a:solidFill>
-                  <a:srgbClr val="103552"/>
-                </a:solidFill>
-                <a:latin typeface="Liberation Mono"/>
-              </a:rPr>
-              <a:t>},</a:t>
-            </a:r>
-          </a:p>
-          <a:p>
-            <a:pPr algn="l">
-              <a:spcBef>
-                <a:spcPts val="0"/>
-              </a:spcBef>
-              <a:spcAft>
-                <a:spcPts val="0"/>
-              </a:spcAft>
-            </a:pPr>
-            <a:r>
-              <a:rPr sz="1045">
-                <a:solidFill>
-                  <a:srgbClr val="103552"/>
-                </a:solidFill>
-                <a:latin typeface="Liberation Mono"/>
-              </a:rPr>
-              <a:t>  {</a:t>
-            </a:r>
-            <a:r>
-              <a:rPr sz="1045">
-                <a:solidFill>
-                  <a:srgbClr val="6C3D80"/>
-                </a:solidFill>
-                <a:latin typeface="Liberation Mono"/>
-              </a:rPr>
-              <a:t>"activation_format"</a:t>
-            </a:r>
-            <a:r>
-              <a:rPr sz="1045">
-                <a:solidFill>
-                  <a:srgbClr val="103552"/>
-                </a:solidFill>
-                <a:latin typeface="Liberation Mono"/>
-              </a:rPr>
-              <a:t>:</a:t>
-            </a:r>
-            <a:r>
-              <a:rPr sz="1045">
-                <a:solidFill>
-                  <a:srgbClr val="28704F"/>
-                </a:solidFill>
-                <a:latin typeface="Liberation Mono"/>
-              </a:rPr>
-              <a:t>"fp8_e4m3"</a:t>
-            </a:r>
-            <a:r>
-              <a:rPr sz="1045">
-                <a:solidFill>
-                  <a:srgbClr val="103552"/>
-                </a:solidFill>
-                <a:latin typeface="Liberation Mono"/>
-              </a:rPr>
-              <a:t>,</a:t>
-            </a:r>
-          </a:p>
-          <a:p>
-            <a:pPr algn="l">
-              <a:spcBef>
-                <a:spcPts val="0"/>
-              </a:spcBef>
-              <a:spcAft>
-                <a:spcPts val="0"/>
-              </a:spcAft>
-            </a:pPr>
-            <a:r>
-              <a:rPr sz="1045">
-                <a:solidFill>
-                  <a:srgbClr val="103552"/>
-                </a:solidFill>
-                <a:latin typeface="Liberation Mono"/>
-              </a:rPr>
-              <a:t>   </a:t>
-            </a:r>
-            <a:r>
-              <a:rPr sz="1045">
-                <a:solidFill>
-                  <a:srgbClr val="6C3D80"/>
-                </a:solidFill>
-                <a:latin typeface="Liberation Mono"/>
-              </a:rPr>
-              <a:t>"weight_format"</a:t>
-            </a:r>
-            <a:r>
-              <a:rPr sz="1045">
-                <a:solidFill>
-                  <a:srgbClr val="103552"/>
-                </a:solidFill>
-                <a:latin typeface="Liberation Mono"/>
-              </a:rPr>
-              <a:t>:</a:t>
-            </a:r>
-            <a:r>
-              <a:rPr sz="1045">
-                <a:solidFill>
-                  <a:srgbClr val="28704F"/>
-                </a:solidFill>
-                <a:latin typeface="Liberation Mono"/>
-              </a:rPr>
-              <a:t>"fp8_e4m3"</a:t>
-            </a:r>
-            <a:r>
-              <a:rPr sz="1045">
-                <a:solidFill>
-                  <a:srgbClr val="103552"/>
-                </a:solidFill>
-                <a:latin typeface="Liberation Mono"/>
-              </a:rPr>
-              <a:t>,</a:t>
-            </a:r>
-            <a:r>
-              <a:rPr sz="1045">
-                <a:solidFill>
-                  <a:srgbClr val="6C3D80"/>
-                </a:solidFill>
-                <a:latin typeface="Liberation Mono"/>
-              </a:rPr>
-              <a:t>"pe_mode"</a:t>
-            </a:r>
-            <a:r>
-              <a:rPr sz="1045">
-                <a:solidFill>
-                  <a:srgbClr val="103552"/>
-                </a:solidFill>
-                <a:latin typeface="Liberation Mono"/>
-              </a:rPr>
-              <a:t>:</a:t>
-            </a:r>
-            <a:r>
-              <a:rPr sz="1045">
-                <a:solidFill>
-                  <a:srgbClr val="A44F25"/>
-                </a:solidFill>
-                <a:latin typeface="Liberation Mono"/>
-              </a:rPr>
-              <a:t>8</a:t>
-            </a:r>
-            <a:r>
-              <a:rPr sz="1045">
-                <a:solidFill>
-                  <a:srgbClr val="103552"/>
-                </a:solidFill>
-                <a:latin typeface="Liberation Mono"/>
-              </a:rPr>
-              <a:t>}</a:t>
-            </a:r>
-          </a:p>
-          <a:p>
-            <a:pPr algn="l">
-              <a:spcBef>
-                <a:spcPts val="0"/>
-              </a:spcBef>
-              <a:spcAft>
-                <a:spcPts val="0"/>
-              </a:spcAft>
-            </a:pPr>
-            <a:r>
-              <a:rPr sz="1045">
-                <a:solidFill>
-                  <a:srgbClr val="103552"/>
-                </a:solidFill>
-                <a:latin typeface="Liberation Mono"/>
-              </a:rPr>
-              <a:t> ],</a:t>
-            </a:r>
-          </a:p>
-          <a:p>
-            <a:pPr algn="l">
-              <a:spcBef>
-                <a:spcPts val="0"/>
-              </a:spcBef>
-              <a:spcAft>
-                <a:spcPts val="0"/>
-              </a:spcAft>
-            </a:pPr>
-            <a:r>
-              <a:rPr sz="1045">
-                <a:solidFill>
-                  <a:srgbClr val="103552"/>
-                </a:solidFill>
-                <a:latin typeface="Liberation Mono"/>
-              </a:rPr>
-              <a:t> </a:t>
-            </a:r>
-            <a:r>
-              <a:rPr sz="1045">
-                <a:solidFill>
-                  <a:srgbClr val="6C3D80"/>
-                </a:solidFill>
-                <a:latin typeface="Liberation Mono"/>
-              </a:rPr>
-              <a:t>"resources"</a:t>
-            </a:r>
-            <a:r>
-              <a:rPr sz="1045">
-                <a:solidFill>
-                  <a:srgbClr val="103552"/>
-                </a:solidFill>
-                <a:latin typeface="Liberation Mono"/>
-              </a:rPr>
-              <a:t>: {</a:t>
-            </a:r>
-            <a:r>
-              <a:rPr sz="1045">
-                <a:solidFill>
-                  <a:srgbClr val="6C3D80"/>
-                </a:solidFill>
-                <a:latin typeface="Liberation Mono"/>
-              </a:rPr>
-              <a:t>"scratchpad_bytes"</a:t>
-            </a:r>
-            <a:r>
-              <a:rPr sz="1045">
-                <a:solidFill>
-                  <a:srgbClr val="103552"/>
-                </a:solidFill>
-                <a:latin typeface="Liberation Mono"/>
-              </a:rPr>
-              <a:t>:</a:t>
-            </a:r>
-            <a:r>
-              <a:rPr sz="1045">
-                <a:solidFill>
-                  <a:srgbClr val="A44F25"/>
-                </a:solidFill>
-                <a:latin typeface="Liberation Mono"/>
-              </a:rPr>
-              <a:t>262144</a:t>
-            </a:r>
-            <a:r>
-              <a:rPr sz="1045">
-                <a:solidFill>
-                  <a:srgbClr val="103552"/>
-                </a:solidFill>
-                <a:latin typeface="Liberation Mono"/>
-              </a:rPr>
-              <a:t>,</a:t>
-            </a:r>
-          </a:p>
-          <a:p>
-            <a:pPr algn="l">
-              <a:spcBef>
-                <a:spcPts val="0"/>
-              </a:spcBef>
-              <a:spcAft>
-                <a:spcPts val="0"/>
-              </a:spcAft>
-            </a:pPr>
-            <a:r>
-              <a:rPr sz="1045">
-                <a:solidFill>
-                  <a:srgbClr val="103552"/>
-                </a:solidFill>
-                <a:latin typeface="Liberation Mono"/>
-              </a:rPr>
-              <a:t>               </a:t>
-            </a:r>
-            <a:r>
-              <a:rPr sz="1045">
-                <a:solidFill>
-                  <a:srgbClr val="6C3D80"/>
-                </a:solidFill>
-                <a:latin typeface="Liberation Mono"/>
-              </a:rPr>
-              <a:t>"vpu"</a:t>
-            </a:r>
-            <a:r>
-              <a:rPr sz="1045">
-                <a:solidFill>
-                  <a:srgbClr val="103552"/>
-                </a:solidFill>
-                <a:latin typeface="Liberation Mono"/>
-              </a:rPr>
-              <a:t>:</a:t>
-            </a:r>
-            <a:r>
-              <a:rPr sz="1045">
-                <a:solidFill>
-                  <a:srgbClr val="6C3D80"/>
-                </a:solidFill>
-                <a:latin typeface="Liberation Mono"/>
-              </a:rPr>
-              <a:t>true</a:t>
-            </a:r>
-            <a:r>
-              <a:rPr sz="1045">
-                <a:solidFill>
-                  <a:srgbClr val="103552"/>
-                </a:solidFill>
-                <a:latin typeface="Liberation Mono"/>
-              </a:rPr>
-              <a:t>,</a:t>
-            </a:r>
-            <a:r>
-              <a:rPr sz="1045">
-                <a:solidFill>
-                  <a:srgbClr val="6C3D80"/>
-                </a:solidFill>
-                <a:latin typeface="Liberation Mono"/>
-              </a:rPr>
-              <a:t>"lut"</a:t>
-            </a:r>
-            <a:r>
-              <a:rPr sz="1045">
-                <a:solidFill>
-                  <a:srgbClr val="103552"/>
-                </a:solidFill>
-                <a:latin typeface="Liberation Mono"/>
-              </a:rPr>
-              <a:t>:</a:t>
-            </a:r>
-            <a:r>
-              <a:rPr sz="1045">
-                <a:solidFill>
-                  <a:srgbClr val="6C3D80"/>
-                </a:solidFill>
-                <a:latin typeface="Liberation Mono"/>
-              </a:rPr>
-              <a:t>false</a:t>
-            </a:r>
-            <a:r>
-              <a:rPr sz="1045">
-                <a:solidFill>
-                  <a:srgbClr val="103552"/>
-                </a:solidFill>
-                <a:latin typeface="Liberation Mono"/>
-              </a:rPr>
-              <a:t>}</a:t>
-            </a:r>
-          </a:p>
-          <a:p>
-            <a:pPr algn="l">
-              <a:spcBef>
-                <a:spcPts val="0"/>
-              </a:spcBef>
-              <a:spcAft>
-                <a:spcPts val="0"/>
-              </a:spcAft>
-            </a:pPr>
-            <a:r>
-              <a:rPr sz="1045">
-                <a:solidFill>
-                  <a:srgbClr val="103552"/>
-                </a:solidFill>
-                <a:latin typeface="Liberation Mono"/>
-              </a:rPr>
-              <a:t>}</a:t>
+              <a:t>)</a:t>
             </a:r>
           </a:p>
         </p:txBody>
@@ -17403,8 +17072,8 @@
         </p:nvSpPr>
         <p:spPr>
           <a:xfrm>
-            <a:off x="1051560" y="4736592"/>
-            <a:ext cx="5093208" cy="475488"/>
+            <a:off x="1051560" y="3438144"/>
+            <a:ext cx="4727448" cy="685800"/>
           </a:xfrm>
           <a:prstGeom prst="rect">
             <a:avLst/>
@@ -17426,13 +17095,13 @@
               </a:spcAft>
             </a:pPr>
             <a:r>
-              <a:rPr sz="1110" b="0">
+              <a:rPr sz="1060" b="0">
                 <a:solidFill>
                   <a:srgbClr val="313455"/>
                 </a:solidFill>
                 <a:latin typeface="Inter"/>
               </a:rPr>
-              <a:t>MxE4M3Fp4VpuGemminiRocketConfig · direct projections in both legal rows · two 8-lane BF16 VPUs.</a:t>
+              <a:t>resource supplies packed A/B codes + E8M0 scales. contract computes C[m,n] = Σk A[m,k]×B[k,n] in the selected PE mode; readout_bf16 returns BF16. VPU can do softmax; Radiance uses Muon SIMT.</a:t>
             </a:r>
           </a:p>
         </p:txBody>
@@ -17445,8 +17114,8 @@
         </p:nvSpPr>
         <p:spPr>
           <a:xfrm>
-            <a:off x="1051560" y="5312664"/>
-            <a:ext cx="5093208" cy="356616"/>
+            <a:off x="6382512" y="1664208"/>
+            <a:ext cx="4754880" cy="310896"/>
           </a:xfrm>
           <a:prstGeom prst="rect">
             <a:avLst/>
@@ -17468,69 +17137,27 @@
               </a:spcAft>
             </a:pPr>
             <a:r>
-              <a:rPr sz="1040" b="0">
-                <a:solidFill>
-                  <a:srgbClr val="5B5957"/>
-                </a:solidFill>
-                <a:latin typeface="Inter"/>
-              </a:rPr>
-              <a:t>RTL 266c593 + MxGen dba3e7 → 41 fragments / 40 SoC wrappers; each JSON stores source hashes.</a:t>
+              <a:rPr sz="1750" b="1">
+                <a:solidFill>
+                  <a:srgbClr val="103552"/>
+                </a:solidFill>
+                <a:latin typeface="Inter"/>
+              </a:rPr>
+              <a:t>Compiled attention object → binary</a:t>
             </a:r>
           </a:p>
         </p:txBody>
       </p:sp>
       <p:sp>
         <p:nvSpPr>
-          <p:cNvPr id="12" name="TextBox 11"/>
-          <p:cNvSpPr txBox="1"/>
-          <p:nvPr/>
-        </p:nvSpPr>
-        <p:spPr>
-          <a:xfrm>
-            <a:off x="6748272" y="1636776"/>
-            <a:ext cx="4370832" cy="310896"/>
-          </a:xfrm>
-          <a:prstGeom prst="rect">
-            <a:avLst/>
-          </a:prstGeom>
-          <a:noFill/>
-        </p:spPr>
-        <p:txBody>
-          <a:bodyPr wrap="square" lIns="18288" rIns="18288" tIns="9144" bIns="9144" anchor="ctr">
-            <a:spAutoFit/>
-          </a:bodyPr>
-          <a:lstStyle/>
-          <a:p>
-            <a:pPr algn="l">
-              <a:spcBef>
-                <a:spcPts val="0"/>
-              </a:spcBef>
-              <a:spcAft>
-                <a:spcPts val="0"/>
-              </a:spcAft>
-            </a:pPr>
-            <a:r>
-              <a:rPr sz="1720" b="1">
-                <a:solidFill>
-                  <a:srgbClr val="103552"/>
-                </a:solidFill>
-                <a:latin typeface="Inter"/>
-              </a:rPr>
-              <a:t>Before → after bind_profile</a:t>
-            </a:r>
-          </a:p>
-        </p:txBody>
-      </p:sp>
-      <p:sp>
-        <p:nvSpPr>
-          <p:cNvPr id="13" name="Rounded Rectangle 12"/>
+          <p:cNvPr id="12" name="Rounded Rectangle 11"/>
           <p:cNvSpPr/>
           <p:nvPr/>
         </p:nvSpPr>
         <p:spPr>
           <a:xfrm>
-            <a:off x="6748272" y="2029968"/>
-            <a:ext cx="4379976" cy="1499616"/>
+            <a:off x="6382512" y="2048256"/>
+            <a:ext cx="4754880" cy="1298448"/>
           </a:xfrm>
           <a:prstGeom prst="roundRect">
             <a:avLst/>
@@ -17571,58 +17198,40 @@
               </a:spcAft>
             </a:pPr>
             <a:r>
-              <a:rPr sz="1085">
+              <a:rPr sz="1030">
                 <a:solidFill>
                   <a:srgbClr val="6C3D80"/>
                 </a:solidFill>
                 <a:latin typeface="Liberation Mono"/>
               </a:rPr>
-              <a:t>before</a:t>
-            </a:r>
-            <a:r>
-              <a:rPr sz="1085">
+              <a:t>__asm__</a:t>
+            </a:r>
+            <a:r>
+              <a:rPr sz="1030">
                 <a:solidFill>
                   <a:srgbClr val="103552"/>
                 </a:solidFill>
                 <a:latin typeface="Liberation Mono"/>
               </a:rPr>
-              <a:t>: </a:t>
-            </a:r>
-            <a:r>
-              <a:rPr sz="1085">
+              <a:t> </a:t>
+            </a:r>
+            <a:r>
+              <a:rPr sz="1030">
                 <a:solidFill>
                   <a:srgbClr val="6C3D80"/>
                 </a:solidFill>
                 <a:latin typeface="Liberation Mono"/>
               </a:rPr>
-              <a:t>contract</a:t>
-            </a:r>
-            <a:r>
-              <a:rPr sz="1085">
+              <a:t>volatile</a:t>
+            </a:r>
+            <a:r>
+              <a:rPr sz="1030">
                 <a:solidFill>
                   <a:srgbClr val="103552"/>
                 </a:solidFill>
                 <a:latin typeface="Liberation Mono"/>
               </a:rPr>
-              <a:t> {format = </a:t>
-            </a:r>
-            <a:r>
-              <a:rPr sz="1085">
-                <a:solidFill>
-                  <a:srgbClr val="28704F"/>
-                </a:solidFill>
-                <a:latin typeface="Liberation Mono"/>
-              </a:rPr>
-              <a:t>"mxfp4"</a:t>
-            </a:r>
-            <a:r>
-              <a:rPr sz="1085">
-                <a:solidFill>
-                  <a:srgbClr val="103552"/>
-                </a:solidFill>
-                <a:latin typeface="Liberation Mono"/>
-              </a:rPr>
-              <a:t>}</a:t>
+              <a:t>(</a:t>
             </a:r>
           </a:p>
           <a:p>
@@ -17635,40 +17244,22 @@
               </a:spcAft>
             </a:pPr>
             <a:r>
-              <a:rPr sz="1085">
-                <a:solidFill>
-                  <a:srgbClr val="6C3D80"/>
+              <a:rPr sz="1030">
+                <a:solidFill>
+                  <a:srgbClr val="103552"/>
                 </a:solidFill>
                 <a:latin typeface="Liberation Mono"/>
               </a:rPr>
-              <a:t>after</a:t>
-            </a:r>
-            <a:r>
-              <a:rPr sz="1085">
-                <a:solidFill>
-                  <a:srgbClr val="103552"/>
+              <a:t>  </a:t>
+            </a:r>
+            <a:r>
+              <a:rPr sz="1030">
+                <a:solidFill>
+                  <a:srgbClr val="28704F"/>
                 </a:solidFill>
                 <a:latin typeface="Liberation Mono"/>
               </a:rPr>
-              <a:t>:  </a:t>
-            </a:r>
-            <a:r>
-              <a:rPr sz="1085">
-                <a:solidFill>
-                  <a:srgbClr val="6C3D80"/>
-                </a:solidFill>
-                <a:latin typeface="Liberation Mono"/>
-              </a:rPr>
-              <a:t>contract</a:t>
-            </a:r>
-            <a:r>
-              <a:rPr sz="1085">
-                <a:solidFill>
-                  <a:srgbClr val="103552"/>
-                </a:solidFill>
-                <a:latin typeface="Liberation Mono"/>
-              </a:rPr>
-              <a:t> {</a:t>
+              <a:t>".insn r 0x7b, 3, 2, x0, %0, %1"</a:t>
             </a:r>
           </a:p>
           <a:p>
@@ -17681,49 +17272,31 @@
               </a:spcAft>
             </a:pPr>
             <a:r>
-              <a:rPr sz="1085">
+              <a:rPr sz="1030">
                 <a:solidFill>
                   <a:srgbClr val="103552"/>
                 </a:solidFill>
                 <a:latin typeface="Liberation Mono"/>
               </a:rPr>
-              <a:t>  </a:t>
-            </a:r>
-            <a:r>
-              <a:rPr sz="1085">
-                <a:solidFill>
-                  <a:srgbClr val="6C3D80"/>
+              <a:t>  : : </a:t>
+            </a:r>
+            <a:r>
+              <a:rPr sz="1030">
+                <a:solidFill>
+                  <a:srgbClr val="28704F"/>
                 </a:solidFill>
                 <a:latin typeface="Liberation Mono"/>
               </a:rPr>
-              <a:t>activation_format</a:t>
-            </a:r>
-            <a:r>
-              <a:rPr sz="1085">
+              <a:t>"r"</a:t>
+            </a:r>
+            <a:r>
+              <a:rPr sz="1030">
                 <a:solidFill>
                   <a:srgbClr val="103552"/>
                 </a:solidFill>
                 <a:latin typeface="Liberation Mono"/>
               </a:rPr>
-              <a:t> = </a:t>
-            </a:r>
-            <a:r>
-              <a:rPr sz="1085">
-                <a:solidFill>
-                  <a:srgbClr val="28704F"/>
-                </a:solidFill>
-                <a:latin typeface="Liberation Mono"/>
-              </a:rPr>
-              <a:t>"fp4_e2m1"</a:t>
-            </a:r>
-            <a:r>
-              <a:rPr sz="1085">
-                <a:solidFill>
-                  <a:srgbClr val="103552"/>
-                </a:solidFill>
-                <a:latin typeface="Liberation Mono"/>
-              </a:rPr>
-              <a:t>,</a:t>
+              <a:t>(Q_IN),</a:t>
             </a:r>
           </a:p>
           <a:p>
@@ -17736,49 +17309,49 @@
               </a:spcAft>
             </a:pPr>
             <a:r>
-              <a:rPr sz="1085">
+              <a:rPr sz="1030">
                 <a:solidFill>
                   <a:srgbClr val="103552"/>
                 </a:solidFill>
                 <a:latin typeface="Liberation Mono"/>
               </a:rPr>
-              <a:t>  </a:t>
-            </a:r>
-            <a:r>
-              <a:rPr sz="1085">
-                <a:solidFill>
-                  <a:srgbClr val="6C3D80"/>
+              <a:t>      </a:t>
+            </a:r>
+            <a:r>
+              <a:rPr sz="1030">
+                <a:solidFill>
+                  <a:srgbClr val="28704F"/>
                 </a:solidFill>
                 <a:latin typeface="Liberation Mono"/>
               </a:rPr>
-              <a:t>weight_format</a:t>
-            </a:r>
-            <a:r>
-              <a:rPr sz="1085">
+              <a:t>"r"</a:t>
+            </a:r>
+            <a:r>
+              <a:rPr sz="1030">
                 <a:solidFill>
                   <a:srgbClr val="103552"/>
                 </a:solidFill>
                 <a:latin typeface="Liberation Mono"/>
               </a:rPr>
-              <a:t> = </a:t>
-            </a:r>
-            <a:r>
-              <a:rPr sz="1085">
-                <a:solidFill>
-                  <a:srgbClr val="28704F"/>
+              <a:t>(</a:t>
+            </a:r>
+            <a:r>
+              <a:rPr sz="1030">
+                <a:solidFill>
+                  <a:srgbClr val="A44F25"/>
                 </a:solidFill>
                 <a:latin typeface="Liberation Mono"/>
               </a:rPr>
-              <a:t>"fp4_e2m1"</a:t>
-            </a:r>
-            <a:r>
-              <a:rPr sz="1085">
+              <a:t>0x0010001000000000</a:t>
+            </a:r>
+            <a:r>
+              <a:rPr sz="1030">
                 <a:solidFill>
                   <a:srgbClr val="103552"/>
                 </a:solidFill>
                 <a:latin typeface="Liberation Mono"/>
               </a:rPr>
-              <a:t>,</a:t>
+              <a:t>));</a:t>
             </a:r>
           </a:p>
           <a:p>
@@ -17791,118 +17364,63 @@
               </a:spcAft>
             </a:pPr>
             <a:r>
-              <a:rPr sz="1085">
+              <a:rPr sz="1030">
+                <a:solidFill>
+                  <a:srgbClr val="6C3D80"/>
+                </a:solidFill>
+                <a:latin typeface="Liberation Mono"/>
+              </a:rPr>
+              <a:t>objdump</a:t>
+            </a:r>
+            <a:r>
+              <a:rPr sz="1030">
                 <a:solidFill>
                   <a:srgbClr val="103552"/>
                 </a:solidFill>
                 <a:latin typeface="Liberation Mono"/>
               </a:rPr>
-              <a:t>  </a:t>
-            </a:r>
-            <a:r>
-              <a:rPr sz="1085">
-                <a:solidFill>
-                  <a:srgbClr val="6C3D80"/>
+              <a:t>: 4a: 04b6b07b  .insn </a:t>
+            </a:r>
+            <a:r>
+              <a:rPr sz="1030">
+                <a:solidFill>
+                  <a:srgbClr val="A44F25"/>
                 </a:solidFill>
                 <a:latin typeface="Liberation Mono"/>
               </a:rPr>
-              <a:t>pe_mode</a:t>
-            </a:r>
-            <a:r>
-              <a:rPr sz="1085">
+              <a:t>4</a:t>
+            </a:r>
+            <a:r>
+              <a:rPr sz="1030">
                 <a:solidFill>
                   <a:srgbClr val="103552"/>
                 </a:solidFill>
                 <a:latin typeface="Liberation Mono"/>
               </a:rPr>
-              <a:t> = </a:t>
-            </a:r>
-            <a:r>
-              <a:rPr sz="1085">
+              <a:t>, </a:t>
+            </a:r>
+            <a:r>
+              <a:rPr sz="1030">
                 <a:solidFill>
                   <a:srgbClr val="A44F25"/>
                 </a:solidFill>
                 <a:latin typeface="Liberation Mono"/>
               </a:rPr>
-              <a:t>0</a:t>
-            </a:r>
-            <a:r>
-              <a:rPr sz="1085">
-                <a:solidFill>
-                  <a:srgbClr val="103552"/>
-                </a:solidFill>
-                <a:latin typeface="Liberation Mono"/>
-              </a:rPr>
-              <a:t> : i32,</a:t>
-            </a:r>
-          </a:p>
-          <a:p>
-            <a:pPr algn="l">
-              <a:spcBef>
-                <a:spcPts val="0"/>
-              </a:spcBef>
-              <a:spcAft>
-                <a:spcPts val="0"/>
-              </a:spcAft>
-            </a:pPr>
-            <a:r>
-              <a:rPr sz="1085">
-                <a:solidFill>
-                  <a:srgbClr val="103552"/>
-                </a:solidFill>
-                <a:latin typeface="Liberation Mono"/>
-              </a:rPr>
-              <a:t>  </a:t>
-            </a:r>
-            <a:r>
-              <a:rPr sz="1085">
-                <a:solidFill>
-                  <a:srgbClr val="6C3D80"/>
-                </a:solidFill>
-                <a:latin typeface="Liberation Mono"/>
-              </a:rPr>
-              <a:t>profile_sha256</a:t>
-            </a:r>
-            <a:r>
-              <a:rPr sz="1085">
-                <a:solidFill>
-                  <a:srgbClr val="103552"/>
-                </a:solidFill>
-                <a:latin typeface="Liberation Mono"/>
-              </a:rPr>
-              <a:t> = </a:t>
-            </a:r>
-            <a:r>
-              <a:rPr sz="1085">
-                <a:solidFill>
-                  <a:srgbClr val="28704F"/>
-                </a:solidFill>
-                <a:latin typeface="Liberation Mono"/>
-              </a:rPr>
-              <a:t>"e9e33f..."</a:t>
-            </a:r>
-            <a:r>
-              <a:rPr sz="1085">
-                <a:solidFill>
-                  <a:srgbClr val="103552"/>
-                </a:solidFill>
-                <a:latin typeface="Liberation Mono"/>
-              </a:rPr>
-              <a:t> }</a:t>
+              <a:t>0x04b6b07b</a:t>
             </a:r>
           </a:p>
         </p:txBody>
       </p:sp>
       <p:sp>
         <p:nvSpPr>
-          <p:cNvPr id="14" name="TextBox 13"/>
+          <p:cNvPr id="13" name="TextBox 12"/>
           <p:cNvSpPr txBox="1"/>
           <p:nvPr/>
         </p:nvSpPr>
         <p:spPr>
           <a:xfrm>
-            <a:off x="6748272" y="3712463"/>
-            <a:ext cx="4370832" cy="274320"/>
+            <a:off x="6382512" y="3493008"/>
+            <a:ext cx="4727448" cy="548640"/>
           </a:xfrm>
           <a:prstGeom prst="rect">
             <a:avLst/>
@@ -17924,27 +17442,27 @@
               </a:spcAft>
             </a:pPr>
             <a:r>
-              <a:rPr sz="1410" b="1">
-                <a:solidFill>
-                  <a:srgbClr val="103552"/>
-                </a:solidFill>
-                <a:latin typeface="Inter"/>
-              </a:rPr>
-              <a:t>Compiler consequences</a:t>
+              <a:rPr sz="1100" b="0">
+                <a:solidFill>
+                  <a:srgbClr val="313455"/>
+                </a:solidFill>
+                <a:latin typeface="Inter"/>
+              </a:rPr>
+              <a:t>physical_program orders mvin → compute → VPU → mvout. RoCC C + data asm → RV64 GCC → ELF → Nicolas Spike.</a:t>
             </a:r>
           </a:p>
         </p:txBody>
       </p:sp>
       <p:sp>
         <p:nvSpPr>
-          <p:cNvPr id="15" name="TextBox 14"/>
+          <p:cNvPr id="14" name="TextBox 13"/>
           <p:cNvSpPr txBox="1"/>
           <p:nvPr/>
         </p:nvSpPr>
         <p:spPr>
           <a:xfrm>
-            <a:off x="6748272" y="4041648"/>
-            <a:ext cx="4370832" cy="1481328"/>
+            <a:off x="877824" y="4352544"/>
+            <a:ext cx="10424160" cy="274320"/>
           </a:xfrm>
           <a:prstGeom prst="rect">
             <a:avLst/>
@@ -17966,109 +17484,59 @@
               </a:spcAft>
             </a:pPr>
             <a:r>
-              <a:rPr sz="1100" b="0">
-                <a:solidFill>
-                  <a:srgbClr val="313455"/>
-                </a:solidFill>
-                <a:latin typeface="Inter"/>
-              </a:rPr>
-              <a:t>• TinyLlama: 155 FP4 / 45 FP8 MX sites per stage.</a:t>
-            </a:r>
-          </a:p>
-          <a:p>
-            <a:pPr algn="l">
-              <a:spcBef>
-                <a:spcPts val="0"/>
-              </a:spcBef>
-              <a:spcAft>
-                <a:spcPts val="0"/>
-              </a:spcAft>
-            </a:pPr>
-            <a:r>
-              <a:rPr sz="1100" b="0">
-                <a:solidFill>
-                  <a:srgbClr val="313455"/>
-                </a:solidFill>
-                <a:latin typeface="Inter"/>
-              </a:rPr>
-              <a:t>• PE 0 = direct FP4 × FP4; PE 8 = direct FP8 × FP8.</a:t>
-            </a:r>
-          </a:p>
-          <a:p>
-            <a:pPr algn="l">
-              <a:spcBef>
-                <a:spcPts val="0"/>
-              </a:spcBef>
-              <a:spcAft>
-                <a:spcPts val="0"/>
-              </a:spcAft>
-            </a:pPr>
-            <a:r>
-              <a:rPr sz="1100" b="0">
-                <a:solidFill>
-                  <a:srgbClr val="313455"/>
-                </a:solidFill>
-                <a:latin typeface="Inter"/>
-              </a:rPr>
-              <a:t>• 256 KiB SPAD caps tiles; VPU/requant legal.</a:t>
-            </a:r>
-          </a:p>
-          <a:p>
-            <a:pPr algn="l">
-              <a:spcBef>
-                <a:spcPts val="0"/>
-              </a:spcBef>
-              <a:spcAft>
-                <a:spcPts val="0"/>
-              </a:spcAft>
-            </a:pPr>
-            <a:r>
-              <a:rPr sz="1100" b="0">
-                <a:solidFill>
-                  <a:srgbClr val="313455"/>
-                </a:solidFill>
-                <a:latin typeface="Inter"/>
-              </a:rPr>
-              <a:t>• Selected profile: no operand LUT or FP6.</a:t>
-            </a:r>
-          </a:p>
-          <a:p>
-            <a:pPr algn="l">
-              <a:spcBef>
-                <a:spcPts val="0"/>
-              </a:spcBef>
-              <a:spcAft>
-                <a:spcPts val="0"/>
-              </a:spcAft>
-            </a:pPr>
-            <a:r>
-              <a:rPr sz="1100" b="0">
-                <a:solidFill>
-                  <a:srgbClr val="313455"/>
-                </a:solidFill>
-                <a:latin typeface="Inter"/>
-              </a:rPr>
-              <a:t>• FP6×FP4 profile: E3M2 LUT × FP4 direct → PE 3; VPU off.</a:t>
-            </a:r>
-          </a:p>
-          <a:p>
-            <a:pPr algn="l">
-              <a:spcBef>
-                <a:spcPts val="0"/>
-              </a:spcBef>
-              <a:spcAft>
-                <a:spcPts val="0"/>
-              </a:spcAft>
-            </a:pPr>
-            <a:r>
-              <a:rPr sz="1100" b="0">
-                <a:solidFill>
-                  <a:srgbClr val="313455"/>
-                </a:solidFill>
-                <a:latin typeface="Inter"/>
-              </a:rPr>
-              <a:t>• load_profile(profile, rtl_root=rtl) rejects drift.</a:t>
-            </a:r>
+              <a:rPr sz="1600" b="1">
+                <a:solidFill>
+                  <a:srgbClr val="103552"/>
+                </a:solidFill>
+                <a:latin typeface="Inter"/>
+              </a:rPr>
+              <a:t>Implemented transforms and checks</a:t>
+            </a:r>
+          </a:p>
+        </p:txBody>
+      </p:sp>
+      <p:sp>
+        <p:nvSpPr>
+          <p:cNvPr id="15" name="Rounded Rectangle 14"/>
+          <p:cNvSpPr/>
+          <p:nvPr/>
+        </p:nvSpPr>
+        <p:spPr>
+          <a:xfrm>
+            <a:off x="859536" y="4709160"/>
+            <a:ext cx="1965960" cy="987552"/>
+          </a:xfrm>
+          <a:prstGeom prst="roundRect">
+            <a:avLst/>
+          </a:prstGeom>
+          <a:solidFill>
+            <a:srgbClr val="FDF8F1"/>
+          </a:solidFill>
+          <a:ln>
+            <a:solidFill>
+              <a:srgbClr val="B0A597"/>
+            </a:solidFill>
+          </a:ln>
+        </p:spPr>
+        <p:style>
+          <a:lnRef idx="1">
+            <a:schemeClr val="accent1"/>
+          </a:lnRef>
+          <a:fillRef idx="3">
+            <a:schemeClr val="accent1"/>
+          </a:fillRef>
+          <a:effectRef idx="2">
+            <a:schemeClr val="accent1"/>
+          </a:effectRef>
+          <a:fontRef idx="minor">
+            <a:schemeClr val="lt1"/>
+          </a:fontRef>
+        </p:style>
+        <p:txBody>
+          <a:bodyPr rtlCol="0" anchor="ctr"/>
+          <a:lstStyle/>
+          <a:p>
+            <a:pPr algn="ctr"/>
           </a:p>
         </p:txBody>
       </p:sp>
@@ -18080,8 +17548,8 @@
         </p:nvSpPr>
         <p:spPr>
           <a:xfrm>
-            <a:off x="877824" y="5943600"/>
-            <a:ext cx="10469880" cy="228600"/>
+            <a:off x="950976" y="4800600"/>
+            <a:ext cx="1783080" cy="338328"/>
           </a:xfrm>
           <a:prstGeom prst="rect">
             <a:avLst/>
@@ -18094,7 +17562,7 @@
           </a:bodyPr>
           <a:lstStyle/>
           <a:p>
-            <a:pPr algn="l">
+            <a:pPr algn="ctr">
               <a:spcBef>
                 <a:spcPts val="0"/>
               </a:spcBef>
@@ -18103,13 +17571,13 @@
               </a:spcAft>
             </a:pPr>
             <a:r>
-              <a:rPr sz="1019" b="0">
-                <a:solidFill>
-                  <a:srgbClr val="5B5957"/>
-                </a:solidFill>
-                <a:latin typeface="Inter"/>
-              </a:rPr>
-              <a:t>npu-exploration supplies source kernels for per-mode Spike checks; the RTL profile alone is structural, not a performance claim.</a:t>
+              <a:rPr sz="1170" b="1">
+                <a:solidFill>
+                  <a:srgbClr val="103552"/>
+                </a:solidFill>
+                <a:latin typeface="Inter"/>
+              </a:rPr>
+              <a:t>bind_profile</a:t>
             </a:r>
           </a:p>
         </p:txBody>
@@ -18117,6 +17585,720 @@
       <p:sp>
         <p:nvSpPr>
           <p:cNvPr id="17" name="TextBox 16"/>
+          <p:cNvSpPr txBox="1"/>
+          <p:nvPr/>
+        </p:nvSpPr>
+        <p:spPr>
+          <a:xfrm>
+            <a:off x="950976" y="5230368"/>
+            <a:ext cx="1783080" cy="365760"/>
+          </a:xfrm>
+          <a:prstGeom prst="rect">
+            <a:avLst/>
+          </a:prstGeom>
+          <a:noFill/>
+        </p:spPr>
+        <p:txBody>
+          <a:bodyPr wrap="square" lIns="18288" rIns="18288" tIns="9144" bIns="9144" anchor="ctr">
+            <a:spAutoFit/>
+          </a:bodyPr>
+          <a:lstStyle/>
+          <a:p>
+            <a:pPr algn="ctr">
+              <a:spcBef>
+                <a:spcPts val="0"/>
+              </a:spcBef>
+              <a:spcAft>
+                <a:spcPts val="0"/>
+              </a:spcAft>
+            </a:pPr>
+            <a:r>
+              <a:rPr sz="1080" b="0">
+                <a:solidFill>
+                  <a:srgbClr val="313455"/>
+                </a:solidFill>
+                <a:latin typeface="Inter"/>
+              </a:rPr>
+              <a:t>Legal PE tuple +</a:t>
+            </a:r>
+          </a:p>
+          <a:p>
+            <a:pPr algn="ctr">
+              <a:spcBef>
+                <a:spcPts val="0"/>
+              </a:spcBef>
+              <a:spcAft>
+                <a:spcPts val="0"/>
+              </a:spcAft>
+            </a:pPr>
+            <a:r>
+              <a:rPr sz="1080" b="0">
+                <a:solidFill>
+                  <a:srgbClr val="313455"/>
+                </a:solidFill>
+                <a:latin typeface="Inter"/>
+              </a:rPr>
+              <a:t>profile digest</a:t>
+            </a:r>
+          </a:p>
+        </p:txBody>
+      </p:sp>
+      <p:sp>
+        <p:nvSpPr>
+          <p:cNvPr id="18" name="Rounded Rectangle 17"/>
+          <p:cNvSpPr/>
+          <p:nvPr/>
+        </p:nvSpPr>
+        <p:spPr>
+          <a:xfrm>
+            <a:off x="2999232" y="4709160"/>
+            <a:ext cx="1965960" cy="987552"/>
+          </a:xfrm>
+          <a:prstGeom prst="roundRect">
+            <a:avLst/>
+          </a:prstGeom>
+          <a:solidFill>
+            <a:srgbClr val="E1E8EC"/>
+          </a:solidFill>
+          <a:ln>
+            <a:solidFill>
+              <a:srgbClr val="B0A597"/>
+            </a:solidFill>
+          </a:ln>
+        </p:spPr>
+        <p:style>
+          <a:lnRef idx="1">
+            <a:schemeClr val="accent1"/>
+          </a:lnRef>
+          <a:fillRef idx="3">
+            <a:schemeClr val="accent1"/>
+          </a:fillRef>
+          <a:effectRef idx="2">
+            <a:schemeClr val="accent1"/>
+          </a:effectRef>
+          <a:fontRef idx="minor">
+            <a:schemeClr val="lt1"/>
+          </a:fontRef>
+        </p:style>
+        <p:txBody>
+          <a:bodyPr rtlCol="0" anchor="ctr"/>
+          <a:lstStyle/>
+          <a:p>
+            <a:pPr algn="ctr"/>
+          </a:p>
+        </p:txBody>
+      </p:sp>
+      <p:sp>
+        <p:nvSpPr>
+          <p:cNvPr id="19" name="TextBox 18"/>
+          <p:cNvSpPr txBox="1"/>
+          <p:nvPr/>
+        </p:nvSpPr>
+        <p:spPr>
+          <a:xfrm>
+            <a:off x="3090672" y="4800600"/>
+            <a:ext cx="1783080" cy="338328"/>
+          </a:xfrm>
+          <a:prstGeom prst="rect">
+            <a:avLst/>
+          </a:prstGeom>
+          <a:noFill/>
+        </p:spPr>
+        <p:txBody>
+          <a:bodyPr wrap="square" lIns="18288" rIns="18288" tIns="9144" bIns="9144" anchor="ctr">
+            <a:spAutoFit/>
+          </a:bodyPr>
+          <a:lstStyle/>
+          <a:p>
+            <a:pPr algn="ctr">
+              <a:spcBef>
+                <a:spcPts val="0"/>
+              </a:spcBef>
+              <a:spcAft>
+                <a:spcPts val="0"/>
+              </a:spcAft>
+            </a:pPr>
+            <a:r>
+              <a:rPr sz="1170" b="1">
+                <a:solidFill>
+                  <a:srgbClr val="103552"/>
+                </a:solidFill>
+                <a:latin typeface="Inter"/>
+              </a:rPr>
+              <a:t>MXBF16Catalog</a:t>
+            </a:r>
+          </a:p>
+          <a:p>
+            <a:pPr algn="ctr">
+              <a:spcBef>
+                <a:spcPts val="0"/>
+              </a:spcBef>
+              <a:spcAft>
+                <a:spcPts val="0"/>
+              </a:spcAft>
+            </a:pPr>
+            <a:r>
+              <a:rPr sz="1170" b="1">
+                <a:solidFill>
+                  <a:srgbClr val="103552"/>
+                </a:solidFill>
+                <a:latin typeface="Inter"/>
+              </a:rPr>
+              <a:t>Preparation</a:t>
+            </a:r>
+          </a:p>
+        </p:txBody>
+      </p:sp>
+      <p:sp>
+        <p:nvSpPr>
+          <p:cNvPr id="20" name="TextBox 19"/>
+          <p:cNvSpPr txBox="1"/>
+          <p:nvPr/>
+        </p:nvSpPr>
+        <p:spPr>
+          <a:xfrm>
+            <a:off x="3090672" y="5230368"/>
+            <a:ext cx="1783080" cy="365760"/>
+          </a:xfrm>
+          <a:prstGeom prst="rect">
+            <a:avLst/>
+          </a:prstGeom>
+          <a:noFill/>
+        </p:spPr>
+        <p:txBody>
+          <a:bodyPr wrap="square" lIns="18288" rIns="18288" tIns="9144" bIns="9144" anchor="ctr">
+            <a:spAutoFit/>
+          </a:bodyPr>
+          <a:lstStyle/>
+          <a:p>
+            <a:pPr algn="ctr">
+              <a:spcBef>
+                <a:spcPts val="0"/>
+              </a:spcBef>
+              <a:spcAft>
+                <a:spcPts val="0"/>
+              </a:spcAft>
+            </a:pPr>
+            <a:r>
+              <a:rPr sz="1080" b="0">
+                <a:solidFill>
+                  <a:srgbClr val="313455"/>
+                </a:solidFill>
+                <a:latin typeface="Inter"/>
+              </a:rPr>
+              <a:t>Select BF16</a:t>
+            </a:r>
+          </a:p>
+          <a:p>
+            <a:pPr algn="ctr">
+              <a:spcBef>
+                <a:spcPts val="0"/>
+              </a:spcBef>
+              <a:spcAft>
+                <a:spcPts val="0"/>
+              </a:spcAft>
+            </a:pPr>
+            <a:r>
+              <a:rPr sz="1080" b="0">
+                <a:solidFill>
+                  <a:srgbClr val="313455"/>
+                </a:solidFill>
+                <a:latin typeface="Inter"/>
+              </a:rPr>
+              <a:t>MX sites</a:t>
+            </a:r>
+          </a:p>
+        </p:txBody>
+      </p:sp>
+      <p:sp>
+        <p:nvSpPr>
+          <p:cNvPr id="21" name="Rounded Rectangle 20"/>
+          <p:cNvSpPr/>
+          <p:nvPr/>
+        </p:nvSpPr>
+        <p:spPr>
+          <a:xfrm>
+            <a:off x="5138927" y="4709160"/>
+            <a:ext cx="1965960" cy="987552"/>
+          </a:xfrm>
+          <a:prstGeom prst="roundRect">
+            <a:avLst/>
+          </a:prstGeom>
+          <a:solidFill>
+            <a:srgbClr val="FDF8F1"/>
+          </a:solidFill>
+          <a:ln>
+            <a:solidFill>
+              <a:srgbClr val="B0A597"/>
+            </a:solidFill>
+          </a:ln>
+        </p:spPr>
+        <p:style>
+          <a:lnRef idx="1">
+            <a:schemeClr val="accent1"/>
+          </a:lnRef>
+          <a:fillRef idx="3">
+            <a:schemeClr val="accent1"/>
+          </a:fillRef>
+          <a:effectRef idx="2">
+            <a:schemeClr val="accent1"/>
+          </a:effectRef>
+          <a:fontRef idx="minor">
+            <a:schemeClr val="lt1"/>
+          </a:fontRef>
+        </p:style>
+        <p:txBody>
+          <a:bodyPr rtlCol="0" anchor="ctr"/>
+          <a:lstStyle/>
+          <a:p>
+            <a:pPr algn="ctr"/>
+          </a:p>
+        </p:txBody>
+      </p:sp>
+      <p:sp>
+        <p:nvSpPr>
+          <p:cNvPr id="22" name="TextBox 21"/>
+          <p:cNvSpPr txBox="1"/>
+          <p:nvPr/>
+        </p:nvSpPr>
+        <p:spPr>
+          <a:xfrm>
+            <a:off x="5230367" y="4800600"/>
+            <a:ext cx="1783080" cy="338328"/>
+          </a:xfrm>
+          <a:prstGeom prst="rect">
+            <a:avLst/>
+          </a:prstGeom>
+          <a:noFill/>
+        </p:spPr>
+        <p:txBody>
+          <a:bodyPr wrap="square" lIns="18288" rIns="18288" tIns="9144" bIns="9144" anchor="ctr">
+            <a:spAutoFit/>
+          </a:bodyPr>
+          <a:lstStyle/>
+          <a:p>
+            <a:pPr algn="ctr">
+              <a:spcBef>
+                <a:spcPts val="0"/>
+              </a:spcBef>
+              <a:spcAft>
+                <a:spcPts val="0"/>
+              </a:spcAft>
+            </a:pPr>
+            <a:r>
+              <a:rPr sz="1170" b="1">
+                <a:solidFill>
+                  <a:srgbClr val="103552"/>
+                </a:solidFill>
+                <a:latin typeface="Inter"/>
+              </a:rPr>
+              <a:t>schedule.plan</a:t>
+            </a:r>
+          </a:p>
+        </p:txBody>
+      </p:sp>
+      <p:sp>
+        <p:nvSpPr>
+          <p:cNvPr id="23" name="TextBox 22"/>
+          <p:cNvSpPr txBox="1"/>
+          <p:nvPr/>
+        </p:nvSpPr>
+        <p:spPr>
+          <a:xfrm>
+            <a:off x="5230367" y="5230368"/>
+            <a:ext cx="1783080" cy="365760"/>
+          </a:xfrm>
+          <a:prstGeom prst="rect">
+            <a:avLst/>
+          </a:prstGeom>
+          <a:noFill/>
+        </p:spPr>
+        <p:txBody>
+          <a:bodyPr wrap="square" lIns="18288" rIns="18288" tIns="9144" bIns="9144" anchor="ctr">
+            <a:spAutoFit/>
+          </a:bodyPr>
+          <a:lstStyle/>
+          <a:p>
+            <a:pPr algn="ctr">
+              <a:spcBef>
+                <a:spcPts val="0"/>
+              </a:spcBef>
+              <a:spcAft>
+                <a:spcPts val="0"/>
+              </a:spcAft>
+            </a:pPr>
+            <a:r>
+              <a:rPr sz="1080" b="0">
+                <a:solidFill>
+                  <a:srgbClr val="313455"/>
+                </a:solidFill>
+                <a:latin typeface="Inter"/>
+              </a:rPr>
+              <a:t>Choose native</a:t>
+            </a:r>
+          </a:p>
+          <a:p>
+            <a:pPr algn="ctr">
+              <a:spcBef>
+                <a:spcPts val="0"/>
+              </a:spcBef>
+              <a:spcAft>
+                <a:spcPts val="0"/>
+              </a:spcAft>
+            </a:pPr>
+            <a:r>
+              <a:rPr sz="1080" b="0">
+                <a:solidFill>
+                  <a:srgbClr val="313455"/>
+                </a:solidFill>
+                <a:latin typeface="Inter"/>
+              </a:rPr>
+              <a:t>loop policy</a:t>
+            </a:r>
+          </a:p>
+        </p:txBody>
+      </p:sp>
+      <p:sp>
+        <p:nvSpPr>
+          <p:cNvPr id="24" name="Rounded Rectangle 23"/>
+          <p:cNvSpPr/>
+          <p:nvPr/>
+        </p:nvSpPr>
+        <p:spPr>
+          <a:xfrm>
+            <a:off x="7278623" y="4709160"/>
+            <a:ext cx="1965960" cy="987552"/>
+          </a:xfrm>
+          <a:prstGeom prst="roundRect">
+            <a:avLst/>
+          </a:prstGeom>
+          <a:solidFill>
+            <a:srgbClr val="E5E7DA"/>
+          </a:solidFill>
+          <a:ln>
+            <a:solidFill>
+              <a:srgbClr val="B0A597"/>
+            </a:solidFill>
+          </a:ln>
+        </p:spPr>
+        <p:style>
+          <a:lnRef idx="1">
+            <a:schemeClr val="accent1"/>
+          </a:lnRef>
+          <a:fillRef idx="3">
+            <a:schemeClr val="accent1"/>
+          </a:fillRef>
+          <a:effectRef idx="2">
+            <a:schemeClr val="accent1"/>
+          </a:effectRef>
+          <a:fontRef idx="minor">
+            <a:schemeClr val="lt1"/>
+          </a:fontRef>
+        </p:style>
+        <p:txBody>
+          <a:bodyPr rtlCol="0" anchor="ctr"/>
+          <a:lstStyle/>
+          <a:p>
+            <a:pPr algn="ctr"/>
+          </a:p>
+        </p:txBody>
+      </p:sp>
+      <p:sp>
+        <p:nvSpPr>
+          <p:cNvPr id="25" name="TextBox 24"/>
+          <p:cNvSpPr txBox="1"/>
+          <p:nvPr/>
+        </p:nvSpPr>
+        <p:spPr>
+          <a:xfrm>
+            <a:off x="7370063" y="4800600"/>
+            <a:ext cx="1783080" cy="338328"/>
+          </a:xfrm>
+          <a:prstGeom prst="rect">
+            <a:avLst/>
+          </a:prstGeom>
+          <a:noFill/>
+        </p:spPr>
+        <p:txBody>
+          <a:bodyPr wrap="square" lIns="18288" rIns="18288" tIns="9144" bIns="9144" anchor="ctr">
+            <a:spAutoFit/>
+          </a:bodyPr>
+          <a:lstStyle/>
+          <a:p>
+            <a:pPr algn="ctr">
+              <a:spcBef>
+                <a:spcPts val="0"/>
+              </a:spcBef>
+              <a:spcAft>
+                <a:spcPts val="0"/>
+              </a:spcAft>
+            </a:pPr>
+            <a:r>
+              <a:rPr sz="1170" b="1">
+                <a:solidFill>
+                  <a:srgbClr val="103552"/>
+                </a:solidFill>
+                <a:latin typeface="Inter"/>
+              </a:rPr>
+              <a:t>MXVPUPostOffload</a:t>
+            </a:r>
+          </a:p>
+        </p:txBody>
+      </p:sp>
+      <p:sp>
+        <p:nvSpPr>
+          <p:cNvPr id="26" name="TextBox 25"/>
+          <p:cNvSpPr txBox="1"/>
+          <p:nvPr/>
+        </p:nvSpPr>
+        <p:spPr>
+          <a:xfrm>
+            <a:off x="7370063" y="5230368"/>
+            <a:ext cx="1783080" cy="365760"/>
+          </a:xfrm>
+          <a:prstGeom prst="rect">
+            <a:avLst/>
+          </a:prstGeom>
+          <a:noFill/>
+        </p:spPr>
+        <p:txBody>
+          <a:bodyPr wrap="square" lIns="18288" rIns="18288" tIns="9144" bIns="9144" anchor="ctr">
+            <a:spAutoFit/>
+          </a:bodyPr>
+          <a:lstStyle/>
+          <a:p>
+            <a:pPr algn="ctr">
+              <a:spcBef>
+                <a:spcPts val="0"/>
+              </a:spcBef>
+              <a:spcAft>
+                <a:spcPts val="0"/>
+              </a:spcAft>
+            </a:pPr>
+            <a:r>
+              <a:rPr sz="1080" b="0">
+                <a:solidFill>
+                  <a:srgbClr val="313455"/>
+                </a:solidFill>
+                <a:latin typeface="Inter"/>
+              </a:rPr>
+              <a:t>Map softmax, add</a:t>
+            </a:r>
+          </a:p>
+          <a:p>
+            <a:pPr algn="ctr">
+              <a:spcBef>
+                <a:spcPts val="0"/>
+              </a:spcBef>
+              <a:spcAft>
+                <a:spcPts val="0"/>
+              </a:spcAft>
+            </a:pPr>
+            <a:r>
+              <a:rPr sz="1080" b="0">
+                <a:solidFill>
+                  <a:srgbClr val="313455"/>
+                </a:solidFill>
+                <a:latin typeface="Inter"/>
+              </a:rPr>
+              <a:t>and reductions</a:t>
+            </a:r>
+          </a:p>
+        </p:txBody>
+      </p:sp>
+      <p:sp>
+        <p:nvSpPr>
+          <p:cNvPr id="27" name="Rounded Rectangle 26"/>
+          <p:cNvSpPr/>
+          <p:nvPr/>
+        </p:nvSpPr>
+        <p:spPr>
+          <a:xfrm>
+            <a:off x="9418319" y="4709160"/>
+            <a:ext cx="1965960" cy="987552"/>
+          </a:xfrm>
+          <a:prstGeom prst="roundRect">
+            <a:avLst/>
+          </a:prstGeom>
+          <a:solidFill>
+            <a:srgbClr val="FDF8F1"/>
+          </a:solidFill>
+          <a:ln>
+            <a:solidFill>
+              <a:srgbClr val="B0A597"/>
+            </a:solidFill>
+          </a:ln>
+        </p:spPr>
+        <p:style>
+          <a:lnRef idx="1">
+            <a:schemeClr val="accent1"/>
+          </a:lnRef>
+          <a:fillRef idx="3">
+            <a:schemeClr val="accent1"/>
+          </a:fillRef>
+          <a:effectRef idx="2">
+            <a:schemeClr val="accent1"/>
+          </a:effectRef>
+          <a:fontRef idx="minor">
+            <a:schemeClr val="lt1"/>
+          </a:fontRef>
+        </p:style>
+        <p:txBody>
+          <a:bodyPr rtlCol="0" anchor="ctr"/>
+          <a:lstStyle/>
+          <a:p>
+            <a:pPr algn="ctr"/>
+          </a:p>
+        </p:txBody>
+      </p:sp>
+      <p:sp>
+        <p:nvSpPr>
+          <p:cNvPr id="28" name="TextBox 27"/>
+          <p:cNvSpPr txBox="1"/>
+          <p:nvPr/>
+        </p:nvSpPr>
+        <p:spPr>
+          <a:xfrm>
+            <a:off x="9509759" y="4800600"/>
+            <a:ext cx="1783080" cy="338328"/>
+          </a:xfrm>
+          <a:prstGeom prst="rect">
+            <a:avLst/>
+          </a:prstGeom>
+          <a:noFill/>
+        </p:spPr>
+        <p:txBody>
+          <a:bodyPr wrap="square" lIns="18288" rIns="18288" tIns="9144" bIns="9144" anchor="ctr">
+            <a:spAutoFit/>
+          </a:bodyPr>
+          <a:lstStyle/>
+          <a:p>
+            <a:pPr algn="ctr">
+              <a:spcBef>
+                <a:spcPts val="0"/>
+              </a:spcBef>
+              <a:spcAft>
+                <a:spcPts val="0"/>
+              </a:spcAft>
+            </a:pPr>
+            <a:r>
+              <a:rPr sz="1170" b="1">
+                <a:solidFill>
+                  <a:srgbClr val="103552"/>
+                </a:solidFill>
+                <a:latin typeface="Inter"/>
+              </a:rPr>
+              <a:t>physical_program</a:t>
+            </a:r>
+          </a:p>
+        </p:txBody>
+      </p:sp>
+      <p:sp>
+        <p:nvSpPr>
+          <p:cNvPr id="29" name="TextBox 28"/>
+          <p:cNvSpPr txBox="1"/>
+          <p:nvPr/>
+        </p:nvSpPr>
+        <p:spPr>
+          <a:xfrm>
+            <a:off x="9509759" y="5230368"/>
+            <a:ext cx="1783080" cy="365760"/>
+          </a:xfrm>
+          <a:prstGeom prst="rect">
+            <a:avLst/>
+          </a:prstGeom>
+          <a:noFill/>
+        </p:spPr>
+        <p:txBody>
+          <a:bodyPr wrap="square" lIns="18288" rIns="18288" tIns="9144" bIns="9144" anchor="ctr">
+            <a:spAutoFit/>
+          </a:bodyPr>
+          <a:lstStyle/>
+          <a:p>
+            <a:pPr algn="ctr">
+              <a:spcBef>
+                <a:spcPts val="0"/>
+              </a:spcBef>
+              <a:spcAft>
+                <a:spcPts val="0"/>
+              </a:spcAft>
+            </a:pPr>
+            <a:r>
+              <a:rPr sz="1080" b="0">
+                <a:solidFill>
+                  <a:srgbClr val="313455"/>
+                </a:solidFill>
+                <a:latin typeface="Inter"/>
+              </a:rPr>
+              <a:t>Order DMA, compute</a:t>
+            </a:r>
+          </a:p>
+          <a:p>
+            <a:pPr algn="ctr">
+              <a:spcBef>
+                <a:spcPts val="0"/>
+              </a:spcBef>
+              <a:spcAft>
+                <a:spcPts val="0"/>
+              </a:spcAft>
+            </a:pPr>
+            <a:r>
+              <a:rPr sz="1080" b="0">
+                <a:solidFill>
+                  <a:srgbClr val="313455"/>
+                </a:solidFill>
+                <a:latin typeface="Inter"/>
+              </a:rPr>
+              <a:t>and VPU commands</a:t>
+            </a:r>
+          </a:p>
+        </p:txBody>
+      </p:sp>
+      <p:sp>
+        <p:nvSpPr>
+          <p:cNvPr id="30" name="TextBox 29"/>
+          <p:cNvSpPr txBox="1"/>
+          <p:nvPr/>
+        </p:nvSpPr>
+        <p:spPr>
+          <a:xfrm>
+            <a:off x="877824" y="5833872"/>
+            <a:ext cx="10469880" cy="329184"/>
+          </a:xfrm>
+          <a:prstGeom prst="rect">
+            <a:avLst/>
+          </a:prstGeom>
+          <a:noFill/>
+        </p:spPr>
+        <p:txBody>
+          <a:bodyPr wrap="square" lIns="18288" rIns="18288" tIns="9144" bIns="9144" anchor="ctr">
+            <a:spAutoFit/>
+          </a:bodyPr>
+          <a:lstStyle/>
+          <a:p>
+            <a:pPr algn="l">
+              <a:spcBef>
+                <a:spcPts val="0"/>
+              </a:spcBef>
+              <a:spcAft>
+                <a:spcPts val="0"/>
+              </a:spcAft>
+            </a:pPr>
+            <a:r>
+              <a:rPr sz="1019" b="0">
+                <a:solidFill>
+                  <a:srgbClr val="5B5957"/>
+                </a:solidFill>
+                <a:latin typeface="Inter"/>
+              </a:rPr>
+              <a:t>mx-gemmini-opt verifies typed IR. The standalone command path bypasses LLVM; the generic full-model host currently uses Merlin → LLVM → RV64.</a:t>
+            </a:r>
+          </a:p>
+        </p:txBody>
+      </p:sp>
+      <p:sp>
+        <p:nvSpPr>
+          <p:cNvPr id="31" name="TextBox 30"/>
           <p:cNvSpPr txBox="1"/>
           <p:nvPr/>
         </p:nvSpPr>
@@ -18151,7 +18333,7 @@
                 </a:solidFill>
                 <a:latin typeface="Inter"/>
               </a:rPr>
-              <a:t>02 / 04</a:t>
+              <a:t>01 / 04</a:t>
             </a:r>
           </a:p>
         </p:txBody>
@@ -18164,7 +18346,7 @@
 </p:sld>
 </file>
 
-<file path=ppt/slides/slide23.xml><?xml version="1.0" encoding="utf-8"?>
+<file path=ppt/slides/slide2.xml><?xml version="1.0" encoding="utf-8"?>
 <p:sld xmlns:a="http://schemas.openxmlformats.org/drawingml/2006/main" xmlns:p="http://schemas.openxmlformats.org/presentationml/2006/main" xmlns:r="http://schemas.openxmlformats.org/officeDocument/2006/relationships" showMasterSp="1">
   <p:cSld>
     <p:bg>
@@ -18223,7 +18405,7 @@
                 </a:solidFill>
                 <a:latin typeface="Inter"/>
               </a:rPr>
-              <a:t>MX dialect: typed IR to RV64</a:t>
+              <a:t>One JSON profile changes legal MLIR</a:t>
             </a:r>
           </a:p>
         </p:txBody>
@@ -18236,8 +18418,8 @@
         </p:nvSpPr>
         <p:spPr>
           <a:xfrm>
-            <a:off x="859536" y="1499616"/>
-            <a:ext cx="5166360" cy="2724912"/>
+            <a:off x="859536" y="1481328"/>
+            <a:ext cx="5522976" cy="4407408"/>
           </a:xfrm>
           <a:prstGeom prst="roundRect">
             <a:avLst/>
@@ -18281,8 +18463,8 @@
         </p:nvSpPr>
         <p:spPr>
           <a:xfrm>
-            <a:off x="6181344" y="1499616"/>
-            <a:ext cx="5166360" cy="2724912"/>
+            <a:off x="6547104" y="1481328"/>
+            <a:ext cx="4800600" cy="4407408"/>
           </a:xfrm>
           <a:prstGeom prst="roundRect">
             <a:avLst/>
@@ -18326,8 +18508,8 @@
         </p:nvSpPr>
         <p:spPr>
           <a:xfrm>
-            <a:off x="1051560" y="1664208"/>
-            <a:ext cx="4754880" cy="310896"/>
+            <a:off x="1051560" y="1636776"/>
+            <a:ext cx="5102352" cy="310896"/>
           </a:xfrm>
           <a:prstGeom prst="rect">
             <a:avLst/>
@@ -18349,13 +18531,13 @@
               </a:spcAft>
             </a:pPr>
             <a:r>
-              <a:rPr sz="1750" b="1">
+              <a:rPr sz="1720" b="1">
                 <a:solidFill>
                   <a:srgbClr val="103552"/>
                 </a:solidFill>
                 <a:latin typeface="Inter"/>
               </a:rPr>
-              <a:t>FP4 GEMM → typed MX</a:t>
+              <a:t>Selected RTL profile fields</a:t>
             </a:r>
           </a:p>
         </p:txBody>
@@ -18368,8 +18550,8 @@
         </p:nvSpPr>
         <p:spPr>
           <a:xfrm>
-            <a:off x="1051560" y="2048256"/>
-            <a:ext cx="4754880" cy="1298448"/>
+            <a:off x="1051560" y="2029968"/>
+            <a:ext cx="5093208" cy="2569464"/>
           </a:xfrm>
           <a:prstGeom prst="roundRect">
             <a:avLst/>
@@ -18410,112 +18592,13 @@
               </a:spcAft>
             </a:pPr>
             <a:r>
-              <a:rPr sz="1110">
-                <a:solidFill>
-                  <a:srgbClr val="006874"/>
+              <a:rPr sz="1045">
+                <a:solidFill>
+                  <a:srgbClr val="103552"/>
                 </a:solidFill>
                 <a:latin typeface="Liberation Mono"/>
               </a:rPr>
-              <a:t>%acc</a:t>
-            </a:r>
-            <a:r>
-              <a:rPr sz="1110">
-                <a:solidFill>
-                  <a:srgbClr val="103552"/>
-                </a:solidFill>
-                <a:latin typeface="Liberation Mono"/>
-              </a:rPr>
-              <a:t> = </a:t>
-            </a:r>
-            <a:r>
-              <a:rPr sz="1110">
-                <a:solidFill>
-                  <a:srgbClr val="6C3D80"/>
-                </a:solidFill>
-                <a:latin typeface="Liberation Mono"/>
-              </a:rPr>
-              <a:t>"mx_gemmini.contract"</a:t>
-            </a:r>
-            <a:r>
-              <a:rPr sz="1110">
-                <a:solidFill>
-                  <a:srgbClr val="103552"/>
-                </a:solidFill>
-                <a:latin typeface="Liberation Mono"/>
-              </a:rPr>
-              <a:t>(</a:t>
-            </a:r>
-            <a:r>
-              <a:rPr sz="1110">
-                <a:solidFill>
-                  <a:srgbClr val="006874"/>
-                </a:solidFill>
-                <a:latin typeface="Liberation Mono"/>
-              </a:rPr>
-              <a:t>%A</a:t>
-            </a:r>
-            <a:r>
-              <a:rPr sz="1110">
-                <a:solidFill>
-                  <a:srgbClr val="103552"/>
-                </a:solidFill>
-                <a:latin typeface="Liberation Mono"/>
-              </a:rPr>
-              <a:t>,</a:t>
-            </a:r>
-            <a:r>
-              <a:rPr sz="1110">
-                <a:solidFill>
-                  <a:srgbClr val="006874"/>
-                </a:solidFill>
-                <a:latin typeface="Liberation Mono"/>
-              </a:rPr>
-              <a:t>%As</a:t>
-            </a:r>
-            <a:r>
-              <a:rPr sz="1110">
-                <a:solidFill>
-                  <a:srgbClr val="103552"/>
-                </a:solidFill>
-                <a:latin typeface="Liberation Mono"/>
-              </a:rPr>
-              <a:t>,</a:t>
-            </a:r>
-            <a:r>
-              <a:rPr sz="1110">
-                <a:solidFill>
-                  <a:srgbClr val="006874"/>
-                </a:solidFill>
-                <a:latin typeface="Liberation Mono"/>
-              </a:rPr>
-              <a:t>%B</a:t>
-            </a:r>
-            <a:r>
-              <a:rPr sz="1110">
-                <a:solidFill>
-                  <a:srgbClr val="103552"/>
-                </a:solidFill>
-                <a:latin typeface="Liberation Mono"/>
-              </a:rPr>
-              <a:t>,</a:t>
-            </a:r>
-            <a:r>
-              <a:rPr sz="1110">
-                <a:solidFill>
-                  <a:srgbClr val="006874"/>
-                </a:solidFill>
-                <a:latin typeface="Liberation Mono"/>
-              </a:rPr>
-              <a:t>%Bs</a:t>
-            </a:r>
-            <a:r>
-              <a:rPr sz="1110">
-                <a:solidFill>
-                  <a:srgbClr val="103552"/>
-                </a:solidFill>
-                <a:latin typeface="Liberation Mono"/>
-              </a:rPr>
-              <a:t>) {</a:t>
+              <a:t>{</a:t>
             </a:r>
           </a:p>
           <a:p>
@@ -18528,49 +18611,103 @@
               </a:spcAft>
             </a:pPr>
             <a:r>
-              <a:rPr sz="1110">
+              <a:rPr sz="1045">
                 <a:solidFill>
                   <a:srgbClr val="103552"/>
                 </a:solidFill>
                 <a:latin typeface="Liberation Mono"/>
               </a:rPr>
-              <a:t>  </a:t>
-            </a:r>
-            <a:r>
-              <a:rPr sz="1110">
+              <a:t> </a:t>
+            </a:r>
+            <a:r>
+              <a:rPr sz="1045">
                 <a:solidFill>
                   <a:srgbClr val="6C3D80"/>
                 </a:solidFill>
                 <a:latin typeface="Liberation Mono"/>
               </a:rPr>
-              <a:t>activation_format</a:t>
-            </a:r>
-            <a:r>
-              <a:rPr sz="1110">
+              <a:t>"geometry"</a:t>
+            </a:r>
+            <a:r>
+              <a:rPr sz="1045">
                 <a:solidFill>
                   <a:srgbClr val="103552"/>
                 </a:solidFill>
                 <a:latin typeface="Liberation Mono"/>
               </a:rPr>
-              <a:t> = </a:t>
-            </a:r>
-            <a:r>
-              <a:rPr sz="1110">
-                <a:solidFill>
-                  <a:srgbClr val="28704F"/>
+              <a:t>: {</a:t>
+            </a:r>
+            <a:r>
+              <a:rPr sz="1045">
+                <a:solidFill>
+                  <a:srgbClr val="6C3D80"/>
                 </a:solidFill>
                 <a:latin typeface="Liberation Mono"/>
               </a:rPr>
-              <a:t>"fp4_e2m1"</a:t>
-            </a:r>
-            <a:r>
-              <a:rPr sz="1110">
+              <a:t>"mesh_rows"</a:t>
+            </a:r>
+            <a:r>
+              <a:rPr sz="1045">
                 <a:solidFill>
                   <a:srgbClr val="103552"/>
                 </a:solidFill>
                 <a:latin typeface="Liberation Mono"/>
               </a:rPr>
+              <a:t>:</a:t>
+            </a:r>
+            <a:r>
+              <a:rPr sz="1045">
+                <a:solidFill>
+                  <a:srgbClr val="A44F25"/>
+                </a:solidFill>
+                <a:latin typeface="Liberation Mono"/>
+              </a:rPr>
+              <a:t>16</a:t>
+            </a:r>
+            <a:r>
+              <a:rPr sz="1045">
+                <a:solidFill>
+                  <a:srgbClr val="103552"/>
+                </a:solidFill>
+                <a:latin typeface="Liberation Mono"/>
+              </a:rPr>
               <a:t>,</a:t>
+            </a:r>
+            <a:r>
+              <a:rPr sz="1045">
+                <a:solidFill>
+                  <a:srgbClr val="6C3D80"/>
+                </a:solidFill>
+                <a:latin typeface="Liberation Mono"/>
+              </a:rPr>
+              <a:t>"mesh_columns"</a:t>
+            </a:r>
+            <a:r>
+              <a:rPr sz="1045">
+                <a:solidFill>
+                  <a:srgbClr val="103552"/>
+                </a:solidFill>
+                <a:latin typeface="Liberation Mono"/>
+              </a:rPr>
+              <a:t>:</a:t>
+            </a:r>
+            <a:r>
+              <a:rPr sz="1045">
+                <a:solidFill>
+                  <a:srgbClr val="A44F25"/>
+                </a:solidFill>
+                <a:latin typeface="Liberation Mono"/>
+              </a:rPr>
+              <a:t>16</a:t>
+            </a:r>
+            <a:r>
+              <a:rPr sz="1045">
+                <a:solidFill>
+                  <a:srgbClr val="103552"/>
+                </a:solidFill>
+                <a:latin typeface="Liberation Mono"/>
+              </a:rPr>
+              <a:t>},</a:t>
             </a:r>
           </a:p>
           <a:p>
@@ -18583,85 +18720,31 @@
               </a:spcAft>
             </a:pPr>
             <a:r>
-              <a:rPr sz="1110">
+              <a:rPr sz="1045">
                 <a:solidFill>
                   <a:srgbClr val="103552"/>
                 </a:solidFill>
                 <a:latin typeface="Liberation Mono"/>
               </a:rPr>
-              <a:t>  </a:t>
-            </a:r>
-            <a:r>
-              <a:rPr sz="1110">
+              <a:t> </a:t>
+            </a:r>
+            <a:r>
+              <a:rPr sz="1045">
                 <a:solidFill>
                   <a:srgbClr val="6C3D80"/>
                 </a:solidFill>
                 <a:latin typeface="Liberation Mono"/>
               </a:rPr>
-              <a:t>weight_format</a:t>
-            </a:r>
-            <a:r>
-              <a:rPr sz="1110">
+              <a:t>"legal_compute"</a:t>
+            </a:r>
+            <a:r>
+              <a:rPr sz="1045">
                 <a:solidFill>
                   <a:srgbClr val="103552"/>
                 </a:solidFill>
                 <a:latin typeface="Liberation Mono"/>
               </a:rPr>
-              <a:t> = </a:t>
-            </a:r>
-            <a:r>
-              <a:rPr sz="1110">
-                <a:solidFill>
-                  <a:srgbClr val="28704F"/>
-                </a:solidFill>
-                <a:latin typeface="Liberation Mono"/>
-              </a:rPr>
-              <a:t>"fp4_e2m1"</a:t>
-            </a:r>
-            <a:r>
-              <a:rPr sz="1110">
-                <a:solidFill>
-                  <a:srgbClr val="103552"/>
-                </a:solidFill>
-                <a:latin typeface="Liberation Mono"/>
-              </a:rPr>
-              <a:t>, </a:t>
-            </a:r>
-            <a:r>
-              <a:rPr sz="1110">
-                <a:solidFill>
-                  <a:srgbClr val="6C3D80"/>
-                </a:solidFill>
-                <a:latin typeface="Liberation Mono"/>
-              </a:rPr>
-              <a:t>pe_mode</a:t>
-            </a:r>
-            <a:r>
-              <a:rPr sz="1110">
-                <a:solidFill>
-                  <a:srgbClr val="103552"/>
-                </a:solidFill>
-                <a:latin typeface="Liberation Mono"/>
-              </a:rPr>
-              <a:t> = </a:t>
-            </a:r>
-            <a:r>
-              <a:rPr sz="1110">
-                <a:solidFill>
-                  <a:srgbClr val="A44F25"/>
-                </a:solidFill>
-                <a:latin typeface="Liberation Mono"/>
-              </a:rPr>
-              <a:t>0</a:t>
-            </a:r>
-            <a:r>
-              <a:rPr sz="1110">
-                <a:solidFill>
-                  <a:srgbClr val="103552"/>
-                </a:solidFill>
-                <a:latin typeface="Liberation Mono"/>
-              </a:rPr>
-              <a:t> : i32 }</a:t>
+              <a:t>: [</a:t>
             </a:r>
           </a:p>
           <a:p>
@@ -18674,58 +18757,488 @@
               </a:spcAft>
             </a:pPr>
             <a:r>
-              <a:rPr sz="1110">
-                <a:solidFill>
-                  <a:srgbClr val="006874"/>
+              <a:rPr sz="1045">
+                <a:solidFill>
+                  <a:srgbClr val="103552"/>
                 </a:solidFill>
                 <a:latin typeface="Liberation Mono"/>
               </a:rPr>
-              <a:t>%out</a:t>
-            </a:r>
-            <a:r>
-              <a:rPr sz="1110">
+              <a:t>  {</a:t>
+            </a:r>
+            <a:r>
+              <a:rPr sz="1045">
+                <a:solidFill>
+                  <a:srgbClr val="6C3D80"/>
+                </a:solidFill>
+                <a:latin typeface="Liberation Mono"/>
+              </a:rPr>
+              <a:t>"activation_format"</a:t>
+            </a:r>
+            <a:r>
+              <a:rPr sz="1045">
                 <a:solidFill>
                   <a:srgbClr val="103552"/>
                 </a:solidFill>
                 <a:latin typeface="Liberation Mono"/>
               </a:rPr>
-              <a:t> = </a:t>
-            </a:r>
-            <a:r>
-              <a:rPr sz="1110">
+              <a:t>:</a:t>
+            </a:r>
+            <a:r>
+              <a:rPr sz="1045">
+                <a:solidFill>
+                  <a:srgbClr val="28704F"/>
+                </a:solidFill>
+                <a:latin typeface="Liberation Mono"/>
+              </a:rPr>
+              <a:t>"fp4_e2m1"</a:t>
+            </a:r>
+            <a:r>
+              <a:rPr sz="1045">
+                <a:solidFill>
+                  <a:srgbClr val="103552"/>
+                </a:solidFill>
+                <a:latin typeface="Liberation Mono"/>
+              </a:rPr>
+              <a:t>,</a:t>
+            </a:r>
+          </a:p>
+          <a:p>
+            <a:pPr algn="l">
+              <a:spcBef>
+                <a:spcPts val="0"/>
+              </a:spcBef>
+              <a:spcAft>
+                <a:spcPts val="0"/>
+              </a:spcAft>
+            </a:pPr>
+            <a:r>
+              <a:rPr sz="1045">
+                <a:solidFill>
+                  <a:srgbClr val="103552"/>
+                </a:solidFill>
+                <a:latin typeface="Liberation Mono"/>
+              </a:rPr>
+              <a:t>   </a:t>
+            </a:r>
+            <a:r>
+              <a:rPr sz="1045">
                 <a:solidFill>
                   <a:srgbClr val="6C3D80"/>
                 </a:solidFill>
                 <a:latin typeface="Liberation Mono"/>
               </a:rPr>
-              <a:t>"mx_gemmini.readout_bf16"</a:t>
-            </a:r>
-            <a:r>
-              <a:rPr sz="1110">
+              <a:t>"weight_format"</a:t>
+            </a:r>
+            <a:r>
+              <a:rPr sz="1045">
                 <a:solidFill>
                   <a:srgbClr val="103552"/>
                 </a:solidFill>
                 <a:latin typeface="Liberation Mono"/>
               </a:rPr>
-              <a:t>(</a:t>
-            </a:r>
-            <a:r>
-              <a:rPr sz="1110">
-                <a:solidFill>
-                  <a:srgbClr val="006874"/>
+              <a:t>:</a:t>
+            </a:r>
+            <a:r>
+              <a:rPr sz="1045">
+                <a:solidFill>
+                  <a:srgbClr val="28704F"/>
                 </a:solidFill>
                 <a:latin typeface="Liberation Mono"/>
               </a:rPr>
-              <a:t>%acc</a:t>
-            </a:r>
-            <a:r>
-              <a:rPr sz="1110">
+              <a:t>"fp4_e2m1"</a:t>
+            </a:r>
+            <a:r>
+              <a:rPr sz="1045">
                 <a:solidFill>
                   <a:srgbClr val="103552"/>
                 </a:solidFill>
                 <a:latin typeface="Liberation Mono"/>
               </a:rPr>
-              <a:t>)</a:t>
+              <a:t>,</a:t>
+            </a:r>
+            <a:r>
+              <a:rPr sz="1045">
+                <a:solidFill>
+                  <a:srgbClr val="6C3D80"/>
+                </a:solidFill>
+                <a:latin typeface="Liberation Mono"/>
+              </a:rPr>
+              <a:t>"pe_mode"</a:t>
+            </a:r>
+            <a:r>
+              <a:rPr sz="1045">
+                <a:solidFill>
+                  <a:srgbClr val="103552"/>
+                </a:solidFill>
+                <a:latin typeface="Liberation Mono"/>
+              </a:rPr>
+              <a:t>:</a:t>
+            </a:r>
+            <a:r>
+              <a:rPr sz="1045">
+                <a:solidFill>
+                  <a:srgbClr val="A44F25"/>
+                </a:solidFill>
+                <a:latin typeface="Liberation Mono"/>
+              </a:rPr>
+              <a:t>0</a:t>
+            </a:r>
+            <a:r>
+              <a:rPr sz="1045">
+                <a:solidFill>
+                  <a:srgbClr val="103552"/>
+                </a:solidFill>
+                <a:latin typeface="Liberation Mono"/>
+              </a:rPr>
+              <a:t>},</a:t>
+            </a:r>
+          </a:p>
+          <a:p>
+            <a:pPr algn="l">
+              <a:spcBef>
+                <a:spcPts val="0"/>
+              </a:spcBef>
+              <a:spcAft>
+                <a:spcPts val="0"/>
+              </a:spcAft>
+            </a:pPr>
+            <a:r>
+              <a:rPr sz="1045">
+                <a:solidFill>
+                  <a:srgbClr val="103552"/>
+                </a:solidFill>
+                <a:latin typeface="Liberation Mono"/>
+              </a:rPr>
+              <a:t>  {</a:t>
+            </a:r>
+            <a:r>
+              <a:rPr sz="1045">
+                <a:solidFill>
+                  <a:srgbClr val="6C3D80"/>
+                </a:solidFill>
+                <a:latin typeface="Liberation Mono"/>
+              </a:rPr>
+              <a:t>"activation_format"</a:t>
+            </a:r>
+            <a:r>
+              <a:rPr sz="1045">
+                <a:solidFill>
+                  <a:srgbClr val="103552"/>
+                </a:solidFill>
+                <a:latin typeface="Liberation Mono"/>
+              </a:rPr>
+              <a:t>:</a:t>
+            </a:r>
+            <a:r>
+              <a:rPr sz="1045">
+                <a:solidFill>
+                  <a:srgbClr val="28704F"/>
+                </a:solidFill>
+                <a:latin typeface="Liberation Mono"/>
+              </a:rPr>
+              <a:t>"fp8_e4m3"</a:t>
+            </a:r>
+            <a:r>
+              <a:rPr sz="1045">
+                <a:solidFill>
+                  <a:srgbClr val="103552"/>
+                </a:solidFill>
+                <a:latin typeface="Liberation Mono"/>
+              </a:rPr>
+              <a:t>,</a:t>
+            </a:r>
+          </a:p>
+          <a:p>
+            <a:pPr algn="l">
+              <a:spcBef>
+                <a:spcPts val="0"/>
+              </a:spcBef>
+              <a:spcAft>
+                <a:spcPts val="0"/>
+              </a:spcAft>
+            </a:pPr>
+            <a:r>
+              <a:rPr sz="1045">
+                <a:solidFill>
+                  <a:srgbClr val="103552"/>
+                </a:solidFill>
+                <a:latin typeface="Liberation Mono"/>
+              </a:rPr>
+              <a:t>   </a:t>
+            </a:r>
+            <a:r>
+              <a:rPr sz="1045">
+                <a:solidFill>
+                  <a:srgbClr val="6C3D80"/>
+                </a:solidFill>
+                <a:latin typeface="Liberation Mono"/>
+              </a:rPr>
+              <a:t>"weight_format"</a:t>
+            </a:r>
+            <a:r>
+              <a:rPr sz="1045">
+                <a:solidFill>
+                  <a:srgbClr val="103552"/>
+                </a:solidFill>
+                <a:latin typeface="Liberation Mono"/>
+              </a:rPr>
+              <a:t>:</a:t>
+            </a:r>
+            <a:r>
+              <a:rPr sz="1045">
+                <a:solidFill>
+                  <a:srgbClr val="28704F"/>
+                </a:solidFill>
+                <a:latin typeface="Liberation Mono"/>
+              </a:rPr>
+              <a:t>"fp8_e4m3"</a:t>
+            </a:r>
+            <a:r>
+              <a:rPr sz="1045">
+                <a:solidFill>
+                  <a:srgbClr val="103552"/>
+                </a:solidFill>
+                <a:latin typeface="Liberation Mono"/>
+              </a:rPr>
+              <a:t>,</a:t>
+            </a:r>
+            <a:r>
+              <a:rPr sz="1045">
+                <a:solidFill>
+                  <a:srgbClr val="6C3D80"/>
+                </a:solidFill>
+                <a:latin typeface="Liberation Mono"/>
+              </a:rPr>
+              <a:t>"pe_mode"</a:t>
+            </a:r>
+            <a:r>
+              <a:rPr sz="1045">
+                <a:solidFill>
+                  <a:srgbClr val="103552"/>
+                </a:solidFill>
+                <a:latin typeface="Liberation Mono"/>
+              </a:rPr>
+              <a:t>:</a:t>
+            </a:r>
+            <a:r>
+              <a:rPr sz="1045">
+                <a:solidFill>
+                  <a:srgbClr val="A44F25"/>
+                </a:solidFill>
+                <a:latin typeface="Liberation Mono"/>
+              </a:rPr>
+              <a:t>8</a:t>
+            </a:r>
+            <a:r>
+              <a:rPr sz="1045">
+                <a:solidFill>
+                  <a:srgbClr val="103552"/>
+                </a:solidFill>
+                <a:latin typeface="Liberation Mono"/>
+              </a:rPr>
+              <a:t>}</a:t>
+            </a:r>
+          </a:p>
+          <a:p>
+            <a:pPr algn="l">
+              <a:spcBef>
+                <a:spcPts val="0"/>
+              </a:spcBef>
+              <a:spcAft>
+                <a:spcPts val="0"/>
+              </a:spcAft>
+            </a:pPr>
+            <a:r>
+              <a:rPr sz="1045">
+                <a:solidFill>
+                  <a:srgbClr val="103552"/>
+                </a:solidFill>
+                <a:latin typeface="Liberation Mono"/>
+              </a:rPr>
+              <a:t> ],</a:t>
+            </a:r>
+          </a:p>
+          <a:p>
+            <a:pPr algn="l">
+              <a:spcBef>
+                <a:spcPts val="0"/>
+              </a:spcBef>
+              <a:spcAft>
+                <a:spcPts val="0"/>
+              </a:spcAft>
+            </a:pPr>
+            <a:r>
+              <a:rPr sz="1045">
+                <a:solidFill>
+                  <a:srgbClr val="103552"/>
+                </a:solidFill>
+                <a:latin typeface="Liberation Mono"/>
+              </a:rPr>
+              <a:t> </a:t>
+            </a:r>
+            <a:r>
+              <a:rPr sz="1045">
+                <a:solidFill>
+                  <a:srgbClr val="6C3D80"/>
+                </a:solidFill>
+                <a:latin typeface="Liberation Mono"/>
+              </a:rPr>
+              <a:t>"resources"</a:t>
+            </a:r>
+            <a:r>
+              <a:rPr sz="1045">
+                <a:solidFill>
+                  <a:srgbClr val="103552"/>
+                </a:solidFill>
+                <a:latin typeface="Liberation Mono"/>
+              </a:rPr>
+              <a:t>: {</a:t>
+            </a:r>
+            <a:r>
+              <a:rPr sz="1045">
+                <a:solidFill>
+                  <a:srgbClr val="6C3D80"/>
+                </a:solidFill>
+                <a:latin typeface="Liberation Mono"/>
+              </a:rPr>
+              <a:t>"scratchpad_bytes"</a:t>
+            </a:r>
+            <a:r>
+              <a:rPr sz="1045">
+                <a:solidFill>
+                  <a:srgbClr val="103552"/>
+                </a:solidFill>
+                <a:latin typeface="Liberation Mono"/>
+              </a:rPr>
+              <a:t>:</a:t>
+            </a:r>
+            <a:r>
+              <a:rPr sz="1045">
+                <a:solidFill>
+                  <a:srgbClr val="A44F25"/>
+                </a:solidFill>
+                <a:latin typeface="Liberation Mono"/>
+              </a:rPr>
+              <a:t>262144</a:t>
+            </a:r>
+            <a:r>
+              <a:rPr sz="1045">
+                <a:solidFill>
+                  <a:srgbClr val="103552"/>
+                </a:solidFill>
+                <a:latin typeface="Liberation Mono"/>
+              </a:rPr>
+              <a:t>,</a:t>
+            </a:r>
+          </a:p>
+          <a:p>
+            <a:pPr algn="l">
+              <a:spcBef>
+                <a:spcPts val="0"/>
+              </a:spcBef>
+              <a:spcAft>
+                <a:spcPts val="0"/>
+              </a:spcAft>
+            </a:pPr>
+            <a:r>
+              <a:rPr sz="1045">
+                <a:solidFill>
+                  <a:srgbClr val="103552"/>
+                </a:solidFill>
+                <a:latin typeface="Liberation Mono"/>
+              </a:rPr>
+              <a:t>               </a:t>
+            </a:r>
+            <a:r>
+              <a:rPr sz="1045">
+                <a:solidFill>
+                  <a:srgbClr val="6C3D80"/>
+                </a:solidFill>
+                <a:latin typeface="Liberation Mono"/>
+              </a:rPr>
+              <a:t>"vpu"</a:t>
+            </a:r>
+            <a:r>
+              <a:rPr sz="1045">
+                <a:solidFill>
+                  <a:srgbClr val="103552"/>
+                </a:solidFill>
+                <a:latin typeface="Liberation Mono"/>
+              </a:rPr>
+              <a:t>:</a:t>
+            </a:r>
+            <a:r>
+              <a:rPr sz="1045">
+                <a:solidFill>
+                  <a:srgbClr val="6C3D80"/>
+                </a:solidFill>
+                <a:latin typeface="Liberation Mono"/>
+              </a:rPr>
+              <a:t>true</a:t>
+            </a:r>
+            <a:r>
+              <a:rPr sz="1045">
+                <a:solidFill>
+                  <a:srgbClr val="103552"/>
+                </a:solidFill>
+                <a:latin typeface="Liberation Mono"/>
+              </a:rPr>
+              <a:t>,</a:t>
+            </a:r>
+            <a:r>
+              <a:rPr sz="1045">
+                <a:solidFill>
+                  <a:srgbClr val="6C3D80"/>
+                </a:solidFill>
+                <a:latin typeface="Liberation Mono"/>
+              </a:rPr>
+              <a:t>"lut"</a:t>
+            </a:r>
+            <a:r>
+              <a:rPr sz="1045">
+                <a:solidFill>
+                  <a:srgbClr val="103552"/>
+                </a:solidFill>
+                <a:latin typeface="Liberation Mono"/>
+              </a:rPr>
+              <a:t>:</a:t>
+            </a:r>
+            <a:r>
+              <a:rPr sz="1045">
+                <a:solidFill>
+                  <a:srgbClr val="6C3D80"/>
+                </a:solidFill>
+                <a:latin typeface="Liberation Mono"/>
+              </a:rPr>
+              <a:t>false</a:t>
+            </a:r>
+            <a:r>
+              <a:rPr sz="1045">
+                <a:solidFill>
+                  <a:srgbClr val="103552"/>
+                </a:solidFill>
+                <a:latin typeface="Liberation Mono"/>
+              </a:rPr>
+              <a:t>}</a:t>
+            </a:r>
+          </a:p>
+          <a:p>
+            <a:pPr algn="l">
+              <a:spcBef>
+                <a:spcPts val="0"/>
+              </a:spcBef>
+              <a:spcAft>
+                <a:spcPts val="0"/>
+              </a:spcAft>
+            </a:pPr>
+            <a:r>
+              <a:rPr sz="1045">
+                <a:solidFill>
+                  <a:srgbClr val="103552"/>
+                </a:solidFill>
+                <a:latin typeface="Liberation Mono"/>
+              </a:rPr>
+              <a:t>}</a:t>
             </a:r>
           </a:p>
         </p:txBody>
@@ -18738,8 +19251,8 @@
         </p:nvSpPr>
         <p:spPr>
           <a:xfrm>
-            <a:off x="1051560" y="3438144"/>
-            <a:ext cx="4727448" cy="685800"/>
+            <a:off x="1051560" y="4736592"/>
+            <a:ext cx="5093208" cy="475488"/>
           </a:xfrm>
           <a:prstGeom prst="rect">
             <a:avLst/>
@@ -18761,13 +19274,13 @@
               </a:spcAft>
             </a:pPr>
             <a:r>
-              <a:rPr sz="1060" b="0">
+              <a:rPr sz="1110" b="0">
                 <a:solidFill>
                   <a:srgbClr val="313455"/>
                 </a:solidFill>
                 <a:latin typeface="Inter"/>
               </a:rPr>
-              <a:t>resource supplies packed A/B codes + E8M0 scales. contract computes C[m,n] = Σk A[m,k]×B[k,n] in the selected PE mode; readout_bf16 returns BF16. VPU can do softmax; Radiance uses Muon SIMT.</a:t>
+              <a:t>MxE4M3Fp4VpuGemminiRocketConfig · direct projections in both legal rows · two 8-lane BF16 VPUs.</a:t>
             </a:r>
           </a:p>
         </p:txBody>
@@ -18780,8 +19293,8 @@
         </p:nvSpPr>
         <p:spPr>
           <a:xfrm>
-            <a:off x="6382512" y="1664208"/>
-            <a:ext cx="4754880" cy="310896"/>
+            <a:off x="1051560" y="5312664"/>
+            <a:ext cx="5093208" cy="356616"/>
           </a:xfrm>
           <a:prstGeom prst="rect">
             <a:avLst/>
@@ -18803,27 +19316,69 @@
               </a:spcAft>
             </a:pPr>
             <a:r>
-              <a:rPr sz="1750" b="1">
-                <a:solidFill>
-                  <a:srgbClr val="103552"/>
-                </a:solidFill>
-                <a:latin typeface="Inter"/>
-              </a:rPr>
-              <a:t>Compiled attention object → binary</a:t>
+              <a:rPr sz="1040" b="0">
+                <a:solidFill>
+                  <a:srgbClr val="5B5957"/>
+                </a:solidFill>
+                <a:latin typeface="Inter"/>
+              </a:rPr>
+              <a:t>RTL 266c593 + MxGen dba3e7 → 41 fragments / 40 SoC wrappers; each JSON stores source hashes.</a:t>
             </a:r>
           </a:p>
         </p:txBody>
       </p:sp>
       <p:sp>
         <p:nvSpPr>
-          <p:cNvPr id="12" name="Rounded Rectangle 11"/>
+          <p:cNvPr id="12" name="TextBox 11"/>
+          <p:cNvSpPr txBox="1"/>
+          <p:nvPr/>
+        </p:nvSpPr>
+        <p:spPr>
+          <a:xfrm>
+            <a:off x="6748272" y="1636776"/>
+            <a:ext cx="4370832" cy="310896"/>
+          </a:xfrm>
+          <a:prstGeom prst="rect">
+            <a:avLst/>
+          </a:prstGeom>
+          <a:noFill/>
+        </p:spPr>
+        <p:txBody>
+          <a:bodyPr wrap="square" lIns="18288" rIns="18288" tIns="9144" bIns="9144" anchor="ctr">
+            <a:spAutoFit/>
+          </a:bodyPr>
+          <a:lstStyle/>
+          <a:p>
+            <a:pPr algn="l">
+              <a:spcBef>
+                <a:spcPts val="0"/>
+              </a:spcBef>
+              <a:spcAft>
+                <a:spcPts val="0"/>
+              </a:spcAft>
+            </a:pPr>
+            <a:r>
+              <a:rPr sz="1720" b="1">
+                <a:solidFill>
+                  <a:srgbClr val="103552"/>
+                </a:solidFill>
+                <a:latin typeface="Inter"/>
+              </a:rPr>
+              <a:t>Before → after bind_profile</a:t>
+            </a:r>
+          </a:p>
+        </p:txBody>
+      </p:sp>
+      <p:sp>
+        <p:nvSpPr>
+          <p:cNvPr id="13" name="Rounded Rectangle 12"/>
           <p:cNvSpPr/>
           <p:nvPr/>
         </p:nvSpPr>
         <p:spPr>
           <a:xfrm>
-            <a:off x="6382512" y="2048256"/>
-            <a:ext cx="4754880" cy="1298448"/>
+            <a:off x="6748272" y="2029968"/>
+            <a:ext cx="4379976" cy="1499616"/>
           </a:xfrm>
           <a:prstGeom prst="roundRect">
             <a:avLst/>
@@ -18864,40 +19419,58 @@
               </a:spcAft>
             </a:pPr>
             <a:r>
-              <a:rPr sz="1030">
+              <a:rPr sz="1085">
                 <a:solidFill>
                   <a:srgbClr val="6C3D80"/>
                 </a:solidFill>
                 <a:latin typeface="Liberation Mono"/>
               </a:rPr>
-              <a:t>__asm__</a:t>
-            </a:r>
-            <a:r>
-              <a:rPr sz="1030">
+              <a:t>before</a:t>
+            </a:r>
+            <a:r>
+              <a:rPr sz="1085">
                 <a:solidFill>
                   <a:srgbClr val="103552"/>
                 </a:solidFill>
                 <a:latin typeface="Liberation Mono"/>
               </a:rPr>
-              <a:t> </a:t>
-            </a:r>
-            <a:r>
-              <a:rPr sz="1030">
+              <a:t>: </a:t>
+            </a:r>
+            <a:r>
+              <a:rPr sz="1085">
                 <a:solidFill>
                   <a:srgbClr val="6C3D80"/>
                 </a:solidFill>
                 <a:latin typeface="Liberation Mono"/>
               </a:rPr>
-              <a:t>volatile</a:t>
-            </a:r>
-            <a:r>
-              <a:rPr sz="1030">
+              <a:t>contract</a:t>
+            </a:r>
+            <a:r>
+              <a:rPr sz="1085">
                 <a:solidFill>
                   <a:srgbClr val="103552"/>
                 </a:solidFill>
                 <a:latin typeface="Liberation Mono"/>
               </a:rPr>
-              <a:t>(</a:t>
+              <a:t> {format = </a:t>
+            </a:r>
+            <a:r>
+              <a:rPr sz="1085">
+                <a:solidFill>
+                  <a:srgbClr val="28704F"/>
+                </a:solidFill>
+                <a:latin typeface="Liberation Mono"/>
+              </a:rPr>
+              <a:t>"mxfp4"</a:t>
+            </a:r>
+            <a:r>
+              <a:rPr sz="1085">
+                <a:solidFill>
+                  <a:srgbClr val="103552"/>
+                </a:solidFill>
+                <a:latin typeface="Liberation Mono"/>
+              </a:rPr>
+              <a:t>}</a:t>
             </a:r>
           </a:p>
           <a:p>
@@ -18910,22 +19483,40 @@
               </a:spcAft>
             </a:pPr>
             <a:r>
-              <a:rPr sz="1030">
+              <a:rPr sz="1085">
+                <a:solidFill>
+                  <a:srgbClr val="6C3D80"/>
+                </a:solidFill>
+                <a:latin typeface="Liberation Mono"/>
+              </a:rPr>
+              <a:t>after</a:t>
+            </a:r>
+            <a:r>
+              <a:rPr sz="1085">
                 <a:solidFill>
                   <a:srgbClr val="103552"/>
                 </a:solidFill>
                 <a:latin typeface="Liberation Mono"/>
               </a:rPr>
-              <a:t>  </a:t>
-            </a:r>
-            <a:r>
-              <a:rPr sz="1030">
-                <a:solidFill>
-                  <a:srgbClr val="28704F"/>
+              <a:t>:  </a:t>
+            </a:r>
+            <a:r>
+              <a:rPr sz="1085">
+                <a:solidFill>
+                  <a:srgbClr val="6C3D80"/>
                 </a:solidFill>
                 <a:latin typeface="Liberation Mono"/>
               </a:rPr>
-              <a:t>".insn r 0x7b, 3, 2, x0, %0, %1"</a:t>
+              <a:t>contract</a:t>
+            </a:r>
+            <a:r>
+              <a:rPr sz="1085">
+                <a:solidFill>
+                  <a:srgbClr val="103552"/>
+                </a:solidFill>
+                <a:latin typeface="Liberation Mono"/>
+              </a:rPr>
+              <a:t> {</a:t>
             </a:r>
           </a:p>
           <a:p>
@@ -18938,31 +19529,49 @@
               </a:spcAft>
             </a:pPr>
             <a:r>
-              <a:rPr sz="1030">
+              <a:rPr sz="1085">
                 <a:solidFill>
                   <a:srgbClr val="103552"/>
                 </a:solidFill>
                 <a:latin typeface="Liberation Mono"/>
               </a:rPr>
-              <a:t>  : : </a:t>
-            </a:r>
-            <a:r>
-              <a:rPr sz="1030">
+              <a:t>  </a:t>
+            </a:r>
+            <a:r>
+              <a:rPr sz="1085">
+                <a:solidFill>
+                  <a:srgbClr val="6C3D80"/>
+                </a:solidFill>
+                <a:latin typeface="Liberation Mono"/>
+              </a:rPr>
+              <a:t>activation_format</a:t>
+            </a:r>
+            <a:r>
+              <a:rPr sz="1085">
+                <a:solidFill>
+                  <a:srgbClr val="103552"/>
+                </a:solidFill>
+                <a:latin typeface="Liberation Mono"/>
+              </a:rPr>
+              <a:t> = </a:t>
+            </a:r>
+            <a:r>
+              <a:rPr sz="1085">
                 <a:solidFill>
                   <a:srgbClr val="28704F"/>
                 </a:solidFill>
                 <a:latin typeface="Liberation Mono"/>
               </a:rPr>
-              <a:t>"r"</a:t>
-            </a:r>
-            <a:r>
-              <a:rPr sz="1030">
+              <a:t>"fp4_e2m1"</a:t>
+            </a:r>
+            <a:r>
+              <a:rPr sz="1085">
                 <a:solidFill>
                   <a:srgbClr val="103552"/>
                 </a:solidFill>
                 <a:latin typeface="Liberation Mono"/>
               </a:rPr>
-              <a:t>(Q_IN),</a:t>
+              <a:t>,</a:t>
             </a:r>
           </a:p>
           <a:p>
@@ -18975,49 +19584,49 @@
               </a:spcAft>
             </a:pPr>
             <a:r>
-              <a:rPr sz="1030">
+              <a:rPr sz="1085">
                 <a:solidFill>
                   <a:srgbClr val="103552"/>
                 </a:solidFill>
                 <a:latin typeface="Liberation Mono"/>
               </a:rPr>
-              <a:t>      </a:t>
-            </a:r>
-            <a:r>
-              <a:rPr sz="1030">
+              <a:t>  </a:t>
+            </a:r>
+            <a:r>
+              <a:rPr sz="1085">
+                <a:solidFill>
+                  <a:srgbClr val="6C3D80"/>
+                </a:solidFill>
+                <a:latin typeface="Liberation Mono"/>
+              </a:rPr>
+              <a:t>weight_format</a:t>
+            </a:r>
+            <a:r>
+              <a:rPr sz="1085">
+                <a:solidFill>
+                  <a:srgbClr val="103552"/>
+                </a:solidFill>
+                <a:latin typeface="Liberation Mono"/>
+              </a:rPr>
+              <a:t> = </a:t>
+            </a:r>
+            <a:r>
+              <a:rPr sz="1085">
                 <a:solidFill>
                   <a:srgbClr val="28704F"/>
                 </a:solidFill>
                 <a:latin typeface="Liberation Mono"/>
               </a:rPr>
-              <a:t>"r"</a:t>
-            </a:r>
-            <a:r>
-              <a:rPr sz="1030">
+              <a:t>"fp4_e2m1"</a:t>
+            </a:r>
+            <a:r>
+              <a:rPr sz="1085">
                 <a:solidFill>
                   <a:srgbClr val="103552"/>
                 </a:solidFill>
                 <a:latin typeface="Liberation Mono"/>
               </a:rPr>
-              <a:t>(</a:t>
-            </a:r>
-            <a:r>
-              <a:rPr sz="1030">
-                <a:solidFill>
-                  <a:srgbClr val="A44F25"/>
-                </a:solidFill>
-                <a:latin typeface="Liberation Mono"/>
-              </a:rPr>
-              <a:t>0x0010001000000000</a:t>
-            </a:r>
-            <a:r>
-              <a:rPr sz="1030">
-                <a:solidFill>
-                  <a:srgbClr val="103552"/>
-                </a:solidFill>
-                <a:latin typeface="Liberation Mono"/>
-              </a:rPr>
-              <a:t>));</a:t>
+              <a:t>,</a:t>
             </a:r>
           </a:p>
           <a:p>
@@ -19030,63 +19639,118 @@
               </a:spcAft>
             </a:pPr>
             <a:r>
-              <a:rPr sz="1030">
+              <a:rPr sz="1085">
+                <a:solidFill>
+                  <a:srgbClr val="103552"/>
+                </a:solidFill>
+                <a:latin typeface="Liberation Mono"/>
+              </a:rPr>
+              <a:t>  </a:t>
+            </a:r>
+            <a:r>
+              <a:rPr sz="1085">
                 <a:solidFill>
                   <a:srgbClr val="6C3D80"/>
                 </a:solidFill>
                 <a:latin typeface="Liberation Mono"/>
               </a:rPr>
-              <a:t>objdump</a:t>
-            </a:r>
-            <a:r>
-              <a:rPr sz="1030">
+              <a:t>pe_mode</a:t>
+            </a:r>
+            <a:r>
+              <a:rPr sz="1085">
                 <a:solidFill>
                   <a:srgbClr val="103552"/>
                 </a:solidFill>
                 <a:latin typeface="Liberation Mono"/>
               </a:rPr>
-              <a:t>: 4a: 04b6b07b  .insn </a:t>
-            </a:r>
-            <a:r>
-              <a:rPr sz="1030">
+              <a:t> = </a:t>
+            </a:r>
+            <a:r>
+              <a:rPr sz="1085">
                 <a:solidFill>
                   <a:srgbClr val="A44F25"/>
                 </a:solidFill>
                 <a:latin typeface="Liberation Mono"/>
               </a:rPr>
-              <a:t>4</a:t>
-            </a:r>
-            <a:r>
-              <a:rPr sz="1030">
+              <a:t>0</a:t>
+            </a:r>
+            <a:r>
+              <a:rPr sz="1085">
                 <a:solidFill>
                   <a:srgbClr val="103552"/>
                 </a:solidFill>
                 <a:latin typeface="Liberation Mono"/>
               </a:rPr>
-              <a:t>, </a:t>
-            </a:r>
-            <a:r>
-              <a:rPr sz="1030">
-                <a:solidFill>
-                  <a:srgbClr val="A44F25"/>
+              <a:t> : i32,</a:t>
+            </a:r>
+          </a:p>
+          <a:p>
+            <a:pPr algn="l">
+              <a:spcBef>
+                <a:spcPts val="0"/>
+              </a:spcBef>
+              <a:spcAft>
+                <a:spcPts val="0"/>
+              </a:spcAft>
+            </a:pPr>
+            <a:r>
+              <a:rPr sz="1085">
+                <a:solidFill>
+                  <a:srgbClr val="103552"/>
                 </a:solidFill>
                 <a:latin typeface="Liberation Mono"/>
               </a:rPr>
-              <a:t>0x04b6b07b</a:t>
+              <a:t>  </a:t>
+            </a:r>
+            <a:r>
+              <a:rPr sz="1085">
+                <a:solidFill>
+                  <a:srgbClr val="6C3D80"/>
+                </a:solidFill>
+                <a:latin typeface="Liberation Mono"/>
+              </a:rPr>
+              <a:t>profile_sha256</a:t>
+            </a:r>
+            <a:r>
+              <a:rPr sz="1085">
+                <a:solidFill>
+                  <a:srgbClr val="103552"/>
+                </a:solidFill>
+                <a:latin typeface="Liberation Mono"/>
+              </a:rPr>
+              <a:t> = </a:t>
+            </a:r>
+            <a:r>
+              <a:rPr sz="1085">
+                <a:solidFill>
+                  <a:srgbClr val="28704F"/>
+                </a:solidFill>
+                <a:latin typeface="Liberation Mono"/>
+              </a:rPr>
+              <a:t>"e9e33f..."</a:t>
+            </a:r>
+            <a:r>
+              <a:rPr sz="1085">
+                <a:solidFill>
+                  <a:srgbClr val="103552"/>
+                </a:solidFill>
+                <a:latin typeface="Liberation Mono"/>
+              </a:rPr>
+              <a:t> }</a:t>
             </a:r>
           </a:p>
         </p:txBody>
       </p:sp>
       <p:sp>
         <p:nvSpPr>
-          <p:cNvPr id="13" name="TextBox 12"/>
+          <p:cNvPr id="14" name="TextBox 13"/>
           <p:cNvSpPr txBox="1"/>
           <p:nvPr/>
         </p:nvSpPr>
         <p:spPr>
           <a:xfrm>
-            <a:off x="6382512" y="3493008"/>
-            <a:ext cx="4727448" cy="548640"/>
+            <a:off x="6748272" y="3712463"/>
+            <a:ext cx="4370832" cy="274320"/>
           </a:xfrm>
           <a:prstGeom prst="rect">
             <a:avLst/>
@@ -19108,27 +19772,27 @@
               </a:spcAft>
             </a:pPr>
             <a:r>
-              <a:rPr sz="1100" b="0">
-                <a:solidFill>
-                  <a:srgbClr val="313455"/>
-                </a:solidFill>
-                <a:latin typeface="Inter"/>
-              </a:rPr>
-              <a:t>physical_program orders mvin → compute → VPU → mvout. RoCC C + data asm → RV64 GCC → ELF → Nicolas Spike.</a:t>
+              <a:rPr sz="1410" b="1">
+                <a:solidFill>
+                  <a:srgbClr val="103552"/>
+                </a:solidFill>
+                <a:latin typeface="Inter"/>
+              </a:rPr>
+              <a:t>Compiler consequences</a:t>
             </a:r>
           </a:p>
         </p:txBody>
       </p:sp>
       <p:sp>
         <p:nvSpPr>
-          <p:cNvPr id="14" name="TextBox 13"/>
+          <p:cNvPr id="15" name="TextBox 14"/>
           <p:cNvSpPr txBox="1"/>
           <p:nvPr/>
         </p:nvSpPr>
         <p:spPr>
           <a:xfrm>
-            <a:off x="877824" y="4352544"/>
-            <a:ext cx="10424160" cy="274320"/>
+            <a:off x="6748272" y="4041648"/>
+            <a:ext cx="4370832" cy="1481328"/>
           </a:xfrm>
           <a:prstGeom prst="rect">
             <a:avLst/>
@@ -19150,59 +19814,109 @@
               </a:spcAft>
             </a:pPr>
             <a:r>
-              <a:rPr sz="1600" b="1">
-                <a:solidFill>
-                  <a:srgbClr val="103552"/>
-                </a:solidFill>
-                <a:latin typeface="Inter"/>
-              </a:rPr>
-              <a:t>Implemented transforms and checks</a:t>
-            </a:r>
-          </a:p>
-        </p:txBody>
-      </p:sp>
-      <p:sp>
-        <p:nvSpPr>
-          <p:cNvPr id="15" name="Rounded Rectangle 14"/>
-          <p:cNvSpPr/>
-          <p:nvPr/>
-        </p:nvSpPr>
-        <p:spPr>
-          <a:xfrm>
-            <a:off x="859536" y="4709160"/>
-            <a:ext cx="1965960" cy="987552"/>
-          </a:xfrm>
-          <a:prstGeom prst="roundRect">
-            <a:avLst/>
-          </a:prstGeom>
-          <a:solidFill>
-            <a:srgbClr val="FDF8F1"/>
-          </a:solidFill>
-          <a:ln>
-            <a:solidFill>
-              <a:srgbClr val="B0A597"/>
-            </a:solidFill>
-          </a:ln>
-        </p:spPr>
-        <p:style>
-          <a:lnRef idx="1">
-            <a:schemeClr val="accent1"/>
-          </a:lnRef>
-          <a:fillRef idx="3">
-            <a:schemeClr val="accent1"/>
-          </a:fillRef>
-          <a:effectRef idx="2">
-            <a:schemeClr val="accent1"/>
-          </a:effectRef>
-          <a:fontRef idx="minor">
-            <a:schemeClr val="lt1"/>
-          </a:fontRef>
-        </p:style>
-        <p:txBody>
-          <a:bodyPr rtlCol="0" anchor="ctr"/>
-          <a:lstStyle/>
-          <a:p>
-            <a:pPr algn="ctr"/>
+              <a:rPr sz="1100" b="0">
+                <a:solidFill>
+                  <a:srgbClr val="313455"/>
+                </a:solidFill>
+                <a:latin typeface="Inter"/>
+              </a:rPr>
+              <a:t>• TinyLlama: 155 FP4 / 45 FP8 MX sites per stage.</a:t>
+            </a:r>
+          </a:p>
+          <a:p>
+            <a:pPr algn="l">
+              <a:spcBef>
+                <a:spcPts val="0"/>
+              </a:spcBef>
+              <a:spcAft>
+                <a:spcPts val="0"/>
+              </a:spcAft>
+            </a:pPr>
+            <a:r>
+              <a:rPr sz="1100" b="0">
+                <a:solidFill>
+                  <a:srgbClr val="313455"/>
+                </a:solidFill>
+                <a:latin typeface="Inter"/>
+              </a:rPr>
+              <a:t>• PE 0 = direct FP4 × FP4; PE 8 = direct FP8 × FP8.</a:t>
+            </a:r>
+          </a:p>
+          <a:p>
+            <a:pPr algn="l">
+              <a:spcBef>
+                <a:spcPts val="0"/>
+              </a:spcBef>
+              <a:spcAft>
+                <a:spcPts val="0"/>
+              </a:spcAft>
+            </a:pPr>
+            <a:r>
+              <a:rPr sz="1100" b="0">
+                <a:solidFill>
+                  <a:srgbClr val="313455"/>
+                </a:solidFill>
+                <a:latin typeface="Inter"/>
+              </a:rPr>
+              <a:t>• 256 KiB SPAD caps tiles; VPU/requant legal.</a:t>
+            </a:r>
+          </a:p>
+          <a:p>
+            <a:pPr algn="l">
+              <a:spcBef>
+                <a:spcPts val="0"/>
+              </a:spcBef>
+              <a:spcAft>
+                <a:spcPts val="0"/>
+              </a:spcAft>
+            </a:pPr>
+            <a:r>
+              <a:rPr sz="1100" b="0">
+                <a:solidFill>
+                  <a:srgbClr val="313455"/>
+                </a:solidFill>
+                <a:latin typeface="Inter"/>
+              </a:rPr>
+              <a:t>• Selected profile: no operand LUT or FP6.</a:t>
+            </a:r>
+          </a:p>
+          <a:p>
+            <a:pPr algn="l">
+              <a:spcBef>
+                <a:spcPts val="0"/>
+              </a:spcBef>
+              <a:spcAft>
+                <a:spcPts val="0"/>
+              </a:spcAft>
+            </a:pPr>
+            <a:r>
+              <a:rPr sz="1100" b="0">
+                <a:solidFill>
+                  <a:srgbClr val="313455"/>
+                </a:solidFill>
+                <a:latin typeface="Inter"/>
+              </a:rPr>
+              <a:t>• FP6×FP4 profile: E3M2 LUT × FP4 direct → PE 3; VPU off.</a:t>
+            </a:r>
+          </a:p>
+          <a:p>
+            <a:pPr algn="l">
+              <a:spcBef>
+                <a:spcPts val="0"/>
+              </a:spcBef>
+              <a:spcAft>
+                <a:spcPts val="0"/>
+              </a:spcAft>
+            </a:pPr>
+            <a:r>
+              <a:rPr sz="1100" b="0">
+                <a:solidFill>
+                  <a:srgbClr val="313455"/>
+                </a:solidFill>
+                <a:latin typeface="Inter"/>
+              </a:rPr>
+              <a:t>• load_profile(profile, rtl_root=rtl) rejects drift.</a:t>
+            </a:r>
           </a:p>
         </p:txBody>
       </p:sp>
@@ -19214,8 +19928,8 @@
         </p:nvSpPr>
         <p:spPr>
           <a:xfrm>
-            <a:off x="950976" y="4800600"/>
-            <a:ext cx="1783080" cy="338328"/>
+            <a:off x="877824" y="5943600"/>
+            <a:ext cx="10469880" cy="228600"/>
           </a:xfrm>
           <a:prstGeom prst="rect">
             <a:avLst/>
@@ -19228,7 +19942,7 @@
           </a:bodyPr>
           <a:lstStyle/>
           <a:p>
-            <a:pPr algn="ctr">
+            <a:pPr algn="l">
               <a:spcBef>
                 <a:spcPts val="0"/>
               </a:spcBef>
@@ -19237,13 +19951,13 @@
               </a:spcAft>
             </a:pPr>
             <a:r>
-              <a:rPr sz="1170" b="1">
-                <a:solidFill>
-                  <a:srgbClr val="103552"/>
-                </a:solidFill>
-                <a:latin typeface="Inter"/>
-              </a:rPr>
-              <a:t>bind_profile</a:t>
+              <a:rPr sz="1019" b="0">
+                <a:solidFill>
+                  <a:srgbClr val="5B5957"/>
+                </a:solidFill>
+                <a:latin typeface="Inter"/>
+              </a:rPr>
+              <a:t>npu-exploration supplies source kernels for per-mode Spike checks; the RTL profile alone is structural, not a performance claim.</a:t>
             </a:r>
           </a:p>
         </p:txBody>
@@ -19251,720 +19965,6 @@
       <p:sp>
         <p:nvSpPr>
           <p:cNvPr id="17" name="TextBox 16"/>
-          <p:cNvSpPr txBox="1"/>
-          <p:nvPr/>
-        </p:nvSpPr>
-        <p:spPr>
-          <a:xfrm>
-            <a:off x="950976" y="5230368"/>
-            <a:ext cx="1783080" cy="365760"/>
-          </a:xfrm>
-          <a:prstGeom prst="rect">
-            <a:avLst/>
-          </a:prstGeom>
-          <a:noFill/>
-        </p:spPr>
-        <p:txBody>
-          <a:bodyPr wrap="square" lIns="18288" rIns="18288" tIns="9144" bIns="9144" anchor="ctr">
-            <a:spAutoFit/>
-          </a:bodyPr>
-          <a:lstStyle/>
-          <a:p>
-            <a:pPr algn="ctr">
-              <a:spcBef>
-                <a:spcPts val="0"/>
-              </a:spcBef>
-              <a:spcAft>
-                <a:spcPts val="0"/>
-              </a:spcAft>
-            </a:pPr>
-            <a:r>
-              <a:rPr sz="1080" b="0">
-                <a:solidFill>
-                  <a:srgbClr val="313455"/>
-                </a:solidFill>
-                <a:latin typeface="Inter"/>
-              </a:rPr>
-              <a:t>Legal PE tuple +</a:t>
-            </a:r>
-          </a:p>
-          <a:p>
-            <a:pPr algn="ctr">
-              <a:spcBef>
-                <a:spcPts val="0"/>
-              </a:spcBef>
-              <a:spcAft>
-                <a:spcPts val="0"/>
-              </a:spcAft>
-            </a:pPr>
-            <a:r>
-              <a:rPr sz="1080" b="0">
-                <a:solidFill>
-                  <a:srgbClr val="313455"/>
-                </a:solidFill>
-                <a:latin typeface="Inter"/>
-              </a:rPr>
-              <a:t>profile digest</a:t>
-            </a:r>
-          </a:p>
-        </p:txBody>
-      </p:sp>
-      <p:sp>
-        <p:nvSpPr>
-          <p:cNvPr id="18" name="Rounded Rectangle 17"/>
-          <p:cNvSpPr/>
-          <p:nvPr/>
-        </p:nvSpPr>
-        <p:spPr>
-          <a:xfrm>
-            <a:off x="2999232" y="4709160"/>
-            <a:ext cx="1965960" cy="987552"/>
-          </a:xfrm>
-          <a:prstGeom prst="roundRect">
-            <a:avLst/>
-          </a:prstGeom>
-          <a:solidFill>
-            <a:srgbClr val="E1E8EC"/>
-          </a:solidFill>
-          <a:ln>
-            <a:solidFill>
-              <a:srgbClr val="B0A597"/>
-            </a:solidFill>
-          </a:ln>
-        </p:spPr>
-        <p:style>
-          <a:lnRef idx="1">
-            <a:schemeClr val="accent1"/>
-          </a:lnRef>
-          <a:fillRef idx="3">
-            <a:schemeClr val="accent1"/>
-          </a:fillRef>
-          <a:effectRef idx="2">
-            <a:schemeClr val="accent1"/>
-          </a:effectRef>
-          <a:fontRef idx="minor">
-            <a:schemeClr val="lt1"/>
-          </a:fontRef>
-        </p:style>
-        <p:txBody>
-          <a:bodyPr rtlCol="0" anchor="ctr"/>
-          <a:lstStyle/>
-          <a:p>
-            <a:pPr algn="ctr"/>
-          </a:p>
-        </p:txBody>
-      </p:sp>
-      <p:sp>
-        <p:nvSpPr>
-          <p:cNvPr id="19" name="TextBox 18"/>
-          <p:cNvSpPr txBox="1"/>
-          <p:nvPr/>
-        </p:nvSpPr>
-        <p:spPr>
-          <a:xfrm>
-            <a:off x="3090672" y="4800600"/>
-            <a:ext cx="1783080" cy="338328"/>
-          </a:xfrm>
-          <a:prstGeom prst="rect">
-            <a:avLst/>
-          </a:prstGeom>
-          <a:noFill/>
-        </p:spPr>
-        <p:txBody>
-          <a:bodyPr wrap="square" lIns="18288" rIns="18288" tIns="9144" bIns="9144" anchor="ctr">
-            <a:spAutoFit/>
-          </a:bodyPr>
-          <a:lstStyle/>
-          <a:p>
-            <a:pPr algn="ctr">
-              <a:spcBef>
-                <a:spcPts val="0"/>
-              </a:spcBef>
-              <a:spcAft>
-                <a:spcPts val="0"/>
-              </a:spcAft>
-            </a:pPr>
-            <a:r>
-              <a:rPr sz="1170" b="1">
-                <a:solidFill>
-                  <a:srgbClr val="103552"/>
-                </a:solidFill>
-                <a:latin typeface="Inter"/>
-              </a:rPr>
-              <a:t>MXBF16Catalog</a:t>
-            </a:r>
-          </a:p>
-          <a:p>
-            <a:pPr algn="ctr">
-              <a:spcBef>
-                <a:spcPts val="0"/>
-              </a:spcBef>
-              <a:spcAft>
-                <a:spcPts val="0"/>
-              </a:spcAft>
-            </a:pPr>
-            <a:r>
-              <a:rPr sz="1170" b="1">
-                <a:solidFill>
-                  <a:srgbClr val="103552"/>
-                </a:solidFill>
-                <a:latin typeface="Inter"/>
-              </a:rPr>
-              <a:t>Preparation</a:t>
-            </a:r>
-          </a:p>
-        </p:txBody>
-      </p:sp>
-      <p:sp>
-        <p:nvSpPr>
-          <p:cNvPr id="20" name="TextBox 19"/>
-          <p:cNvSpPr txBox="1"/>
-          <p:nvPr/>
-        </p:nvSpPr>
-        <p:spPr>
-          <a:xfrm>
-            <a:off x="3090672" y="5230368"/>
-            <a:ext cx="1783080" cy="365760"/>
-          </a:xfrm>
-          <a:prstGeom prst="rect">
-            <a:avLst/>
-          </a:prstGeom>
-          <a:noFill/>
-        </p:spPr>
-        <p:txBody>
-          <a:bodyPr wrap="square" lIns="18288" rIns="18288" tIns="9144" bIns="9144" anchor="ctr">
-            <a:spAutoFit/>
-          </a:bodyPr>
-          <a:lstStyle/>
-          <a:p>
-            <a:pPr algn="ctr">
-              <a:spcBef>
-                <a:spcPts val="0"/>
-              </a:spcBef>
-              <a:spcAft>
-                <a:spcPts val="0"/>
-              </a:spcAft>
-            </a:pPr>
-            <a:r>
-              <a:rPr sz="1080" b="0">
-                <a:solidFill>
-                  <a:srgbClr val="313455"/>
-                </a:solidFill>
-                <a:latin typeface="Inter"/>
-              </a:rPr>
-              <a:t>Select BF16</a:t>
-            </a:r>
-          </a:p>
-          <a:p>
-            <a:pPr algn="ctr">
-              <a:spcBef>
-                <a:spcPts val="0"/>
-              </a:spcBef>
-              <a:spcAft>
-                <a:spcPts val="0"/>
-              </a:spcAft>
-            </a:pPr>
-            <a:r>
-              <a:rPr sz="1080" b="0">
-                <a:solidFill>
-                  <a:srgbClr val="313455"/>
-                </a:solidFill>
-                <a:latin typeface="Inter"/>
-              </a:rPr>
-              <a:t>MX sites</a:t>
-            </a:r>
-          </a:p>
-        </p:txBody>
-      </p:sp>
-      <p:sp>
-        <p:nvSpPr>
-          <p:cNvPr id="21" name="Rounded Rectangle 20"/>
-          <p:cNvSpPr/>
-          <p:nvPr/>
-        </p:nvSpPr>
-        <p:spPr>
-          <a:xfrm>
-            <a:off x="5138927" y="4709160"/>
-            <a:ext cx="1965960" cy="987552"/>
-          </a:xfrm>
-          <a:prstGeom prst="roundRect">
-            <a:avLst/>
-          </a:prstGeom>
-          <a:solidFill>
-            <a:srgbClr val="FDF8F1"/>
-          </a:solidFill>
-          <a:ln>
-            <a:solidFill>
-              <a:srgbClr val="B0A597"/>
-            </a:solidFill>
-          </a:ln>
-        </p:spPr>
-        <p:style>
-          <a:lnRef idx="1">
-            <a:schemeClr val="accent1"/>
-          </a:lnRef>
-          <a:fillRef idx="3">
-            <a:schemeClr val="accent1"/>
-          </a:fillRef>
-          <a:effectRef idx="2">
-            <a:schemeClr val="accent1"/>
-          </a:effectRef>
-          <a:fontRef idx="minor">
-            <a:schemeClr val="lt1"/>
-          </a:fontRef>
-        </p:style>
-        <p:txBody>
-          <a:bodyPr rtlCol="0" anchor="ctr"/>
-          <a:lstStyle/>
-          <a:p>
-            <a:pPr algn="ctr"/>
-          </a:p>
-        </p:txBody>
-      </p:sp>
-      <p:sp>
-        <p:nvSpPr>
-          <p:cNvPr id="22" name="TextBox 21"/>
-          <p:cNvSpPr txBox="1"/>
-          <p:nvPr/>
-        </p:nvSpPr>
-        <p:spPr>
-          <a:xfrm>
-            <a:off x="5230367" y="4800600"/>
-            <a:ext cx="1783080" cy="338328"/>
-          </a:xfrm>
-          <a:prstGeom prst="rect">
-            <a:avLst/>
-          </a:prstGeom>
-          <a:noFill/>
-        </p:spPr>
-        <p:txBody>
-          <a:bodyPr wrap="square" lIns="18288" rIns="18288" tIns="9144" bIns="9144" anchor="ctr">
-            <a:spAutoFit/>
-          </a:bodyPr>
-          <a:lstStyle/>
-          <a:p>
-            <a:pPr algn="ctr">
-              <a:spcBef>
-                <a:spcPts val="0"/>
-              </a:spcBef>
-              <a:spcAft>
-                <a:spcPts val="0"/>
-              </a:spcAft>
-            </a:pPr>
-            <a:r>
-              <a:rPr sz="1170" b="1">
-                <a:solidFill>
-                  <a:srgbClr val="103552"/>
-                </a:solidFill>
-                <a:latin typeface="Inter"/>
-              </a:rPr>
-              <a:t>schedule.plan</a:t>
-            </a:r>
-          </a:p>
-        </p:txBody>
-      </p:sp>
-      <p:sp>
-        <p:nvSpPr>
-          <p:cNvPr id="23" name="TextBox 22"/>
-          <p:cNvSpPr txBox="1"/>
-          <p:nvPr/>
-        </p:nvSpPr>
-        <p:spPr>
-          <a:xfrm>
-            <a:off x="5230367" y="5230368"/>
-            <a:ext cx="1783080" cy="365760"/>
-          </a:xfrm>
-          <a:prstGeom prst="rect">
-            <a:avLst/>
-          </a:prstGeom>
-          <a:noFill/>
-        </p:spPr>
-        <p:txBody>
-          <a:bodyPr wrap="square" lIns="18288" rIns="18288" tIns="9144" bIns="9144" anchor="ctr">
-            <a:spAutoFit/>
-          </a:bodyPr>
-          <a:lstStyle/>
-          <a:p>
-            <a:pPr algn="ctr">
-              <a:spcBef>
-                <a:spcPts val="0"/>
-              </a:spcBef>
-              <a:spcAft>
-                <a:spcPts val="0"/>
-              </a:spcAft>
-            </a:pPr>
-            <a:r>
-              <a:rPr sz="1080" b="0">
-                <a:solidFill>
-                  <a:srgbClr val="313455"/>
-                </a:solidFill>
-                <a:latin typeface="Inter"/>
-              </a:rPr>
-              <a:t>Choose native</a:t>
-            </a:r>
-          </a:p>
-          <a:p>
-            <a:pPr algn="ctr">
-              <a:spcBef>
-                <a:spcPts val="0"/>
-              </a:spcBef>
-              <a:spcAft>
-                <a:spcPts val="0"/>
-              </a:spcAft>
-            </a:pPr>
-            <a:r>
-              <a:rPr sz="1080" b="0">
-                <a:solidFill>
-                  <a:srgbClr val="313455"/>
-                </a:solidFill>
-                <a:latin typeface="Inter"/>
-              </a:rPr>
-              <a:t>loop policy</a:t>
-            </a:r>
-          </a:p>
-        </p:txBody>
-      </p:sp>
-      <p:sp>
-        <p:nvSpPr>
-          <p:cNvPr id="24" name="Rounded Rectangle 23"/>
-          <p:cNvSpPr/>
-          <p:nvPr/>
-        </p:nvSpPr>
-        <p:spPr>
-          <a:xfrm>
-            <a:off x="7278623" y="4709160"/>
-            <a:ext cx="1965960" cy="987552"/>
-          </a:xfrm>
-          <a:prstGeom prst="roundRect">
-            <a:avLst/>
-          </a:prstGeom>
-          <a:solidFill>
-            <a:srgbClr val="E5E7DA"/>
-          </a:solidFill>
-          <a:ln>
-            <a:solidFill>
-              <a:srgbClr val="B0A597"/>
-            </a:solidFill>
-          </a:ln>
-        </p:spPr>
-        <p:style>
-          <a:lnRef idx="1">
-            <a:schemeClr val="accent1"/>
-          </a:lnRef>
-          <a:fillRef idx="3">
-            <a:schemeClr val="accent1"/>
-          </a:fillRef>
-          <a:effectRef idx="2">
-            <a:schemeClr val="accent1"/>
-          </a:effectRef>
-          <a:fontRef idx="minor">
-            <a:schemeClr val="lt1"/>
-          </a:fontRef>
-        </p:style>
-        <p:txBody>
-          <a:bodyPr rtlCol="0" anchor="ctr"/>
-          <a:lstStyle/>
-          <a:p>
-            <a:pPr algn="ctr"/>
-          </a:p>
-        </p:txBody>
-      </p:sp>
-      <p:sp>
-        <p:nvSpPr>
-          <p:cNvPr id="25" name="TextBox 24"/>
-          <p:cNvSpPr txBox="1"/>
-          <p:nvPr/>
-        </p:nvSpPr>
-        <p:spPr>
-          <a:xfrm>
-            <a:off x="7370063" y="4800600"/>
-            <a:ext cx="1783080" cy="338328"/>
-          </a:xfrm>
-          <a:prstGeom prst="rect">
-            <a:avLst/>
-          </a:prstGeom>
-          <a:noFill/>
-        </p:spPr>
-        <p:txBody>
-          <a:bodyPr wrap="square" lIns="18288" rIns="18288" tIns="9144" bIns="9144" anchor="ctr">
-            <a:spAutoFit/>
-          </a:bodyPr>
-          <a:lstStyle/>
-          <a:p>
-            <a:pPr algn="ctr">
-              <a:spcBef>
-                <a:spcPts val="0"/>
-              </a:spcBef>
-              <a:spcAft>
-                <a:spcPts val="0"/>
-              </a:spcAft>
-            </a:pPr>
-            <a:r>
-              <a:rPr sz="1170" b="1">
-                <a:solidFill>
-                  <a:srgbClr val="103552"/>
-                </a:solidFill>
-                <a:latin typeface="Inter"/>
-              </a:rPr>
-              <a:t>MXVPUPostOffload</a:t>
-            </a:r>
-          </a:p>
-        </p:txBody>
-      </p:sp>
-      <p:sp>
-        <p:nvSpPr>
-          <p:cNvPr id="26" name="TextBox 25"/>
-          <p:cNvSpPr txBox="1"/>
-          <p:nvPr/>
-        </p:nvSpPr>
-        <p:spPr>
-          <a:xfrm>
-            <a:off x="7370063" y="5230368"/>
-            <a:ext cx="1783080" cy="365760"/>
-          </a:xfrm>
-          <a:prstGeom prst="rect">
-            <a:avLst/>
-          </a:prstGeom>
-          <a:noFill/>
-        </p:spPr>
-        <p:txBody>
-          <a:bodyPr wrap="square" lIns="18288" rIns="18288" tIns="9144" bIns="9144" anchor="ctr">
-            <a:spAutoFit/>
-          </a:bodyPr>
-          <a:lstStyle/>
-          <a:p>
-            <a:pPr algn="ctr">
-              <a:spcBef>
-                <a:spcPts val="0"/>
-              </a:spcBef>
-              <a:spcAft>
-                <a:spcPts val="0"/>
-              </a:spcAft>
-            </a:pPr>
-            <a:r>
-              <a:rPr sz="1080" b="0">
-                <a:solidFill>
-                  <a:srgbClr val="313455"/>
-                </a:solidFill>
-                <a:latin typeface="Inter"/>
-              </a:rPr>
-              <a:t>Map softmax, add</a:t>
-            </a:r>
-          </a:p>
-          <a:p>
-            <a:pPr algn="ctr">
-              <a:spcBef>
-                <a:spcPts val="0"/>
-              </a:spcBef>
-              <a:spcAft>
-                <a:spcPts val="0"/>
-              </a:spcAft>
-            </a:pPr>
-            <a:r>
-              <a:rPr sz="1080" b="0">
-                <a:solidFill>
-                  <a:srgbClr val="313455"/>
-                </a:solidFill>
-                <a:latin typeface="Inter"/>
-              </a:rPr>
-              <a:t>and reductions</a:t>
-            </a:r>
-          </a:p>
-        </p:txBody>
-      </p:sp>
-      <p:sp>
-        <p:nvSpPr>
-          <p:cNvPr id="27" name="Rounded Rectangle 26"/>
-          <p:cNvSpPr/>
-          <p:nvPr/>
-        </p:nvSpPr>
-        <p:spPr>
-          <a:xfrm>
-            <a:off x="9418319" y="4709160"/>
-            <a:ext cx="1965960" cy="987552"/>
-          </a:xfrm>
-          <a:prstGeom prst="roundRect">
-            <a:avLst/>
-          </a:prstGeom>
-          <a:solidFill>
-            <a:srgbClr val="FDF8F1"/>
-          </a:solidFill>
-          <a:ln>
-            <a:solidFill>
-              <a:srgbClr val="B0A597"/>
-            </a:solidFill>
-          </a:ln>
-        </p:spPr>
-        <p:style>
-          <a:lnRef idx="1">
-            <a:schemeClr val="accent1"/>
-          </a:lnRef>
-          <a:fillRef idx="3">
-            <a:schemeClr val="accent1"/>
-          </a:fillRef>
-          <a:effectRef idx="2">
-            <a:schemeClr val="accent1"/>
-          </a:effectRef>
-          <a:fontRef idx="minor">
-            <a:schemeClr val="lt1"/>
-          </a:fontRef>
-        </p:style>
-        <p:txBody>
-          <a:bodyPr rtlCol="0" anchor="ctr"/>
-          <a:lstStyle/>
-          <a:p>
-            <a:pPr algn="ctr"/>
-          </a:p>
-        </p:txBody>
-      </p:sp>
-      <p:sp>
-        <p:nvSpPr>
-          <p:cNvPr id="28" name="TextBox 27"/>
-          <p:cNvSpPr txBox="1"/>
-          <p:nvPr/>
-        </p:nvSpPr>
-        <p:spPr>
-          <a:xfrm>
-            <a:off x="9509759" y="4800600"/>
-            <a:ext cx="1783080" cy="338328"/>
-          </a:xfrm>
-          <a:prstGeom prst="rect">
-            <a:avLst/>
-          </a:prstGeom>
-          <a:noFill/>
-        </p:spPr>
-        <p:txBody>
-          <a:bodyPr wrap="square" lIns="18288" rIns="18288" tIns="9144" bIns="9144" anchor="ctr">
-            <a:spAutoFit/>
-          </a:bodyPr>
-          <a:lstStyle/>
-          <a:p>
-            <a:pPr algn="ctr">
-              <a:spcBef>
-                <a:spcPts val="0"/>
-              </a:spcBef>
-              <a:spcAft>
-                <a:spcPts val="0"/>
-              </a:spcAft>
-            </a:pPr>
-            <a:r>
-              <a:rPr sz="1170" b="1">
-                <a:solidFill>
-                  <a:srgbClr val="103552"/>
-                </a:solidFill>
-                <a:latin typeface="Inter"/>
-              </a:rPr>
-              <a:t>physical_program</a:t>
-            </a:r>
-          </a:p>
-        </p:txBody>
-      </p:sp>
-      <p:sp>
-        <p:nvSpPr>
-          <p:cNvPr id="29" name="TextBox 28"/>
-          <p:cNvSpPr txBox="1"/>
-          <p:nvPr/>
-        </p:nvSpPr>
-        <p:spPr>
-          <a:xfrm>
-            <a:off x="9509759" y="5230368"/>
-            <a:ext cx="1783080" cy="365760"/>
-          </a:xfrm>
-          <a:prstGeom prst="rect">
-            <a:avLst/>
-          </a:prstGeom>
-          <a:noFill/>
-        </p:spPr>
-        <p:txBody>
-          <a:bodyPr wrap="square" lIns="18288" rIns="18288" tIns="9144" bIns="9144" anchor="ctr">
-            <a:spAutoFit/>
-          </a:bodyPr>
-          <a:lstStyle/>
-          <a:p>
-            <a:pPr algn="ctr">
-              <a:spcBef>
-                <a:spcPts val="0"/>
-              </a:spcBef>
-              <a:spcAft>
-                <a:spcPts val="0"/>
-              </a:spcAft>
-            </a:pPr>
-            <a:r>
-              <a:rPr sz="1080" b="0">
-                <a:solidFill>
-                  <a:srgbClr val="313455"/>
-                </a:solidFill>
-                <a:latin typeface="Inter"/>
-              </a:rPr>
-              <a:t>Order DMA, compute</a:t>
-            </a:r>
-          </a:p>
-          <a:p>
-            <a:pPr algn="ctr">
-              <a:spcBef>
-                <a:spcPts val="0"/>
-              </a:spcBef>
-              <a:spcAft>
-                <a:spcPts val="0"/>
-              </a:spcAft>
-            </a:pPr>
-            <a:r>
-              <a:rPr sz="1080" b="0">
-                <a:solidFill>
-                  <a:srgbClr val="313455"/>
-                </a:solidFill>
-                <a:latin typeface="Inter"/>
-              </a:rPr>
-              <a:t>and VPU commands</a:t>
-            </a:r>
-          </a:p>
-        </p:txBody>
-      </p:sp>
-      <p:sp>
-        <p:nvSpPr>
-          <p:cNvPr id="30" name="TextBox 29"/>
-          <p:cNvSpPr txBox="1"/>
-          <p:nvPr/>
-        </p:nvSpPr>
-        <p:spPr>
-          <a:xfrm>
-            <a:off x="877824" y="5833872"/>
-            <a:ext cx="10469880" cy="329184"/>
-          </a:xfrm>
-          <a:prstGeom prst="rect">
-            <a:avLst/>
-          </a:prstGeom>
-          <a:noFill/>
-        </p:spPr>
-        <p:txBody>
-          <a:bodyPr wrap="square" lIns="18288" rIns="18288" tIns="9144" bIns="9144" anchor="ctr">
-            <a:spAutoFit/>
-          </a:bodyPr>
-          <a:lstStyle/>
-          <a:p>
-            <a:pPr algn="l">
-              <a:spcBef>
-                <a:spcPts val="0"/>
-              </a:spcBef>
-              <a:spcAft>
-                <a:spcPts val="0"/>
-              </a:spcAft>
-            </a:pPr>
-            <a:r>
-              <a:rPr sz="1019" b="0">
-                <a:solidFill>
-                  <a:srgbClr val="5B5957"/>
-                </a:solidFill>
-                <a:latin typeface="Inter"/>
-              </a:rPr>
-              <a:t>mx-gemmini-opt verifies typed IR. The standalone command path bypasses LLVM; the generic full-model host currently uses Merlin → LLVM → RV64.</a:t>
-            </a:r>
-          </a:p>
-        </p:txBody>
-      </p:sp>
-      <p:sp>
-        <p:nvSpPr>
-          <p:cNvPr id="31" name="TextBox 30"/>
           <p:cNvSpPr txBox="1"/>
           <p:nvPr/>
         </p:nvSpPr>
@@ -19999,7 +19999,7 @@
                 </a:solidFill>
                 <a:latin typeface="Inter"/>
               </a:rPr>
-              <a:t>01 / 04</a:t>
+              <a:t>02 / 04</a:t>
             </a:r>
           </a:p>
         </p:txBody>
@@ -20012,7 +20012,7 @@
 </p:sld>
 </file>
 
-<file path=ppt/slides/slide33.xml><?xml version="1.0" encoding="utf-8"?>
+<file path=ppt/slides/slide3.xml><?xml version="1.0" encoding="utf-8"?>
 <p:sld xmlns:a="http://schemas.openxmlformats.org/drawingml/2006/main" xmlns:p="http://schemas.openxmlformats.org/presentationml/2006/main" xmlns:r="http://schemas.openxmlformats.org/officeDocument/2006/relationships" showMasterSp="1">
   <p:cSld>
     <p:bg>
@@ -21122,7 +21122,7 @@
         </p:nvSpPr>
         <p:spPr>
           <a:xfrm>
-            <a:off x="859536" y="5404104"/>
+            <a:off x="859536" y="5522976"/>
             <a:ext cx="10515600" cy="603504"/>
           </a:xfrm>
           <a:prstGeom prst="rect">
@@ -21188,7 +21188,7 @@
         <p:spPr>
           <a:xfrm>
             <a:off x="859536" y="4663440"/>
-            <a:ext cx="10479024" cy="557784"/>
+            <a:ext cx="10479024" cy="713232"/>
           </a:xfrm>
           <a:prstGeom prst="roundRect">
             <a:avLst/>
@@ -21233,7 +21233,7 @@
                 </a:solidFill>
                 <a:latin typeface="Inter"/>
               </a:rPr>
-              <a:t>FP32 drift on fixed synthetic inputs: TinyLlama prefill logits cosine -0.313; decode mean -0.324, top matches 0/32.</a:t>
+              <a:t>TinyLlama logits vs FP32: prefill mixed -0.313, all-FP8 0.943; decode mean -0.324, 0/32 top matches.</a:t>
             </a:r>
           </a:p>
           <a:p>
@@ -21245,6 +21245,18 @@
                 <a:spcPts val="0"/>
               </a:spcAft>
             </a:pPr>
+            <a:r>
+              <a:rPr sz="1060" b="1">
+                <a:solidFill>
+                  <a:srgbClr val="103552"/>
+                </a:solidFill>
+                <a:latin typeface="Inter"/>
+              </a:rPr>
+              <a:t>First11 FP8: prepacked and runtime logits equal; 12.11B vs 90.55B cycles; cosine -0.440.</a:t>
+            </a:r>
+          </a:p>
+          <a:p>
+            <a:pPr algn="ctr"/>
             <a:r>
               <a:rPr sz="1060" b="1">
                 <a:solidFill>

</xml_diff>

<commit_message>
Qualify compiled SmolVLA attention against source
</commit_message>
<xml_diff>
--- a/docs/presentations/mx_gemmini_dialect_overview.pptx
+++ b/docs/presentations/mx_gemmini_dialect_overview.pptx
@@ -16498,7 +16498,7 @@
 </p:sldMaster>
 </file>
 
-<file path=ppt/slides/slide1.xml><?xml version="1.0" encoding="utf-8"?>
+<file path=ppt/slides/slide20.xml><?xml version="1.0" encoding="utf-8"?>
 <p:sld xmlns:a="http://schemas.openxmlformats.org/drawingml/2006/main" xmlns:p="http://schemas.openxmlformats.org/presentationml/2006/main" xmlns:r="http://schemas.openxmlformats.org/officeDocument/2006/relationships" showMasterSp="1">
   <p:cSld>
     <p:bg>
@@ -16557,7 +16557,7 @@
                 </a:solidFill>
                 <a:latin typeface="Inter"/>
               </a:rPr>
-              <a:t>MX dialect: typed IR to RV64</a:t>
+              <a:t>One JSON profile changes legal MLIR</a:t>
             </a:r>
           </a:p>
         </p:txBody>
@@ -16570,8 +16570,8 @@
         </p:nvSpPr>
         <p:spPr>
           <a:xfrm>
-            <a:off x="859536" y="1499616"/>
-            <a:ext cx="5166360" cy="2724912"/>
+            <a:off x="859536" y="1481328"/>
+            <a:ext cx="5522976" cy="4407408"/>
           </a:xfrm>
           <a:prstGeom prst="roundRect">
             <a:avLst/>
@@ -16615,8 +16615,8 @@
         </p:nvSpPr>
         <p:spPr>
           <a:xfrm>
-            <a:off x="6181344" y="1499616"/>
-            <a:ext cx="5166360" cy="2724912"/>
+            <a:off x="6547104" y="1481328"/>
+            <a:ext cx="4800600" cy="4407408"/>
           </a:xfrm>
           <a:prstGeom prst="roundRect">
             <a:avLst/>
@@ -16660,8 +16660,8 @@
         </p:nvSpPr>
         <p:spPr>
           <a:xfrm>
-            <a:off x="1051560" y="1664208"/>
-            <a:ext cx="4754880" cy="310896"/>
+            <a:off x="1051560" y="1636776"/>
+            <a:ext cx="5102352" cy="310896"/>
           </a:xfrm>
           <a:prstGeom prst="rect">
             <a:avLst/>
@@ -16683,13 +16683,13 @@
               </a:spcAft>
             </a:pPr>
             <a:r>
-              <a:rPr sz="1750" b="1">
+              <a:rPr sz="1720" b="1">
                 <a:solidFill>
                   <a:srgbClr val="103552"/>
                 </a:solidFill>
                 <a:latin typeface="Inter"/>
               </a:rPr>
-              <a:t>FP4 GEMM → typed MX</a:t>
+              <a:t>Selected RTL profile fields</a:t>
             </a:r>
           </a:p>
         </p:txBody>
@@ -16702,8 +16702,8 @@
         </p:nvSpPr>
         <p:spPr>
           <a:xfrm>
-            <a:off x="1051560" y="2048256"/>
-            <a:ext cx="4754880" cy="1298448"/>
+            <a:off x="1051560" y="2029968"/>
+            <a:ext cx="5093208" cy="2569464"/>
           </a:xfrm>
           <a:prstGeom prst="roundRect">
             <a:avLst/>
@@ -16744,112 +16744,13 @@
               </a:spcAft>
             </a:pPr>
             <a:r>
-              <a:rPr sz="1110">
-                <a:solidFill>
-                  <a:srgbClr val="006874"/>
+              <a:rPr sz="1045">
+                <a:solidFill>
+                  <a:srgbClr val="103552"/>
                 </a:solidFill>
                 <a:latin typeface="Liberation Mono"/>
               </a:rPr>
-              <a:t>%acc</a:t>
-            </a:r>
-            <a:r>
-              <a:rPr sz="1110">
-                <a:solidFill>
-                  <a:srgbClr val="103552"/>
-                </a:solidFill>
-                <a:latin typeface="Liberation Mono"/>
-              </a:rPr>
-              <a:t> = </a:t>
-            </a:r>
-            <a:r>
-              <a:rPr sz="1110">
-                <a:solidFill>
-                  <a:srgbClr val="6C3D80"/>
-                </a:solidFill>
-                <a:latin typeface="Liberation Mono"/>
-              </a:rPr>
-              <a:t>"mx_gemmini.contract"</a:t>
-            </a:r>
-            <a:r>
-              <a:rPr sz="1110">
-                <a:solidFill>
-                  <a:srgbClr val="103552"/>
-                </a:solidFill>
-                <a:latin typeface="Liberation Mono"/>
-              </a:rPr>
-              <a:t>(</a:t>
-            </a:r>
-            <a:r>
-              <a:rPr sz="1110">
-                <a:solidFill>
-                  <a:srgbClr val="006874"/>
-                </a:solidFill>
-                <a:latin typeface="Liberation Mono"/>
-              </a:rPr>
-              <a:t>%A</a:t>
-            </a:r>
-            <a:r>
-              <a:rPr sz="1110">
-                <a:solidFill>
-                  <a:srgbClr val="103552"/>
-                </a:solidFill>
-                <a:latin typeface="Liberation Mono"/>
-              </a:rPr>
-              <a:t>,</a:t>
-            </a:r>
-            <a:r>
-              <a:rPr sz="1110">
-                <a:solidFill>
-                  <a:srgbClr val="006874"/>
-                </a:solidFill>
-                <a:latin typeface="Liberation Mono"/>
-              </a:rPr>
-              <a:t>%As</a:t>
-            </a:r>
-            <a:r>
-              <a:rPr sz="1110">
-                <a:solidFill>
-                  <a:srgbClr val="103552"/>
-                </a:solidFill>
-                <a:latin typeface="Liberation Mono"/>
-              </a:rPr>
-              <a:t>,</a:t>
-            </a:r>
-            <a:r>
-              <a:rPr sz="1110">
-                <a:solidFill>
-                  <a:srgbClr val="006874"/>
-                </a:solidFill>
-                <a:latin typeface="Liberation Mono"/>
-              </a:rPr>
-              <a:t>%B</a:t>
-            </a:r>
-            <a:r>
-              <a:rPr sz="1110">
-                <a:solidFill>
-                  <a:srgbClr val="103552"/>
-                </a:solidFill>
-                <a:latin typeface="Liberation Mono"/>
-              </a:rPr>
-              <a:t>,</a:t>
-            </a:r>
-            <a:r>
-              <a:rPr sz="1110">
-                <a:solidFill>
-                  <a:srgbClr val="006874"/>
-                </a:solidFill>
-                <a:latin typeface="Liberation Mono"/>
-              </a:rPr>
-              <a:t>%Bs</a:t>
-            </a:r>
-            <a:r>
-              <a:rPr sz="1110">
-                <a:solidFill>
-                  <a:srgbClr val="103552"/>
-                </a:solidFill>
-                <a:latin typeface="Liberation Mono"/>
-              </a:rPr>
-              <a:t>) {</a:t>
+              <a:t>{</a:t>
             </a:r>
           </a:p>
           <a:p>
@@ -16862,49 +16763,103 @@
               </a:spcAft>
             </a:pPr>
             <a:r>
-              <a:rPr sz="1110">
+              <a:rPr sz="1045">
                 <a:solidFill>
                   <a:srgbClr val="103552"/>
                 </a:solidFill>
                 <a:latin typeface="Liberation Mono"/>
               </a:rPr>
-              <a:t>  </a:t>
-            </a:r>
-            <a:r>
-              <a:rPr sz="1110">
+              <a:t> </a:t>
+            </a:r>
+            <a:r>
+              <a:rPr sz="1045">
                 <a:solidFill>
                   <a:srgbClr val="6C3D80"/>
                 </a:solidFill>
                 <a:latin typeface="Liberation Mono"/>
               </a:rPr>
-              <a:t>activation_format</a:t>
-            </a:r>
-            <a:r>
-              <a:rPr sz="1110">
+              <a:t>"geometry"</a:t>
+            </a:r>
+            <a:r>
+              <a:rPr sz="1045">
                 <a:solidFill>
                   <a:srgbClr val="103552"/>
                 </a:solidFill>
                 <a:latin typeface="Liberation Mono"/>
               </a:rPr>
-              <a:t> = </a:t>
-            </a:r>
-            <a:r>
-              <a:rPr sz="1110">
-                <a:solidFill>
-                  <a:srgbClr val="28704F"/>
+              <a:t>: {</a:t>
+            </a:r>
+            <a:r>
+              <a:rPr sz="1045">
+                <a:solidFill>
+                  <a:srgbClr val="6C3D80"/>
                 </a:solidFill>
                 <a:latin typeface="Liberation Mono"/>
               </a:rPr>
-              <a:t>"fp4_e2m1"</a:t>
-            </a:r>
-            <a:r>
-              <a:rPr sz="1110">
+              <a:t>"mesh_rows"</a:t>
+            </a:r>
+            <a:r>
+              <a:rPr sz="1045">
                 <a:solidFill>
                   <a:srgbClr val="103552"/>
                 </a:solidFill>
                 <a:latin typeface="Liberation Mono"/>
               </a:rPr>
+              <a:t>:</a:t>
+            </a:r>
+            <a:r>
+              <a:rPr sz="1045">
+                <a:solidFill>
+                  <a:srgbClr val="A44F25"/>
+                </a:solidFill>
+                <a:latin typeface="Liberation Mono"/>
+              </a:rPr>
+              <a:t>16</a:t>
+            </a:r>
+            <a:r>
+              <a:rPr sz="1045">
+                <a:solidFill>
+                  <a:srgbClr val="103552"/>
+                </a:solidFill>
+                <a:latin typeface="Liberation Mono"/>
+              </a:rPr>
               <a:t>,</a:t>
+            </a:r>
+            <a:r>
+              <a:rPr sz="1045">
+                <a:solidFill>
+                  <a:srgbClr val="6C3D80"/>
+                </a:solidFill>
+                <a:latin typeface="Liberation Mono"/>
+              </a:rPr>
+              <a:t>"mesh_columns"</a:t>
+            </a:r>
+            <a:r>
+              <a:rPr sz="1045">
+                <a:solidFill>
+                  <a:srgbClr val="103552"/>
+                </a:solidFill>
+                <a:latin typeface="Liberation Mono"/>
+              </a:rPr>
+              <a:t>:</a:t>
+            </a:r>
+            <a:r>
+              <a:rPr sz="1045">
+                <a:solidFill>
+                  <a:srgbClr val="A44F25"/>
+                </a:solidFill>
+                <a:latin typeface="Liberation Mono"/>
+              </a:rPr>
+              <a:t>16</a:t>
+            </a:r>
+            <a:r>
+              <a:rPr sz="1045">
+                <a:solidFill>
+                  <a:srgbClr val="103552"/>
+                </a:solidFill>
+                <a:latin typeface="Liberation Mono"/>
+              </a:rPr>
+              <a:t>},</a:t>
             </a:r>
           </a:p>
           <a:p>
@@ -16917,85 +16872,31 @@
               </a:spcAft>
             </a:pPr>
             <a:r>
-              <a:rPr sz="1110">
+              <a:rPr sz="1045">
                 <a:solidFill>
                   <a:srgbClr val="103552"/>
                 </a:solidFill>
                 <a:latin typeface="Liberation Mono"/>
               </a:rPr>
-              <a:t>  </a:t>
-            </a:r>
-            <a:r>
-              <a:rPr sz="1110">
+              <a:t> </a:t>
+            </a:r>
+            <a:r>
+              <a:rPr sz="1045">
                 <a:solidFill>
                   <a:srgbClr val="6C3D80"/>
                 </a:solidFill>
                 <a:latin typeface="Liberation Mono"/>
               </a:rPr>
-              <a:t>weight_format</a:t>
-            </a:r>
-            <a:r>
-              <a:rPr sz="1110">
+              <a:t>"legal_compute"</a:t>
+            </a:r>
+            <a:r>
+              <a:rPr sz="1045">
                 <a:solidFill>
                   <a:srgbClr val="103552"/>
                 </a:solidFill>
                 <a:latin typeface="Liberation Mono"/>
               </a:rPr>
-              <a:t> = </a:t>
-            </a:r>
-            <a:r>
-              <a:rPr sz="1110">
-                <a:solidFill>
-                  <a:srgbClr val="28704F"/>
-                </a:solidFill>
-                <a:latin typeface="Liberation Mono"/>
-              </a:rPr>
-              <a:t>"fp4_e2m1"</a:t>
-            </a:r>
-            <a:r>
-              <a:rPr sz="1110">
-                <a:solidFill>
-                  <a:srgbClr val="103552"/>
-                </a:solidFill>
-                <a:latin typeface="Liberation Mono"/>
-              </a:rPr>
-              <a:t>, </a:t>
-            </a:r>
-            <a:r>
-              <a:rPr sz="1110">
-                <a:solidFill>
-                  <a:srgbClr val="6C3D80"/>
-                </a:solidFill>
-                <a:latin typeface="Liberation Mono"/>
-              </a:rPr>
-              <a:t>pe_mode</a:t>
-            </a:r>
-            <a:r>
-              <a:rPr sz="1110">
-                <a:solidFill>
-                  <a:srgbClr val="103552"/>
-                </a:solidFill>
-                <a:latin typeface="Liberation Mono"/>
-              </a:rPr>
-              <a:t> = </a:t>
-            </a:r>
-            <a:r>
-              <a:rPr sz="1110">
-                <a:solidFill>
-                  <a:srgbClr val="A44F25"/>
-                </a:solidFill>
-                <a:latin typeface="Liberation Mono"/>
-              </a:rPr>
-              <a:t>0</a:t>
-            </a:r>
-            <a:r>
-              <a:rPr sz="1110">
-                <a:solidFill>
-                  <a:srgbClr val="103552"/>
-                </a:solidFill>
-                <a:latin typeface="Liberation Mono"/>
-              </a:rPr>
-              <a:t> : i32 }</a:t>
+              <a:t>: [</a:t>
             </a:r>
           </a:p>
           <a:p>
@@ -17008,58 +16909,488 @@
               </a:spcAft>
             </a:pPr>
             <a:r>
-              <a:rPr sz="1110">
-                <a:solidFill>
-                  <a:srgbClr val="006874"/>
+              <a:rPr sz="1045">
+                <a:solidFill>
+                  <a:srgbClr val="103552"/>
                 </a:solidFill>
                 <a:latin typeface="Liberation Mono"/>
               </a:rPr>
-              <a:t>%out</a:t>
-            </a:r>
-            <a:r>
-              <a:rPr sz="1110">
+              <a:t>  {</a:t>
+            </a:r>
+            <a:r>
+              <a:rPr sz="1045">
+                <a:solidFill>
+                  <a:srgbClr val="6C3D80"/>
+                </a:solidFill>
+                <a:latin typeface="Liberation Mono"/>
+              </a:rPr>
+              <a:t>"activation_format"</a:t>
+            </a:r>
+            <a:r>
+              <a:rPr sz="1045">
                 <a:solidFill>
                   <a:srgbClr val="103552"/>
                 </a:solidFill>
                 <a:latin typeface="Liberation Mono"/>
               </a:rPr>
-              <a:t> = </a:t>
-            </a:r>
-            <a:r>
-              <a:rPr sz="1110">
+              <a:t>:</a:t>
+            </a:r>
+            <a:r>
+              <a:rPr sz="1045">
+                <a:solidFill>
+                  <a:srgbClr val="28704F"/>
+                </a:solidFill>
+                <a:latin typeface="Liberation Mono"/>
+              </a:rPr>
+              <a:t>"fp4_e2m1"</a:t>
+            </a:r>
+            <a:r>
+              <a:rPr sz="1045">
+                <a:solidFill>
+                  <a:srgbClr val="103552"/>
+                </a:solidFill>
+                <a:latin typeface="Liberation Mono"/>
+              </a:rPr>
+              <a:t>,</a:t>
+            </a:r>
+          </a:p>
+          <a:p>
+            <a:pPr algn="l">
+              <a:spcBef>
+                <a:spcPts val="0"/>
+              </a:spcBef>
+              <a:spcAft>
+                <a:spcPts val="0"/>
+              </a:spcAft>
+            </a:pPr>
+            <a:r>
+              <a:rPr sz="1045">
+                <a:solidFill>
+                  <a:srgbClr val="103552"/>
+                </a:solidFill>
+                <a:latin typeface="Liberation Mono"/>
+              </a:rPr>
+              <a:t>   </a:t>
+            </a:r>
+            <a:r>
+              <a:rPr sz="1045">
                 <a:solidFill>
                   <a:srgbClr val="6C3D80"/>
                 </a:solidFill>
                 <a:latin typeface="Liberation Mono"/>
               </a:rPr>
-              <a:t>"mx_gemmini.readout_bf16"</a:t>
-            </a:r>
-            <a:r>
-              <a:rPr sz="1110">
+              <a:t>"weight_format"</a:t>
+            </a:r>
+            <a:r>
+              <a:rPr sz="1045">
                 <a:solidFill>
                   <a:srgbClr val="103552"/>
                 </a:solidFill>
                 <a:latin typeface="Liberation Mono"/>
               </a:rPr>
-              <a:t>(</a:t>
-            </a:r>
-            <a:r>
-              <a:rPr sz="1110">
-                <a:solidFill>
-                  <a:srgbClr val="006874"/>
+              <a:t>:</a:t>
+            </a:r>
+            <a:r>
+              <a:rPr sz="1045">
+                <a:solidFill>
+                  <a:srgbClr val="28704F"/>
                 </a:solidFill>
                 <a:latin typeface="Liberation Mono"/>
               </a:rPr>
-              <a:t>%acc</a:t>
-            </a:r>
-            <a:r>
-              <a:rPr sz="1110">
+              <a:t>"fp4_e2m1"</a:t>
+            </a:r>
+            <a:r>
+              <a:rPr sz="1045">
                 <a:solidFill>
                   <a:srgbClr val="103552"/>
                 </a:solidFill>
                 <a:latin typeface="Liberation Mono"/>
               </a:rPr>
-              <a:t>)</a:t>
+              <a:t>,</a:t>
+            </a:r>
+            <a:r>
+              <a:rPr sz="1045">
+                <a:solidFill>
+                  <a:srgbClr val="6C3D80"/>
+                </a:solidFill>
+                <a:latin typeface="Liberation Mono"/>
+              </a:rPr>
+              <a:t>"pe_mode"</a:t>
+            </a:r>
+            <a:r>
+              <a:rPr sz="1045">
+                <a:solidFill>
+                  <a:srgbClr val="103552"/>
+                </a:solidFill>
+                <a:latin typeface="Liberation Mono"/>
+              </a:rPr>
+              <a:t>:</a:t>
+            </a:r>
+            <a:r>
+              <a:rPr sz="1045">
+                <a:solidFill>
+                  <a:srgbClr val="A44F25"/>
+                </a:solidFill>
+                <a:latin typeface="Liberation Mono"/>
+              </a:rPr>
+              <a:t>0</a:t>
+            </a:r>
+            <a:r>
+              <a:rPr sz="1045">
+                <a:solidFill>
+                  <a:srgbClr val="103552"/>
+                </a:solidFill>
+                <a:latin typeface="Liberation Mono"/>
+              </a:rPr>
+              <a:t>},</a:t>
+            </a:r>
+          </a:p>
+          <a:p>
+            <a:pPr algn="l">
+              <a:spcBef>
+                <a:spcPts val="0"/>
+              </a:spcBef>
+              <a:spcAft>
+                <a:spcPts val="0"/>
+              </a:spcAft>
+            </a:pPr>
+            <a:r>
+              <a:rPr sz="1045">
+                <a:solidFill>
+                  <a:srgbClr val="103552"/>
+                </a:solidFill>
+                <a:latin typeface="Liberation Mono"/>
+              </a:rPr>
+              <a:t>  {</a:t>
+            </a:r>
+            <a:r>
+              <a:rPr sz="1045">
+                <a:solidFill>
+                  <a:srgbClr val="6C3D80"/>
+                </a:solidFill>
+                <a:latin typeface="Liberation Mono"/>
+              </a:rPr>
+              <a:t>"activation_format"</a:t>
+            </a:r>
+            <a:r>
+              <a:rPr sz="1045">
+                <a:solidFill>
+                  <a:srgbClr val="103552"/>
+                </a:solidFill>
+                <a:latin typeface="Liberation Mono"/>
+              </a:rPr>
+              <a:t>:</a:t>
+            </a:r>
+            <a:r>
+              <a:rPr sz="1045">
+                <a:solidFill>
+                  <a:srgbClr val="28704F"/>
+                </a:solidFill>
+                <a:latin typeface="Liberation Mono"/>
+              </a:rPr>
+              <a:t>"fp8_e4m3"</a:t>
+            </a:r>
+            <a:r>
+              <a:rPr sz="1045">
+                <a:solidFill>
+                  <a:srgbClr val="103552"/>
+                </a:solidFill>
+                <a:latin typeface="Liberation Mono"/>
+              </a:rPr>
+              <a:t>,</a:t>
+            </a:r>
+          </a:p>
+          <a:p>
+            <a:pPr algn="l">
+              <a:spcBef>
+                <a:spcPts val="0"/>
+              </a:spcBef>
+              <a:spcAft>
+                <a:spcPts val="0"/>
+              </a:spcAft>
+            </a:pPr>
+            <a:r>
+              <a:rPr sz="1045">
+                <a:solidFill>
+                  <a:srgbClr val="103552"/>
+                </a:solidFill>
+                <a:latin typeface="Liberation Mono"/>
+              </a:rPr>
+              <a:t>   </a:t>
+            </a:r>
+            <a:r>
+              <a:rPr sz="1045">
+                <a:solidFill>
+                  <a:srgbClr val="6C3D80"/>
+                </a:solidFill>
+                <a:latin typeface="Liberation Mono"/>
+              </a:rPr>
+              <a:t>"weight_format"</a:t>
+            </a:r>
+            <a:r>
+              <a:rPr sz="1045">
+                <a:solidFill>
+                  <a:srgbClr val="103552"/>
+                </a:solidFill>
+                <a:latin typeface="Liberation Mono"/>
+              </a:rPr>
+              <a:t>:</a:t>
+            </a:r>
+            <a:r>
+              <a:rPr sz="1045">
+                <a:solidFill>
+                  <a:srgbClr val="28704F"/>
+                </a:solidFill>
+                <a:latin typeface="Liberation Mono"/>
+              </a:rPr>
+              <a:t>"fp8_e4m3"</a:t>
+            </a:r>
+            <a:r>
+              <a:rPr sz="1045">
+                <a:solidFill>
+                  <a:srgbClr val="103552"/>
+                </a:solidFill>
+                <a:latin typeface="Liberation Mono"/>
+              </a:rPr>
+              <a:t>,</a:t>
+            </a:r>
+            <a:r>
+              <a:rPr sz="1045">
+                <a:solidFill>
+                  <a:srgbClr val="6C3D80"/>
+                </a:solidFill>
+                <a:latin typeface="Liberation Mono"/>
+              </a:rPr>
+              <a:t>"pe_mode"</a:t>
+            </a:r>
+            <a:r>
+              <a:rPr sz="1045">
+                <a:solidFill>
+                  <a:srgbClr val="103552"/>
+                </a:solidFill>
+                <a:latin typeface="Liberation Mono"/>
+              </a:rPr>
+              <a:t>:</a:t>
+            </a:r>
+            <a:r>
+              <a:rPr sz="1045">
+                <a:solidFill>
+                  <a:srgbClr val="A44F25"/>
+                </a:solidFill>
+                <a:latin typeface="Liberation Mono"/>
+              </a:rPr>
+              <a:t>8</a:t>
+            </a:r>
+            <a:r>
+              <a:rPr sz="1045">
+                <a:solidFill>
+                  <a:srgbClr val="103552"/>
+                </a:solidFill>
+                <a:latin typeface="Liberation Mono"/>
+              </a:rPr>
+              <a:t>}</a:t>
+            </a:r>
+          </a:p>
+          <a:p>
+            <a:pPr algn="l">
+              <a:spcBef>
+                <a:spcPts val="0"/>
+              </a:spcBef>
+              <a:spcAft>
+                <a:spcPts val="0"/>
+              </a:spcAft>
+            </a:pPr>
+            <a:r>
+              <a:rPr sz="1045">
+                <a:solidFill>
+                  <a:srgbClr val="103552"/>
+                </a:solidFill>
+                <a:latin typeface="Liberation Mono"/>
+              </a:rPr>
+              <a:t> ],</a:t>
+            </a:r>
+          </a:p>
+          <a:p>
+            <a:pPr algn="l">
+              <a:spcBef>
+                <a:spcPts val="0"/>
+              </a:spcBef>
+              <a:spcAft>
+                <a:spcPts val="0"/>
+              </a:spcAft>
+            </a:pPr>
+            <a:r>
+              <a:rPr sz="1045">
+                <a:solidFill>
+                  <a:srgbClr val="103552"/>
+                </a:solidFill>
+                <a:latin typeface="Liberation Mono"/>
+              </a:rPr>
+              <a:t> </a:t>
+            </a:r>
+            <a:r>
+              <a:rPr sz="1045">
+                <a:solidFill>
+                  <a:srgbClr val="6C3D80"/>
+                </a:solidFill>
+                <a:latin typeface="Liberation Mono"/>
+              </a:rPr>
+              <a:t>"resources"</a:t>
+            </a:r>
+            <a:r>
+              <a:rPr sz="1045">
+                <a:solidFill>
+                  <a:srgbClr val="103552"/>
+                </a:solidFill>
+                <a:latin typeface="Liberation Mono"/>
+              </a:rPr>
+              <a:t>: {</a:t>
+            </a:r>
+            <a:r>
+              <a:rPr sz="1045">
+                <a:solidFill>
+                  <a:srgbClr val="6C3D80"/>
+                </a:solidFill>
+                <a:latin typeface="Liberation Mono"/>
+              </a:rPr>
+              <a:t>"scratchpad_bytes"</a:t>
+            </a:r>
+            <a:r>
+              <a:rPr sz="1045">
+                <a:solidFill>
+                  <a:srgbClr val="103552"/>
+                </a:solidFill>
+                <a:latin typeface="Liberation Mono"/>
+              </a:rPr>
+              <a:t>:</a:t>
+            </a:r>
+            <a:r>
+              <a:rPr sz="1045">
+                <a:solidFill>
+                  <a:srgbClr val="A44F25"/>
+                </a:solidFill>
+                <a:latin typeface="Liberation Mono"/>
+              </a:rPr>
+              <a:t>262144</a:t>
+            </a:r>
+            <a:r>
+              <a:rPr sz="1045">
+                <a:solidFill>
+                  <a:srgbClr val="103552"/>
+                </a:solidFill>
+                <a:latin typeface="Liberation Mono"/>
+              </a:rPr>
+              <a:t>,</a:t>
+            </a:r>
+          </a:p>
+          <a:p>
+            <a:pPr algn="l">
+              <a:spcBef>
+                <a:spcPts val="0"/>
+              </a:spcBef>
+              <a:spcAft>
+                <a:spcPts val="0"/>
+              </a:spcAft>
+            </a:pPr>
+            <a:r>
+              <a:rPr sz="1045">
+                <a:solidFill>
+                  <a:srgbClr val="103552"/>
+                </a:solidFill>
+                <a:latin typeface="Liberation Mono"/>
+              </a:rPr>
+              <a:t>               </a:t>
+            </a:r>
+            <a:r>
+              <a:rPr sz="1045">
+                <a:solidFill>
+                  <a:srgbClr val="6C3D80"/>
+                </a:solidFill>
+                <a:latin typeface="Liberation Mono"/>
+              </a:rPr>
+              <a:t>"vpu"</a:t>
+            </a:r>
+            <a:r>
+              <a:rPr sz="1045">
+                <a:solidFill>
+                  <a:srgbClr val="103552"/>
+                </a:solidFill>
+                <a:latin typeface="Liberation Mono"/>
+              </a:rPr>
+              <a:t>:</a:t>
+            </a:r>
+            <a:r>
+              <a:rPr sz="1045">
+                <a:solidFill>
+                  <a:srgbClr val="6C3D80"/>
+                </a:solidFill>
+                <a:latin typeface="Liberation Mono"/>
+              </a:rPr>
+              <a:t>true</a:t>
+            </a:r>
+            <a:r>
+              <a:rPr sz="1045">
+                <a:solidFill>
+                  <a:srgbClr val="103552"/>
+                </a:solidFill>
+                <a:latin typeface="Liberation Mono"/>
+              </a:rPr>
+              <a:t>,</a:t>
+            </a:r>
+            <a:r>
+              <a:rPr sz="1045">
+                <a:solidFill>
+                  <a:srgbClr val="6C3D80"/>
+                </a:solidFill>
+                <a:latin typeface="Liberation Mono"/>
+              </a:rPr>
+              <a:t>"lut"</a:t>
+            </a:r>
+            <a:r>
+              <a:rPr sz="1045">
+                <a:solidFill>
+                  <a:srgbClr val="103552"/>
+                </a:solidFill>
+                <a:latin typeface="Liberation Mono"/>
+              </a:rPr>
+              <a:t>:</a:t>
+            </a:r>
+            <a:r>
+              <a:rPr sz="1045">
+                <a:solidFill>
+                  <a:srgbClr val="6C3D80"/>
+                </a:solidFill>
+                <a:latin typeface="Liberation Mono"/>
+              </a:rPr>
+              <a:t>false</a:t>
+            </a:r>
+            <a:r>
+              <a:rPr sz="1045">
+                <a:solidFill>
+                  <a:srgbClr val="103552"/>
+                </a:solidFill>
+                <a:latin typeface="Liberation Mono"/>
+              </a:rPr>
+              <a:t>}</a:t>
+            </a:r>
+          </a:p>
+          <a:p>
+            <a:pPr algn="l">
+              <a:spcBef>
+                <a:spcPts val="0"/>
+              </a:spcBef>
+              <a:spcAft>
+                <a:spcPts val="0"/>
+              </a:spcAft>
+            </a:pPr>
+            <a:r>
+              <a:rPr sz="1045">
+                <a:solidFill>
+                  <a:srgbClr val="103552"/>
+                </a:solidFill>
+                <a:latin typeface="Liberation Mono"/>
+              </a:rPr>
+              <a:t>}</a:t>
             </a:r>
           </a:p>
         </p:txBody>
@@ -17072,8 +17403,8 @@
         </p:nvSpPr>
         <p:spPr>
           <a:xfrm>
-            <a:off x="1051560" y="3438144"/>
-            <a:ext cx="4727448" cy="685800"/>
+            <a:off x="1051560" y="4736592"/>
+            <a:ext cx="5093208" cy="475488"/>
           </a:xfrm>
           <a:prstGeom prst="rect">
             <a:avLst/>
@@ -17095,13 +17426,13 @@
               </a:spcAft>
             </a:pPr>
             <a:r>
-              <a:rPr sz="1060" b="0">
+              <a:rPr sz="1110" b="0">
                 <a:solidFill>
                   <a:srgbClr val="313455"/>
                 </a:solidFill>
                 <a:latin typeface="Inter"/>
               </a:rPr>
-              <a:t>resource supplies packed A/B codes + E8M0 scales. contract computes C[m,n] = Σk A[m,k]×B[k,n] in the selected PE mode; readout_bf16 returns BF16. VPU can do softmax; Radiance uses Muon SIMT.</a:t>
+              <a:t>MxE4M3Fp4VpuGemminiRocketConfig · direct projections in both legal rows · two 8-lane BF16 VPUs.</a:t>
             </a:r>
           </a:p>
         </p:txBody>
@@ -17114,8 +17445,8 @@
         </p:nvSpPr>
         <p:spPr>
           <a:xfrm>
-            <a:off x="6382512" y="1664208"/>
-            <a:ext cx="4754880" cy="310896"/>
+            <a:off x="1051560" y="5312664"/>
+            <a:ext cx="5093208" cy="356616"/>
           </a:xfrm>
           <a:prstGeom prst="rect">
             <a:avLst/>
@@ -17137,27 +17468,69 @@
               </a:spcAft>
             </a:pPr>
             <a:r>
-              <a:rPr sz="1750" b="1">
-                <a:solidFill>
-                  <a:srgbClr val="103552"/>
-                </a:solidFill>
-                <a:latin typeface="Inter"/>
-              </a:rPr>
-              <a:t>Compiled attention object → binary</a:t>
+              <a:rPr sz="1040" b="0">
+                <a:solidFill>
+                  <a:srgbClr val="5B5957"/>
+                </a:solidFill>
+                <a:latin typeface="Inter"/>
+              </a:rPr>
+              <a:t>RTL 266c593 + MxGen dba3e7 → 41 fragments / 40 SoC wrappers; each JSON stores source hashes.</a:t>
             </a:r>
           </a:p>
         </p:txBody>
       </p:sp>
       <p:sp>
         <p:nvSpPr>
-          <p:cNvPr id="12" name="Rounded Rectangle 11"/>
+          <p:cNvPr id="12" name="TextBox 11"/>
+          <p:cNvSpPr txBox="1"/>
+          <p:nvPr/>
+        </p:nvSpPr>
+        <p:spPr>
+          <a:xfrm>
+            <a:off x="6748272" y="1636776"/>
+            <a:ext cx="4370832" cy="310896"/>
+          </a:xfrm>
+          <a:prstGeom prst="rect">
+            <a:avLst/>
+          </a:prstGeom>
+          <a:noFill/>
+        </p:spPr>
+        <p:txBody>
+          <a:bodyPr wrap="square" lIns="18288" rIns="18288" tIns="9144" bIns="9144" anchor="ctr">
+            <a:spAutoFit/>
+          </a:bodyPr>
+          <a:lstStyle/>
+          <a:p>
+            <a:pPr algn="l">
+              <a:spcBef>
+                <a:spcPts val="0"/>
+              </a:spcBef>
+              <a:spcAft>
+                <a:spcPts val="0"/>
+              </a:spcAft>
+            </a:pPr>
+            <a:r>
+              <a:rPr sz="1720" b="1">
+                <a:solidFill>
+                  <a:srgbClr val="103552"/>
+                </a:solidFill>
+                <a:latin typeface="Inter"/>
+              </a:rPr>
+              <a:t>Before → after bind_profile</a:t>
+            </a:r>
+          </a:p>
+        </p:txBody>
+      </p:sp>
+      <p:sp>
+        <p:nvSpPr>
+          <p:cNvPr id="13" name="Rounded Rectangle 12"/>
           <p:cNvSpPr/>
           <p:nvPr/>
         </p:nvSpPr>
         <p:spPr>
           <a:xfrm>
-            <a:off x="6382512" y="2048256"/>
-            <a:ext cx="4754880" cy="1298448"/>
+            <a:off x="6748272" y="2029968"/>
+            <a:ext cx="4379976" cy="1499616"/>
           </a:xfrm>
           <a:prstGeom prst="roundRect">
             <a:avLst/>
@@ -17198,40 +17571,58 @@
               </a:spcAft>
             </a:pPr>
             <a:r>
-              <a:rPr sz="1030">
+              <a:rPr sz="1085">
                 <a:solidFill>
                   <a:srgbClr val="6C3D80"/>
                 </a:solidFill>
                 <a:latin typeface="Liberation Mono"/>
               </a:rPr>
-              <a:t>__asm__</a:t>
-            </a:r>
-            <a:r>
-              <a:rPr sz="1030">
+              <a:t>before</a:t>
+            </a:r>
+            <a:r>
+              <a:rPr sz="1085">
                 <a:solidFill>
                   <a:srgbClr val="103552"/>
                 </a:solidFill>
                 <a:latin typeface="Liberation Mono"/>
               </a:rPr>
-              <a:t> </a:t>
-            </a:r>
-            <a:r>
-              <a:rPr sz="1030">
+              <a:t>: </a:t>
+            </a:r>
+            <a:r>
+              <a:rPr sz="1085">
                 <a:solidFill>
                   <a:srgbClr val="6C3D80"/>
                 </a:solidFill>
                 <a:latin typeface="Liberation Mono"/>
               </a:rPr>
-              <a:t>volatile</a:t>
-            </a:r>
-            <a:r>
-              <a:rPr sz="1030">
+              <a:t>contract</a:t>
+            </a:r>
+            <a:r>
+              <a:rPr sz="1085">
                 <a:solidFill>
                   <a:srgbClr val="103552"/>
                 </a:solidFill>
                 <a:latin typeface="Liberation Mono"/>
               </a:rPr>
-              <a:t>(</a:t>
+              <a:t> {format = </a:t>
+            </a:r>
+            <a:r>
+              <a:rPr sz="1085">
+                <a:solidFill>
+                  <a:srgbClr val="28704F"/>
+                </a:solidFill>
+                <a:latin typeface="Liberation Mono"/>
+              </a:rPr>
+              <a:t>"mxfp4"</a:t>
+            </a:r>
+            <a:r>
+              <a:rPr sz="1085">
+                <a:solidFill>
+                  <a:srgbClr val="103552"/>
+                </a:solidFill>
+                <a:latin typeface="Liberation Mono"/>
+              </a:rPr>
+              <a:t>}</a:t>
             </a:r>
           </a:p>
           <a:p>
@@ -17244,22 +17635,40 @@
               </a:spcAft>
             </a:pPr>
             <a:r>
-              <a:rPr sz="1030">
+              <a:rPr sz="1085">
+                <a:solidFill>
+                  <a:srgbClr val="6C3D80"/>
+                </a:solidFill>
+                <a:latin typeface="Liberation Mono"/>
+              </a:rPr>
+              <a:t>after</a:t>
+            </a:r>
+            <a:r>
+              <a:rPr sz="1085">
                 <a:solidFill>
                   <a:srgbClr val="103552"/>
                 </a:solidFill>
                 <a:latin typeface="Liberation Mono"/>
               </a:rPr>
-              <a:t>  </a:t>
-            </a:r>
-            <a:r>
-              <a:rPr sz="1030">
-                <a:solidFill>
-                  <a:srgbClr val="28704F"/>
+              <a:t>:  </a:t>
+            </a:r>
+            <a:r>
+              <a:rPr sz="1085">
+                <a:solidFill>
+                  <a:srgbClr val="6C3D80"/>
                 </a:solidFill>
                 <a:latin typeface="Liberation Mono"/>
               </a:rPr>
-              <a:t>".insn r 0x7b, 3, 2, x0, %0, %1"</a:t>
+              <a:t>contract</a:t>
+            </a:r>
+            <a:r>
+              <a:rPr sz="1085">
+                <a:solidFill>
+                  <a:srgbClr val="103552"/>
+                </a:solidFill>
+                <a:latin typeface="Liberation Mono"/>
+              </a:rPr>
+              <a:t> {</a:t>
             </a:r>
           </a:p>
           <a:p>
@@ -17272,31 +17681,49 @@
               </a:spcAft>
             </a:pPr>
             <a:r>
-              <a:rPr sz="1030">
+              <a:rPr sz="1085">
                 <a:solidFill>
                   <a:srgbClr val="103552"/>
                 </a:solidFill>
                 <a:latin typeface="Liberation Mono"/>
               </a:rPr>
-              <a:t>  : : </a:t>
-            </a:r>
-            <a:r>
-              <a:rPr sz="1030">
+              <a:t>  </a:t>
+            </a:r>
+            <a:r>
+              <a:rPr sz="1085">
+                <a:solidFill>
+                  <a:srgbClr val="6C3D80"/>
+                </a:solidFill>
+                <a:latin typeface="Liberation Mono"/>
+              </a:rPr>
+              <a:t>activation_format</a:t>
+            </a:r>
+            <a:r>
+              <a:rPr sz="1085">
+                <a:solidFill>
+                  <a:srgbClr val="103552"/>
+                </a:solidFill>
+                <a:latin typeface="Liberation Mono"/>
+              </a:rPr>
+              <a:t> = </a:t>
+            </a:r>
+            <a:r>
+              <a:rPr sz="1085">
                 <a:solidFill>
                   <a:srgbClr val="28704F"/>
                 </a:solidFill>
                 <a:latin typeface="Liberation Mono"/>
               </a:rPr>
-              <a:t>"r"</a:t>
-            </a:r>
-            <a:r>
-              <a:rPr sz="1030">
+              <a:t>"fp4_e2m1"</a:t>
+            </a:r>
+            <a:r>
+              <a:rPr sz="1085">
                 <a:solidFill>
                   <a:srgbClr val="103552"/>
                 </a:solidFill>
                 <a:latin typeface="Liberation Mono"/>
               </a:rPr>
-              <a:t>(Q_IN),</a:t>
+              <a:t>,</a:t>
             </a:r>
           </a:p>
           <a:p>
@@ -17309,49 +17736,49 @@
               </a:spcAft>
             </a:pPr>
             <a:r>
-              <a:rPr sz="1030">
+              <a:rPr sz="1085">
                 <a:solidFill>
                   <a:srgbClr val="103552"/>
                 </a:solidFill>
                 <a:latin typeface="Liberation Mono"/>
               </a:rPr>
-              <a:t>      </a:t>
-            </a:r>
-            <a:r>
-              <a:rPr sz="1030">
+              <a:t>  </a:t>
+            </a:r>
+            <a:r>
+              <a:rPr sz="1085">
+                <a:solidFill>
+                  <a:srgbClr val="6C3D80"/>
+                </a:solidFill>
+                <a:latin typeface="Liberation Mono"/>
+              </a:rPr>
+              <a:t>weight_format</a:t>
+            </a:r>
+            <a:r>
+              <a:rPr sz="1085">
+                <a:solidFill>
+                  <a:srgbClr val="103552"/>
+                </a:solidFill>
+                <a:latin typeface="Liberation Mono"/>
+              </a:rPr>
+              <a:t> = </a:t>
+            </a:r>
+            <a:r>
+              <a:rPr sz="1085">
                 <a:solidFill>
                   <a:srgbClr val="28704F"/>
                 </a:solidFill>
                 <a:latin typeface="Liberation Mono"/>
               </a:rPr>
-              <a:t>"r"</a:t>
-            </a:r>
-            <a:r>
-              <a:rPr sz="1030">
+              <a:t>"fp4_e2m1"</a:t>
+            </a:r>
+            <a:r>
+              <a:rPr sz="1085">
                 <a:solidFill>
                   <a:srgbClr val="103552"/>
                 </a:solidFill>
                 <a:latin typeface="Liberation Mono"/>
               </a:rPr>
-              <a:t>(</a:t>
-            </a:r>
-            <a:r>
-              <a:rPr sz="1030">
-                <a:solidFill>
-                  <a:srgbClr val="A44F25"/>
-                </a:solidFill>
-                <a:latin typeface="Liberation Mono"/>
-              </a:rPr>
-              <a:t>0x0010001000000000</a:t>
-            </a:r>
-            <a:r>
-              <a:rPr sz="1030">
-                <a:solidFill>
-                  <a:srgbClr val="103552"/>
-                </a:solidFill>
-                <a:latin typeface="Liberation Mono"/>
-              </a:rPr>
-              <a:t>));</a:t>
+              <a:t>,</a:t>
             </a:r>
           </a:p>
           <a:p>
@@ -17364,63 +17791,118 @@
               </a:spcAft>
             </a:pPr>
             <a:r>
-              <a:rPr sz="1030">
+              <a:rPr sz="1085">
+                <a:solidFill>
+                  <a:srgbClr val="103552"/>
+                </a:solidFill>
+                <a:latin typeface="Liberation Mono"/>
+              </a:rPr>
+              <a:t>  </a:t>
+            </a:r>
+            <a:r>
+              <a:rPr sz="1085">
                 <a:solidFill>
                   <a:srgbClr val="6C3D80"/>
                 </a:solidFill>
                 <a:latin typeface="Liberation Mono"/>
               </a:rPr>
-              <a:t>objdump</a:t>
-            </a:r>
-            <a:r>
-              <a:rPr sz="1030">
+              <a:t>pe_mode</a:t>
+            </a:r>
+            <a:r>
+              <a:rPr sz="1085">
                 <a:solidFill>
                   <a:srgbClr val="103552"/>
                 </a:solidFill>
                 <a:latin typeface="Liberation Mono"/>
               </a:rPr>
-              <a:t>: 4a: 04b6b07b  .insn </a:t>
-            </a:r>
-            <a:r>
-              <a:rPr sz="1030">
+              <a:t> = </a:t>
+            </a:r>
+            <a:r>
+              <a:rPr sz="1085">
                 <a:solidFill>
                   <a:srgbClr val="A44F25"/>
                 </a:solidFill>
                 <a:latin typeface="Liberation Mono"/>
               </a:rPr>
-              <a:t>4</a:t>
-            </a:r>
-            <a:r>
-              <a:rPr sz="1030">
+              <a:t>0</a:t>
+            </a:r>
+            <a:r>
+              <a:rPr sz="1085">
                 <a:solidFill>
                   <a:srgbClr val="103552"/>
                 </a:solidFill>
                 <a:latin typeface="Liberation Mono"/>
               </a:rPr>
-              <a:t>, </a:t>
-            </a:r>
-            <a:r>
-              <a:rPr sz="1030">
-                <a:solidFill>
-                  <a:srgbClr val="A44F25"/>
+              <a:t> : i32,</a:t>
+            </a:r>
+          </a:p>
+          <a:p>
+            <a:pPr algn="l">
+              <a:spcBef>
+                <a:spcPts val="0"/>
+              </a:spcBef>
+              <a:spcAft>
+                <a:spcPts val="0"/>
+              </a:spcAft>
+            </a:pPr>
+            <a:r>
+              <a:rPr sz="1085">
+                <a:solidFill>
+                  <a:srgbClr val="103552"/>
                 </a:solidFill>
                 <a:latin typeface="Liberation Mono"/>
               </a:rPr>
-              <a:t>0x04b6b07b</a:t>
+              <a:t>  </a:t>
+            </a:r>
+            <a:r>
+              <a:rPr sz="1085">
+                <a:solidFill>
+                  <a:srgbClr val="6C3D80"/>
+                </a:solidFill>
+                <a:latin typeface="Liberation Mono"/>
+              </a:rPr>
+              <a:t>profile_sha256</a:t>
+            </a:r>
+            <a:r>
+              <a:rPr sz="1085">
+                <a:solidFill>
+                  <a:srgbClr val="103552"/>
+                </a:solidFill>
+                <a:latin typeface="Liberation Mono"/>
+              </a:rPr>
+              <a:t> = </a:t>
+            </a:r>
+            <a:r>
+              <a:rPr sz="1085">
+                <a:solidFill>
+                  <a:srgbClr val="28704F"/>
+                </a:solidFill>
+                <a:latin typeface="Liberation Mono"/>
+              </a:rPr>
+              <a:t>"e9e33f..."</a:t>
+            </a:r>
+            <a:r>
+              <a:rPr sz="1085">
+                <a:solidFill>
+                  <a:srgbClr val="103552"/>
+                </a:solidFill>
+                <a:latin typeface="Liberation Mono"/>
+              </a:rPr>
+              <a:t> }</a:t>
             </a:r>
           </a:p>
         </p:txBody>
       </p:sp>
       <p:sp>
         <p:nvSpPr>
-          <p:cNvPr id="13" name="TextBox 12"/>
+          <p:cNvPr id="14" name="TextBox 13"/>
           <p:cNvSpPr txBox="1"/>
           <p:nvPr/>
         </p:nvSpPr>
         <p:spPr>
           <a:xfrm>
-            <a:off x="6382512" y="3493008"/>
-            <a:ext cx="4727448" cy="548640"/>
+            <a:off x="6748272" y="3712463"/>
+            <a:ext cx="4370832" cy="274320"/>
           </a:xfrm>
           <a:prstGeom prst="rect">
             <a:avLst/>
@@ -17442,27 +17924,27 @@
               </a:spcAft>
             </a:pPr>
             <a:r>
-              <a:rPr sz="1100" b="0">
-                <a:solidFill>
-                  <a:srgbClr val="313455"/>
-                </a:solidFill>
-                <a:latin typeface="Inter"/>
-              </a:rPr>
-              <a:t>physical_program orders mvin → compute → VPU → mvout. RoCC C + data asm → RV64 GCC → ELF → Nicolas Spike.</a:t>
+              <a:rPr sz="1410" b="1">
+                <a:solidFill>
+                  <a:srgbClr val="103552"/>
+                </a:solidFill>
+                <a:latin typeface="Inter"/>
+              </a:rPr>
+              <a:t>Compiler consequences</a:t>
             </a:r>
           </a:p>
         </p:txBody>
       </p:sp>
       <p:sp>
         <p:nvSpPr>
-          <p:cNvPr id="14" name="TextBox 13"/>
+          <p:cNvPr id="15" name="TextBox 14"/>
           <p:cNvSpPr txBox="1"/>
           <p:nvPr/>
         </p:nvSpPr>
         <p:spPr>
           <a:xfrm>
-            <a:off x="877824" y="4352544"/>
-            <a:ext cx="10424160" cy="274320"/>
+            <a:off x="6748272" y="4041648"/>
+            <a:ext cx="4370832" cy="1481328"/>
           </a:xfrm>
           <a:prstGeom prst="rect">
             <a:avLst/>
@@ -17484,59 +17966,109 @@
               </a:spcAft>
             </a:pPr>
             <a:r>
-              <a:rPr sz="1600" b="1">
-                <a:solidFill>
-                  <a:srgbClr val="103552"/>
-                </a:solidFill>
-                <a:latin typeface="Inter"/>
-              </a:rPr>
-              <a:t>Implemented transforms and checks</a:t>
-            </a:r>
-          </a:p>
-        </p:txBody>
-      </p:sp>
-      <p:sp>
-        <p:nvSpPr>
-          <p:cNvPr id="15" name="Rounded Rectangle 14"/>
-          <p:cNvSpPr/>
-          <p:nvPr/>
-        </p:nvSpPr>
-        <p:spPr>
-          <a:xfrm>
-            <a:off x="859536" y="4709160"/>
-            <a:ext cx="1965960" cy="987552"/>
-          </a:xfrm>
-          <a:prstGeom prst="roundRect">
-            <a:avLst/>
-          </a:prstGeom>
-          <a:solidFill>
-            <a:srgbClr val="FDF8F1"/>
-          </a:solidFill>
-          <a:ln>
-            <a:solidFill>
-              <a:srgbClr val="B0A597"/>
-            </a:solidFill>
-          </a:ln>
-        </p:spPr>
-        <p:style>
-          <a:lnRef idx="1">
-            <a:schemeClr val="accent1"/>
-          </a:lnRef>
-          <a:fillRef idx="3">
-            <a:schemeClr val="accent1"/>
-          </a:fillRef>
-          <a:effectRef idx="2">
-            <a:schemeClr val="accent1"/>
-          </a:effectRef>
-          <a:fontRef idx="minor">
-            <a:schemeClr val="lt1"/>
-          </a:fontRef>
-        </p:style>
-        <p:txBody>
-          <a:bodyPr rtlCol="0" anchor="ctr"/>
-          <a:lstStyle/>
-          <a:p>
-            <a:pPr algn="ctr"/>
+              <a:rPr sz="1100" b="0">
+                <a:solidFill>
+                  <a:srgbClr val="313455"/>
+                </a:solidFill>
+                <a:latin typeface="Inter"/>
+              </a:rPr>
+              <a:t>• TinyLlama: 155 FP4 / 45 FP8 MX sites per stage.</a:t>
+            </a:r>
+          </a:p>
+          <a:p>
+            <a:pPr algn="l">
+              <a:spcBef>
+                <a:spcPts val="0"/>
+              </a:spcBef>
+              <a:spcAft>
+                <a:spcPts val="0"/>
+              </a:spcAft>
+            </a:pPr>
+            <a:r>
+              <a:rPr sz="1100" b="0">
+                <a:solidFill>
+                  <a:srgbClr val="313455"/>
+                </a:solidFill>
+                <a:latin typeface="Inter"/>
+              </a:rPr>
+              <a:t>• PE 0 = direct FP4 × FP4; PE 8 = direct FP8 × FP8.</a:t>
+            </a:r>
+          </a:p>
+          <a:p>
+            <a:pPr algn="l">
+              <a:spcBef>
+                <a:spcPts val="0"/>
+              </a:spcBef>
+              <a:spcAft>
+                <a:spcPts val="0"/>
+              </a:spcAft>
+            </a:pPr>
+            <a:r>
+              <a:rPr sz="1100" b="0">
+                <a:solidFill>
+                  <a:srgbClr val="313455"/>
+                </a:solidFill>
+                <a:latin typeface="Inter"/>
+              </a:rPr>
+              <a:t>• 256 KiB SPAD caps tiles; VPU/requant legal.</a:t>
+            </a:r>
+          </a:p>
+          <a:p>
+            <a:pPr algn="l">
+              <a:spcBef>
+                <a:spcPts val="0"/>
+              </a:spcBef>
+              <a:spcAft>
+                <a:spcPts val="0"/>
+              </a:spcAft>
+            </a:pPr>
+            <a:r>
+              <a:rPr sz="1100" b="0">
+                <a:solidFill>
+                  <a:srgbClr val="313455"/>
+                </a:solidFill>
+                <a:latin typeface="Inter"/>
+              </a:rPr>
+              <a:t>• Selected profile: no operand LUT or FP6.</a:t>
+            </a:r>
+          </a:p>
+          <a:p>
+            <a:pPr algn="l">
+              <a:spcBef>
+                <a:spcPts val="0"/>
+              </a:spcBef>
+              <a:spcAft>
+                <a:spcPts val="0"/>
+              </a:spcAft>
+            </a:pPr>
+            <a:r>
+              <a:rPr sz="1100" b="0">
+                <a:solidFill>
+                  <a:srgbClr val="313455"/>
+                </a:solidFill>
+                <a:latin typeface="Inter"/>
+              </a:rPr>
+              <a:t>• FP6×FP4 profile: E3M2 LUT × FP4 direct → PE 3; VPU off.</a:t>
+            </a:r>
+          </a:p>
+          <a:p>
+            <a:pPr algn="l">
+              <a:spcBef>
+                <a:spcPts val="0"/>
+              </a:spcBef>
+              <a:spcAft>
+                <a:spcPts val="0"/>
+              </a:spcAft>
+            </a:pPr>
+            <a:r>
+              <a:rPr sz="1100" b="0">
+                <a:solidFill>
+                  <a:srgbClr val="313455"/>
+                </a:solidFill>
+                <a:latin typeface="Inter"/>
+              </a:rPr>
+              <a:t>• load_profile(profile, rtl_root=rtl) rejects drift.</a:t>
+            </a:r>
           </a:p>
         </p:txBody>
       </p:sp>
@@ -17548,8 +18080,8 @@
         </p:nvSpPr>
         <p:spPr>
           <a:xfrm>
-            <a:off x="950976" y="4800600"/>
-            <a:ext cx="1783080" cy="338328"/>
+            <a:off x="877824" y="5943600"/>
+            <a:ext cx="10469880" cy="228600"/>
           </a:xfrm>
           <a:prstGeom prst="rect">
             <a:avLst/>
@@ -17562,7 +18094,7 @@
           </a:bodyPr>
           <a:lstStyle/>
           <a:p>
-            <a:pPr algn="ctr">
+            <a:pPr algn="l">
               <a:spcBef>
                 <a:spcPts val="0"/>
               </a:spcBef>
@@ -17571,13 +18103,13 @@
               </a:spcAft>
             </a:pPr>
             <a:r>
-              <a:rPr sz="1170" b="1">
-                <a:solidFill>
-                  <a:srgbClr val="103552"/>
-                </a:solidFill>
-                <a:latin typeface="Inter"/>
-              </a:rPr>
-              <a:t>bind_profile</a:t>
+              <a:rPr sz="1019" b="0">
+                <a:solidFill>
+                  <a:srgbClr val="5B5957"/>
+                </a:solidFill>
+                <a:latin typeface="Inter"/>
+              </a:rPr>
+              <a:t>npu-exploration supplies source kernels for per-mode Spike checks; the RTL profile alone is structural, not a performance claim.</a:t>
             </a:r>
           </a:p>
         </p:txBody>
@@ -17585,720 +18117,6 @@
       <p:sp>
         <p:nvSpPr>
           <p:cNvPr id="17" name="TextBox 16"/>
-          <p:cNvSpPr txBox="1"/>
-          <p:nvPr/>
-        </p:nvSpPr>
-        <p:spPr>
-          <a:xfrm>
-            <a:off x="950976" y="5230368"/>
-            <a:ext cx="1783080" cy="365760"/>
-          </a:xfrm>
-          <a:prstGeom prst="rect">
-            <a:avLst/>
-          </a:prstGeom>
-          <a:noFill/>
-        </p:spPr>
-        <p:txBody>
-          <a:bodyPr wrap="square" lIns="18288" rIns="18288" tIns="9144" bIns="9144" anchor="ctr">
-            <a:spAutoFit/>
-          </a:bodyPr>
-          <a:lstStyle/>
-          <a:p>
-            <a:pPr algn="ctr">
-              <a:spcBef>
-                <a:spcPts val="0"/>
-              </a:spcBef>
-              <a:spcAft>
-                <a:spcPts val="0"/>
-              </a:spcAft>
-            </a:pPr>
-            <a:r>
-              <a:rPr sz="1080" b="0">
-                <a:solidFill>
-                  <a:srgbClr val="313455"/>
-                </a:solidFill>
-                <a:latin typeface="Inter"/>
-              </a:rPr>
-              <a:t>Legal PE tuple +</a:t>
-            </a:r>
-          </a:p>
-          <a:p>
-            <a:pPr algn="ctr">
-              <a:spcBef>
-                <a:spcPts val="0"/>
-              </a:spcBef>
-              <a:spcAft>
-                <a:spcPts val="0"/>
-              </a:spcAft>
-            </a:pPr>
-            <a:r>
-              <a:rPr sz="1080" b="0">
-                <a:solidFill>
-                  <a:srgbClr val="313455"/>
-                </a:solidFill>
-                <a:latin typeface="Inter"/>
-              </a:rPr>
-              <a:t>profile digest</a:t>
-            </a:r>
-          </a:p>
-        </p:txBody>
-      </p:sp>
-      <p:sp>
-        <p:nvSpPr>
-          <p:cNvPr id="18" name="Rounded Rectangle 17"/>
-          <p:cNvSpPr/>
-          <p:nvPr/>
-        </p:nvSpPr>
-        <p:spPr>
-          <a:xfrm>
-            <a:off x="2999232" y="4709160"/>
-            <a:ext cx="1965960" cy="987552"/>
-          </a:xfrm>
-          <a:prstGeom prst="roundRect">
-            <a:avLst/>
-          </a:prstGeom>
-          <a:solidFill>
-            <a:srgbClr val="E1E8EC"/>
-          </a:solidFill>
-          <a:ln>
-            <a:solidFill>
-              <a:srgbClr val="B0A597"/>
-            </a:solidFill>
-          </a:ln>
-        </p:spPr>
-        <p:style>
-          <a:lnRef idx="1">
-            <a:schemeClr val="accent1"/>
-          </a:lnRef>
-          <a:fillRef idx="3">
-            <a:schemeClr val="accent1"/>
-          </a:fillRef>
-          <a:effectRef idx="2">
-            <a:schemeClr val="accent1"/>
-          </a:effectRef>
-          <a:fontRef idx="minor">
-            <a:schemeClr val="lt1"/>
-          </a:fontRef>
-        </p:style>
-        <p:txBody>
-          <a:bodyPr rtlCol="0" anchor="ctr"/>
-          <a:lstStyle/>
-          <a:p>
-            <a:pPr algn="ctr"/>
-          </a:p>
-        </p:txBody>
-      </p:sp>
-      <p:sp>
-        <p:nvSpPr>
-          <p:cNvPr id="19" name="TextBox 18"/>
-          <p:cNvSpPr txBox="1"/>
-          <p:nvPr/>
-        </p:nvSpPr>
-        <p:spPr>
-          <a:xfrm>
-            <a:off x="3090672" y="4800600"/>
-            <a:ext cx="1783080" cy="338328"/>
-          </a:xfrm>
-          <a:prstGeom prst="rect">
-            <a:avLst/>
-          </a:prstGeom>
-          <a:noFill/>
-        </p:spPr>
-        <p:txBody>
-          <a:bodyPr wrap="square" lIns="18288" rIns="18288" tIns="9144" bIns="9144" anchor="ctr">
-            <a:spAutoFit/>
-          </a:bodyPr>
-          <a:lstStyle/>
-          <a:p>
-            <a:pPr algn="ctr">
-              <a:spcBef>
-                <a:spcPts val="0"/>
-              </a:spcBef>
-              <a:spcAft>
-                <a:spcPts val="0"/>
-              </a:spcAft>
-            </a:pPr>
-            <a:r>
-              <a:rPr sz="1170" b="1">
-                <a:solidFill>
-                  <a:srgbClr val="103552"/>
-                </a:solidFill>
-                <a:latin typeface="Inter"/>
-              </a:rPr>
-              <a:t>MXBF16Catalog</a:t>
-            </a:r>
-          </a:p>
-          <a:p>
-            <a:pPr algn="ctr">
-              <a:spcBef>
-                <a:spcPts val="0"/>
-              </a:spcBef>
-              <a:spcAft>
-                <a:spcPts val="0"/>
-              </a:spcAft>
-            </a:pPr>
-            <a:r>
-              <a:rPr sz="1170" b="1">
-                <a:solidFill>
-                  <a:srgbClr val="103552"/>
-                </a:solidFill>
-                <a:latin typeface="Inter"/>
-              </a:rPr>
-              <a:t>Preparation</a:t>
-            </a:r>
-          </a:p>
-        </p:txBody>
-      </p:sp>
-      <p:sp>
-        <p:nvSpPr>
-          <p:cNvPr id="20" name="TextBox 19"/>
-          <p:cNvSpPr txBox="1"/>
-          <p:nvPr/>
-        </p:nvSpPr>
-        <p:spPr>
-          <a:xfrm>
-            <a:off x="3090672" y="5230368"/>
-            <a:ext cx="1783080" cy="365760"/>
-          </a:xfrm>
-          <a:prstGeom prst="rect">
-            <a:avLst/>
-          </a:prstGeom>
-          <a:noFill/>
-        </p:spPr>
-        <p:txBody>
-          <a:bodyPr wrap="square" lIns="18288" rIns="18288" tIns="9144" bIns="9144" anchor="ctr">
-            <a:spAutoFit/>
-          </a:bodyPr>
-          <a:lstStyle/>
-          <a:p>
-            <a:pPr algn="ctr">
-              <a:spcBef>
-                <a:spcPts val="0"/>
-              </a:spcBef>
-              <a:spcAft>
-                <a:spcPts val="0"/>
-              </a:spcAft>
-            </a:pPr>
-            <a:r>
-              <a:rPr sz="1080" b="0">
-                <a:solidFill>
-                  <a:srgbClr val="313455"/>
-                </a:solidFill>
-                <a:latin typeface="Inter"/>
-              </a:rPr>
-              <a:t>Select BF16</a:t>
-            </a:r>
-          </a:p>
-          <a:p>
-            <a:pPr algn="ctr">
-              <a:spcBef>
-                <a:spcPts val="0"/>
-              </a:spcBef>
-              <a:spcAft>
-                <a:spcPts val="0"/>
-              </a:spcAft>
-            </a:pPr>
-            <a:r>
-              <a:rPr sz="1080" b="0">
-                <a:solidFill>
-                  <a:srgbClr val="313455"/>
-                </a:solidFill>
-                <a:latin typeface="Inter"/>
-              </a:rPr>
-              <a:t>MX sites</a:t>
-            </a:r>
-          </a:p>
-        </p:txBody>
-      </p:sp>
-      <p:sp>
-        <p:nvSpPr>
-          <p:cNvPr id="21" name="Rounded Rectangle 20"/>
-          <p:cNvSpPr/>
-          <p:nvPr/>
-        </p:nvSpPr>
-        <p:spPr>
-          <a:xfrm>
-            <a:off x="5138927" y="4709160"/>
-            <a:ext cx="1965960" cy="987552"/>
-          </a:xfrm>
-          <a:prstGeom prst="roundRect">
-            <a:avLst/>
-          </a:prstGeom>
-          <a:solidFill>
-            <a:srgbClr val="FDF8F1"/>
-          </a:solidFill>
-          <a:ln>
-            <a:solidFill>
-              <a:srgbClr val="B0A597"/>
-            </a:solidFill>
-          </a:ln>
-        </p:spPr>
-        <p:style>
-          <a:lnRef idx="1">
-            <a:schemeClr val="accent1"/>
-          </a:lnRef>
-          <a:fillRef idx="3">
-            <a:schemeClr val="accent1"/>
-          </a:fillRef>
-          <a:effectRef idx="2">
-            <a:schemeClr val="accent1"/>
-          </a:effectRef>
-          <a:fontRef idx="minor">
-            <a:schemeClr val="lt1"/>
-          </a:fontRef>
-        </p:style>
-        <p:txBody>
-          <a:bodyPr rtlCol="0" anchor="ctr"/>
-          <a:lstStyle/>
-          <a:p>
-            <a:pPr algn="ctr"/>
-          </a:p>
-        </p:txBody>
-      </p:sp>
-      <p:sp>
-        <p:nvSpPr>
-          <p:cNvPr id="22" name="TextBox 21"/>
-          <p:cNvSpPr txBox="1"/>
-          <p:nvPr/>
-        </p:nvSpPr>
-        <p:spPr>
-          <a:xfrm>
-            <a:off x="5230367" y="4800600"/>
-            <a:ext cx="1783080" cy="338328"/>
-          </a:xfrm>
-          <a:prstGeom prst="rect">
-            <a:avLst/>
-          </a:prstGeom>
-          <a:noFill/>
-        </p:spPr>
-        <p:txBody>
-          <a:bodyPr wrap="square" lIns="18288" rIns="18288" tIns="9144" bIns="9144" anchor="ctr">
-            <a:spAutoFit/>
-          </a:bodyPr>
-          <a:lstStyle/>
-          <a:p>
-            <a:pPr algn="ctr">
-              <a:spcBef>
-                <a:spcPts val="0"/>
-              </a:spcBef>
-              <a:spcAft>
-                <a:spcPts val="0"/>
-              </a:spcAft>
-            </a:pPr>
-            <a:r>
-              <a:rPr sz="1170" b="1">
-                <a:solidFill>
-                  <a:srgbClr val="103552"/>
-                </a:solidFill>
-                <a:latin typeface="Inter"/>
-              </a:rPr>
-              <a:t>schedule.plan</a:t>
-            </a:r>
-          </a:p>
-        </p:txBody>
-      </p:sp>
-      <p:sp>
-        <p:nvSpPr>
-          <p:cNvPr id="23" name="TextBox 22"/>
-          <p:cNvSpPr txBox="1"/>
-          <p:nvPr/>
-        </p:nvSpPr>
-        <p:spPr>
-          <a:xfrm>
-            <a:off x="5230367" y="5230368"/>
-            <a:ext cx="1783080" cy="365760"/>
-          </a:xfrm>
-          <a:prstGeom prst="rect">
-            <a:avLst/>
-          </a:prstGeom>
-          <a:noFill/>
-        </p:spPr>
-        <p:txBody>
-          <a:bodyPr wrap="square" lIns="18288" rIns="18288" tIns="9144" bIns="9144" anchor="ctr">
-            <a:spAutoFit/>
-          </a:bodyPr>
-          <a:lstStyle/>
-          <a:p>
-            <a:pPr algn="ctr">
-              <a:spcBef>
-                <a:spcPts val="0"/>
-              </a:spcBef>
-              <a:spcAft>
-                <a:spcPts val="0"/>
-              </a:spcAft>
-            </a:pPr>
-            <a:r>
-              <a:rPr sz="1080" b="0">
-                <a:solidFill>
-                  <a:srgbClr val="313455"/>
-                </a:solidFill>
-                <a:latin typeface="Inter"/>
-              </a:rPr>
-              <a:t>Choose native</a:t>
-            </a:r>
-          </a:p>
-          <a:p>
-            <a:pPr algn="ctr">
-              <a:spcBef>
-                <a:spcPts val="0"/>
-              </a:spcBef>
-              <a:spcAft>
-                <a:spcPts val="0"/>
-              </a:spcAft>
-            </a:pPr>
-            <a:r>
-              <a:rPr sz="1080" b="0">
-                <a:solidFill>
-                  <a:srgbClr val="313455"/>
-                </a:solidFill>
-                <a:latin typeface="Inter"/>
-              </a:rPr>
-              <a:t>loop policy</a:t>
-            </a:r>
-          </a:p>
-        </p:txBody>
-      </p:sp>
-      <p:sp>
-        <p:nvSpPr>
-          <p:cNvPr id="24" name="Rounded Rectangle 23"/>
-          <p:cNvSpPr/>
-          <p:nvPr/>
-        </p:nvSpPr>
-        <p:spPr>
-          <a:xfrm>
-            <a:off x="7278623" y="4709160"/>
-            <a:ext cx="1965960" cy="987552"/>
-          </a:xfrm>
-          <a:prstGeom prst="roundRect">
-            <a:avLst/>
-          </a:prstGeom>
-          <a:solidFill>
-            <a:srgbClr val="E5E7DA"/>
-          </a:solidFill>
-          <a:ln>
-            <a:solidFill>
-              <a:srgbClr val="B0A597"/>
-            </a:solidFill>
-          </a:ln>
-        </p:spPr>
-        <p:style>
-          <a:lnRef idx="1">
-            <a:schemeClr val="accent1"/>
-          </a:lnRef>
-          <a:fillRef idx="3">
-            <a:schemeClr val="accent1"/>
-          </a:fillRef>
-          <a:effectRef idx="2">
-            <a:schemeClr val="accent1"/>
-          </a:effectRef>
-          <a:fontRef idx="minor">
-            <a:schemeClr val="lt1"/>
-          </a:fontRef>
-        </p:style>
-        <p:txBody>
-          <a:bodyPr rtlCol="0" anchor="ctr"/>
-          <a:lstStyle/>
-          <a:p>
-            <a:pPr algn="ctr"/>
-          </a:p>
-        </p:txBody>
-      </p:sp>
-      <p:sp>
-        <p:nvSpPr>
-          <p:cNvPr id="25" name="TextBox 24"/>
-          <p:cNvSpPr txBox="1"/>
-          <p:nvPr/>
-        </p:nvSpPr>
-        <p:spPr>
-          <a:xfrm>
-            <a:off x="7370063" y="4800600"/>
-            <a:ext cx="1783080" cy="338328"/>
-          </a:xfrm>
-          <a:prstGeom prst="rect">
-            <a:avLst/>
-          </a:prstGeom>
-          <a:noFill/>
-        </p:spPr>
-        <p:txBody>
-          <a:bodyPr wrap="square" lIns="18288" rIns="18288" tIns="9144" bIns="9144" anchor="ctr">
-            <a:spAutoFit/>
-          </a:bodyPr>
-          <a:lstStyle/>
-          <a:p>
-            <a:pPr algn="ctr">
-              <a:spcBef>
-                <a:spcPts val="0"/>
-              </a:spcBef>
-              <a:spcAft>
-                <a:spcPts val="0"/>
-              </a:spcAft>
-            </a:pPr>
-            <a:r>
-              <a:rPr sz="1170" b="1">
-                <a:solidFill>
-                  <a:srgbClr val="103552"/>
-                </a:solidFill>
-                <a:latin typeface="Inter"/>
-              </a:rPr>
-              <a:t>MXVPUPostOffload</a:t>
-            </a:r>
-          </a:p>
-        </p:txBody>
-      </p:sp>
-      <p:sp>
-        <p:nvSpPr>
-          <p:cNvPr id="26" name="TextBox 25"/>
-          <p:cNvSpPr txBox="1"/>
-          <p:nvPr/>
-        </p:nvSpPr>
-        <p:spPr>
-          <a:xfrm>
-            <a:off x="7370063" y="5230368"/>
-            <a:ext cx="1783080" cy="365760"/>
-          </a:xfrm>
-          <a:prstGeom prst="rect">
-            <a:avLst/>
-          </a:prstGeom>
-          <a:noFill/>
-        </p:spPr>
-        <p:txBody>
-          <a:bodyPr wrap="square" lIns="18288" rIns="18288" tIns="9144" bIns="9144" anchor="ctr">
-            <a:spAutoFit/>
-          </a:bodyPr>
-          <a:lstStyle/>
-          <a:p>
-            <a:pPr algn="ctr">
-              <a:spcBef>
-                <a:spcPts val="0"/>
-              </a:spcBef>
-              <a:spcAft>
-                <a:spcPts val="0"/>
-              </a:spcAft>
-            </a:pPr>
-            <a:r>
-              <a:rPr sz="1080" b="0">
-                <a:solidFill>
-                  <a:srgbClr val="313455"/>
-                </a:solidFill>
-                <a:latin typeface="Inter"/>
-              </a:rPr>
-              <a:t>Map softmax, add</a:t>
-            </a:r>
-          </a:p>
-          <a:p>
-            <a:pPr algn="ctr">
-              <a:spcBef>
-                <a:spcPts val="0"/>
-              </a:spcBef>
-              <a:spcAft>
-                <a:spcPts val="0"/>
-              </a:spcAft>
-            </a:pPr>
-            <a:r>
-              <a:rPr sz="1080" b="0">
-                <a:solidFill>
-                  <a:srgbClr val="313455"/>
-                </a:solidFill>
-                <a:latin typeface="Inter"/>
-              </a:rPr>
-              <a:t>and reductions</a:t>
-            </a:r>
-          </a:p>
-        </p:txBody>
-      </p:sp>
-      <p:sp>
-        <p:nvSpPr>
-          <p:cNvPr id="27" name="Rounded Rectangle 26"/>
-          <p:cNvSpPr/>
-          <p:nvPr/>
-        </p:nvSpPr>
-        <p:spPr>
-          <a:xfrm>
-            <a:off x="9418319" y="4709160"/>
-            <a:ext cx="1965960" cy="987552"/>
-          </a:xfrm>
-          <a:prstGeom prst="roundRect">
-            <a:avLst/>
-          </a:prstGeom>
-          <a:solidFill>
-            <a:srgbClr val="FDF8F1"/>
-          </a:solidFill>
-          <a:ln>
-            <a:solidFill>
-              <a:srgbClr val="B0A597"/>
-            </a:solidFill>
-          </a:ln>
-        </p:spPr>
-        <p:style>
-          <a:lnRef idx="1">
-            <a:schemeClr val="accent1"/>
-          </a:lnRef>
-          <a:fillRef idx="3">
-            <a:schemeClr val="accent1"/>
-          </a:fillRef>
-          <a:effectRef idx="2">
-            <a:schemeClr val="accent1"/>
-          </a:effectRef>
-          <a:fontRef idx="minor">
-            <a:schemeClr val="lt1"/>
-          </a:fontRef>
-        </p:style>
-        <p:txBody>
-          <a:bodyPr rtlCol="0" anchor="ctr"/>
-          <a:lstStyle/>
-          <a:p>
-            <a:pPr algn="ctr"/>
-          </a:p>
-        </p:txBody>
-      </p:sp>
-      <p:sp>
-        <p:nvSpPr>
-          <p:cNvPr id="28" name="TextBox 27"/>
-          <p:cNvSpPr txBox="1"/>
-          <p:nvPr/>
-        </p:nvSpPr>
-        <p:spPr>
-          <a:xfrm>
-            <a:off x="9509759" y="4800600"/>
-            <a:ext cx="1783080" cy="338328"/>
-          </a:xfrm>
-          <a:prstGeom prst="rect">
-            <a:avLst/>
-          </a:prstGeom>
-          <a:noFill/>
-        </p:spPr>
-        <p:txBody>
-          <a:bodyPr wrap="square" lIns="18288" rIns="18288" tIns="9144" bIns="9144" anchor="ctr">
-            <a:spAutoFit/>
-          </a:bodyPr>
-          <a:lstStyle/>
-          <a:p>
-            <a:pPr algn="ctr">
-              <a:spcBef>
-                <a:spcPts val="0"/>
-              </a:spcBef>
-              <a:spcAft>
-                <a:spcPts val="0"/>
-              </a:spcAft>
-            </a:pPr>
-            <a:r>
-              <a:rPr sz="1170" b="1">
-                <a:solidFill>
-                  <a:srgbClr val="103552"/>
-                </a:solidFill>
-                <a:latin typeface="Inter"/>
-              </a:rPr>
-              <a:t>physical_program</a:t>
-            </a:r>
-          </a:p>
-        </p:txBody>
-      </p:sp>
-      <p:sp>
-        <p:nvSpPr>
-          <p:cNvPr id="29" name="TextBox 28"/>
-          <p:cNvSpPr txBox="1"/>
-          <p:nvPr/>
-        </p:nvSpPr>
-        <p:spPr>
-          <a:xfrm>
-            <a:off x="9509759" y="5230368"/>
-            <a:ext cx="1783080" cy="365760"/>
-          </a:xfrm>
-          <a:prstGeom prst="rect">
-            <a:avLst/>
-          </a:prstGeom>
-          <a:noFill/>
-        </p:spPr>
-        <p:txBody>
-          <a:bodyPr wrap="square" lIns="18288" rIns="18288" tIns="9144" bIns="9144" anchor="ctr">
-            <a:spAutoFit/>
-          </a:bodyPr>
-          <a:lstStyle/>
-          <a:p>
-            <a:pPr algn="ctr">
-              <a:spcBef>
-                <a:spcPts val="0"/>
-              </a:spcBef>
-              <a:spcAft>
-                <a:spcPts val="0"/>
-              </a:spcAft>
-            </a:pPr>
-            <a:r>
-              <a:rPr sz="1080" b="0">
-                <a:solidFill>
-                  <a:srgbClr val="313455"/>
-                </a:solidFill>
-                <a:latin typeface="Inter"/>
-              </a:rPr>
-              <a:t>Order DMA, compute</a:t>
-            </a:r>
-          </a:p>
-          <a:p>
-            <a:pPr algn="ctr">
-              <a:spcBef>
-                <a:spcPts val="0"/>
-              </a:spcBef>
-              <a:spcAft>
-                <a:spcPts val="0"/>
-              </a:spcAft>
-            </a:pPr>
-            <a:r>
-              <a:rPr sz="1080" b="0">
-                <a:solidFill>
-                  <a:srgbClr val="313455"/>
-                </a:solidFill>
-                <a:latin typeface="Inter"/>
-              </a:rPr>
-              <a:t>and VPU commands</a:t>
-            </a:r>
-          </a:p>
-        </p:txBody>
-      </p:sp>
-      <p:sp>
-        <p:nvSpPr>
-          <p:cNvPr id="30" name="TextBox 29"/>
-          <p:cNvSpPr txBox="1"/>
-          <p:nvPr/>
-        </p:nvSpPr>
-        <p:spPr>
-          <a:xfrm>
-            <a:off x="877824" y="5833872"/>
-            <a:ext cx="10469880" cy="329184"/>
-          </a:xfrm>
-          <a:prstGeom prst="rect">
-            <a:avLst/>
-          </a:prstGeom>
-          <a:noFill/>
-        </p:spPr>
-        <p:txBody>
-          <a:bodyPr wrap="square" lIns="18288" rIns="18288" tIns="9144" bIns="9144" anchor="ctr">
-            <a:spAutoFit/>
-          </a:bodyPr>
-          <a:lstStyle/>
-          <a:p>
-            <a:pPr algn="l">
-              <a:spcBef>
-                <a:spcPts val="0"/>
-              </a:spcBef>
-              <a:spcAft>
-                <a:spcPts val="0"/>
-              </a:spcAft>
-            </a:pPr>
-            <a:r>
-              <a:rPr sz="1019" b="0">
-                <a:solidFill>
-                  <a:srgbClr val="5B5957"/>
-                </a:solidFill>
-                <a:latin typeface="Inter"/>
-              </a:rPr>
-              <a:t>mx-gemmini-opt verifies typed IR. The standalone command path bypasses LLVM; the generic full-model host currently uses Merlin → LLVM → RV64.</a:t>
-            </a:r>
-          </a:p>
-        </p:txBody>
-      </p:sp>
-      <p:sp>
-        <p:nvSpPr>
-          <p:cNvPr id="31" name="TextBox 30"/>
           <p:cNvSpPr txBox="1"/>
           <p:nvPr/>
         </p:nvSpPr>
@@ -18333,7 +18151,7 @@
                 </a:solidFill>
                 <a:latin typeface="Inter"/>
               </a:rPr>
-              <a:t>01 / 04</a:t>
+              <a:t>02 / 04</a:t>
             </a:r>
           </a:p>
         </p:txBody>
@@ -18346,7 +18164,7 @@
 </p:sld>
 </file>
 
-<file path=ppt/slides/slide2.xml><?xml version="1.0" encoding="utf-8"?>
+<file path=ppt/slides/slide23.xml><?xml version="1.0" encoding="utf-8"?>
 <p:sld xmlns:a="http://schemas.openxmlformats.org/drawingml/2006/main" xmlns:p="http://schemas.openxmlformats.org/presentationml/2006/main" xmlns:r="http://schemas.openxmlformats.org/officeDocument/2006/relationships" showMasterSp="1">
   <p:cSld>
     <p:bg>
@@ -18405,7 +18223,7 @@
                 </a:solidFill>
                 <a:latin typeface="Inter"/>
               </a:rPr>
-              <a:t>One JSON profile changes legal MLIR</a:t>
+              <a:t>MX dialect: typed IR to RV64</a:t>
             </a:r>
           </a:p>
         </p:txBody>
@@ -18418,8 +18236,8 @@
         </p:nvSpPr>
         <p:spPr>
           <a:xfrm>
-            <a:off x="859536" y="1481328"/>
-            <a:ext cx="5522976" cy="4407408"/>
+            <a:off x="859536" y="1499616"/>
+            <a:ext cx="5166360" cy="2724912"/>
           </a:xfrm>
           <a:prstGeom prst="roundRect">
             <a:avLst/>
@@ -18463,8 +18281,8 @@
         </p:nvSpPr>
         <p:spPr>
           <a:xfrm>
-            <a:off x="6547104" y="1481328"/>
-            <a:ext cx="4800600" cy="4407408"/>
+            <a:off x="6181344" y="1499616"/>
+            <a:ext cx="5166360" cy="2724912"/>
           </a:xfrm>
           <a:prstGeom prst="roundRect">
             <a:avLst/>
@@ -18508,8 +18326,8 @@
         </p:nvSpPr>
         <p:spPr>
           <a:xfrm>
-            <a:off x="1051560" y="1636776"/>
-            <a:ext cx="5102352" cy="310896"/>
+            <a:off x="1051560" y="1664208"/>
+            <a:ext cx="4754880" cy="310896"/>
           </a:xfrm>
           <a:prstGeom prst="rect">
             <a:avLst/>
@@ -18531,13 +18349,13 @@
               </a:spcAft>
             </a:pPr>
             <a:r>
-              <a:rPr sz="1720" b="1">
+              <a:rPr sz="1750" b="1">
                 <a:solidFill>
                   <a:srgbClr val="103552"/>
                 </a:solidFill>
                 <a:latin typeface="Inter"/>
               </a:rPr>
-              <a:t>Selected RTL profile fields</a:t>
+              <a:t>FP4 GEMM → typed MX</a:t>
             </a:r>
           </a:p>
         </p:txBody>
@@ -18550,8 +18368,8 @@
         </p:nvSpPr>
         <p:spPr>
           <a:xfrm>
-            <a:off x="1051560" y="2029968"/>
-            <a:ext cx="5093208" cy="2569464"/>
+            <a:off x="1051560" y="2048256"/>
+            <a:ext cx="4754880" cy="1298448"/>
           </a:xfrm>
           <a:prstGeom prst="roundRect">
             <a:avLst/>
@@ -18592,13 +18410,112 @@
               </a:spcAft>
             </a:pPr>
             <a:r>
-              <a:rPr sz="1045">
+              <a:rPr sz="1110">
+                <a:solidFill>
+                  <a:srgbClr val="006874"/>
+                </a:solidFill>
+                <a:latin typeface="Liberation Mono"/>
+              </a:rPr>
+              <a:t>%acc</a:t>
+            </a:r>
+            <a:r>
+              <a:rPr sz="1110">
                 <a:solidFill>
                   <a:srgbClr val="103552"/>
                 </a:solidFill>
                 <a:latin typeface="Liberation Mono"/>
               </a:rPr>
-              <a:t>{</a:t>
+              <a:t> = </a:t>
+            </a:r>
+            <a:r>
+              <a:rPr sz="1110">
+                <a:solidFill>
+                  <a:srgbClr val="6C3D80"/>
+                </a:solidFill>
+                <a:latin typeface="Liberation Mono"/>
+              </a:rPr>
+              <a:t>"mx_gemmini.contract"</a:t>
+            </a:r>
+            <a:r>
+              <a:rPr sz="1110">
+                <a:solidFill>
+                  <a:srgbClr val="103552"/>
+                </a:solidFill>
+                <a:latin typeface="Liberation Mono"/>
+              </a:rPr>
+              <a:t>(</a:t>
+            </a:r>
+            <a:r>
+              <a:rPr sz="1110">
+                <a:solidFill>
+                  <a:srgbClr val="006874"/>
+                </a:solidFill>
+                <a:latin typeface="Liberation Mono"/>
+              </a:rPr>
+              <a:t>%A</a:t>
+            </a:r>
+            <a:r>
+              <a:rPr sz="1110">
+                <a:solidFill>
+                  <a:srgbClr val="103552"/>
+                </a:solidFill>
+                <a:latin typeface="Liberation Mono"/>
+              </a:rPr>
+              <a:t>,</a:t>
+            </a:r>
+            <a:r>
+              <a:rPr sz="1110">
+                <a:solidFill>
+                  <a:srgbClr val="006874"/>
+                </a:solidFill>
+                <a:latin typeface="Liberation Mono"/>
+              </a:rPr>
+              <a:t>%As</a:t>
+            </a:r>
+            <a:r>
+              <a:rPr sz="1110">
+                <a:solidFill>
+                  <a:srgbClr val="103552"/>
+                </a:solidFill>
+                <a:latin typeface="Liberation Mono"/>
+              </a:rPr>
+              <a:t>,</a:t>
+            </a:r>
+            <a:r>
+              <a:rPr sz="1110">
+                <a:solidFill>
+                  <a:srgbClr val="006874"/>
+                </a:solidFill>
+                <a:latin typeface="Liberation Mono"/>
+              </a:rPr>
+              <a:t>%B</a:t>
+            </a:r>
+            <a:r>
+              <a:rPr sz="1110">
+                <a:solidFill>
+                  <a:srgbClr val="103552"/>
+                </a:solidFill>
+                <a:latin typeface="Liberation Mono"/>
+              </a:rPr>
+              <a:t>,</a:t>
+            </a:r>
+            <a:r>
+              <a:rPr sz="1110">
+                <a:solidFill>
+                  <a:srgbClr val="006874"/>
+                </a:solidFill>
+                <a:latin typeface="Liberation Mono"/>
+              </a:rPr>
+              <a:t>%Bs</a:t>
+            </a:r>
+            <a:r>
+              <a:rPr sz="1110">
+                <a:solidFill>
+                  <a:srgbClr val="103552"/>
+                </a:solidFill>
+                <a:latin typeface="Liberation Mono"/>
+              </a:rPr>
+              <a:t>) {</a:t>
             </a:r>
           </a:p>
           <a:p>
@@ -18611,103 +18528,49 @@
               </a:spcAft>
             </a:pPr>
             <a:r>
-              <a:rPr sz="1045">
+              <a:rPr sz="1110">
                 <a:solidFill>
                   <a:srgbClr val="103552"/>
                 </a:solidFill>
                 <a:latin typeface="Liberation Mono"/>
               </a:rPr>
-              <a:t> </a:t>
-            </a:r>
-            <a:r>
-              <a:rPr sz="1045">
+              <a:t>  </a:t>
+            </a:r>
+            <a:r>
+              <a:rPr sz="1110">
                 <a:solidFill>
                   <a:srgbClr val="6C3D80"/>
                 </a:solidFill>
                 <a:latin typeface="Liberation Mono"/>
               </a:rPr>
-              <a:t>"geometry"</a:t>
-            </a:r>
-            <a:r>
-              <a:rPr sz="1045">
+              <a:t>activation_format</a:t>
+            </a:r>
+            <a:r>
+              <a:rPr sz="1110">
                 <a:solidFill>
                   <a:srgbClr val="103552"/>
                 </a:solidFill>
                 <a:latin typeface="Liberation Mono"/>
               </a:rPr>
-              <a:t>: {</a:t>
-            </a:r>
-            <a:r>
-              <a:rPr sz="1045">
-                <a:solidFill>
-                  <a:srgbClr val="6C3D80"/>
+              <a:t> = </a:t>
+            </a:r>
+            <a:r>
+              <a:rPr sz="1110">
+                <a:solidFill>
+                  <a:srgbClr val="28704F"/>
                 </a:solidFill>
                 <a:latin typeface="Liberation Mono"/>
               </a:rPr>
-              <a:t>"mesh_rows"</a:t>
-            </a:r>
-            <a:r>
-              <a:rPr sz="1045">
+              <a:t>"fp4_e2m1"</a:t>
+            </a:r>
+            <a:r>
+              <a:rPr sz="1110">
                 <a:solidFill>
                   <a:srgbClr val="103552"/>
                 </a:solidFill>
                 <a:latin typeface="Liberation Mono"/>
               </a:rPr>
-              <a:t>:</a:t>
-            </a:r>
-            <a:r>
-              <a:rPr sz="1045">
-                <a:solidFill>
-                  <a:srgbClr val="A44F25"/>
-                </a:solidFill>
-                <a:latin typeface="Liberation Mono"/>
-              </a:rPr>
-              <a:t>16</a:t>
-            </a:r>
-            <a:r>
-              <a:rPr sz="1045">
-                <a:solidFill>
-                  <a:srgbClr val="103552"/>
-                </a:solidFill>
-                <a:latin typeface="Liberation Mono"/>
-              </a:rPr>
               <a:t>,</a:t>
-            </a:r>
-            <a:r>
-              <a:rPr sz="1045">
-                <a:solidFill>
-                  <a:srgbClr val="6C3D80"/>
-                </a:solidFill>
-                <a:latin typeface="Liberation Mono"/>
-              </a:rPr>
-              <a:t>"mesh_columns"</a:t>
-            </a:r>
-            <a:r>
-              <a:rPr sz="1045">
-                <a:solidFill>
-                  <a:srgbClr val="103552"/>
-                </a:solidFill>
-                <a:latin typeface="Liberation Mono"/>
-              </a:rPr>
-              <a:t>:</a:t>
-            </a:r>
-            <a:r>
-              <a:rPr sz="1045">
-                <a:solidFill>
-                  <a:srgbClr val="A44F25"/>
-                </a:solidFill>
-                <a:latin typeface="Liberation Mono"/>
-              </a:rPr>
-              <a:t>16</a:t>
-            </a:r>
-            <a:r>
-              <a:rPr sz="1045">
-                <a:solidFill>
-                  <a:srgbClr val="103552"/>
-                </a:solidFill>
-                <a:latin typeface="Liberation Mono"/>
-              </a:rPr>
-              <a:t>},</a:t>
             </a:r>
           </a:p>
           <a:p>
@@ -18720,31 +18583,85 @@
               </a:spcAft>
             </a:pPr>
             <a:r>
-              <a:rPr sz="1045">
+              <a:rPr sz="1110">
                 <a:solidFill>
                   <a:srgbClr val="103552"/>
                 </a:solidFill>
                 <a:latin typeface="Liberation Mono"/>
               </a:rPr>
-              <a:t> </a:t>
-            </a:r>
-            <a:r>
-              <a:rPr sz="1045">
+              <a:t>  </a:t>
+            </a:r>
+            <a:r>
+              <a:rPr sz="1110">
                 <a:solidFill>
                   <a:srgbClr val="6C3D80"/>
                 </a:solidFill>
                 <a:latin typeface="Liberation Mono"/>
               </a:rPr>
-              <a:t>"legal_compute"</a:t>
-            </a:r>
-            <a:r>
-              <a:rPr sz="1045">
+              <a:t>weight_format</a:t>
+            </a:r>
+            <a:r>
+              <a:rPr sz="1110">
                 <a:solidFill>
                   <a:srgbClr val="103552"/>
                 </a:solidFill>
                 <a:latin typeface="Liberation Mono"/>
               </a:rPr>
-              <a:t>: [</a:t>
+              <a:t> = </a:t>
+            </a:r>
+            <a:r>
+              <a:rPr sz="1110">
+                <a:solidFill>
+                  <a:srgbClr val="28704F"/>
+                </a:solidFill>
+                <a:latin typeface="Liberation Mono"/>
+              </a:rPr>
+              <a:t>"fp4_e2m1"</a:t>
+            </a:r>
+            <a:r>
+              <a:rPr sz="1110">
+                <a:solidFill>
+                  <a:srgbClr val="103552"/>
+                </a:solidFill>
+                <a:latin typeface="Liberation Mono"/>
+              </a:rPr>
+              <a:t>, </a:t>
+            </a:r>
+            <a:r>
+              <a:rPr sz="1110">
+                <a:solidFill>
+                  <a:srgbClr val="6C3D80"/>
+                </a:solidFill>
+                <a:latin typeface="Liberation Mono"/>
+              </a:rPr>
+              <a:t>pe_mode</a:t>
+            </a:r>
+            <a:r>
+              <a:rPr sz="1110">
+                <a:solidFill>
+                  <a:srgbClr val="103552"/>
+                </a:solidFill>
+                <a:latin typeface="Liberation Mono"/>
+              </a:rPr>
+              <a:t> = </a:t>
+            </a:r>
+            <a:r>
+              <a:rPr sz="1110">
+                <a:solidFill>
+                  <a:srgbClr val="A44F25"/>
+                </a:solidFill>
+                <a:latin typeface="Liberation Mono"/>
+              </a:rPr>
+              <a:t>0</a:t>
+            </a:r>
+            <a:r>
+              <a:rPr sz="1110">
+                <a:solidFill>
+                  <a:srgbClr val="103552"/>
+                </a:solidFill>
+                <a:latin typeface="Liberation Mono"/>
+              </a:rPr>
+              <a:t> : i32 }</a:t>
             </a:r>
           </a:p>
           <a:p>
@@ -18757,488 +18674,58 @@
               </a:spcAft>
             </a:pPr>
             <a:r>
-              <a:rPr sz="1045">
+              <a:rPr sz="1110">
+                <a:solidFill>
+                  <a:srgbClr val="006874"/>
+                </a:solidFill>
+                <a:latin typeface="Liberation Mono"/>
+              </a:rPr>
+              <a:t>%out</a:t>
+            </a:r>
+            <a:r>
+              <a:rPr sz="1110">
                 <a:solidFill>
                   <a:srgbClr val="103552"/>
                 </a:solidFill>
                 <a:latin typeface="Liberation Mono"/>
               </a:rPr>
-              <a:t>  {</a:t>
-            </a:r>
-            <a:r>
-              <a:rPr sz="1045">
+              <a:t> = </a:t>
+            </a:r>
+            <a:r>
+              <a:rPr sz="1110">
                 <a:solidFill>
                   <a:srgbClr val="6C3D80"/>
                 </a:solidFill>
                 <a:latin typeface="Liberation Mono"/>
               </a:rPr>
-              <a:t>"activation_format"</a:t>
-            </a:r>
-            <a:r>
-              <a:rPr sz="1045">
+              <a:t>"mx_gemmini.readout_bf16"</a:t>
+            </a:r>
+            <a:r>
+              <a:rPr sz="1110">
                 <a:solidFill>
                   <a:srgbClr val="103552"/>
                 </a:solidFill>
                 <a:latin typeface="Liberation Mono"/>
               </a:rPr>
-              <a:t>:</a:t>
-            </a:r>
-            <a:r>
-              <a:rPr sz="1045">
-                <a:solidFill>
-                  <a:srgbClr val="28704F"/>
+              <a:t>(</a:t>
+            </a:r>
+            <a:r>
+              <a:rPr sz="1110">
+                <a:solidFill>
+                  <a:srgbClr val="006874"/>
                 </a:solidFill>
                 <a:latin typeface="Liberation Mono"/>
               </a:rPr>
-              <a:t>"fp4_e2m1"</a:t>
-            </a:r>
-            <a:r>
-              <a:rPr sz="1045">
+              <a:t>%acc</a:t>
+            </a:r>
+            <a:r>
+              <a:rPr sz="1110">
                 <a:solidFill>
                   <a:srgbClr val="103552"/>
                 </a:solidFill>
                 <a:latin typeface="Liberation Mono"/>
               </a:rPr>
-              <a:t>,</a:t>
-            </a:r>
-          </a:p>
-          <a:p>
-            <a:pPr algn="l">
-              <a:spcBef>
-                <a:spcPts val="0"/>
-              </a:spcBef>
-              <a:spcAft>
-                <a:spcPts val="0"/>
-              </a:spcAft>
-            </a:pPr>
-            <a:r>
-              <a:rPr sz="1045">
-                <a:solidFill>
-                  <a:srgbClr val="103552"/>
-                </a:solidFill>
-                <a:latin typeface="Liberation Mono"/>
-              </a:rPr>
-              <a:t>   </a:t>
-            </a:r>
-            <a:r>
-              <a:rPr sz="1045">
-                <a:solidFill>
-                  <a:srgbClr val="6C3D80"/>
-                </a:solidFill>
-                <a:latin typeface="Liberation Mono"/>
-              </a:rPr>
-              <a:t>"weight_format"</a:t>
-            </a:r>
-            <a:r>
-              <a:rPr sz="1045">
-                <a:solidFill>
-                  <a:srgbClr val="103552"/>
-                </a:solidFill>
-                <a:latin typeface="Liberation Mono"/>
-              </a:rPr>
-              <a:t>:</a:t>
-            </a:r>
-            <a:r>
-              <a:rPr sz="1045">
-                <a:solidFill>
-                  <a:srgbClr val="28704F"/>
-                </a:solidFill>
-                <a:latin typeface="Liberation Mono"/>
-              </a:rPr>
-              <a:t>"fp4_e2m1"</a:t>
-            </a:r>
-            <a:r>
-              <a:rPr sz="1045">
-                <a:solidFill>
-                  <a:srgbClr val="103552"/>
-                </a:solidFill>
-                <a:latin typeface="Liberation Mono"/>
-              </a:rPr>
-              <a:t>,</a:t>
-            </a:r>
-            <a:r>
-              <a:rPr sz="1045">
-                <a:solidFill>
-                  <a:srgbClr val="6C3D80"/>
-                </a:solidFill>
-                <a:latin typeface="Liberation Mono"/>
-              </a:rPr>
-              <a:t>"pe_mode"</a:t>
-            </a:r>
-            <a:r>
-              <a:rPr sz="1045">
-                <a:solidFill>
-                  <a:srgbClr val="103552"/>
-                </a:solidFill>
-                <a:latin typeface="Liberation Mono"/>
-              </a:rPr>
-              <a:t>:</a:t>
-            </a:r>
-            <a:r>
-              <a:rPr sz="1045">
-                <a:solidFill>
-                  <a:srgbClr val="A44F25"/>
-                </a:solidFill>
-                <a:latin typeface="Liberation Mono"/>
-              </a:rPr>
-              <a:t>0</a:t>
-            </a:r>
-            <a:r>
-              <a:rPr sz="1045">
-                <a:solidFill>
-                  <a:srgbClr val="103552"/>
-                </a:solidFill>
-                <a:latin typeface="Liberation Mono"/>
-              </a:rPr>
-              <a:t>},</a:t>
-            </a:r>
-          </a:p>
-          <a:p>
-            <a:pPr algn="l">
-              <a:spcBef>
-                <a:spcPts val="0"/>
-              </a:spcBef>
-              <a:spcAft>
-                <a:spcPts val="0"/>
-              </a:spcAft>
-            </a:pPr>
-            <a:r>
-              <a:rPr sz="1045">
-                <a:solidFill>
-                  <a:srgbClr val="103552"/>
-                </a:solidFill>
-                <a:latin typeface="Liberation Mono"/>
-              </a:rPr>
-              <a:t>  {</a:t>
-            </a:r>
-            <a:r>
-              <a:rPr sz="1045">
-                <a:solidFill>
-                  <a:srgbClr val="6C3D80"/>
-                </a:solidFill>
-                <a:latin typeface="Liberation Mono"/>
-              </a:rPr>
-              <a:t>"activation_format"</a:t>
-            </a:r>
-            <a:r>
-              <a:rPr sz="1045">
-                <a:solidFill>
-                  <a:srgbClr val="103552"/>
-                </a:solidFill>
-                <a:latin typeface="Liberation Mono"/>
-              </a:rPr>
-              <a:t>:</a:t>
-            </a:r>
-            <a:r>
-              <a:rPr sz="1045">
-                <a:solidFill>
-                  <a:srgbClr val="28704F"/>
-                </a:solidFill>
-                <a:latin typeface="Liberation Mono"/>
-              </a:rPr>
-              <a:t>"fp8_e4m3"</a:t>
-            </a:r>
-            <a:r>
-              <a:rPr sz="1045">
-                <a:solidFill>
-                  <a:srgbClr val="103552"/>
-                </a:solidFill>
-                <a:latin typeface="Liberation Mono"/>
-              </a:rPr>
-              <a:t>,</a:t>
-            </a:r>
-          </a:p>
-          <a:p>
-            <a:pPr algn="l">
-              <a:spcBef>
-                <a:spcPts val="0"/>
-              </a:spcBef>
-              <a:spcAft>
-                <a:spcPts val="0"/>
-              </a:spcAft>
-            </a:pPr>
-            <a:r>
-              <a:rPr sz="1045">
-                <a:solidFill>
-                  <a:srgbClr val="103552"/>
-                </a:solidFill>
-                <a:latin typeface="Liberation Mono"/>
-              </a:rPr>
-              <a:t>   </a:t>
-            </a:r>
-            <a:r>
-              <a:rPr sz="1045">
-                <a:solidFill>
-                  <a:srgbClr val="6C3D80"/>
-                </a:solidFill>
-                <a:latin typeface="Liberation Mono"/>
-              </a:rPr>
-              <a:t>"weight_format"</a:t>
-            </a:r>
-            <a:r>
-              <a:rPr sz="1045">
-                <a:solidFill>
-                  <a:srgbClr val="103552"/>
-                </a:solidFill>
-                <a:latin typeface="Liberation Mono"/>
-              </a:rPr>
-              <a:t>:</a:t>
-            </a:r>
-            <a:r>
-              <a:rPr sz="1045">
-                <a:solidFill>
-                  <a:srgbClr val="28704F"/>
-                </a:solidFill>
-                <a:latin typeface="Liberation Mono"/>
-              </a:rPr>
-              <a:t>"fp8_e4m3"</a:t>
-            </a:r>
-            <a:r>
-              <a:rPr sz="1045">
-                <a:solidFill>
-                  <a:srgbClr val="103552"/>
-                </a:solidFill>
-                <a:latin typeface="Liberation Mono"/>
-              </a:rPr>
-              <a:t>,</a:t>
-            </a:r>
-            <a:r>
-              <a:rPr sz="1045">
-                <a:solidFill>
-                  <a:srgbClr val="6C3D80"/>
-                </a:solidFill>
-                <a:latin typeface="Liberation Mono"/>
-              </a:rPr>
-              <a:t>"pe_mode"</a:t>
-            </a:r>
-            <a:r>
-              <a:rPr sz="1045">
-                <a:solidFill>
-                  <a:srgbClr val="103552"/>
-                </a:solidFill>
-                <a:latin typeface="Liberation Mono"/>
-              </a:rPr>
-              <a:t>:</a:t>
-            </a:r>
-            <a:r>
-              <a:rPr sz="1045">
-                <a:solidFill>
-                  <a:srgbClr val="A44F25"/>
-                </a:solidFill>
-                <a:latin typeface="Liberation Mono"/>
-              </a:rPr>
-              <a:t>8</a:t>
-            </a:r>
-            <a:r>
-              <a:rPr sz="1045">
-                <a:solidFill>
-                  <a:srgbClr val="103552"/>
-                </a:solidFill>
-                <a:latin typeface="Liberation Mono"/>
-              </a:rPr>
-              <a:t>}</a:t>
-            </a:r>
-          </a:p>
-          <a:p>
-            <a:pPr algn="l">
-              <a:spcBef>
-                <a:spcPts val="0"/>
-              </a:spcBef>
-              <a:spcAft>
-                <a:spcPts val="0"/>
-              </a:spcAft>
-            </a:pPr>
-            <a:r>
-              <a:rPr sz="1045">
-                <a:solidFill>
-                  <a:srgbClr val="103552"/>
-                </a:solidFill>
-                <a:latin typeface="Liberation Mono"/>
-              </a:rPr>
-              <a:t> ],</a:t>
-            </a:r>
-          </a:p>
-          <a:p>
-            <a:pPr algn="l">
-              <a:spcBef>
-                <a:spcPts val="0"/>
-              </a:spcBef>
-              <a:spcAft>
-                <a:spcPts val="0"/>
-              </a:spcAft>
-            </a:pPr>
-            <a:r>
-              <a:rPr sz="1045">
-                <a:solidFill>
-                  <a:srgbClr val="103552"/>
-                </a:solidFill>
-                <a:latin typeface="Liberation Mono"/>
-              </a:rPr>
-              <a:t> </a:t>
-            </a:r>
-            <a:r>
-              <a:rPr sz="1045">
-                <a:solidFill>
-                  <a:srgbClr val="6C3D80"/>
-                </a:solidFill>
-                <a:latin typeface="Liberation Mono"/>
-              </a:rPr>
-              <a:t>"resources"</a:t>
-            </a:r>
-            <a:r>
-              <a:rPr sz="1045">
-                <a:solidFill>
-                  <a:srgbClr val="103552"/>
-                </a:solidFill>
-                <a:latin typeface="Liberation Mono"/>
-              </a:rPr>
-              <a:t>: {</a:t>
-            </a:r>
-            <a:r>
-              <a:rPr sz="1045">
-                <a:solidFill>
-                  <a:srgbClr val="6C3D80"/>
-                </a:solidFill>
-                <a:latin typeface="Liberation Mono"/>
-              </a:rPr>
-              <a:t>"scratchpad_bytes"</a:t>
-            </a:r>
-            <a:r>
-              <a:rPr sz="1045">
-                <a:solidFill>
-                  <a:srgbClr val="103552"/>
-                </a:solidFill>
-                <a:latin typeface="Liberation Mono"/>
-              </a:rPr>
-              <a:t>:</a:t>
-            </a:r>
-            <a:r>
-              <a:rPr sz="1045">
-                <a:solidFill>
-                  <a:srgbClr val="A44F25"/>
-                </a:solidFill>
-                <a:latin typeface="Liberation Mono"/>
-              </a:rPr>
-              <a:t>262144</a:t>
-            </a:r>
-            <a:r>
-              <a:rPr sz="1045">
-                <a:solidFill>
-                  <a:srgbClr val="103552"/>
-                </a:solidFill>
-                <a:latin typeface="Liberation Mono"/>
-              </a:rPr>
-              <a:t>,</a:t>
-            </a:r>
-          </a:p>
-          <a:p>
-            <a:pPr algn="l">
-              <a:spcBef>
-                <a:spcPts val="0"/>
-              </a:spcBef>
-              <a:spcAft>
-                <a:spcPts val="0"/>
-              </a:spcAft>
-            </a:pPr>
-            <a:r>
-              <a:rPr sz="1045">
-                <a:solidFill>
-                  <a:srgbClr val="103552"/>
-                </a:solidFill>
-                <a:latin typeface="Liberation Mono"/>
-              </a:rPr>
-              <a:t>               </a:t>
-            </a:r>
-            <a:r>
-              <a:rPr sz="1045">
-                <a:solidFill>
-                  <a:srgbClr val="6C3D80"/>
-                </a:solidFill>
-                <a:latin typeface="Liberation Mono"/>
-              </a:rPr>
-              <a:t>"vpu"</a:t>
-            </a:r>
-            <a:r>
-              <a:rPr sz="1045">
-                <a:solidFill>
-                  <a:srgbClr val="103552"/>
-                </a:solidFill>
-                <a:latin typeface="Liberation Mono"/>
-              </a:rPr>
-              <a:t>:</a:t>
-            </a:r>
-            <a:r>
-              <a:rPr sz="1045">
-                <a:solidFill>
-                  <a:srgbClr val="6C3D80"/>
-                </a:solidFill>
-                <a:latin typeface="Liberation Mono"/>
-              </a:rPr>
-              <a:t>true</a:t>
-            </a:r>
-            <a:r>
-              <a:rPr sz="1045">
-                <a:solidFill>
-                  <a:srgbClr val="103552"/>
-                </a:solidFill>
-                <a:latin typeface="Liberation Mono"/>
-              </a:rPr>
-              <a:t>,</a:t>
-            </a:r>
-            <a:r>
-              <a:rPr sz="1045">
-                <a:solidFill>
-                  <a:srgbClr val="6C3D80"/>
-                </a:solidFill>
-                <a:latin typeface="Liberation Mono"/>
-              </a:rPr>
-              <a:t>"lut"</a:t>
-            </a:r>
-            <a:r>
-              <a:rPr sz="1045">
-                <a:solidFill>
-                  <a:srgbClr val="103552"/>
-                </a:solidFill>
-                <a:latin typeface="Liberation Mono"/>
-              </a:rPr>
-              <a:t>:</a:t>
-            </a:r>
-            <a:r>
-              <a:rPr sz="1045">
-                <a:solidFill>
-                  <a:srgbClr val="6C3D80"/>
-                </a:solidFill>
-                <a:latin typeface="Liberation Mono"/>
-              </a:rPr>
-              <a:t>false</a:t>
-            </a:r>
-            <a:r>
-              <a:rPr sz="1045">
-                <a:solidFill>
-                  <a:srgbClr val="103552"/>
-                </a:solidFill>
-                <a:latin typeface="Liberation Mono"/>
-              </a:rPr>
-              <a:t>}</a:t>
-            </a:r>
-          </a:p>
-          <a:p>
-            <a:pPr algn="l">
-              <a:spcBef>
-                <a:spcPts val="0"/>
-              </a:spcBef>
-              <a:spcAft>
-                <a:spcPts val="0"/>
-              </a:spcAft>
-            </a:pPr>
-            <a:r>
-              <a:rPr sz="1045">
-                <a:solidFill>
-                  <a:srgbClr val="103552"/>
-                </a:solidFill>
-                <a:latin typeface="Liberation Mono"/>
-              </a:rPr>
-              <a:t>}</a:t>
+              <a:t>)</a:t>
             </a:r>
           </a:p>
         </p:txBody>
@@ -19251,8 +18738,8 @@
         </p:nvSpPr>
         <p:spPr>
           <a:xfrm>
-            <a:off x="1051560" y="4736592"/>
-            <a:ext cx="5093208" cy="475488"/>
+            <a:off x="1051560" y="3438144"/>
+            <a:ext cx="4727448" cy="685800"/>
           </a:xfrm>
           <a:prstGeom prst="rect">
             <a:avLst/>
@@ -19274,13 +18761,13 @@
               </a:spcAft>
             </a:pPr>
             <a:r>
-              <a:rPr sz="1110" b="0">
+              <a:rPr sz="1060" b="0">
                 <a:solidFill>
                   <a:srgbClr val="313455"/>
                 </a:solidFill>
                 <a:latin typeface="Inter"/>
               </a:rPr>
-              <a:t>MxE4M3Fp4VpuGemminiRocketConfig · direct projections in both legal rows · two 8-lane BF16 VPUs.</a:t>
+              <a:t>resource supplies packed A/B codes + E8M0 scales. contract computes C[m,n] = Σk A[m,k]×B[k,n] in the selected PE mode; readout_bf16 returns BF16. VPU can do softmax; Radiance uses Muon SIMT.</a:t>
             </a:r>
           </a:p>
         </p:txBody>
@@ -19293,8 +18780,8 @@
         </p:nvSpPr>
         <p:spPr>
           <a:xfrm>
-            <a:off x="1051560" y="5312664"/>
-            <a:ext cx="5093208" cy="356616"/>
+            <a:off x="6382512" y="1664208"/>
+            <a:ext cx="4754880" cy="310896"/>
           </a:xfrm>
           <a:prstGeom prst="rect">
             <a:avLst/>
@@ -19316,69 +18803,27 @@
               </a:spcAft>
             </a:pPr>
             <a:r>
-              <a:rPr sz="1040" b="0">
-                <a:solidFill>
-                  <a:srgbClr val="5B5957"/>
-                </a:solidFill>
-                <a:latin typeface="Inter"/>
-              </a:rPr>
-              <a:t>RTL 266c593 + MxGen dba3e7 → 41 fragments / 40 SoC wrappers; each JSON stores source hashes.</a:t>
+              <a:rPr sz="1750" b="1">
+                <a:solidFill>
+                  <a:srgbClr val="103552"/>
+                </a:solidFill>
+                <a:latin typeface="Inter"/>
+              </a:rPr>
+              <a:t>Compiled attention object → binary</a:t>
             </a:r>
           </a:p>
         </p:txBody>
       </p:sp>
       <p:sp>
         <p:nvSpPr>
-          <p:cNvPr id="12" name="TextBox 11"/>
-          <p:cNvSpPr txBox="1"/>
-          <p:nvPr/>
-        </p:nvSpPr>
-        <p:spPr>
-          <a:xfrm>
-            <a:off x="6748272" y="1636776"/>
-            <a:ext cx="4370832" cy="310896"/>
-          </a:xfrm>
-          <a:prstGeom prst="rect">
-            <a:avLst/>
-          </a:prstGeom>
-          <a:noFill/>
-        </p:spPr>
-        <p:txBody>
-          <a:bodyPr wrap="square" lIns="18288" rIns="18288" tIns="9144" bIns="9144" anchor="ctr">
-            <a:spAutoFit/>
-          </a:bodyPr>
-          <a:lstStyle/>
-          <a:p>
-            <a:pPr algn="l">
-              <a:spcBef>
-                <a:spcPts val="0"/>
-              </a:spcBef>
-              <a:spcAft>
-                <a:spcPts val="0"/>
-              </a:spcAft>
-            </a:pPr>
-            <a:r>
-              <a:rPr sz="1720" b="1">
-                <a:solidFill>
-                  <a:srgbClr val="103552"/>
-                </a:solidFill>
-                <a:latin typeface="Inter"/>
-              </a:rPr>
-              <a:t>Before → after bind_profile</a:t>
-            </a:r>
-          </a:p>
-        </p:txBody>
-      </p:sp>
-      <p:sp>
-        <p:nvSpPr>
-          <p:cNvPr id="13" name="Rounded Rectangle 12"/>
+          <p:cNvPr id="12" name="Rounded Rectangle 11"/>
           <p:cNvSpPr/>
           <p:nvPr/>
         </p:nvSpPr>
         <p:spPr>
           <a:xfrm>
-            <a:off x="6748272" y="2029968"/>
-            <a:ext cx="4379976" cy="1499616"/>
+            <a:off x="6382512" y="2048256"/>
+            <a:ext cx="4754880" cy="1298448"/>
           </a:xfrm>
           <a:prstGeom prst="roundRect">
             <a:avLst/>
@@ -19419,58 +18864,40 @@
               </a:spcAft>
             </a:pPr>
             <a:r>
-              <a:rPr sz="1085">
+              <a:rPr sz="1030">
                 <a:solidFill>
                   <a:srgbClr val="6C3D80"/>
                 </a:solidFill>
                 <a:latin typeface="Liberation Mono"/>
               </a:rPr>
-              <a:t>before</a:t>
-            </a:r>
-            <a:r>
-              <a:rPr sz="1085">
+              <a:t>__asm__</a:t>
+            </a:r>
+            <a:r>
+              <a:rPr sz="1030">
                 <a:solidFill>
                   <a:srgbClr val="103552"/>
                 </a:solidFill>
                 <a:latin typeface="Liberation Mono"/>
               </a:rPr>
-              <a:t>: </a:t>
-            </a:r>
-            <a:r>
-              <a:rPr sz="1085">
+              <a:t> </a:t>
+            </a:r>
+            <a:r>
+              <a:rPr sz="1030">
                 <a:solidFill>
                   <a:srgbClr val="6C3D80"/>
                 </a:solidFill>
                 <a:latin typeface="Liberation Mono"/>
               </a:rPr>
-              <a:t>contract</a:t>
-            </a:r>
-            <a:r>
-              <a:rPr sz="1085">
+              <a:t>volatile</a:t>
+            </a:r>
+            <a:r>
+              <a:rPr sz="1030">
                 <a:solidFill>
                   <a:srgbClr val="103552"/>
                 </a:solidFill>
                 <a:latin typeface="Liberation Mono"/>
               </a:rPr>
-              <a:t> {format = </a:t>
-            </a:r>
-            <a:r>
-              <a:rPr sz="1085">
-                <a:solidFill>
-                  <a:srgbClr val="28704F"/>
-                </a:solidFill>
-                <a:latin typeface="Liberation Mono"/>
-              </a:rPr>
-              <a:t>"mxfp4"</a:t>
-            </a:r>
-            <a:r>
-              <a:rPr sz="1085">
-                <a:solidFill>
-                  <a:srgbClr val="103552"/>
-                </a:solidFill>
-                <a:latin typeface="Liberation Mono"/>
-              </a:rPr>
-              <a:t>}</a:t>
+              <a:t>(</a:t>
             </a:r>
           </a:p>
           <a:p>
@@ -19483,40 +18910,22 @@
               </a:spcAft>
             </a:pPr>
             <a:r>
-              <a:rPr sz="1085">
-                <a:solidFill>
-                  <a:srgbClr val="6C3D80"/>
+              <a:rPr sz="1030">
+                <a:solidFill>
+                  <a:srgbClr val="103552"/>
                 </a:solidFill>
                 <a:latin typeface="Liberation Mono"/>
               </a:rPr>
-              <a:t>after</a:t>
-            </a:r>
-            <a:r>
-              <a:rPr sz="1085">
-                <a:solidFill>
-                  <a:srgbClr val="103552"/>
+              <a:t>  </a:t>
+            </a:r>
+            <a:r>
+              <a:rPr sz="1030">
+                <a:solidFill>
+                  <a:srgbClr val="28704F"/>
                 </a:solidFill>
                 <a:latin typeface="Liberation Mono"/>
               </a:rPr>
-              <a:t>:  </a:t>
-            </a:r>
-            <a:r>
-              <a:rPr sz="1085">
-                <a:solidFill>
-                  <a:srgbClr val="6C3D80"/>
-                </a:solidFill>
-                <a:latin typeface="Liberation Mono"/>
-              </a:rPr>
-              <a:t>contract</a:t>
-            </a:r>
-            <a:r>
-              <a:rPr sz="1085">
-                <a:solidFill>
-                  <a:srgbClr val="103552"/>
-                </a:solidFill>
-                <a:latin typeface="Liberation Mono"/>
-              </a:rPr>
-              <a:t> {</a:t>
+              <a:t>".insn r 0x7b, 3, 2, x0, %0, %1"</a:t>
             </a:r>
           </a:p>
           <a:p>
@@ -19529,49 +18938,31 @@
               </a:spcAft>
             </a:pPr>
             <a:r>
-              <a:rPr sz="1085">
+              <a:rPr sz="1030">
                 <a:solidFill>
                   <a:srgbClr val="103552"/>
                 </a:solidFill>
                 <a:latin typeface="Liberation Mono"/>
               </a:rPr>
-              <a:t>  </a:t>
-            </a:r>
-            <a:r>
-              <a:rPr sz="1085">
-                <a:solidFill>
-                  <a:srgbClr val="6C3D80"/>
+              <a:t>  : : </a:t>
+            </a:r>
+            <a:r>
+              <a:rPr sz="1030">
+                <a:solidFill>
+                  <a:srgbClr val="28704F"/>
                 </a:solidFill>
                 <a:latin typeface="Liberation Mono"/>
               </a:rPr>
-              <a:t>activation_format</a:t>
-            </a:r>
-            <a:r>
-              <a:rPr sz="1085">
+              <a:t>"r"</a:t>
+            </a:r>
+            <a:r>
+              <a:rPr sz="1030">
                 <a:solidFill>
                   <a:srgbClr val="103552"/>
                 </a:solidFill>
                 <a:latin typeface="Liberation Mono"/>
               </a:rPr>
-              <a:t> = </a:t>
-            </a:r>
-            <a:r>
-              <a:rPr sz="1085">
-                <a:solidFill>
-                  <a:srgbClr val="28704F"/>
-                </a:solidFill>
-                <a:latin typeface="Liberation Mono"/>
-              </a:rPr>
-              <a:t>"fp4_e2m1"</a:t>
-            </a:r>
-            <a:r>
-              <a:rPr sz="1085">
-                <a:solidFill>
-                  <a:srgbClr val="103552"/>
-                </a:solidFill>
-                <a:latin typeface="Liberation Mono"/>
-              </a:rPr>
-              <a:t>,</a:t>
+              <a:t>(Q_IN),</a:t>
             </a:r>
           </a:p>
           <a:p>
@@ -19584,49 +18975,49 @@
               </a:spcAft>
             </a:pPr>
             <a:r>
-              <a:rPr sz="1085">
+              <a:rPr sz="1030">
                 <a:solidFill>
                   <a:srgbClr val="103552"/>
                 </a:solidFill>
                 <a:latin typeface="Liberation Mono"/>
               </a:rPr>
-              <a:t>  </a:t>
-            </a:r>
-            <a:r>
-              <a:rPr sz="1085">
-                <a:solidFill>
-                  <a:srgbClr val="6C3D80"/>
+              <a:t>      </a:t>
+            </a:r>
+            <a:r>
+              <a:rPr sz="1030">
+                <a:solidFill>
+                  <a:srgbClr val="28704F"/>
                 </a:solidFill>
                 <a:latin typeface="Liberation Mono"/>
               </a:rPr>
-              <a:t>weight_format</a:t>
-            </a:r>
-            <a:r>
-              <a:rPr sz="1085">
+              <a:t>"r"</a:t>
+            </a:r>
+            <a:r>
+              <a:rPr sz="1030">
                 <a:solidFill>
                   <a:srgbClr val="103552"/>
                 </a:solidFill>
                 <a:latin typeface="Liberation Mono"/>
               </a:rPr>
-              <a:t> = </a:t>
-            </a:r>
-            <a:r>
-              <a:rPr sz="1085">
-                <a:solidFill>
-                  <a:srgbClr val="28704F"/>
+              <a:t>(</a:t>
+            </a:r>
+            <a:r>
+              <a:rPr sz="1030">
+                <a:solidFill>
+                  <a:srgbClr val="A44F25"/>
                 </a:solidFill>
                 <a:latin typeface="Liberation Mono"/>
               </a:rPr>
-              <a:t>"fp4_e2m1"</a:t>
-            </a:r>
-            <a:r>
-              <a:rPr sz="1085">
+              <a:t>0x0010001000000000</a:t>
+            </a:r>
+            <a:r>
+              <a:rPr sz="1030">
                 <a:solidFill>
                   <a:srgbClr val="103552"/>
                 </a:solidFill>
                 <a:latin typeface="Liberation Mono"/>
               </a:rPr>
-              <a:t>,</a:t>
+              <a:t>));</a:t>
             </a:r>
           </a:p>
           <a:p>
@@ -19639,118 +19030,63 @@
               </a:spcAft>
             </a:pPr>
             <a:r>
-              <a:rPr sz="1085">
+              <a:rPr sz="1030">
+                <a:solidFill>
+                  <a:srgbClr val="6C3D80"/>
+                </a:solidFill>
+                <a:latin typeface="Liberation Mono"/>
+              </a:rPr>
+              <a:t>objdump</a:t>
+            </a:r>
+            <a:r>
+              <a:rPr sz="1030">
                 <a:solidFill>
                   <a:srgbClr val="103552"/>
                 </a:solidFill>
                 <a:latin typeface="Liberation Mono"/>
               </a:rPr>
-              <a:t>  </a:t>
-            </a:r>
-            <a:r>
-              <a:rPr sz="1085">
-                <a:solidFill>
-                  <a:srgbClr val="6C3D80"/>
+              <a:t>: 4a: 04b6b07b  .insn </a:t>
+            </a:r>
+            <a:r>
+              <a:rPr sz="1030">
+                <a:solidFill>
+                  <a:srgbClr val="A44F25"/>
                 </a:solidFill>
                 <a:latin typeface="Liberation Mono"/>
               </a:rPr>
-              <a:t>pe_mode</a:t>
-            </a:r>
-            <a:r>
-              <a:rPr sz="1085">
+              <a:t>4</a:t>
+            </a:r>
+            <a:r>
+              <a:rPr sz="1030">
                 <a:solidFill>
                   <a:srgbClr val="103552"/>
                 </a:solidFill>
                 <a:latin typeface="Liberation Mono"/>
               </a:rPr>
-              <a:t> = </a:t>
-            </a:r>
-            <a:r>
-              <a:rPr sz="1085">
+              <a:t>, </a:t>
+            </a:r>
+            <a:r>
+              <a:rPr sz="1030">
                 <a:solidFill>
                   <a:srgbClr val="A44F25"/>
                 </a:solidFill>
                 <a:latin typeface="Liberation Mono"/>
               </a:rPr>
-              <a:t>0</a:t>
-            </a:r>
-            <a:r>
-              <a:rPr sz="1085">
-                <a:solidFill>
-                  <a:srgbClr val="103552"/>
-                </a:solidFill>
-                <a:latin typeface="Liberation Mono"/>
-              </a:rPr>
-              <a:t> : i32,</a:t>
-            </a:r>
-          </a:p>
-          <a:p>
-            <a:pPr algn="l">
-              <a:spcBef>
-                <a:spcPts val="0"/>
-              </a:spcBef>
-              <a:spcAft>
-                <a:spcPts val="0"/>
-              </a:spcAft>
-            </a:pPr>
-            <a:r>
-              <a:rPr sz="1085">
-                <a:solidFill>
-                  <a:srgbClr val="103552"/>
-                </a:solidFill>
-                <a:latin typeface="Liberation Mono"/>
-              </a:rPr>
-              <a:t>  </a:t>
-            </a:r>
-            <a:r>
-              <a:rPr sz="1085">
-                <a:solidFill>
-                  <a:srgbClr val="6C3D80"/>
-                </a:solidFill>
-                <a:latin typeface="Liberation Mono"/>
-              </a:rPr>
-              <a:t>profile_sha256</a:t>
-            </a:r>
-            <a:r>
-              <a:rPr sz="1085">
-                <a:solidFill>
-                  <a:srgbClr val="103552"/>
-                </a:solidFill>
-                <a:latin typeface="Liberation Mono"/>
-              </a:rPr>
-              <a:t> = </a:t>
-            </a:r>
-            <a:r>
-              <a:rPr sz="1085">
-                <a:solidFill>
-                  <a:srgbClr val="28704F"/>
-                </a:solidFill>
-                <a:latin typeface="Liberation Mono"/>
-              </a:rPr>
-              <a:t>"e9e33f..."</a:t>
-            </a:r>
-            <a:r>
-              <a:rPr sz="1085">
-                <a:solidFill>
-                  <a:srgbClr val="103552"/>
-                </a:solidFill>
-                <a:latin typeface="Liberation Mono"/>
-              </a:rPr>
-              <a:t> }</a:t>
+              <a:t>0x04b6b07b</a:t>
             </a:r>
           </a:p>
         </p:txBody>
       </p:sp>
       <p:sp>
         <p:nvSpPr>
-          <p:cNvPr id="14" name="TextBox 13"/>
+          <p:cNvPr id="13" name="TextBox 12"/>
           <p:cNvSpPr txBox="1"/>
           <p:nvPr/>
         </p:nvSpPr>
         <p:spPr>
           <a:xfrm>
-            <a:off x="6748272" y="3712463"/>
-            <a:ext cx="4370832" cy="274320"/>
+            <a:off x="6382512" y="3493008"/>
+            <a:ext cx="4727448" cy="548640"/>
           </a:xfrm>
           <a:prstGeom prst="rect">
             <a:avLst/>
@@ -19772,27 +19108,27 @@
               </a:spcAft>
             </a:pPr>
             <a:r>
-              <a:rPr sz="1410" b="1">
-                <a:solidFill>
-                  <a:srgbClr val="103552"/>
-                </a:solidFill>
-                <a:latin typeface="Inter"/>
-              </a:rPr>
-              <a:t>Compiler consequences</a:t>
+              <a:rPr sz="1100" b="0">
+                <a:solidFill>
+                  <a:srgbClr val="313455"/>
+                </a:solidFill>
+                <a:latin typeface="Inter"/>
+              </a:rPr>
+              <a:t>physical_program orders mvin → compute → VPU → mvout. RoCC C + data asm → RV64 GCC → ELF → Nicolas Spike.</a:t>
             </a:r>
           </a:p>
         </p:txBody>
       </p:sp>
       <p:sp>
         <p:nvSpPr>
-          <p:cNvPr id="15" name="TextBox 14"/>
+          <p:cNvPr id="14" name="TextBox 13"/>
           <p:cNvSpPr txBox="1"/>
           <p:nvPr/>
         </p:nvSpPr>
         <p:spPr>
           <a:xfrm>
-            <a:off x="6748272" y="4041648"/>
-            <a:ext cx="4370832" cy="1481328"/>
+            <a:off x="877824" y="4352544"/>
+            <a:ext cx="10424160" cy="274320"/>
           </a:xfrm>
           <a:prstGeom prst="rect">
             <a:avLst/>
@@ -19814,109 +19150,59 @@
               </a:spcAft>
             </a:pPr>
             <a:r>
-              <a:rPr sz="1100" b="0">
-                <a:solidFill>
-                  <a:srgbClr val="313455"/>
-                </a:solidFill>
-                <a:latin typeface="Inter"/>
-              </a:rPr>
-              <a:t>• TinyLlama: 155 FP4 / 45 FP8 MX sites per stage.</a:t>
-            </a:r>
-          </a:p>
-          <a:p>
-            <a:pPr algn="l">
-              <a:spcBef>
-                <a:spcPts val="0"/>
-              </a:spcBef>
-              <a:spcAft>
-                <a:spcPts val="0"/>
-              </a:spcAft>
-            </a:pPr>
-            <a:r>
-              <a:rPr sz="1100" b="0">
-                <a:solidFill>
-                  <a:srgbClr val="313455"/>
-                </a:solidFill>
-                <a:latin typeface="Inter"/>
-              </a:rPr>
-              <a:t>• PE 0 = direct FP4 × FP4; PE 8 = direct FP8 × FP8.</a:t>
-            </a:r>
-          </a:p>
-          <a:p>
-            <a:pPr algn="l">
-              <a:spcBef>
-                <a:spcPts val="0"/>
-              </a:spcBef>
-              <a:spcAft>
-                <a:spcPts val="0"/>
-              </a:spcAft>
-            </a:pPr>
-            <a:r>
-              <a:rPr sz="1100" b="0">
-                <a:solidFill>
-                  <a:srgbClr val="313455"/>
-                </a:solidFill>
-                <a:latin typeface="Inter"/>
-              </a:rPr>
-              <a:t>• 256 KiB SPAD caps tiles; VPU/requant legal.</a:t>
-            </a:r>
-          </a:p>
-          <a:p>
-            <a:pPr algn="l">
-              <a:spcBef>
-                <a:spcPts val="0"/>
-              </a:spcBef>
-              <a:spcAft>
-                <a:spcPts val="0"/>
-              </a:spcAft>
-            </a:pPr>
-            <a:r>
-              <a:rPr sz="1100" b="0">
-                <a:solidFill>
-                  <a:srgbClr val="313455"/>
-                </a:solidFill>
-                <a:latin typeface="Inter"/>
-              </a:rPr>
-              <a:t>• Selected profile: no operand LUT or FP6.</a:t>
-            </a:r>
-          </a:p>
-          <a:p>
-            <a:pPr algn="l">
-              <a:spcBef>
-                <a:spcPts val="0"/>
-              </a:spcBef>
-              <a:spcAft>
-                <a:spcPts val="0"/>
-              </a:spcAft>
-            </a:pPr>
-            <a:r>
-              <a:rPr sz="1100" b="0">
-                <a:solidFill>
-                  <a:srgbClr val="313455"/>
-                </a:solidFill>
-                <a:latin typeface="Inter"/>
-              </a:rPr>
-              <a:t>• FP6×FP4 profile: E3M2 LUT × FP4 direct → PE 3; VPU off.</a:t>
-            </a:r>
-          </a:p>
-          <a:p>
-            <a:pPr algn="l">
-              <a:spcBef>
-                <a:spcPts val="0"/>
-              </a:spcBef>
-              <a:spcAft>
-                <a:spcPts val="0"/>
-              </a:spcAft>
-            </a:pPr>
-            <a:r>
-              <a:rPr sz="1100" b="0">
-                <a:solidFill>
-                  <a:srgbClr val="313455"/>
-                </a:solidFill>
-                <a:latin typeface="Inter"/>
-              </a:rPr>
-              <a:t>• load_profile(profile, rtl_root=rtl) rejects drift.</a:t>
-            </a:r>
+              <a:rPr sz="1600" b="1">
+                <a:solidFill>
+                  <a:srgbClr val="103552"/>
+                </a:solidFill>
+                <a:latin typeface="Inter"/>
+              </a:rPr>
+              <a:t>Implemented transforms and checks</a:t>
+            </a:r>
+          </a:p>
+        </p:txBody>
+      </p:sp>
+      <p:sp>
+        <p:nvSpPr>
+          <p:cNvPr id="15" name="Rounded Rectangle 14"/>
+          <p:cNvSpPr/>
+          <p:nvPr/>
+        </p:nvSpPr>
+        <p:spPr>
+          <a:xfrm>
+            <a:off x="859536" y="4709160"/>
+            <a:ext cx="1965960" cy="987552"/>
+          </a:xfrm>
+          <a:prstGeom prst="roundRect">
+            <a:avLst/>
+          </a:prstGeom>
+          <a:solidFill>
+            <a:srgbClr val="FDF8F1"/>
+          </a:solidFill>
+          <a:ln>
+            <a:solidFill>
+              <a:srgbClr val="B0A597"/>
+            </a:solidFill>
+          </a:ln>
+        </p:spPr>
+        <p:style>
+          <a:lnRef idx="1">
+            <a:schemeClr val="accent1"/>
+          </a:lnRef>
+          <a:fillRef idx="3">
+            <a:schemeClr val="accent1"/>
+          </a:fillRef>
+          <a:effectRef idx="2">
+            <a:schemeClr val="accent1"/>
+          </a:effectRef>
+          <a:fontRef idx="minor">
+            <a:schemeClr val="lt1"/>
+          </a:fontRef>
+        </p:style>
+        <p:txBody>
+          <a:bodyPr rtlCol="0" anchor="ctr"/>
+          <a:lstStyle/>
+          <a:p>
+            <a:pPr algn="ctr"/>
           </a:p>
         </p:txBody>
       </p:sp>
@@ -19928,8 +19214,8 @@
         </p:nvSpPr>
         <p:spPr>
           <a:xfrm>
-            <a:off x="877824" y="5943600"/>
-            <a:ext cx="10469880" cy="228600"/>
+            <a:off x="950976" y="4800600"/>
+            <a:ext cx="1783080" cy="338328"/>
           </a:xfrm>
           <a:prstGeom prst="rect">
             <a:avLst/>
@@ -19942,7 +19228,7 @@
           </a:bodyPr>
           <a:lstStyle/>
           <a:p>
-            <a:pPr algn="l">
+            <a:pPr algn="ctr">
               <a:spcBef>
                 <a:spcPts val="0"/>
               </a:spcBef>
@@ -19951,13 +19237,13 @@
               </a:spcAft>
             </a:pPr>
             <a:r>
-              <a:rPr sz="1019" b="0">
-                <a:solidFill>
-                  <a:srgbClr val="5B5957"/>
-                </a:solidFill>
-                <a:latin typeface="Inter"/>
-              </a:rPr>
-              <a:t>npu-exploration supplies source kernels for per-mode Spike checks; the RTL profile alone is structural, not a performance claim.</a:t>
+              <a:rPr sz="1170" b="1">
+                <a:solidFill>
+                  <a:srgbClr val="103552"/>
+                </a:solidFill>
+                <a:latin typeface="Inter"/>
+              </a:rPr>
+              <a:t>bind_profile</a:t>
             </a:r>
           </a:p>
         </p:txBody>
@@ -19965,6 +19251,720 @@
       <p:sp>
         <p:nvSpPr>
           <p:cNvPr id="17" name="TextBox 16"/>
+          <p:cNvSpPr txBox="1"/>
+          <p:nvPr/>
+        </p:nvSpPr>
+        <p:spPr>
+          <a:xfrm>
+            <a:off x="950976" y="5230368"/>
+            <a:ext cx="1783080" cy="365760"/>
+          </a:xfrm>
+          <a:prstGeom prst="rect">
+            <a:avLst/>
+          </a:prstGeom>
+          <a:noFill/>
+        </p:spPr>
+        <p:txBody>
+          <a:bodyPr wrap="square" lIns="18288" rIns="18288" tIns="9144" bIns="9144" anchor="ctr">
+            <a:spAutoFit/>
+          </a:bodyPr>
+          <a:lstStyle/>
+          <a:p>
+            <a:pPr algn="ctr">
+              <a:spcBef>
+                <a:spcPts val="0"/>
+              </a:spcBef>
+              <a:spcAft>
+                <a:spcPts val="0"/>
+              </a:spcAft>
+            </a:pPr>
+            <a:r>
+              <a:rPr sz="1080" b="0">
+                <a:solidFill>
+                  <a:srgbClr val="313455"/>
+                </a:solidFill>
+                <a:latin typeface="Inter"/>
+              </a:rPr>
+              <a:t>Legal PE tuple +</a:t>
+            </a:r>
+          </a:p>
+          <a:p>
+            <a:pPr algn="ctr">
+              <a:spcBef>
+                <a:spcPts val="0"/>
+              </a:spcBef>
+              <a:spcAft>
+                <a:spcPts val="0"/>
+              </a:spcAft>
+            </a:pPr>
+            <a:r>
+              <a:rPr sz="1080" b="0">
+                <a:solidFill>
+                  <a:srgbClr val="313455"/>
+                </a:solidFill>
+                <a:latin typeface="Inter"/>
+              </a:rPr>
+              <a:t>profile digest</a:t>
+            </a:r>
+          </a:p>
+        </p:txBody>
+      </p:sp>
+      <p:sp>
+        <p:nvSpPr>
+          <p:cNvPr id="18" name="Rounded Rectangle 17"/>
+          <p:cNvSpPr/>
+          <p:nvPr/>
+        </p:nvSpPr>
+        <p:spPr>
+          <a:xfrm>
+            <a:off x="2999232" y="4709160"/>
+            <a:ext cx="1965960" cy="987552"/>
+          </a:xfrm>
+          <a:prstGeom prst="roundRect">
+            <a:avLst/>
+          </a:prstGeom>
+          <a:solidFill>
+            <a:srgbClr val="E1E8EC"/>
+          </a:solidFill>
+          <a:ln>
+            <a:solidFill>
+              <a:srgbClr val="B0A597"/>
+            </a:solidFill>
+          </a:ln>
+        </p:spPr>
+        <p:style>
+          <a:lnRef idx="1">
+            <a:schemeClr val="accent1"/>
+          </a:lnRef>
+          <a:fillRef idx="3">
+            <a:schemeClr val="accent1"/>
+          </a:fillRef>
+          <a:effectRef idx="2">
+            <a:schemeClr val="accent1"/>
+          </a:effectRef>
+          <a:fontRef idx="minor">
+            <a:schemeClr val="lt1"/>
+          </a:fontRef>
+        </p:style>
+        <p:txBody>
+          <a:bodyPr rtlCol="0" anchor="ctr"/>
+          <a:lstStyle/>
+          <a:p>
+            <a:pPr algn="ctr"/>
+          </a:p>
+        </p:txBody>
+      </p:sp>
+      <p:sp>
+        <p:nvSpPr>
+          <p:cNvPr id="19" name="TextBox 18"/>
+          <p:cNvSpPr txBox="1"/>
+          <p:nvPr/>
+        </p:nvSpPr>
+        <p:spPr>
+          <a:xfrm>
+            <a:off x="3090672" y="4800600"/>
+            <a:ext cx="1783080" cy="338328"/>
+          </a:xfrm>
+          <a:prstGeom prst="rect">
+            <a:avLst/>
+          </a:prstGeom>
+          <a:noFill/>
+        </p:spPr>
+        <p:txBody>
+          <a:bodyPr wrap="square" lIns="18288" rIns="18288" tIns="9144" bIns="9144" anchor="ctr">
+            <a:spAutoFit/>
+          </a:bodyPr>
+          <a:lstStyle/>
+          <a:p>
+            <a:pPr algn="ctr">
+              <a:spcBef>
+                <a:spcPts val="0"/>
+              </a:spcBef>
+              <a:spcAft>
+                <a:spcPts val="0"/>
+              </a:spcAft>
+            </a:pPr>
+            <a:r>
+              <a:rPr sz="1170" b="1">
+                <a:solidFill>
+                  <a:srgbClr val="103552"/>
+                </a:solidFill>
+                <a:latin typeface="Inter"/>
+              </a:rPr>
+              <a:t>MXBF16Catalog</a:t>
+            </a:r>
+          </a:p>
+          <a:p>
+            <a:pPr algn="ctr">
+              <a:spcBef>
+                <a:spcPts val="0"/>
+              </a:spcBef>
+              <a:spcAft>
+                <a:spcPts val="0"/>
+              </a:spcAft>
+            </a:pPr>
+            <a:r>
+              <a:rPr sz="1170" b="1">
+                <a:solidFill>
+                  <a:srgbClr val="103552"/>
+                </a:solidFill>
+                <a:latin typeface="Inter"/>
+              </a:rPr>
+              <a:t>Preparation</a:t>
+            </a:r>
+          </a:p>
+        </p:txBody>
+      </p:sp>
+      <p:sp>
+        <p:nvSpPr>
+          <p:cNvPr id="20" name="TextBox 19"/>
+          <p:cNvSpPr txBox="1"/>
+          <p:nvPr/>
+        </p:nvSpPr>
+        <p:spPr>
+          <a:xfrm>
+            <a:off x="3090672" y="5230368"/>
+            <a:ext cx="1783080" cy="365760"/>
+          </a:xfrm>
+          <a:prstGeom prst="rect">
+            <a:avLst/>
+          </a:prstGeom>
+          <a:noFill/>
+        </p:spPr>
+        <p:txBody>
+          <a:bodyPr wrap="square" lIns="18288" rIns="18288" tIns="9144" bIns="9144" anchor="ctr">
+            <a:spAutoFit/>
+          </a:bodyPr>
+          <a:lstStyle/>
+          <a:p>
+            <a:pPr algn="ctr">
+              <a:spcBef>
+                <a:spcPts val="0"/>
+              </a:spcBef>
+              <a:spcAft>
+                <a:spcPts val="0"/>
+              </a:spcAft>
+            </a:pPr>
+            <a:r>
+              <a:rPr sz="1080" b="0">
+                <a:solidFill>
+                  <a:srgbClr val="313455"/>
+                </a:solidFill>
+                <a:latin typeface="Inter"/>
+              </a:rPr>
+              <a:t>Select BF16</a:t>
+            </a:r>
+          </a:p>
+          <a:p>
+            <a:pPr algn="ctr">
+              <a:spcBef>
+                <a:spcPts val="0"/>
+              </a:spcBef>
+              <a:spcAft>
+                <a:spcPts val="0"/>
+              </a:spcAft>
+            </a:pPr>
+            <a:r>
+              <a:rPr sz="1080" b="0">
+                <a:solidFill>
+                  <a:srgbClr val="313455"/>
+                </a:solidFill>
+                <a:latin typeface="Inter"/>
+              </a:rPr>
+              <a:t>MX sites</a:t>
+            </a:r>
+          </a:p>
+        </p:txBody>
+      </p:sp>
+      <p:sp>
+        <p:nvSpPr>
+          <p:cNvPr id="21" name="Rounded Rectangle 20"/>
+          <p:cNvSpPr/>
+          <p:nvPr/>
+        </p:nvSpPr>
+        <p:spPr>
+          <a:xfrm>
+            <a:off x="5138927" y="4709160"/>
+            <a:ext cx="1965960" cy="987552"/>
+          </a:xfrm>
+          <a:prstGeom prst="roundRect">
+            <a:avLst/>
+          </a:prstGeom>
+          <a:solidFill>
+            <a:srgbClr val="FDF8F1"/>
+          </a:solidFill>
+          <a:ln>
+            <a:solidFill>
+              <a:srgbClr val="B0A597"/>
+            </a:solidFill>
+          </a:ln>
+        </p:spPr>
+        <p:style>
+          <a:lnRef idx="1">
+            <a:schemeClr val="accent1"/>
+          </a:lnRef>
+          <a:fillRef idx="3">
+            <a:schemeClr val="accent1"/>
+          </a:fillRef>
+          <a:effectRef idx="2">
+            <a:schemeClr val="accent1"/>
+          </a:effectRef>
+          <a:fontRef idx="minor">
+            <a:schemeClr val="lt1"/>
+          </a:fontRef>
+        </p:style>
+        <p:txBody>
+          <a:bodyPr rtlCol="0" anchor="ctr"/>
+          <a:lstStyle/>
+          <a:p>
+            <a:pPr algn="ctr"/>
+          </a:p>
+        </p:txBody>
+      </p:sp>
+      <p:sp>
+        <p:nvSpPr>
+          <p:cNvPr id="22" name="TextBox 21"/>
+          <p:cNvSpPr txBox="1"/>
+          <p:nvPr/>
+        </p:nvSpPr>
+        <p:spPr>
+          <a:xfrm>
+            <a:off x="5230367" y="4800600"/>
+            <a:ext cx="1783080" cy="338328"/>
+          </a:xfrm>
+          <a:prstGeom prst="rect">
+            <a:avLst/>
+          </a:prstGeom>
+          <a:noFill/>
+        </p:spPr>
+        <p:txBody>
+          <a:bodyPr wrap="square" lIns="18288" rIns="18288" tIns="9144" bIns="9144" anchor="ctr">
+            <a:spAutoFit/>
+          </a:bodyPr>
+          <a:lstStyle/>
+          <a:p>
+            <a:pPr algn="ctr">
+              <a:spcBef>
+                <a:spcPts val="0"/>
+              </a:spcBef>
+              <a:spcAft>
+                <a:spcPts val="0"/>
+              </a:spcAft>
+            </a:pPr>
+            <a:r>
+              <a:rPr sz="1170" b="1">
+                <a:solidFill>
+                  <a:srgbClr val="103552"/>
+                </a:solidFill>
+                <a:latin typeface="Inter"/>
+              </a:rPr>
+              <a:t>schedule.plan</a:t>
+            </a:r>
+          </a:p>
+        </p:txBody>
+      </p:sp>
+      <p:sp>
+        <p:nvSpPr>
+          <p:cNvPr id="23" name="TextBox 22"/>
+          <p:cNvSpPr txBox="1"/>
+          <p:nvPr/>
+        </p:nvSpPr>
+        <p:spPr>
+          <a:xfrm>
+            <a:off x="5230367" y="5230368"/>
+            <a:ext cx="1783080" cy="365760"/>
+          </a:xfrm>
+          <a:prstGeom prst="rect">
+            <a:avLst/>
+          </a:prstGeom>
+          <a:noFill/>
+        </p:spPr>
+        <p:txBody>
+          <a:bodyPr wrap="square" lIns="18288" rIns="18288" tIns="9144" bIns="9144" anchor="ctr">
+            <a:spAutoFit/>
+          </a:bodyPr>
+          <a:lstStyle/>
+          <a:p>
+            <a:pPr algn="ctr">
+              <a:spcBef>
+                <a:spcPts val="0"/>
+              </a:spcBef>
+              <a:spcAft>
+                <a:spcPts val="0"/>
+              </a:spcAft>
+            </a:pPr>
+            <a:r>
+              <a:rPr sz="1080" b="0">
+                <a:solidFill>
+                  <a:srgbClr val="313455"/>
+                </a:solidFill>
+                <a:latin typeface="Inter"/>
+              </a:rPr>
+              <a:t>Choose native</a:t>
+            </a:r>
+          </a:p>
+          <a:p>
+            <a:pPr algn="ctr">
+              <a:spcBef>
+                <a:spcPts val="0"/>
+              </a:spcBef>
+              <a:spcAft>
+                <a:spcPts val="0"/>
+              </a:spcAft>
+            </a:pPr>
+            <a:r>
+              <a:rPr sz="1080" b="0">
+                <a:solidFill>
+                  <a:srgbClr val="313455"/>
+                </a:solidFill>
+                <a:latin typeface="Inter"/>
+              </a:rPr>
+              <a:t>loop policy</a:t>
+            </a:r>
+          </a:p>
+        </p:txBody>
+      </p:sp>
+      <p:sp>
+        <p:nvSpPr>
+          <p:cNvPr id="24" name="Rounded Rectangle 23"/>
+          <p:cNvSpPr/>
+          <p:nvPr/>
+        </p:nvSpPr>
+        <p:spPr>
+          <a:xfrm>
+            <a:off x="7278623" y="4709160"/>
+            <a:ext cx="1965960" cy="987552"/>
+          </a:xfrm>
+          <a:prstGeom prst="roundRect">
+            <a:avLst/>
+          </a:prstGeom>
+          <a:solidFill>
+            <a:srgbClr val="E5E7DA"/>
+          </a:solidFill>
+          <a:ln>
+            <a:solidFill>
+              <a:srgbClr val="B0A597"/>
+            </a:solidFill>
+          </a:ln>
+        </p:spPr>
+        <p:style>
+          <a:lnRef idx="1">
+            <a:schemeClr val="accent1"/>
+          </a:lnRef>
+          <a:fillRef idx="3">
+            <a:schemeClr val="accent1"/>
+          </a:fillRef>
+          <a:effectRef idx="2">
+            <a:schemeClr val="accent1"/>
+          </a:effectRef>
+          <a:fontRef idx="minor">
+            <a:schemeClr val="lt1"/>
+          </a:fontRef>
+        </p:style>
+        <p:txBody>
+          <a:bodyPr rtlCol="0" anchor="ctr"/>
+          <a:lstStyle/>
+          <a:p>
+            <a:pPr algn="ctr"/>
+          </a:p>
+        </p:txBody>
+      </p:sp>
+      <p:sp>
+        <p:nvSpPr>
+          <p:cNvPr id="25" name="TextBox 24"/>
+          <p:cNvSpPr txBox="1"/>
+          <p:nvPr/>
+        </p:nvSpPr>
+        <p:spPr>
+          <a:xfrm>
+            <a:off x="7370063" y="4800600"/>
+            <a:ext cx="1783080" cy="338328"/>
+          </a:xfrm>
+          <a:prstGeom prst="rect">
+            <a:avLst/>
+          </a:prstGeom>
+          <a:noFill/>
+        </p:spPr>
+        <p:txBody>
+          <a:bodyPr wrap="square" lIns="18288" rIns="18288" tIns="9144" bIns="9144" anchor="ctr">
+            <a:spAutoFit/>
+          </a:bodyPr>
+          <a:lstStyle/>
+          <a:p>
+            <a:pPr algn="ctr">
+              <a:spcBef>
+                <a:spcPts val="0"/>
+              </a:spcBef>
+              <a:spcAft>
+                <a:spcPts val="0"/>
+              </a:spcAft>
+            </a:pPr>
+            <a:r>
+              <a:rPr sz="1170" b="1">
+                <a:solidFill>
+                  <a:srgbClr val="103552"/>
+                </a:solidFill>
+                <a:latin typeface="Inter"/>
+              </a:rPr>
+              <a:t>MXVPUPostOffload</a:t>
+            </a:r>
+          </a:p>
+        </p:txBody>
+      </p:sp>
+      <p:sp>
+        <p:nvSpPr>
+          <p:cNvPr id="26" name="TextBox 25"/>
+          <p:cNvSpPr txBox="1"/>
+          <p:nvPr/>
+        </p:nvSpPr>
+        <p:spPr>
+          <a:xfrm>
+            <a:off x="7370063" y="5230368"/>
+            <a:ext cx="1783080" cy="365760"/>
+          </a:xfrm>
+          <a:prstGeom prst="rect">
+            <a:avLst/>
+          </a:prstGeom>
+          <a:noFill/>
+        </p:spPr>
+        <p:txBody>
+          <a:bodyPr wrap="square" lIns="18288" rIns="18288" tIns="9144" bIns="9144" anchor="ctr">
+            <a:spAutoFit/>
+          </a:bodyPr>
+          <a:lstStyle/>
+          <a:p>
+            <a:pPr algn="ctr">
+              <a:spcBef>
+                <a:spcPts val="0"/>
+              </a:spcBef>
+              <a:spcAft>
+                <a:spcPts val="0"/>
+              </a:spcAft>
+            </a:pPr>
+            <a:r>
+              <a:rPr sz="1080" b="0">
+                <a:solidFill>
+                  <a:srgbClr val="313455"/>
+                </a:solidFill>
+                <a:latin typeface="Inter"/>
+              </a:rPr>
+              <a:t>Map softmax, add</a:t>
+            </a:r>
+          </a:p>
+          <a:p>
+            <a:pPr algn="ctr">
+              <a:spcBef>
+                <a:spcPts val="0"/>
+              </a:spcBef>
+              <a:spcAft>
+                <a:spcPts val="0"/>
+              </a:spcAft>
+            </a:pPr>
+            <a:r>
+              <a:rPr sz="1080" b="0">
+                <a:solidFill>
+                  <a:srgbClr val="313455"/>
+                </a:solidFill>
+                <a:latin typeface="Inter"/>
+              </a:rPr>
+              <a:t>and reductions</a:t>
+            </a:r>
+          </a:p>
+        </p:txBody>
+      </p:sp>
+      <p:sp>
+        <p:nvSpPr>
+          <p:cNvPr id="27" name="Rounded Rectangle 26"/>
+          <p:cNvSpPr/>
+          <p:nvPr/>
+        </p:nvSpPr>
+        <p:spPr>
+          <a:xfrm>
+            <a:off x="9418319" y="4709160"/>
+            <a:ext cx="1965960" cy="987552"/>
+          </a:xfrm>
+          <a:prstGeom prst="roundRect">
+            <a:avLst/>
+          </a:prstGeom>
+          <a:solidFill>
+            <a:srgbClr val="FDF8F1"/>
+          </a:solidFill>
+          <a:ln>
+            <a:solidFill>
+              <a:srgbClr val="B0A597"/>
+            </a:solidFill>
+          </a:ln>
+        </p:spPr>
+        <p:style>
+          <a:lnRef idx="1">
+            <a:schemeClr val="accent1"/>
+          </a:lnRef>
+          <a:fillRef idx="3">
+            <a:schemeClr val="accent1"/>
+          </a:fillRef>
+          <a:effectRef idx="2">
+            <a:schemeClr val="accent1"/>
+          </a:effectRef>
+          <a:fontRef idx="minor">
+            <a:schemeClr val="lt1"/>
+          </a:fontRef>
+        </p:style>
+        <p:txBody>
+          <a:bodyPr rtlCol="0" anchor="ctr"/>
+          <a:lstStyle/>
+          <a:p>
+            <a:pPr algn="ctr"/>
+          </a:p>
+        </p:txBody>
+      </p:sp>
+      <p:sp>
+        <p:nvSpPr>
+          <p:cNvPr id="28" name="TextBox 27"/>
+          <p:cNvSpPr txBox="1"/>
+          <p:nvPr/>
+        </p:nvSpPr>
+        <p:spPr>
+          <a:xfrm>
+            <a:off x="9509759" y="4800600"/>
+            <a:ext cx="1783080" cy="338328"/>
+          </a:xfrm>
+          <a:prstGeom prst="rect">
+            <a:avLst/>
+          </a:prstGeom>
+          <a:noFill/>
+        </p:spPr>
+        <p:txBody>
+          <a:bodyPr wrap="square" lIns="18288" rIns="18288" tIns="9144" bIns="9144" anchor="ctr">
+            <a:spAutoFit/>
+          </a:bodyPr>
+          <a:lstStyle/>
+          <a:p>
+            <a:pPr algn="ctr">
+              <a:spcBef>
+                <a:spcPts val="0"/>
+              </a:spcBef>
+              <a:spcAft>
+                <a:spcPts val="0"/>
+              </a:spcAft>
+            </a:pPr>
+            <a:r>
+              <a:rPr sz="1170" b="1">
+                <a:solidFill>
+                  <a:srgbClr val="103552"/>
+                </a:solidFill>
+                <a:latin typeface="Inter"/>
+              </a:rPr>
+              <a:t>physical_program</a:t>
+            </a:r>
+          </a:p>
+        </p:txBody>
+      </p:sp>
+      <p:sp>
+        <p:nvSpPr>
+          <p:cNvPr id="29" name="TextBox 28"/>
+          <p:cNvSpPr txBox="1"/>
+          <p:nvPr/>
+        </p:nvSpPr>
+        <p:spPr>
+          <a:xfrm>
+            <a:off x="9509759" y="5230368"/>
+            <a:ext cx="1783080" cy="365760"/>
+          </a:xfrm>
+          <a:prstGeom prst="rect">
+            <a:avLst/>
+          </a:prstGeom>
+          <a:noFill/>
+        </p:spPr>
+        <p:txBody>
+          <a:bodyPr wrap="square" lIns="18288" rIns="18288" tIns="9144" bIns="9144" anchor="ctr">
+            <a:spAutoFit/>
+          </a:bodyPr>
+          <a:lstStyle/>
+          <a:p>
+            <a:pPr algn="ctr">
+              <a:spcBef>
+                <a:spcPts val="0"/>
+              </a:spcBef>
+              <a:spcAft>
+                <a:spcPts val="0"/>
+              </a:spcAft>
+            </a:pPr>
+            <a:r>
+              <a:rPr sz="1080" b="0">
+                <a:solidFill>
+                  <a:srgbClr val="313455"/>
+                </a:solidFill>
+                <a:latin typeface="Inter"/>
+              </a:rPr>
+              <a:t>Order DMA, compute</a:t>
+            </a:r>
+          </a:p>
+          <a:p>
+            <a:pPr algn="ctr">
+              <a:spcBef>
+                <a:spcPts val="0"/>
+              </a:spcBef>
+              <a:spcAft>
+                <a:spcPts val="0"/>
+              </a:spcAft>
+            </a:pPr>
+            <a:r>
+              <a:rPr sz="1080" b="0">
+                <a:solidFill>
+                  <a:srgbClr val="313455"/>
+                </a:solidFill>
+                <a:latin typeface="Inter"/>
+              </a:rPr>
+              <a:t>and VPU commands</a:t>
+            </a:r>
+          </a:p>
+        </p:txBody>
+      </p:sp>
+      <p:sp>
+        <p:nvSpPr>
+          <p:cNvPr id="30" name="TextBox 29"/>
+          <p:cNvSpPr txBox="1"/>
+          <p:nvPr/>
+        </p:nvSpPr>
+        <p:spPr>
+          <a:xfrm>
+            <a:off x="877824" y="5833872"/>
+            <a:ext cx="10469880" cy="329184"/>
+          </a:xfrm>
+          <a:prstGeom prst="rect">
+            <a:avLst/>
+          </a:prstGeom>
+          <a:noFill/>
+        </p:spPr>
+        <p:txBody>
+          <a:bodyPr wrap="square" lIns="18288" rIns="18288" tIns="9144" bIns="9144" anchor="ctr">
+            <a:spAutoFit/>
+          </a:bodyPr>
+          <a:lstStyle/>
+          <a:p>
+            <a:pPr algn="l">
+              <a:spcBef>
+                <a:spcPts val="0"/>
+              </a:spcBef>
+              <a:spcAft>
+                <a:spcPts val="0"/>
+              </a:spcAft>
+            </a:pPr>
+            <a:r>
+              <a:rPr sz="1019" b="0">
+                <a:solidFill>
+                  <a:srgbClr val="5B5957"/>
+                </a:solidFill>
+                <a:latin typeface="Inter"/>
+              </a:rPr>
+              <a:t>mx-gemmini-opt verifies typed IR. The standalone command path bypasses LLVM; the generic full-model host currently uses Merlin → LLVM → RV64.</a:t>
+            </a:r>
+          </a:p>
+        </p:txBody>
+      </p:sp>
+      <p:sp>
+        <p:nvSpPr>
+          <p:cNvPr id="31" name="TextBox 30"/>
           <p:cNvSpPr txBox="1"/>
           <p:nvPr/>
         </p:nvSpPr>
@@ -19999,7 +19999,7 @@
                 </a:solidFill>
                 <a:latin typeface="Inter"/>
               </a:rPr>
-              <a:t>02 / 04</a:t>
+              <a:t>01 / 04</a:t>
             </a:r>
           </a:p>
         </p:txBody>
@@ -20012,7 +20012,7 @@
 </p:sld>
 </file>
 
-<file path=ppt/slides/slide3.xml><?xml version="1.0" encoding="utf-8"?>
+<file path=ppt/slides/slide33.xml><?xml version="1.0" encoding="utf-8"?>
 <p:sld xmlns:a="http://schemas.openxmlformats.org/drawingml/2006/main" xmlns:p="http://schemas.openxmlformats.org/presentationml/2006/main" xmlns:r="http://schemas.openxmlformats.org/officeDocument/2006/relationships" showMasterSp="1">
   <p:cSld>
     <p:bg>
@@ -20929,7 +20929,7 @@
                           </a:solidFill>
                           <a:latin typeface="Inter"/>
                         </a:rPr>
-                        <a:t>Nicolas dense attention · 64×256×128</a:t>
+                        <a:t>SmolVLA attention head · 113 / 163 keys‡</a:t>
                       </a:r>
                     </a:p>
                   </a:txBody>
@@ -20979,7 +20979,7 @@
                           </a:solidFill>
                           <a:latin typeface="Inter"/>
                         </a:rPr>
-                        <a:t>43,523</a:t>
+                        <a:t>18,398 / 27,171</a:t>
                       </a:r>
                     </a:p>
                   </a:txBody>
@@ -21029,7 +21029,7 @@
                           </a:solidFill>
                           <a:latin typeface="Inter"/>
                         </a:rPr>
-                        <a:t>43,641</a:t>
+                        <a:t>16,717 / 22,057</a:t>
                       </a:r>
                     </a:p>
                   </a:txBody>
@@ -21079,7 +21079,7 @@
                           </a:solidFill>
                           <a:latin typeface="Inter"/>
                         </a:rPr>
-                        <a:t>-0.27%</a:t>
+                        <a:t>+10.1% / +23.2%</a:t>
                       </a:r>
                     </a:p>
                   </a:txBody>
@@ -21122,8 +21122,8 @@
         </p:nvSpPr>
         <p:spPr>
           <a:xfrm>
-            <a:off x="859536" y="5522976"/>
-            <a:ext cx="10515600" cy="603504"/>
+            <a:off x="859536" y="5486400"/>
+            <a:ext cx="10515600" cy="685800"/>
           </a:xfrm>
           <a:prstGeom prst="rect">
             <a:avLst/>
@@ -21149,7 +21149,7 @@
               </a:spcAft>
             </a:pPr>
             <a:r>
-              <a:rPr sz="960" b="0">
+              <a:rPr sz="910" b="0">
                 <a:solidFill>
                   <a:srgbClr val="5B5957"/>
                 </a:solidFill>
@@ -21168,13 +21168,32 @@
               </a:spcAft>
             </a:pPr>
             <a:r>
-              <a:rPr sz="960" b="0">
+              <a:rPr sz="910" b="0">
                 <a:solidFill>
                   <a:srgbClr val="5B5957"/>
                 </a:solidFill>
                 <a:latin typeface="Inter"/>
               </a:rPr>
               <a:t>† All-FP8 prefill: 200 weights and 128 IDs match; cosine 0.945, top tokens 29871/362. Host/VPU differ; source 128 keys, compiler 160 slots; no ratio.</a:t>
+            </a:r>
+          </a:p>
+          <a:p>
+            <a:pPr algn="l">
+              <a:spcBef>
+                <a:spcPts val="0"/>
+              </a:spcBef>
+              <a:spcAft>
+                <a:spcPts val="0"/>
+              </a:spcAft>
+            </a:pPr>
+            <a:r>
+              <a:rPr sz="910" b="0">
+                <a:solidFill>
+                  <a:srgbClr val="5B5957"/>
+                </a:solidFill>
+                <a:latin typeface="Inter"/>
+              </a:rPr>
+              <a:t>‡ Captured first-call head 0: all 4,096 BF16 values match per shape; source pipelined, compiler fenced. No whole-model ratio.</a:t>
             </a:r>
           </a:p>
         </p:txBody>
@@ -21256,7 +21275,14 @@
             </a:r>
           </a:p>
           <a:p>
-            <a:pPr algn="ctr"/>
+            <a:pPr algn="ctr">
+              <a:spcBef>
+                <a:spcPts val="0"/>
+              </a:spcBef>
+              <a:spcAft>
+                <a:spcPts val="0"/>
+              </a:spcAft>
+            </a:pPr>
             <a:r>
               <a:rPr sz="1060" b="1">
                 <a:solidFill>

</xml_diff>

<commit_message>
Clarify LUT PE modes on configuration slide
</commit_message>
<xml_diff>
--- a/docs/presentations/mx_gemmini_dialect_overview.pptx
+++ b/docs/presentations/mx_gemmini_dialect_overview.pptx
@@ -17944,7 +17944,7 @@
         <p:spPr>
           <a:xfrm>
             <a:off x="6748272" y="4041648"/>
-            <a:ext cx="4370832" cy="1481328"/>
+            <a:ext cx="4370832" cy="1728216"/>
           </a:xfrm>
           <a:prstGeom prst="rect">
             <a:avLst/>
@@ -17966,13 +17966,13 @@
               </a:spcAft>
             </a:pPr>
             <a:r>
-              <a:rPr sz="1100" b="0">
+              <a:rPr sz="1030" b="0">
                 <a:solidFill>
                   <a:srgbClr val="313455"/>
                 </a:solidFill>
                 <a:latin typeface="Inter"/>
               </a:rPr>
-              <a:t>• TinyLlama: 155 FP4 / 45 FP8 MX sites per stage.</a:t>
+              <a:t>• MX+VPU: direct FP4 PE 0 and FP8 PE 8; no LUT.</a:t>
             </a:r>
           </a:p>
           <a:p>
@@ -17985,13 +17985,13 @@
               </a:spcAft>
             </a:pPr>
             <a:r>
-              <a:rPr sz="1100" b="0">
+              <a:rPr sz="1030" b="0">
                 <a:solidFill>
                   <a:srgbClr val="313455"/>
                 </a:solidFill>
                 <a:latin typeface="Inter"/>
               </a:rPr>
-              <a:t>• PE 0 = direct FP4 × FP4; PE 8 = direct FP8 × FP8.</a:t>
+              <a:t>• FP6 E3M2 LUT × FP4 direct → PE 3; VPU off.</a:t>
             </a:r>
           </a:p>
           <a:p>
@@ -18004,13 +18004,13 @@
               </a:spcAft>
             </a:pPr>
             <a:r>
-              <a:rPr sz="1100" b="0">
+              <a:rPr sz="1030" b="0">
                 <a:solidFill>
                   <a:srgbClr val="313455"/>
                 </a:solidFill>
                 <a:latin typeface="Inter"/>
               </a:rPr>
-              <a:t>• 256 KiB SPAD caps tiles; VPU/requant legal.</a:t>
+              <a:t>• LUT PE 9: both; 10: activation; 11: weight.</a:t>
             </a:r>
           </a:p>
           <a:p>
@@ -18023,13 +18023,13 @@
               </a:spcAft>
             </a:pPr>
             <a:r>
-              <a:rPr sz="1100" b="0">
+              <a:rPr sz="1030" b="0">
                 <a:solidFill>
                   <a:srgbClr val="313455"/>
                 </a:solidFill>
                 <a:latin typeface="Inter"/>
               </a:rPr>
-              <a:t>• Selected profile: no operand LUT or FP6.</a:t>
+              <a:t>• PE 0–8 can also use LUT; mode alone is insufficient.</a:t>
             </a:r>
           </a:p>
           <a:p>
@@ -18042,13 +18042,13 @@
               </a:spcAft>
             </a:pPr>
             <a:r>
-              <a:rPr sz="1100" b="0">
+              <a:rPr sz="1030" b="0">
                 <a:solidFill>
                   <a:srgbClr val="313455"/>
                 </a:solidFill>
                 <a:latin typeface="Inter"/>
               </a:rPr>
-              <a:t>• FP6×FP4 profile: E3M2 LUT × FP4 direct → PE 3; VPU off.</a:t>
+              <a:t>• TinyLlama: 155 FP4 / 45 FP8 sites per stage.</a:t>
             </a:r>
           </a:p>
           <a:p>
@@ -18061,7 +18061,26 @@
               </a:spcAft>
             </a:pPr>
             <a:r>
-              <a:rPr sz="1100" b="0">
+              <a:rPr sz="1030" b="0">
+                <a:solidFill>
+                  <a:srgbClr val="313455"/>
+                </a:solidFill>
+                <a:latin typeface="Inter"/>
+              </a:rPr>
+              <a:t>• 256 KiB SPAD caps tiles; VPU/requant legal.</a:t>
+            </a:r>
+          </a:p>
+          <a:p>
+            <a:pPr algn="l">
+              <a:spcBef>
+                <a:spcPts val="0"/>
+              </a:spcBef>
+              <a:spcAft>
+                <a:spcPts val="0"/>
+              </a:spcAft>
+            </a:pPr>
+            <a:r>
+              <a:rPr sz="1030" b="0">
                 <a:solidFill>
                   <a:srgbClr val="313455"/>
                 </a:solidFill>

</xml_diff>

<commit_message>
Schedule queued SmolVLA attention through Merlin plan
</commit_message>
<xml_diff>
--- a/docs/presentations/mx_gemmini_dialect_overview.pptx
+++ b/docs/presentations/mx_gemmini_dialect_overview.pptx
@@ -20090,7 +20090,7 @@
                 </a:solidFill>
                 <a:latin typeface="Inter"/>
               </a:rPr>
-              <a:t>MX results: full-model Spike</a:t>
+              <a:t>MX results: Spike comparisons</a:t>
             </a:r>
           </a:p>
         </p:txBody>
@@ -20998,7 +20998,7 @@
                           </a:solidFill>
                           <a:latin typeface="Inter"/>
                         </a:rPr>
-                        <a:t>18,398 / 27,171</a:t>
+                        <a:t>17,669 / 24,241</a:t>
                       </a:r>
                     </a:p>
                   </a:txBody>
@@ -21098,7 +21098,7 @@
                           </a:solidFill>
                           <a:latin typeface="Inter"/>
                         </a:rPr>
-                        <a:t>+10.1% / +23.2%</a:t>
+                        <a:t>+5.7% / +9.9%</a:t>
                       </a:r>
                     </a:p>
                   </a:txBody>
@@ -21212,7 +21212,7 @@
                 </a:solidFill>
                 <a:latin typeface="Inter"/>
               </a:rPr>
-              <a:t>‡ Captured first-call head 0: all 4,096 BF16 values match per shape; source pipelined, compiler fenced. No whole-model ratio.</a:t>
+              <a:t>‡ Captured first-call head 0: all 4,096 BF16 values match per shape; source pipelined, compiler queued. No whole-model ratio.</a:t>
             </a:r>
           </a:p>
         </p:txBody>

</xml_diff>

<commit_message>
Pipeline captured SmolVLA attention with checked plan
</commit_message>
<xml_diff>
--- a/docs/presentations/mx_gemmini_dialect_overview.pptx
+++ b/docs/presentations/mx_gemmini_dialect_overview.pptx
@@ -20998,7 +20998,7 @@
                           </a:solidFill>
                           <a:latin typeface="Inter"/>
                         </a:rPr>
-                        <a:t>17,669 / 24,241</a:t>
+                        <a:t>16,033 / 21,382</a:t>
                       </a:r>
                     </a:p>
                   </a:txBody>
@@ -21098,7 +21098,7 @@
                           </a:solidFill>
                           <a:latin typeface="Inter"/>
                         </a:rPr>
-                        <a:t>+5.7% / +9.9%</a:t>
+                        <a:t>-4.1% / -3.1%</a:t>
                       </a:r>
                     </a:p>
                   </a:txBody>
@@ -21212,7 +21212,7 @@
                 </a:solidFill>
                 <a:latin typeface="Inter"/>
               </a:rPr>
-              <a:t>‡ Captured first-call head 0: all 4,096 BF16 values match per shape; source pipelined, compiler queued. No whole-model ratio.</a:t>
+              <a:t>‡ Captured first-call head 0: all 4,096 BF16 values match per shape; source pipelined, compiler pipelined. No whole-model ratio.</a:t>
             </a:r>
           </a:p>
         </p:txBody>

</xml_diff>

<commit_message>
Show late SmolVLA head timing in editable deck
</commit_message>
<xml_diff>
--- a/docs/presentations/mx_gemmini_dialect_overview.pptx
+++ b/docs/presentations/mx_gemmini_dialect_overview.pptx
@@ -20948,7 +20948,7 @@
                           </a:solidFill>
                           <a:latin typeface="Inter"/>
                         </a:rPr>
-                        <a:t>SmolVLA attention head · 113 / 163 keys‡</a:t>
+                        <a:t>SmolVLA final-step head · 113 / 163 keys‡</a:t>
                       </a:r>
                     </a:p>
                   </a:txBody>
@@ -20998,7 +20998,7 @@
                           </a:solidFill>
                           <a:latin typeface="Inter"/>
                         </a:rPr>
-                        <a:t>16,033 / 21,382</a:t>
+                        <a:t>14,132 / 15,733</a:t>
                       </a:r>
                     </a:p>
                   </a:txBody>
@@ -21048,7 +21048,7 @@
                           </a:solidFill>
                           <a:latin typeface="Inter"/>
                         </a:rPr>
-                        <a:t>16,717 / 22,057</a:t>
+                        <a:t>15,165 / 16,956</a:t>
                       </a:r>
                     </a:p>
                   </a:txBody>
@@ -21098,7 +21098,7 @@
                           </a:solidFill>
                           <a:latin typeface="Inter"/>
                         </a:rPr>
-                        <a:t>-4.1% / -3.1%</a:t>
+                        <a:t>-6.8% / -7.2%</a:t>
                       </a:r>
                     </a:p>
                   </a:txBody>
@@ -21212,7 +21212,7 @@
                 </a:solidFill>
                 <a:latin typeface="Inter"/>
               </a:rPr>
-              <a:t>‡ Captured first-call head 0: all 4,096 BF16 values match per shape; source pipelined, compiler pipelined. No whole-model ratio.</a:t>
+              <a:t>‡ Captured final flow step, head 0: all 4,096 BF16 values match per shape; source pipelined, compiler pipelined. No whole-model ratio.</a:t>
             </a:r>
           </a:p>
         </p:txBody>

</xml_diff>

<commit_message>
Show full FP8 controls in MX slides
</commit_message>
<xml_diff>
--- a/docs/presentations/mx_gemmini_dialect_overview.pptx
+++ b/docs/presentations/mx_gemmini_dialect_overview.pptx
@@ -20544,7 +20544,7 @@
                           </a:solidFill>
                           <a:latin typeface="Inter"/>
                         </a:rPr>
-                        <a:t>TinyLlama full 33 steps · issuer swap</a:t>
+                        <a:t>TinyLlama mixed 33 steps · issuer swap</a:t>
                       </a:r>
                     </a:p>
                   </a:txBody>
@@ -20746,7 +20746,7 @@
                           </a:solidFill>
                           <a:latin typeface="Inter"/>
                         </a:rPr>
-                        <a:t>TinyLlama 128-token prefill · independent</a:t>
+                        <a:t>TinyLlama 160-token forward · independent</a:t>
                       </a:r>
                     </a:p>
                   </a:txBody>
@@ -20796,7 +20796,7 @@
                           </a:solidFill>
                           <a:latin typeface="Inter"/>
                         </a:rPr>
-                        <a:t>11,442,665,332†</a:t>
+                        <a:t>running</a:t>
                       </a:r>
                     </a:p>
                   </a:txBody>
@@ -20846,7 +20846,7 @@
                           </a:solidFill>
                           <a:latin typeface="Inter"/>
                         </a:rPr>
-                        <a:t>9,611,186,417†</a:t>
+                        <a:t>12,703,713,784†</a:t>
                       </a:r>
                     </a:p>
                   </a:txBody>
@@ -20896,7 +20896,7 @@
                           </a:solidFill>
                           <a:latin typeface="Inter"/>
                         </a:rPr>
-                        <a:t>NO RATIO</a:t>
+                        <a:t>PENDING</a:t>
                       </a:r>
                     </a:p>
                   </a:txBody>
@@ -21174,7 +21174,7 @@
                 </a:solidFill>
                 <a:latin typeface="Inter"/>
               </a:rPr>
-              <a:t>* Issuer swap: host/VPU fixed; modeled cycles. Output hashes equal for SmolVLA 33/33 and TinyLlama 99/99.</a:t>
+              <a:t>* Issuer swap: host/VPU fixed; output hashes match SmolVLA 33/33 and TinyLlama 99/99.</a:t>
             </a:r>
           </a:p>
           <a:p>
@@ -21193,7 +21193,7 @@
                 </a:solidFill>
                 <a:latin typeface="Inter"/>
               </a:rPr>
-              <a:t>† All-FP8 prefill: 200 weights and 128 IDs match; cosine 0.945, top tokens 29871/362. Host/VPU differ; source 128 keys, compiler 160 slots; no ratio.</a:t>
+              <a:t>† All-FP8 source forward: same 160 IDs and 200 FP32 weights. Compiler one-pass still running; host work and timers differ. No ratio.</a:t>
             </a:r>
           </a:p>
           <a:p>
@@ -21271,26 +21271,7 @@
                 </a:solidFill>
                 <a:latin typeface="Inter"/>
               </a:rPr>
-              <a:t>TinyLlama logits vs FP32: prefill mixed -0.313, all-FP8 0.943; decode mean -0.324, 0/32 top matches.</a:t>
-            </a:r>
-          </a:p>
-          <a:p>
-            <a:pPr algn="ctr">
-              <a:spcBef>
-                <a:spcPts val="0"/>
-              </a:spcBef>
-              <a:spcAft>
-                <a:spcPts val="0"/>
-              </a:spcAft>
-            </a:pPr>
-            <a:r>
-              <a:rPr sz="1060" b="1">
-                <a:solidFill>
-                  <a:srgbClr val="103552"/>
-                </a:solidFill>
-                <a:latin typeface="Inter"/>
-              </a:rPr>
-              <a:t>First11 FP8: prepacked and runtime logits equal; 12.11B vs 90.55B cycles; cosine -0.440.</a:t>
+              <a:t>TinyLlama vs FP32: mixed prefill -0.313, decode -0.324 (0/32 top); all-FP8 full prefill 0.774, decode 0.663 (2/32 top).</a:t>
             </a:r>
           </a:p>
           <a:p>

</xml_diff>

<commit_message>
Archive matched TinyLlama one-pass result
</commit_message>
<xml_diff>
--- a/docs/presentations/mx_gemmini_dialect_overview.pptx
+++ b/docs/presentations/mx_gemmini_dialect_overview.pptx
@@ -20796,7 +20796,7 @@
                           </a:solidFill>
                           <a:latin typeface="Inter"/>
                         </a:rPr>
-                        <a:t>running</a:t>
+                        <a:t>15,170,996,572†</a:t>
                       </a:r>
                     </a:p>
                   </a:txBody>
@@ -20896,7 +20896,7 @@
                           </a:solidFill>
                           <a:latin typeface="Inter"/>
                         </a:rPr>
-                        <a:t>PENDING</a:t>
+                        <a:t>NO RATIO</a:t>
                       </a:r>
                     </a:p>
                   </a:txBody>
@@ -21193,7 +21193,7 @@
                 </a:solidFill>
                 <a:latin typeface="Inter"/>
               </a:rPr>
-              <a:t>† All-FP8 source forward: same 160 IDs and 200 FP32 weights. Compiler one-pass still running; host work and timers differ. No ratio.</a:t>
+              <a:t>† All-FP8 one-pass: same IDs/weights, 24/33 late top tokens. Source starts after embedding; host/VPU work differs. No ratio.</a:t>
             </a:r>
           </a:p>
           <a:p>

</xml_diff>

<commit_message>
Archive FP8 controls and refresh slides
</commit_message>
<xml_diff>
--- a/docs/presentations/mx_gemmini_dialect_overview.pptx
+++ b/docs/presentations/mx_gemmini_dialect_overview.pptx
@@ -20342,7 +20342,7 @@
                           </a:solidFill>
                           <a:latin typeface="Inter"/>
                         </a:rPr>
-                        <a:t>SmolVLA mixed 12-step · issuer swap</a:t>
+                        <a:t>SmolVLA all-FP8 12-step · issuer swap</a:t>
                       </a:r>
                     </a:p>
                   </a:txBody>
@@ -20392,7 +20392,7 @@
                           </a:solidFill>
                           <a:latin typeface="Inter"/>
                         </a:rPr>
-                        <a:t>72,066,544,354*</a:t>
+                        <a:t>180,219,637,915*</a:t>
                       </a:r>
                     </a:p>
                   </a:txBody>
@@ -20442,7 +20442,7 @@
                           </a:solidFill>
                           <a:latin typeface="Inter"/>
                         </a:rPr>
-                        <a:t>71,875,683,634</a:t>
+                        <a:t>179,451,403,096</a:t>
                       </a:r>
                     </a:p>
                   </a:txBody>
@@ -20492,7 +20492,7 @@
                           </a:solidFill>
                           <a:latin typeface="Inter"/>
                         </a:rPr>
-                        <a:t>+0.266%</a:t>
+                        <a:t>+0.428%</a:t>
                       </a:r>
                     </a:p>
                   </a:txBody>

</xml_diff>

<commit_message>
Measure independent TinyLlama token-to-logits control
</commit_message>
<xml_diff>
--- a/docs/presentations/mx_gemmini_dialect_overview.pptx
+++ b/docs/presentations/mx_gemmini_dialect_overview.pptx
@@ -20846,7 +20846,7 @@
                           </a:solidFill>
                           <a:latin typeface="Inter"/>
                         </a:rPr>
-                        <a:t>12,703,713,784†</a:t>
+                        <a:t>12,762,360,525†</a:t>
                       </a:r>
                     </a:p>
                   </a:txBody>
@@ -20896,7 +20896,7 @@
                           </a:solidFill>
                           <a:latin typeface="Inter"/>
                         </a:rPr>
-                        <a:t>NO RATIO</a:t>
+                        <a:t>+18.9% raw</a:t>
                       </a:r>
                     </a:p>
                   </a:txBody>
@@ -21174,7 +21174,7 @@
                 </a:solidFill>
                 <a:latin typeface="Inter"/>
               </a:rPr>
-              <a:t>* Issuer swap: host/VPU fixed; output hashes match SmolVLA 33/33 and TinyLlama 99/99.</a:t>
+              <a:t>* Issuer swap: host/VPU fixed; TinyLlama 99/99 and SmolVLA 33/33 output hashes match.</a:t>
             </a:r>
           </a:p>
           <a:p>
@@ -21193,7 +21193,7 @@
                 </a:solidFill>
                 <a:latin typeface="Inter"/>
               </a:rPr>
-              <a:t>† All-FP8 one-pass: same IDs/weights, 24/33 late top tokens. Source starts after embedding; host/VPU work differs. No ratio.</a:t>
+              <a:t>† All-FP8 token-to-logits: same IDs/weights. FP32 top matches source 131/160, compiler 103/160. Raw cycles; no equal-quality speedup.</a:t>
             </a:r>
           </a:p>
           <a:p>

</xml_diff>